<commit_message>
Update slide deck: correct Android flow, simplify wording throughout
</commit_message>
<xml_diff>
--- a/SGQR_Deep_Linking_Simulation.pptx
+++ b/SGQR_Deep_Linking_Simulation.pptx
@@ -14,9 +14,10 @@
     <p:sldId id="262" r:id="rId8"/>
     <p:sldId id="263" r:id="rId9"/>
     <p:sldId id="264" r:id="rId10"/>
+    <p:sldId id="265" r:id="rId11"/>
   </p:sldIdLst>
   <p:notesMasterIdLst>
-    <p:notesMasterId r:id="rId11"/>
+    <p:notesMasterId r:id="rId12"/>
   </p:notesMasterIdLst>
   <p:sldSz cx="12192000" cy="6858000"/>
   <p:notesSz cx="6858000" cy="12192000"/>
@@ -534,6 +535,94 @@
             <a:fld id="{F7021451-1387-4CA6-816F-3879F97B5CBC}" type="slidenum">
               <a:rPr lang="en-US"/>
               <a:t>1</a:t>
+            </a:fld>
+            <a:endParaRPr lang="en-US"/>
+          </a:p>
+        </p:txBody>
+      </p:sp>
+    </p:spTree>
+    <p:extLst>
+      <p:ext uri="{BB962C8B-B14F-4D97-AF65-F5344CB8AC3E}">
+        <p14:creationId xmlns:p14="http://schemas.microsoft.com/office/powerpoint/2010/main" val="1024086991"/>
+      </p:ext>
+    </p:extLst>
+  </p:cSld>
+  <p:clrMapOvr>
+    <a:masterClrMapping/>
+  </p:clrMapOvr>
+</p:notes>
+</file>
+
+<file path=ppt/notesSlides/notesSlide10.xml><?xml version="1.0" encoding="utf-8"?>
+<p:notes xmlns:a="http://schemas.openxmlformats.org/drawingml/2006/main" xmlns:r="http://schemas.openxmlformats.org/officeDocument/2006/relationships" xmlns:p="http://schemas.openxmlformats.org/presentationml/2006/main">
+  <p:cSld>
+    <p:spTree>
+      <p:nvGrpSpPr>
+        <p:cNvPr id="1" name=""/>
+        <p:cNvGrpSpPr/>
+        <p:nvPr/>
+      </p:nvGrpSpPr>
+      <p:grpSpPr>
+        <a:xfrm>
+          <a:off x="0" y="0"/>
+          <a:ext cx="0" cy="0"/>
+          <a:chOff x="0" y="0"/>
+          <a:chExt cx="0" cy="0"/>
+        </a:xfrm>
+      </p:grpSpPr>
+      <p:sp>
+        <p:nvSpPr>
+          <p:cNvPr id="2" name="Slide Image Placeholder 1"/>
+          <p:cNvSpPr>
+            <a:spLocks noGrp="1" noRot="1" noChangeAspect="1"/>
+          </p:cNvSpPr>
+          <p:nvPr>
+            <p:ph type="sldImg"/>
+          </p:nvPr>
+        </p:nvSpPr>
+        <p:spPr/>
+      </p:sp>
+      <p:sp>
+        <p:nvSpPr>
+          <p:cNvPr id="3" name="Notes Placeholder 2"/>
+          <p:cNvSpPr>
+            <a:spLocks noGrp="1"/>
+          </p:cNvSpPr>
+          <p:nvPr>
+            <p:ph type="body" idx="1"/>
+          </p:nvPr>
+        </p:nvSpPr>
+        <p:spPr/>
+        <p:txBody>
+          <a:bodyPr/>
+          <a:lstStyle/>
+          <a:p>
+            <a:r>
+              <a:rPr lang="en-US" dirty="0"/>
+              <a:t/>
+            </a:r>
+            <a:endParaRPr lang="en-US" dirty="0"/>
+          </a:p>
+        </p:txBody>
+      </p:sp>
+      <p:sp>
+        <p:nvSpPr>
+          <p:cNvPr id="4" name="Slide Number Placeholder 3"/>
+          <p:cNvSpPr>
+            <a:spLocks noGrp="1"/>
+          </p:cNvSpPr>
+          <p:nvPr>
+            <p:ph type="sldNum" sz="quarter" idx="10"/>
+          </p:nvPr>
+        </p:nvSpPr>
+        <p:spPr/>
+        <p:txBody>
+          <a:bodyPr/>
+          <a:lstStyle/>
+          <a:p>
+            <a:fld id="{F7021451-1387-4CA6-816F-3879F97B5CBC}" type="slidenum">
+              <a:rPr lang="en-US"/>
+              <a:t>10</a:t>
             </a:fld>
             <a:endParaRPr lang="en-US"/>
           </a:p>
@@ -1792,7 +1881,7 @@
                 <a:ea typeface="Calibri" pitchFamily="34" charset="-122"/>
                 <a:cs typeface="Calibri" pitchFamily="34" charset="-120"/>
               </a:rPr>
-              <a:t>One QR code. Two platforms. Zero backend branching — Android and iOS diverge purely from how each OS resolves an unverified link.</a:t>
+              <a:t>One QR code, one link. Android and iOS end up in different places because of how each phone's operating system — not our server — decides what to do with an unverified link.</a:t>
             </a:r>
             <a:endParaRPr lang="en-US" sz="1500" dirty="0"/>
           </a:p>
@@ -2143,6 +2232,210 @@
               <a:t>3 Bank Apps</a:t>
             </a:r>
             <a:endParaRPr lang="en-US" sz="1250" dirty="0"/>
+          </a:p>
+        </p:txBody>
+      </p:sp>
+    </p:spTree>
+  </p:cSld>
+  <p:clrMapOvr>
+    <a:masterClrMapping/>
+  </p:clrMapOvr>
+</p:sld>
+</file>
+
+<file path=ppt/slides/slide10.xml><?xml version="1.0" encoding="utf-8"?>
+<p:sld xmlns:a="http://schemas.openxmlformats.org/drawingml/2006/main" xmlns:r="http://schemas.openxmlformats.org/officeDocument/2006/relationships" xmlns:p="http://schemas.openxmlformats.org/presentationml/2006/main">
+  <p:cSld name="Slide 10">
+    <p:bg>
+      <p:bgPr>
+        <a:solidFill>
+          <a:srgbClr val="21295C"/>
+        </a:solidFill>
+      </p:bgPr>
+    </p:bg>
+    <p:spTree>
+      <p:nvGrpSpPr>
+        <p:cNvPr id="1" name=""/>
+        <p:cNvGrpSpPr/>
+        <p:nvPr/>
+      </p:nvGrpSpPr>
+      <p:grpSpPr>
+        <a:xfrm>
+          <a:off x="0" y="0"/>
+          <a:ext cx="0" cy="0"/>
+          <a:chOff x="0" y="0"/>
+          <a:chExt cx="0" cy="0"/>
+        </a:xfrm>
+      </p:grpSpPr>
+      <p:sp>
+        <p:nvSpPr>
+          <p:cNvPr id="2" name="Shape 0"/>
+          <p:cNvSpPr/>
+          <p:nvPr/>
+        </p:nvSpPr>
+        <p:spPr>
+          <a:xfrm>
+            <a:off x="8686800" y="-1828800"/>
+            <a:ext cx="5486400" cy="5486400"/>
+          </a:xfrm>
+          <a:prstGeom prst="ellipse">
+            <a:avLst/>
+          </a:prstGeom>
+          <a:solidFill>
+            <a:srgbClr val="065A82">
+              <a:alpha val="45000"/>
+            </a:srgbClr>
+          </a:solidFill>
+          <a:ln/>
+        </p:spPr>
+      </p:sp>
+      <p:sp>
+        <p:nvSpPr>
+          <p:cNvPr id="3" name="Shape 1"/>
+          <p:cNvSpPr/>
+          <p:nvPr/>
+        </p:nvSpPr>
+        <p:spPr>
+          <a:xfrm>
+            <a:off x="-1828800" y="4572000"/>
+            <a:ext cx="4572000" cy="4572000"/>
+          </a:xfrm>
+          <a:prstGeom prst="ellipse">
+            <a:avLst/>
+          </a:prstGeom>
+          <a:solidFill>
+            <a:srgbClr val="1C7293">
+              <a:alpha val="35000"/>
+            </a:srgbClr>
+          </a:solidFill>
+          <a:ln/>
+        </p:spPr>
+      </p:sp>
+      <p:pic>
+        <p:nvPicPr>
+          <p:cNvPr id="4" name="Image 0" descr="preencoded.png">    </p:cNvPr>
+          <p:cNvPicPr>
+            <a:picLocks noChangeAspect="1"/>
+          </p:cNvPicPr>
+          <p:nvPr/>
+        </p:nvPicPr>
+        <p:blipFill>
+          <a:blip r:embed="rId1"/>
+          <a:stretch>
+            <a:fillRect/>
+          </a:stretch>
+        </p:blipFill>
+        <p:spPr>
+          <a:xfrm>
+            <a:off x="822960" y="1280160"/>
+            <a:ext cx="640080" cy="640080"/>
+          </a:xfrm>
+          <a:prstGeom prst="rect">
+            <a:avLst/>
+          </a:prstGeom>
+        </p:spPr>
+      </p:pic>
+      <p:sp>
+        <p:nvSpPr>
+          <p:cNvPr id="5" name="Text 2"/>
+          <p:cNvSpPr/>
+          <p:nvPr/>
+        </p:nvSpPr>
+        <p:spPr>
+          <a:xfrm>
+            <a:off x="822960" y="2103120"/>
+            <a:ext cx="9875520" cy="1645920"/>
+          </a:xfrm>
+          <a:prstGeom prst="rect">
+            <a:avLst/>
+          </a:prstGeom>
+          <a:noFill/>
+          <a:ln/>
+        </p:spPr>
+        <p:txBody>
+          <a:bodyPr wrap="square" lIns="0" tIns="0" rIns="0" bIns="0" rtlCol="0" anchor="ctr"/>
+          <a:lstStyle/>
+          <a:p>
+            <a:pPr indent="0" marL="0">
+              <a:lnSpc>
+                <a:spcPct val="110000"/>
+              </a:lnSpc>
+              <a:buNone/>
+            </a:pPr>
+            <a:r>
+              <a:rPr lang="en-US" sz="3400" b="1" dirty="0">
+                <a:solidFill>
+                  <a:srgbClr val="FFFFFF"/>
+                </a:solidFill>
+                <a:latin typeface="Cambria" pitchFamily="34" charset="0"/>
+                <a:ea typeface="Cambria" pitchFamily="34" charset="-122"/>
+                <a:cs typeface="Cambria" pitchFamily="34" charset="-120"/>
+              </a:rPr>
+              <a:t>One link. Two different endings.</a:t>
+            </a:r>
+            <a:endParaRPr lang="en-US" sz="3400" dirty="0"/>
+          </a:p>
+          <a:p>
+            <a:pPr indent="0" marL="0">
+              <a:lnSpc>
+                <a:spcPct val="110000"/>
+              </a:lnSpc>
+              <a:buNone/>
+            </a:pPr>
+            <a:r>
+              <a:rPr lang="en-US" sz="3400" b="1" dirty="0">
+                <a:solidFill>
+                  <a:srgbClr val="FFFFFF"/>
+                </a:solidFill>
+                <a:latin typeface="Cambria" pitchFamily="34" charset="0"/>
+                <a:ea typeface="Cambria" pitchFamily="34" charset="-122"/>
+                <a:cs typeface="Cambria" pitchFamily="34" charset="-120"/>
+              </a:rPr>
+              <a:t>Three independent bank apps.</a:t>
+            </a:r>
+            <a:endParaRPr lang="en-US" sz="3400" dirty="0"/>
+          </a:p>
+        </p:txBody>
+      </p:sp>
+      <p:sp>
+        <p:nvSpPr>
+          <p:cNvPr id="6" name="Text 3"/>
+          <p:cNvSpPr/>
+          <p:nvPr/>
+        </p:nvSpPr>
+        <p:spPr>
+          <a:xfrm>
+            <a:off x="822960" y="3657600"/>
+            <a:ext cx="8961120" cy="822960"/>
+          </a:xfrm>
+          <a:prstGeom prst="rect">
+            <a:avLst/>
+          </a:prstGeom>
+          <a:noFill/>
+          <a:ln/>
+        </p:spPr>
+        <p:txBody>
+          <a:bodyPr wrap="square" lIns="0" tIns="0" rIns="0" bIns="0" rtlCol="0" anchor="ctr"/>
+          <a:lstStyle/>
+          <a:p>
+            <a:pPr indent="0" marL="0">
+              <a:lnSpc>
+                <a:spcPct val="125000"/>
+              </a:lnSpc>
+              <a:buNone/>
+            </a:pPr>
+            <a:r>
+              <a:rPr lang="en-US" sz="1500" dirty="0">
+                <a:solidFill>
+                  <a:srgbClr val="CADCFC"/>
+                </a:solidFill>
+                <a:latin typeface="Calibri" pitchFamily="34" charset="0"/>
+                <a:ea typeface="Calibri" pitchFamily="34" charset="-122"/>
+                <a:cs typeface="Calibri" pitchFamily="34" charset="-120"/>
+              </a:rPr>
+              <a:t>Most of the split comes from what each phone's OS does by default with an unregistered link — the app just gives Android one extra nudge to make the chooser appear.</a:t>
+            </a:r>
+            <a:endParaRPr lang="en-US" sz="1500" dirty="0"/>
           </a:p>
         </p:txBody>
       </p:sp>
@@ -2403,7 +2696,7 @@
                 <a:ea typeface="Calibri" pitchFamily="34" charset="-122"/>
                 <a:cs typeface="Calibri" pitchFamily="34" charset="-120"/>
               </a:rPr>
-              <a:t>Node / Express on Render</a:t>
+              <a:t>Node.js server, hosted on Render</a:t>
             </a:r>
             <a:endParaRPr lang="en-US" sz="1150" dirty="0"/>
           </a:p>
@@ -2449,7 +2742,7 @@
                 <a:ea typeface="Calibri" pitchFamily="34" charset="-122"/>
                 <a:cs typeface="Calibri" pitchFamily="34" charset="-120"/>
               </a:rPr>
-              <a:t>Mints payment tokens</a:t>
+              <a:t>Creates a payment record and gives it a token</a:t>
             </a:r>
             <a:endParaRPr lang="en-US" sz="1300" dirty="0"/>
           </a:p>
@@ -2473,7 +2766,7 @@
                 <a:ea typeface="Calibri" pitchFamily="34" charset="-122"/>
                 <a:cs typeface="Calibri" pitchFamily="34" charset="-120"/>
               </a:rPr>
-              <a:t>Generates QR PNGs</a:t>
+              <a:t>Generates the QR code image</a:t>
             </a:r>
             <a:endParaRPr lang="en-US" sz="1300" dirty="0"/>
           </a:p>
@@ -2497,7 +2790,7 @@
                 <a:ea typeface="Calibri" pitchFamily="34" charset="-122"/>
                 <a:cs typeface="Calibri" pitchFamily="34" charset="-120"/>
               </a:rPr>
-              <a:t>Single-use pay endpoint</a:t>
+              <a:t>Marks a payment as paid — once, only</a:t>
             </a:r>
             <a:endParaRPr lang="en-US" sz="1300" dirty="0"/>
           </a:p>
@@ -2611,7 +2904,7 @@
                 <a:ea typeface="Cambria" pitchFamily="34" charset="-122"/>
                 <a:cs typeface="Cambria" pitchFamily="34" charset="-120"/>
               </a:rPr>
-              <a:t>iOS Picker Page</a:t>
+              <a:t>Picker Page</a:t>
             </a:r>
             <a:endParaRPr lang="en-US" sz="1900" dirty="0"/>
           </a:p>
@@ -2650,7 +2943,7 @@
                 <a:ea typeface="Calibri" pitchFamily="34" charset="-122"/>
                 <a:cs typeface="Calibri" pitchFamily="34" charset="-120"/>
               </a:rPr>
-              <a:t>Static HTML, served by backend</a:t>
+              <a:t>One web page, served by the backend</a:t>
             </a:r>
             <a:endParaRPr lang="en-US" sz="1150" dirty="0"/>
           </a:p>
@@ -2696,7 +2989,7 @@
                 <a:ea typeface="Calibri" pitchFamily="34" charset="-122"/>
                 <a:cs typeface="Calibri" pitchFamily="34" charset="-120"/>
               </a:rPr>
-              <a:t>Loaded only by Safari</a:t>
+              <a:t>Loads the merchant name and amount</a:t>
             </a:r>
             <a:endParaRPr lang="en-US" sz="1300" dirty="0"/>
           </a:p>
@@ -2720,7 +3013,7 @@
                 <a:ea typeface="Calibri" pitchFamily="34" charset="-122"/>
                 <a:cs typeface="Calibri" pitchFamily="34" charset="-120"/>
               </a:rPr>
-              <a:t>Fetches payload live</a:t>
+              <a:t>Shows 3 buttons: Bank A, B, C</a:t>
             </a:r>
             <a:endParaRPr lang="en-US" sz="1300" dirty="0"/>
           </a:p>
@@ -2744,7 +3037,7 @@
                 <a:ea typeface="Calibri" pitchFamily="34" charset="-122"/>
                 <a:cs typeface="Calibri" pitchFamily="34" charset="-120"/>
               </a:rPr>
-              <a:t>3 bank buttons → custom scheme</a:t>
+              <a:t>Only the page Safari actually reaches</a:t>
             </a:r>
             <a:endParaRPr lang="en-US" sz="1300" dirty="0"/>
           </a:p>
@@ -2897,7 +3190,7 @@
                 <a:ea typeface="Calibri" pitchFamily="34" charset="-122"/>
                 <a:cs typeface="Calibri" pitchFamily="34" charset="-120"/>
               </a:rPr>
-              <a:t>Flutter, Android + iOS</a:t>
+              <a:t>Flutter apps for Android + iOS</a:t>
             </a:r>
             <a:endParaRPr lang="en-US" sz="1150" dirty="0"/>
           </a:p>
@@ -2943,7 +3236,7 @@
                 <a:ea typeface="Calibri" pitchFamily="34" charset="-122"/>
                 <a:cs typeface="Calibri" pitchFamily="34" charset="-120"/>
               </a:rPr>
-              <a:t>Independent projects</a:t>
+              <a:t>3 separate apps, not 1 app with settings</a:t>
             </a:r>
             <a:endParaRPr lang="en-US" sz="1300" dirty="0"/>
           </a:p>
@@ -2967,7 +3260,7 @@
                 <a:ea typeface="Calibri" pitchFamily="34" charset="-122"/>
                 <a:cs typeface="Calibri" pitchFamily="34" charset="-120"/>
               </a:rPr>
-              <a:t>Own scheme + bundle ID</a:t>
+              <a:t>Each has its own name and app ID</a:t>
             </a:r>
             <a:endParaRPr lang="en-US" sz="1300" dirty="0"/>
           </a:p>
@@ -2991,7 +3284,7 @@
                 <a:ea typeface="Calibri" pitchFamily="34" charset="-122"/>
                 <a:cs typeface="Calibri" pitchFamily="34" charset="-120"/>
               </a:rPr>
-              <a:t>Listen for deep links</a:t>
+              <a:t>Each listens for its own kind of link</a:t>
             </a:r>
             <a:endParaRPr lang="en-US" sz="1300" dirty="0"/>
           </a:p>
@@ -3062,7 +3355,7 @@
                 <a:ea typeface="Cambria" pitchFamily="34" charset="-122"/>
                 <a:cs typeface="Cambria" pitchFamily="34" charset="-120"/>
               </a:rPr>
-              <a:t>Same URL, one deliberate omission each side</a:t>
+              <a:t>Same link, two different endings</a:t>
             </a:r>
             <a:endParaRPr lang="en-US" sz="2800" dirty="0"/>
           </a:p>
@@ -3291,7 +3584,7 @@
                 <a:ea typeface="Calibri" pitchFamily="34" charset="-122"/>
                 <a:cs typeface="Calibri" pitchFamily="34" charset="-120"/>
               </a:rPr>
-              <a:t>No android:autoVerify, no assetlinks.json</a:t>
+              <a:t>Opens in the default browser first</a:t>
             </a:r>
             <a:endParaRPr lang="en-US" sz="1150" dirty="0"/>
           </a:p>
@@ -3337,7 +3630,7 @@
                 <a:ea typeface="Calibri" pitchFamily="34" charset="-122"/>
                 <a:cs typeface="Calibri" pitchFamily="34" charset="-120"/>
               </a:rPr>
-              <a:t>3 apps register unverified BROWSABLE intent-filters for the same host</a:t>
+              <a:t>The link isn't "verified," so it opens like any normal web page</a:t>
             </a:r>
             <a:endParaRPr lang="en-US" sz="1250" dirty="0"/>
           </a:p>
@@ -3361,7 +3654,7 @@
                 <a:ea typeface="Calibri" pitchFamily="34" charset="-122"/>
                 <a:cs typeface="Calibri" pitchFamily="34" charset="-120"/>
               </a:rPr>
-              <a:t>OS can't cryptographically award ownership to one app</a:t>
+              <a:t>The page shows one button: "Continue to pay"</a:t>
             </a:r>
             <a:endParaRPr lang="en-US" sz="1250" dirty="0"/>
           </a:p>
@@ -3385,7 +3678,7 @@
                 <a:ea typeface="Calibri" pitchFamily="34" charset="-122"/>
                 <a:cs typeface="Calibri" pitchFamily="34" charset="-120"/>
               </a:rPr>
-              <a:t>Result: native “Open with…” chooser dialog</a:t>
+              <a:t>Tapping it opens the native chooser (next slide)</a:t>
             </a:r>
             <a:endParaRPr lang="en-US" sz="1250" dirty="0"/>
           </a:p>
@@ -3531,7 +3824,7 @@
                 <a:ea typeface="Calibri" pitchFamily="34" charset="-122"/>
                 <a:cs typeface="Calibri" pitchFamily="34" charset="-120"/>
               </a:rPr>
-              <a:t>No hosted apple-app-site-association</a:t>
+              <a:t>No app is registered for this address</a:t>
             </a:r>
             <a:endParaRPr lang="en-US" sz="1150" dirty="0"/>
           </a:p>
@@ -3577,7 +3870,7 @@
                 <a:ea typeface="Calibri" pitchFamily="34" charset="-122"/>
                 <a:cs typeface="Calibri" pitchFamily="34" charset="-120"/>
               </a:rPr>
-              <a:t>No Universal Link association exists for this domain</a:t>
+              <a:t>iOS has no record linking this domain to an app</a:t>
             </a:r>
             <a:endParaRPr lang="en-US" sz="1250" dirty="0"/>
           </a:p>
@@ -3601,7 +3894,7 @@
                 <a:ea typeface="Calibri" pitchFamily="34" charset="-122"/>
                 <a:cs typeface="Calibri" pitchFamily="34" charset="-120"/>
               </a:rPr>
-              <a:t>iOS treats it as an ordinary link → opens Safari</a:t>
+              <a:t>So it just opens Safari, like any ordinary link</a:t>
             </a:r>
             <a:endParaRPr lang="en-US" sz="1250" dirty="0"/>
           </a:p>
@@ -3625,7 +3918,7 @@
                 <a:ea typeface="Calibri" pitchFamily="34" charset="-122"/>
                 <a:cs typeface="Calibri" pitchFamily="34" charset="-120"/>
               </a:rPr>
-              <a:t>Safari loads the picker page, which offers 3 bank buttons</a:t>
+              <a:t>Safari shows the picker page: 3 bank buttons</a:t>
             </a:r>
             <a:endParaRPr lang="en-US" sz="1250" dirty="0"/>
           </a:p>
@@ -3696,7 +3989,7 @@
                 <a:ea typeface="Cambria" pitchFamily="34" charset="-122"/>
                 <a:cs typeface="Cambria" pitchFamily="34" charset="-120"/>
               </a:rPr>
-              <a:t>iOS: Safari page hands off via custom scheme</a:t>
+              <a:t>Android: from browser tab to app chooser</a:t>
             </a:r>
             <a:endParaRPr lang="en-US" sz="2800" dirty="0"/>
           </a:p>
@@ -3704,14 +3997,53 @@
       </p:sp>
       <p:sp>
         <p:nvSpPr>
-          <p:cNvPr id="3" name="Shape 1"/>
-          <p:cNvSpPr/>
-          <p:nvPr/>
-        </p:nvSpPr>
-        <p:spPr>
-          <a:xfrm>
-            <a:off x="548640" y="1371600"/>
-            <a:ext cx="2514600" cy="4206240"/>
+          <p:cNvPr id="3" name="Text 1"/>
+          <p:cNvSpPr/>
+          <p:nvPr/>
+        </p:nvSpPr>
+        <p:spPr>
+          <a:xfrm>
+            <a:off x="548640" y="914400"/>
+            <a:ext cx="10515600" cy="365760"/>
+          </a:xfrm>
+          <a:prstGeom prst="rect">
+            <a:avLst/>
+          </a:prstGeom>
+          <a:noFill/>
+          <a:ln/>
+        </p:spPr>
+        <p:txBody>
+          <a:bodyPr wrap="square" lIns="0" tIns="0" rIns="0" bIns="0" rtlCol="0" anchor="ctr"/>
+          <a:lstStyle/>
+          <a:p>
+            <a:pPr indent="0" marL="0">
+              <a:buNone/>
+            </a:pPr>
+            <a:r>
+              <a:rPr lang="en-US" sz="1400" dirty="0">
+                <a:solidFill>
+                  <a:srgbClr val="5B6B79"/>
+                </a:solidFill>
+                <a:latin typeface="Calibri" pitchFamily="34" charset="0"/>
+                <a:ea typeface="Calibri" pitchFamily="34" charset="-122"/>
+                <a:cs typeface="Calibri" pitchFamily="34" charset="-120"/>
+              </a:rPr>
+              <a:t>Getting the native "Open with…" dialog to appear takes 3 extra steps</a:t>
+            </a:r>
+            <a:endParaRPr lang="en-US" sz="1400" dirty="0"/>
+          </a:p>
+        </p:txBody>
+      </p:sp>
+      <p:sp>
+        <p:nvSpPr>
+          <p:cNvPr id="4" name="Shape 2"/>
+          <p:cNvSpPr/>
+          <p:nvPr/>
+        </p:nvSpPr>
+        <p:spPr>
+          <a:xfrm>
+            <a:off x="548640" y="1463040"/>
+            <a:ext cx="2514600" cy="4114800"/>
           </a:xfrm>
           <a:prstGeom prst="roundRect">
             <a:avLst>
@@ -3733,13 +4065,13 @@
       </p:sp>
       <p:sp>
         <p:nvSpPr>
-          <p:cNvPr id="4" name="Shape 2"/>
-          <p:cNvSpPr/>
-          <p:nvPr/>
-        </p:nvSpPr>
-        <p:spPr>
-          <a:xfrm>
-            <a:off x="1485900" y="1691640"/>
+          <p:cNvPr id="5" name="Shape 3"/>
+          <p:cNvSpPr/>
+          <p:nvPr/>
+        </p:nvSpPr>
+        <p:spPr>
+          <a:xfrm>
+            <a:off x="1485900" y="1783080"/>
             <a:ext cx="640080" cy="640080"/>
           </a:xfrm>
           <a:prstGeom prst="ellipse">
@@ -3753,7 +4085,7 @@
       </p:sp>
       <p:pic>
         <p:nvPicPr>
-          <p:cNvPr id="5" name="Image 0" descr="preencoded.png">    </p:cNvPr>
+          <p:cNvPr id="6" name="Image 0" descr="preencoded.png">    </p:cNvPr>
           <p:cNvPicPr>
             <a:picLocks noChangeAspect="1"/>
           </p:cNvPicPr>
@@ -3767,7 +4099,7 @@
         </p:blipFill>
         <p:spPr>
           <a:xfrm>
-            <a:off x="1641348" y="1847088"/>
+            <a:off x="1641348" y="1938528"/>
             <a:ext cx="329184" cy="329184"/>
           </a:xfrm>
           <a:prstGeom prst="rect">
@@ -3777,13 +4109,13 @@
       </p:pic>
       <p:sp>
         <p:nvSpPr>
-          <p:cNvPr id="6" name="Text 3"/>
-          <p:cNvSpPr/>
-          <p:nvPr/>
-        </p:nvSpPr>
-        <p:spPr>
-          <a:xfrm>
-            <a:off x="685800" y="1508760"/>
+          <p:cNvPr id="7" name="Text 4"/>
+          <p:cNvSpPr/>
+          <p:nvPr/>
+        </p:nvSpPr>
+        <p:spPr>
+          <a:xfrm>
+            <a:off x="685800" y="1600200"/>
             <a:ext cx="365760" cy="365760"/>
           </a:xfrm>
           <a:prstGeom prst="rect">
@@ -3816,13 +4148,13 @@
       </p:sp>
       <p:sp>
         <p:nvSpPr>
-          <p:cNvPr id="7" name="Text 4"/>
-          <p:cNvSpPr/>
-          <p:nvPr/>
-        </p:nvSpPr>
-        <p:spPr>
-          <a:xfrm>
-            <a:off x="731520" y="2514600"/>
+          <p:cNvPr id="8" name="Text 5"/>
+          <p:cNvSpPr/>
+          <p:nvPr/>
+        </p:nvSpPr>
+        <p:spPr>
+          <a:xfrm>
+            <a:off x="731520" y="2606040"/>
             <a:ext cx="2148840" cy="685800"/>
           </a:xfrm>
           <a:prstGeom prst="rect">
@@ -3847,7 +4179,7 @@
                 <a:ea typeface="Cambria" pitchFamily="34" charset="-122"/>
                 <a:cs typeface="Cambria" pitchFamily="34" charset="-120"/>
               </a:rPr>
-              <a:t>Safari opens pay.html</a:t>
+              <a:t>Page opens normally</a:t>
             </a:r>
             <a:endParaRPr lang="en-US" sz="1500" dirty="0"/>
           </a:p>
@@ -3855,14 +4187,14 @@
       </p:sp>
       <p:sp>
         <p:nvSpPr>
-          <p:cNvPr id="8" name="Text 5"/>
-          <p:cNvSpPr/>
-          <p:nvPr/>
-        </p:nvSpPr>
-        <p:spPr>
-          <a:xfrm>
-            <a:off x="777240" y="3246120"/>
-            <a:ext cx="2057400" cy="2103120"/>
+          <p:cNvPr id="9" name="Text 6"/>
+          <p:cNvSpPr/>
+          <p:nvPr/>
+        </p:nvSpPr>
+        <p:spPr>
+          <a:xfrm>
+            <a:off x="777240" y="3337560"/>
+            <a:ext cx="2057400" cy="2011680"/>
           </a:xfrm>
           <a:prstGeom prst="rect">
             <a:avLst/>
@@ -3889,7 +4221,7 @@
                 <a:ea typeface="Calibri" pitchFamily="34" charset="-122"/>
                 <a:cs typeface="Calibri" pitchFamily="34" charset="-120"/>
               </a:rPr>
-              <a:t>iOS has no Universal Link record, so the https:// link opens normally in Safari.</a:t>
+              <a:t>Chrome (or whichever browser is default) opens the payment page, same as any website.</a:t>
             </a:r>
             <a:endParaRPr lang="en-US" sz="1150" dirty="0"/>
           </a:p>
@@ -3897,7 +4229,7 @@
       </p:sp>
       <p:pic>
         <p:nvPicPr>
-          <p:cNvPr id="9" name="Image 1" descr="preencoded.png">    </p:cNvPr>
+          <p:cNvPr id="10" name="Image 1" descr="preencoded.png">    </p:cNvPr>
           <p:cNvPicPr>
             <a:picLocks noChangeAspect="1"/>
           </p:cNvPicPr>
@@ -3911,7 +4243,7 @@
         </p:blipFill>
         <p:spPr>
           <a:xfrm>
-            <a:off x="3081528" y="3364992"/>
+            <a:off x="3081528" y="3410712"/>
             <a:ext cx="219456" cy="219456"/>
           </a:xfrm>
           <a:prstGeom prst="rect">
@@ -3921,14 +4253,14 @@
       </p:pic>
       <p:sp>
         <p:nvSpPr>
-          <p:cNvPr id="10" name="Shape 6"/>
-          <p:cNvSpPr/>
-          <p:nvPr/>
-        </p:nvSpPr>
-        <p:spPr>
-          <a:xfrm>
-            <a:off x="3291840" y="1371600"/>
-            <a:ext cx="2514600" cy="4206240"/>
+          <p:cNvPr id="11" name="Shape 7"/>
+          <p:cNvSpPr/>
+          <p:nvPr/>
+        </p:nvSpPr>
+        <p:spPr>
+          <a:xfrm>
+            <a:off x="3291840" y="1463040"/>
+            <a:ext cx="2514600" cy="4114800"/>
           </a:xfrm>
           <a:prstGeom prst="roundRect">
             <a:avLst>
@@ -3950,13 +4282,13 @@
       </p:sp>
       <p:sp>
         <p:nvSpPr>
-          <p:cNvPr id="11" name="Shape 7"/>
-          <p:cNvSpPr/>
-          <p:nvPr/>
-        </p:nvSpPr>
-        <p:spPr>
-          <a:xfrm>
-            <a:off x="4229100" y="1691640"/>
+          <p:cNvPr id="12" name="Shape 8"/>
+          <p:cNvSpPr/>
+          <p:nvPr/>
+        </p:nvSpPr>
+        <p:spPr>
+          <a:xfrm>
+            <a:off x="4229100" y="1783080"/>
             <a:ext cx="640080" cy="640080"/>
           </a:xfrm>
           <a:prstGeom prst="ellipse">
@@ -3970,7 +4302,7 @@
       </p:sp>
       <p:pic>
         <p:nvPicPr>
-          <p:cNvPr id="12" name="Image 2" descr="preencoded.png">    </p:cNvPr>
+          <p:cNvPr id="13" name="Image 2" descr="preencoded.png">    </p:cNvPr>
           <p:cNvPicPr>
             <a:picLocks noChangeAspect="1"/>
           </p:cNvPicPr>
@@ -3984,7 +4316,7 @@
         </p:blipFill>
         <p:spPr>
           <a:xfrm>
-            <a:off x="4384548" y="1847088"/>
+            <a:off x="4384548" y="1938528"/>
             <a:ext cx="329184" cy="329184"/>
           </a:xfrm>
           <a:prstGeom prst="rect">
@@ -3994,13 +4326,13 @@
       </p:pic>
       <p:sp>
         <p:nvSpPr>
-          <p:cNvPr id="13" name="Text 8"/>
-          <p:cNvSpPr/>
-          <p:nvPr/>
-        </p:nvSpPr>
-        <p:spPr>
-          <a:xfrm>
-            <a:off x="3429000" y="1508760"/>
+          <p:cNvPr id="14" name="Text 9"/>
+          <p:cNvSpPr/>
+          <p:nvPr/>
+        </p:nvSpPr>
+        <p:spPr>
+          <a:xfrm>
+            <a:off x="3429000" y="1600200"/>
             <a:ext cx="365760" cy="365760"/>
           </a:xfrm>
           <a:prstGeom prst="rect">
@@ -4033,13 +4365,13 @@
       </p:sp>
       <p:sp>
         <p:nvSpPr>
-          <p:cNvPr id="14" name="Text 9"/>
-          <p:cNvSpPr/>
-          <p:nvPr/>
-        </p:nvSpPr>
-        <p:spPr>
-          <a:xfrm>
-            <a:off x="3474720" y="2514600"/>
+          <p:cNvPr id="15" name="Text 10"/>
+          <p:cNvSpPr/>
+          <p:nvPr/>
+        </p:nvSpPr>
+        <p:spPr>
+          <a:xfrm>
+            <a:off x="3474720" y="2606040"/>
             <a:ext cx="2148840" cy="685800"/>
           </a:xfrm>
           <a:prstGeom prst="rect">
@@ -4064,7 +4396,7 @@
                 <a:ea typeface="Cambria" pitchFamily="34" charset="-122"/>
                 <a:cs typeface="Cambria" pitchFamily="34" charset="-120"/>
               </a:rPr>
-              <a:t>Page fetches payload</a:t>
+              <a:t>You tap "Continue"</a:t>
             </a:r>
             <a:endParaRPr lang="en-US" sz="1500" dirty="0"/>
           </a:p>
@@ -4072,14 +4404,14 @@
       </p:sp>
       <p:sp>
         <p:nvSpPr>
-          <p:cNvPr id="15" name="Text 10"/>
-          <p:cNvSpPr/>
-          <p:nvPr/>
-        </p:nvSpPr>
-        <p:spPr>
-          <a:xfrm>
-            <a:off x="3520440" y="3246120"/>
-            <a:ext cx="2057400" cy="2103120"/>
+          <p:cNvPr id="16" name="Text 11"/>
+          <p:cNvSpPr/>
+          <p:nvPr/>
+        </p:nvSpPr>
+        <p:spPr>
+          <a:xfrm>
+            <a:off x="3520440" y="3337560"/>
+            <a:ext cx="2057400" cy="2011680"/>
           </a:xfrm>
           <a:prstGeom prst="rect">
             <a:avLst/>
@@ -4106,7 +4438,7 @@
                 <a:ea typeface="Calibri" pitchFamily="34" charset="-122"/>
                 <a:cs typeface="Calibri" pitchFamily="34" charset="-120"/>
               </a:rPr>
-              <a:t>JS calls GET /api/payload/:token and GET /api/banks, renders merchant + 3 bank buttons.</a:t>
+              <a:t>A real tap, not an automatic redirect — browsers block silent app-switching for security.</a:t>
             </a:r>
             <a:endParaRPr lang="en-US" sz="1150" dirty="0"/>
           </a:p>
@@ -4114,7 +4446,7 @@
       </p:sp>
       <p:pic>
         <p:nvPicPr>
-          <p:cNvPr id="16" name="Image 3" descr="preencoded.png">    </p:cNvPr>
+          <p:cNvPr id="17" name="Image 3" descr="preencoded.png">    </p:cNvPr>
           <p:cNvPicPr>
             <a:picLocks noChangeAspect="1"/>
           </p:cNvPicPr>
@@ -4128,7 +4460,7 @@
         </p:blipFill>
         <p:spPr>
           <a:xfrm>
-            <a:off x="5824728" y="3364992"/>
+            <a:off x="5824728" y="3410712"/>
             <a:ext cx="219456" cy="219456"/>
           </a:xfrm>
           <a:prstGeom prst="rect">
@@ -4138,14 +4470,14 @@
       </p:pic>
       <p:sp>
         <p:nvSpPr>
-          <p:cNvPr id="17" name="Shape 11"/>
-          <p:cNvSpPr/>
-          <p:nvPr/>
-        </p:nvSpPr>
-        <p:spPr>
-          <a:xfrm>
-            <a:off x="6035040" y="1371600"/>
-            <a:ext cx="2514600" cy="4206240"/>
+          <p:cNvPr id="18" name="Shape 12"/>
+          <p:cNvSpPr/>
+          <p:nvPr/>
+        </p:nvSpPr>
+        <p:spPr>
+          <a:xfrm>
+            <a:off x="6035040" y="1463040"/>
+            <a:ext cx="2514600" cy="4114800"/>
           </a:xfrm>
           <a:prstGeom prst="roundRect">
             <a:avLst>
@@ -4167,13 +4499,13 @@
       </p:sp>
       <p:sp>
         <p:nvSpPr>
-          <p:cNvPr id="18" name="Shape 12"/>
-          <p:cNvSpPr/>
-          <p:nvPr/>
-        </p:nvSpPr>
-        <p:spPr>
-          <a:xfrm>
-            <a:off x="6972300" y="1691640"/>
+          <p:cNvPr id="19" name="Shape 13"/>
+          <p:cNvSpPr/>
+          <p:nvPr/>
+        </p:nvSpPr>
+        <p:spPr>
+          <a:xfrm>
+            <a:off x="6972300" y="1783080"/>
             <a:ext cx="640080" cy="640080"/>
           </a:xfrm>
           <a:prstGeom prst="ellipse">
@@ -4187,7 +4519,7 @@
       </p:sp>
       <p:pic>
         <p:nvPicPr>
-          <p:cNvPr id="19" name="Image 4" descr="preencoded.png">    </p:cNvPr>
+          <p:cNvPr id="20" name="Image 4" descr="preencoded.png">    </p:cNvPr>
           <p:cNvPicPr>
             <a:picLocks noChangeAspect="1"/>
           </p:cNvPicPr>
@@ -4201,7 +4533,7 @@
         </p:blipFill>
         <p:spPr>
           <a:xfrm>
-            <a:off x="7127748" y="1847088"/>
+            <a:off x="7127748" y="1938528"/>
             <a:ext cx="329184" cy="329184"/>
           </a:xfrm>
           <a:prstGeom prst="rect">
@@ -4211,13 +4543,13 @@
       </p:pic>
       <p:sp>
         <p:nvSpPr>
-          <p:cNvPr id="20" name="Text 13"/>
-          <p:cNvSpPr/>
-          <p:nvPr/>
-        </p:nvSpPr>
-        <p:spPr>
-          <a:xfrm>
-            <a:off x="6172200" y="1508760"/>
+          <p:cNvPr id="21" name="Text 14"/>
+          <p:cNvSpPr/>
+          <p:nvPr/>
+        </p:nvSpPr>
+        <p:spPr>
+          <a:xfrm>
+            <a:off x="6172200" y="1600200"/>
             <a:ext cx="365760" cy="365760"/>
           </a:xfrm>
           <a:prstGeom prst="rect">
@@ -4250,13 +4582,13 @@
       </p:sp>
       <p:sp>
         <p:nvSpPr>
-          <p:cNvPr id="21" name="Text 14"/>
-          <p:cNvSpPr/>
-          <p:nvPr/>
-        </p:nvSpPr>
-        <p:spPr>
-          <a:xfrm>
-            <a:off x="6217920" y="2514600"/>
+          <p:cNvPr id="22" name="Text 15"/>
+          <p:cNvSpPr/>
+          <p:nvPr/>
+        </p:nvSpPr>
+        <p:spPr>
+          <a:xfrm>
+            <a:off x="6217920" y="2606040"/>
             <a:ext cx="2148840" cy="685800"/>
           </a:xfrm>
           <a:prstGeom prst="rect">
@@ -4281,7 +4613,7 @@
                 <a:ea typeface="Cambria" pitchFamily="34" charset="-122"/>
                 <a:cs typeface="Cambria" pitchFamily="34" charset="-120"/>
               </a:rPr>
-              <a:t>Tap a bank button</a:t>
+              <a:t>The tap opens a special link</a:t>
             </a:r>
             <a:endParaRPr lang="en-US" sz="1500" dirty="0"/>
           </a:p>
@@ -4289,14 +4621,14 @@
       </p:sp>
       <p:sp>
         <p:nvSpPr>
-          <p:cNvPr id="22" name="Text 15"/>
-          <p:cNvSpPr/>
-          <p:nvPr/>
-        </p:nvSpPr>
-        <p:spPr>
-          <a:xfrm>
-            <a:off x="6263640" y="3246120"/>
-            <a:ext cx="2057400" cy="2103120"/>
+          <p:cNvPr id="23" name="Text 16"/>
+          <p:cNvSpPr/>
+          <p:nvPr/>
+        </p:nvSpPr>
+        <p:spPr>
+          <a:xfrm>
+            <a:off x="6263640" y="3337560"/>
+            <a:ext cx="2057400" cy="2011680"/>
           </a:xfrm>
           <a:prstGeom prst="rect">
             <a:avLst/>
@@ -4323,7 +4655,7 @@
                 <a:ea typeface="Calibri" pitchFamily="34" charset="-122"/>
                 <a:cs typeface="Calibri" pitchFamily="34" charset="-120"/>
               </a:rPr>
-              <a:t>onclick sets window.location.href to bankademo://pay?token=... — a custom URL scheme.</a:t>
+              <a:t>A link starting with intent:// instead of https:// — only apps can open this, not browsers.</a:t>
             </a:r>
             <a:endParaRPr lang="en-US" sz="1150" dirty="0"/>
           </a:p>
@@ -4331,7 +4663,7 @@
       </p:sp>
       <p:pic>
         <p:nvPicPr>
-          <p:cNvPr id="23" name="Image 5" descr="preencoded.png">    </p:cNvPr>
+          <p:cNvPr id="24" name="Image 5" descr="preencoded.png">    </p:cNvPr>
           <p:cNvPicPr>
             <a:picLocks noChangeAspect="1"/>
           </p:cNvPicPr>
@@ -4345,7 +4677,7 @@
         </p:blipFill>
         <p:spPr>
           <a:xfrm>
-            <a:off x="8567928" y="3364992"/>
+            <a:off x="8567928" y="3410712"/>
             <a:ext cx="219456" cy="219456"/>
           </a:xfrm>
           <a:prstGeom prst="rect">
@@ -4355,14 +4687,14 @@
       </p:pic>
       <p:sp>
         <p:nvSpPr>
-          <p:cNvPr id="24" name="Shape 16"/>
-          <p:cNvSpPr/>
-          <p:nvPr/>
-        </p:nvSpPr>
-        <p:spPr>
-          <a:xfrm>
-            <a:off x="8778240" y="1371600"/>
-            <a:ext cx="2514600" cy="4206240"/>
+          <p:cNvPr id="25" name="Shape 17"/>
+          <p:cNvSpPr/>
+          <p:nvPr/>
+        </p:nvSpPr>
+        <p:spPr>
+          <a:xfrm>
+            <a:off x="8778240" y="1463040"/>
+            <a:ext cx="2514600" cy="4114800"/>
           </a:xfrm>
           <a:prstGeom prst="roundRect">
             <a:avLst>
@@ -4384,13 +4716,13 @@
       </p:sp>
       <p:sp>
         <p:nvSpPr>
-          <p:cNvPr id="25" name="Shape 17"/>
-          <p:cNvSpPr/>
-          <p:nvPr/>
-        </p:nvSpPr>
-        <p:spPr>
-          <a:xfrm>
-            <a:off x="9715500" y="1691640"/>
+          <p:cNvPr id="26" name="Shape 18"/>
+          <p:cNvSpPr/>
+          <p:nvPr/>
+        </p:nvSpPr>
+        <p:spPr>
+          <a:xfrm>
+            <a:off x="9715500" y="1783080"/>
             <a:ext cx="640080" cy="640080"/>
           </a:xfrm>
           <a:prstGeom prst="ellipse">
@@ -4404,7 +4736,7 @@
       </p:sp>
       <p:pic>
         <p:nvPicPr>
-          <p:cNvPr id="26" name="Image 6" descr="preencoded.png">    </p:cNvPr>
+          <p:cNvPr id="27" name="Image 6" descr="preencoded.png">    </p:cNvPr>
           <p:cNvPicPr>
             <a:picLocks noChangeAspect="1"/>
           </p:cNvPicPr>
@@ -4418,7 +4750,7 @@
         </p:blipFill>
         <p:spPr>
           <a:xfrm>
-            <a:off x="9870948" y="1847088"/>
+            <a:off x="9870948" y="1938528"/>
             <a:ext cx="329184" cy="329184"/>
           </a:xfrm>
           <a:prstGeom prst="rect">
@@ -4428,13 +4760,13 @@
       </p:pic>
       <p:sp>
         <p:nvSpPr>
-          <p:cNvPr id="27" name="Text 18"/>
-          <p:cNvSpPr/>
-          <p:nvPr/>
-        </p:nvSpPr>
-        <p:spPr>
-          <a:xfrm>
-            <a:off x="8915400" y="1508760"/>
+          <p:cNvPr id="28" name="Text 19"/>
+          <p:cNvSpPr/>
+          <p:nvPr/>
+        </p:nvSpPr>
+        <p:spPr>
+          <a:xfrm>
+            <a:off x="8915400" y="1600200"/>
             <a:ext cx="365760" cy="365760"/>
           </a:xfrm>
           <a:prstGeom prst="rect">
@@ -4467,13 +4799,13 @@
       </p:sp>
       <p:sp>
         <p:nvSpPr>
-          <p:cNvPr id="28" name="Text 19"/>
-          <p:cNvSpPr/>
-          <p:nvPr/>
-        </p:nvSpPr>
-        <p:spPr>
-          <a:xfrm>
-            <a:off x="8961120" y="2514600"/>
+          <p:cNvPr id="29" name="Text 20"/>
+          <p:cNvSpPr/>
+          <p:nvPr/>
+        </p:nvSpPr>
+        <p:spPr>
+          <a:xfrm>
+            <a:off x="8961120" y="2606040"/>
             <a:ext cx="2148840" cy="685800"/>
           </a:xfrm>
           <a:prstGeom prst="rect">
@@ -4498,7 +4830,7 @@
                 <a:ea typeface="Cambria" pitchFamily="34" charset="-122"/>
                 <a:cs typeface="Cambria" pitchFamily="34" charset="-120"/>
               </a:rPr>
-              <a:t>iOS hands off to app</a:t>
+              <a:t>Android shows the chooser</a:t>
             </a:r>
             <a:endParaRPr lang="en-US" sz="1500" dirty="0"/>
           </a:p>
@@ -4506,14 +4838,14 @@
       </p:sp>
       <p:sp>
         <p:nvSpPr>
-          <p:cNvPr id="29" name="Text 20"/>
-          <p:cNvSpPr/>
-          <p:nvPr/>
-        </p:nvSpPr>
-        <p:spPr>
-          <a:xfrm>
-            <a:off x="9006840" y="3246120"/>
-            <a:ext cx="2057400" cy="2103120"/>
+          <p:cNvPr id="30" name="Text 21"/>
+          <p:cNvSpPr/>
+          <p:nvPr/>
+        </p:nvSpPr>
+        <p:spPr>
+          <a:xfrm>
+            <a:off x="9006840" y="3337560"/>
+            <a:ext cx="2057400" cy="2011680"/>
           </a:xfrm>
           <a:prstGeom prst="rect">
             <a:avLst/>
@@ -4540,9 +4872,75 @@
                 <a:ea typeface="Calibri" pitchFamily="34" charset="-122"/>
                 <a:cs typeface="Calibri" pitchFamily="34" charset="-120"/>
               </a:rPr>
-              <a:t>The scheme is registered in that app's Info.plist → system confirms → app opens directly to Confirm screen.</a:t>
+              <a:t>3 bank apps can all open that link, so Android asks: which one?</a:t>
             </a:r>
             <a:endParaRPr lang="en-US" sz="1150" dirty="0"/>
+          </a:p>
+        </p:txBody>
+      </p:sp>
+      <p:sp>
+        <p:nvSpPr>
+          <p:cNvPr id="31" name="Shape 22"/>
+          <p:cNvSpPr/>
+          <p:nvPr/>
+        </p:nvSpPr>
+        <p:spPr>
+          <a:xfrm>
+            <a:off x="548640" y="5715000"/>
+            <a:ext cx="11091672" cy="777240"/>
+          </a:xfrm>
+          <a:prstGeom prst="roundRect">
+            <a:avLst>
+              <a:gd name="adj" fmla="val 9412"/>
+            </a:avLst>
+          </a:prstGeom>
+          <a:solidFill>
+            <a:srgbClr val="F96167">
+              <a:alpha val="85000"/>
+            </a:srgbClr>
+          </a:solidFill>
+          <a:ln/>
+        </p:spPr>
+      </p:sp>
+      <p:sp>
+        <p:nvSpPr>
+          <p:cNvPr id="32" name="Text 23"/>
+          <p:cNvSpPr/>
+          <p:nvPr/>
+        </p:nvSpPr>
+        <p:spPr>
+          <a:xfrm>
+            <a:off x="822960" y="5715000"/>
+            <a:ext cx="10543032" cy="777240"/>
+          </a:xfrm>
+          <a:prstGeom prst="rect">
+            <a:avLst/>
+          </a:prstGeom>
+          <a:noFill/>
+          <a:ln/>
+        </p:spPr>
+        <p:txBody>
+          <a:bodyPr wrap="square" lIns="0" tIns="0" rIns="0" bIns="0" rtlCol="0" anchor="ctr"/>
+          <a:lstStyle/>
+          <a:p>
+            <a:pPr indent="0" marL="0">
+              <a:lnSpc>
+                <a:spcPct val="120000"/>
+              </a:lnSpc>
+              <a:buNone/>
+            </a:pPr>
+            <a:r>
+              <a:rPr lang="en-US" sz="1200" dirty="0">
+                <a:solidFill>
+                  <a:srgbClr val="6B2A1E"/>
+                </a:solidFill>
+                <a:latin typeface="Calibri" pitchFamily="34" charset="0"/>
+                <a:ea typeface="Calibri" pitchFamily="34" charset="-122"/>
+                <a:cs typeface="Calibri" pitchFamily="34" charset="-120"/>
+              </a:rPr>
+              <a:t>Why intent:// and not https:// again? Chrome won't hand a link back to a browser (even itself) through this mechanism — it has to be a link only apps can claim.</a:t>
+            </a:r>
+            <a:endParaRPr lang="en-US" sz="1200" dirty="0"/>
           </a:p>
         </p:txBody>
       </p:sp>
@@ -4557,6 +4955,921 @@
 <file path=ppt/slides/slide5.xml><?xml version="1.0" encoding="utf-8"?>
 <p:sld xmlns:a="http://schemas.openxmlformats.org/drawingml/2006/main" xmlns:r="http://schemas.openxmlformats.org/officeDocument/2006/relationships" xmlns:p="http://schemas.openxmlformats.org/presentationml/2006/main">
   <p:cSld name="Slide 5">
+    <p:bg>
+      <p:bgPr>
+        <a:solidFill>
+          <a:srgbClr val="F5F8FA"/>
+        </a:solidFill>
+      </p:bgPr>
+    </p:bg>
+    <p:spTree>
+      <p:nvGrpSpPr>
+        <p:cNvPr id="1" name=""/>
+        <p:cNvGrpSpPr/>
+        <p:nvPr/>
+      </p:nvGrpSpPr>
+      <p:grpSpPr>
+        <a:xfrm>
+          <a:off x="0" y="0"/>
+          <a:ext cx="0" cy="0"/>
+          <a:chOff x="0" y="0"/>
+          <a:chExt cx="0" cy="0"/>
+        </a:xfrm>
+      </p:grpSpPr>
+      <p:sp>
+        <p:nvSpPr>
+          <p:cNvPr id="2" name="Text 0"/>
+          <p:cNvSpPr/>
+          <p:nvPr/>
+        </p:nvSpPr>
+        <p:spPr>
+          <a:xfrm>
+            <a:off x="548640" y="411480"/>
+            <a:ext cx="10515600" cy="548640"/>
+          </a:xfrm>
+          <a:prstGeom prst="rect">
+            <a:avLst/>
+          </a:prstGeom>
+          <a:noFill/>
+          <a:ln/>
+        </p:spPr>
+        <p:txBody>
+          <a:bodyPr wrap="square" lIns="0" tIns="0" rIns="0" bIns="0" rtlCol="0" anchor="ctr"/>
+          <a:lstStyle/>
+          <a:p>
+            <a:pPr indent="0" marL="0">
+              <a:buNone/>
+            </a:pPr>
+            <a:r>
+              <a:rPr lang="en-US" sz="2800" b="1" dirty="0">
+                <a:solidFill>
+                  <a:srgbClr val="1A2233"/>
+                </a:solidFill>
+                <a:latin typeface="Cambria" pitchFamily="34" charset="0"/>
+                <a:ea typeface="Cambria" pitchFamily="34" charset="-122"/>
+                <a:cs typeface="Cambria" pitchFamily="34" charset="-120"/>
+              </a:rPr>
+              <a:t>iOS: Safari hands off to the app you pick</a:t>
+            </a:r>
+            <a:endParaRPr lang="en-US" sz="2800" dirty="0"/>
+          </a:p>
+        </p:txBody>
+      </p:sp>
+      <p:sp>
+        <p:nvSpPr>
+          <p:cNvPr id="3" name="Shape 1"/>
+          <p:cNvSpPr/>
+          <p:nvPr/>
+        </p:nvSpPr>
+        <p:spPr>
+          <a:xfrm>
+            <a:off x="548640" y="1371600"/>
+            <a:ext cx="2514600" cy="4206240"/>
+          </a:xfrm>
+          <a:prstGeom prst="roundRect">
+            <a:avLst>
+              <a:gd name="adj" fmla="val 2909"/>
+            </a:avLst>
+          </a:prstGeom>
+          <a:solidFill>
+            <a:srgbClr val="FFFFFF"/>
+          </a:solidFill>
+          <a:ln/>
+          <a:effectLst>
+            <a:outerShdw sx="100000" sy="100000" kx="0" ky="0" algn="bl" rotWithShape="0" blurRad="101600" dist="38100" dir="2700000">
+              <a:srgbClr val="000000">
+                <a:alpha val="12000"/>
+              </a:srgbClr>
+            </a:outerShdw>
+          </a:effectLst>
+        </p:spPr>
+      </p:sp>
+      <p:sp>
+        <p:nvSpPr>
+          <p:cNvPr id="4" name="Shape 2"/>
+          <p:cNvSpPr/>
+          <p:nvPr/>
+        </p:nvSpPr>
+        <p:spPr>
+          <a:xfrm>
+            <a:off x="1485900" y="1691640"/>
+            <a:ext cx="640080" cy="640080"/>
+          </a:xfrm>
+          <a:prstGeom prst="ellipse">
+            <a:avLst/>
+          </a:prstGeom>
+          <a:solidFill>
+            <a:srgbClr val="065A82"/>
+          </a:solidFill>
+          <a:ln/>
+        </p:spPr>
+      </p:sp>
+      <p:pic>
+        <p:nvPicPr>
+          <p:cNvPr id="5" name="Image 0" descr="preencoded.png">    </p:cNvPr>
+          <p:cNvPicPr>
+            <a:picLocks noChangeAspect="1"/>
+          </p:cNvPicPr>
+          <p:nvPr/>
+        </p:nvPicPr>
+        <p:blipFill>
+          <a:blip r:embed="rId1"/>
+          <a:stretch>
+            <a:fillRect/>
+          </a:stretch>
+        </p:blipFill>
+        <p:spPr>
+          <a:xfrm>
+            <a:off x="1641348" y="1847088"/>
+            <a:ext cx="329184" cy="329184"/>
+          </a:xfrm>
+          <a:prstGeom prst="rect">
+            <a:avLst/>
+          </a:prstGeom>
+        </p:spPr>
+      </p:pic>
+      <p:sp>
+        <p:nvSpPr>
+          <p:cNvPr id="6" name="Text 3"/>
+          <p:cNvSpPr/>
+          <p:nvPr/>
+        </p:nvSpPr>
+        <p:spPr>
+          <a:xfrm>
+            <a:off x="685800" y="1508760"/>
+            <a:ext cx="365760" cy="365760"/>
+          </a:xfrm>
+          <a:prstGeom prst="rect">
+            <a:avLst/>
+          </a:prstGeom>
+          <a:noFill/>
+          <a:ln/>
+        </p:spPr>
+        <p:txBody>
+          <a:bodyPr wrap="square" lIns="0" tIns="0" rIns="0" bIns="0" rtlCol="0" anchor="ctr"/>
+          <a:lstStyle/>
+          <a:p>
+            <a:pPr indent="0" marL="0">
+              <a:buNone/>
+            </a:pPr>
+            <a:r>
+              <a:rPr lang="en-US" sz="1300" b="1" dirty="0">
+                <a:solidFill>
+                  <a:srgbClr val="5B6B79"/>
+                </a:solidFill>
+                <a:latin typeface="Calibri" pitchFamily="34" charset="0"/>
+                <a:ea typeface="Calibri" pitchFamily="34" charset="-122"/>
+                <a:cs typeface="Calibri" pitchFamily="34" charset="-120"/>
+              </a:rPr>
+              <a:t>1</a:t>
+            </a:r>
+            <a:endParaRPr lang="en-US" sz="1300" dirty="0"/>
+          </a:p>
+        </p:txBody>
+      </p:sp>
+      <p:sp>
+        <p:nvSpPr>
+          <p:cNvPr id="7" name="Text 4"/>
+          <p:cNvSpPr/>
+          <p:nvPr/>
+        </p:nvSpPr>
+        <p:spPr>
+          <a:xfrm>
+            <a:off x="731520" y="2514600"/>
+            <a:ext cx="2148840" cy="685800"/>
+          </a:xfrm>
+          <a:prstGeom prst="rect">
+            <a:avLst/>
+          </a:prstGeom>
+          <a:noFill/>
+          <a:ln/>
+        </p:spPr>
+        <p:txBody>
+          <a:bodyPr wrap="square" lIns="0" tIns="0" rIns="0" bIns="0" rtlCol="0" anchor="ctr"/>
+          <a:lstStyle/>
+          <a:p>
+            <a:pPr algn="ctr" indent="0" marL="0">
+              <a:buNone/>
+            </a:pPr>
+            <a:r>
+              <a:rPr lang="en-US" sz="1500" b="1" dirty="0">
+                <a:solidFill>
+                  <a:srgbClr val="1A2233"/>
+                </a:solidFill>
+                <a:latin typeface="Cambria" pitchFamily="34" charset="0"/>
+                <a:ea typeface="Cambria" pitchFamily="34" charset="-122"/>
+                <a:cs typeface="Cambria" pitchFamily="34" charset="-120"/>
+              </a:rPr>
+              <a:t>Safari opens the picker page</a:t>
+            </a:r>
+            <a:endParaRPr lang="en-US" sz="1500" dirty="0"/>
+          </a:p>
+        </p:txBody>
+      </p:sp>
+      <p:sp>
+        <p:nvSpPr>
+          <p:cNvPr id="8" name="Text 5"/>
+          <p:cNvSpPr/>
+          <p:nvPr/>
+        </p:nvSpPr>
+        <p:spPr>
+          <a:xfrm>
+            <a:off x="777240" y="3246120"/>
+            <a:ext cx="2057400" cy="2103120"/>
+          </a:xfrm>
+          <a:prstGeom prst="rect">
+            <a:avLst/>
+          </a:prstGeom>
+          <a:noFill/>
+          <a:ln/>
+        </p:spPr>
+        <p:txBody>
+          <a:bodyPr wrap="square" lIns="0" tIns="0" rIns="0" bIns="0" rtlCol="0" anchor="ctr"/>
+          <a:lstStyle/>
+          <a:p>
+            <a:pPr algn="ctr" indent="0" marL="0">
+              <a:lnSpc>
+                <a:spcPct val="120000"/>
+              </a:lnSpc>
+              <a:buNone/>
+            </a:pPr>
+            <a:r>
+              <a:rPr lang="en-US" sz="1150" dirty="0">
+                <a:solidFill>
+                  <a:srgbClr val="5B6B79"/>
+                </a:solidFill>
+                <a:latin typeface="Calibri" pitchFamily="34" charset="0"/>
+                <a:ea typeface="Calibri" pitchFamily="34" charset="-122"/>
+                <a:cs typeface="Calibri" pitchFamily="34" charset="-120"/>
+              </a:rPr>
+              <a:t>No app is registered for this link, so iOS treats it as an ordinary web address.</a:t>
+            </a:r>
+            <a:endParaRPr lang="en-US" sz="1150" dirty="0"/>
+          </a:p>
+        </p:txBody>
+      </p:sp>
+      <p:pic>
+        <p:nvPicPr>
+          <p:cNvPr id="9" name="Image 1" descr="preencoded.png">    </p:cNvPr>
+          <p:cNvPicPr>
+            <a:picLocks noChangeAspect="1"/>
+          </p:cNvPicPr>
+          <p:nvPr/>
+        </p:nvPicPr>
+        <p:blipFill>
+          <a:blip r:embed="rId2"/>
+          <a:stretch>
+            <a:fillRect/>
+          </a:stretch>
+        </p:blipFill>
+        <p:spPr>
+          <a:xfrm>
+            <a:off x="3081528" y="3364992"/>
+            <a:ext cx="219456" cy="219456"/>
+          </a:xfrm>
+          <a:prstGeom prst="rect">
+            <a:avLst/>
+          </a:prstGeom>
+        </p:spPr>
+      </p:pic>
+      <p:sp>
+        <p:nvSpPr>
+          <p:cNvPr id="10" name="Shape 6"/>
+          <p:cNvSpPr/>
+          <p:nvPr/>
+        </p:nvSpPr>
+        <p:spPr>
+          <a:xfrm>
+            <a:off x="3291840" y="1371600"/>
+            <a:ext cx="2514600" cy="4206240"/>
+          </a:xfrm>
+          <a:prstGeom prst="roundRect">
+            <a:avLst>
+              <a:gd name="adj" fmla="val 2909"/>
+            </a:avLst>
+          </a:prstGeom>
+          <a:solidFill>
+            <a:srgbClr val="FFFFFF"/>
+          </a:solidFill>
+          <a:ln/>
+          <a:effectLst>
+            <a:outerShdw sx="100000" sy="100000" kx="0" ky="0" algn="bl" rotWithShape="0" blurRad="101600" dist="38100" dir="2700000">
+              <a:srgbClr val="000000">
+                <a:alpha val="12000"/>
+              </a:srgbClr>
+            </a:outerShdw>
+          </a:effectLst>
+        </p:spPr>
+      </p:sp>
+      <p:sp>
+        <p:nvSpPr>
+          <p:cNvPr id="11" name="Shape 7"/>
+          <p:cNvSpPr/>
+          <p:nvPr/>
+        </p:nvSpPr>
+        <p:spPr>
+          <a:xfrm>
+            <a:off x="4229100" y="1691640"/>
+            <a:ext cx="640080" cy="640080"/>
+          </a:xfrm>
+          <a:prstGeom prst="ellipse">
+            <a:avLst/>
+          </a:prstGeom>
+          <a:solidFill>
+            <a:srgbClr val="065A82"/>
+          </a:solidFill>
+          <a:ln/>
+        </p:spPr>
+      </p:sp>
+      <p:pic>
+        <p:nvPicPr>
+          <p:cNvPr id="12" name="Image 2" descr="preencoded.png">    </p:cNvPr>
+          <p:cNvPicPr>
+            <a:picLocks noChangeAspect="1"/>
+          </p:cNvPicPr>
+          <p:nvPr/>
+        </p:nvPicPr>
+        <p:blipFill>
+          <a:blip r:embed="rId3"/>
+          <a:stretch>
+            <a:fillRect/>
+          </a:stretch>
+        </p:blipFill>
+        <p:spPr>
+          <a:xfrm>
+            <a:off x="4384548" y="1847088"/>
+            <a:ext cx="329184" cy="329184"/>
+          </a:xfrm>
+          <a:prstGeom prst="rect">
+            <a:avLst/>
+          </a:prstGeom>
+        </p:spPr>
+      </p:pic>
+      <p:sp>
+        <p:nvSpPr>
+          <p:cNvPr id="13" name="Text 8"/>
+          <p:cNvSpPr/>
+          <p:nvPr/>
+        </p:nvSpPr>
+        <p:spPr>
+          <a:xfrm>
+            <a:off x="3429000" y="1508760"/>
+            <a:ext cx="365760" cy="365760"/>
+          </a:xfrm>
+          <a:prstGeom prst="rect">
+            <a:avLst/>
+          </a:prstGeom>
+          <a:noFill/>
+          <a:ln/>
+        </p:spPr>
+        <p:txBody>
+          <a:bodyPr wrap="square" lIns="0" tIns="0" rIns="0" bIns="0" rtlCol="0" anchor="ctr"/>
+          <a:lstStyle/>
+          <a:p>
+            <a:pPr indent="0" marL="0">
+              <a:buNone/>
+            </a:pPr>
+            <a:r>
+              <a:rPr lang="en-US" sz="1300" b="1" dirty="0">
+                <a:solidFill>
+                  <a:srgbClr val="5B6B79"/>
+                </a:solidFill>
+                <a:latin typeface="Calibri" pitchFamily="34" charset="0"/>
+                <a:ea typeface="Calibri" pitchFamily="34" charset="-122"/>
+                <a:cs typeface="Calibri" pitchFamily="34" charset="-120"/>
+              </a:rPr>
+              <a:t>2</a:t>
+            </a:r>
+            <a:endParaRPr lang="en-US" sz="1300" dirty="0"/>
+          </a:p>
+        </p:txBody>
+      </p:sp>
+      <p:sp>
+        <p:nvSpPr>
+          <p:cNvPr id="14" name="Text 9"/>
+          <p:cNvSpPr/>
+          <p:nvPr/>
+        </p:nvSpPr>
+        <p:spPr>
+          <a:xfrm>
+            <a:off x="3474720" y="2514600"/>
+            <a:ext cx="2148840" cy="685800"/>
+          </a:xfrm>
+          <a:prstGeom prst="rect">
+            <a:avLst/>
+          </a:prstGeom>
+          <a:noFill/>
+          <a:ln/>
+        </p:spPr>
+        <p:txBody>
+          <a:bodyPr wrap="square" lIns="0" tIns="0" rIns="0" bIns="0" rtlCol="0" anchor="ctr"/>
+          <a:lstStyle/>
+          <a:p>
+            <a:pPr algn="ctr" indent="0" marL="0">
+              <a:buNone/>
+            </a:pPr>
+            <a:r>
+              <a:rPr lang="en-US" sz="1500" b="1" dirty="0">
+                <a:solidFill>
+                  <a:srgbClr val="1A2233"/>
+                </a:solidFill>
+                <a:latin typeface="Cambria" pitchFamily="34" charset="0"/>
+                <a:ea typeface="Cambria" pitchFamily="34" charset="-122"/>
+                <a:cs typeface="Cambria" pitchFamily="34" charset="-120"/>
+              </a:rPr>
+              <a:t>The page loads payment details</a:t>
+            </a:r>
+            <a:endParaRPr lang="en-US" sz="1500" dirty="0"/>
+          </a:p>
+        </p:txBody>
+      </p:sp>
+      <p:sp>
+        <p:nvSpPr>
+          <p:cNvPr id="15" name="Text 10"/>
+          <p:cNvSpPr/>
+          <p:nvPr/>
+        </p:nvSpPr>
+        <p:spPr>
+          <a:xfrm>
+            <a:off x="3520440" y="3246120"/>
+            <a:ext cx="2057400" cy="2103120"/>
+          </a:xfrm>
+          <a:prstGeom prst="rect">
+            <a:avLst/>
+          </a:prstGeom>
+          <a:noFill/>
+          <a:ln/>
+        </p:spPr>
+        <p:txBody>
+          <a:bodyPr wrap="square" lIns="0" tIns="0" rIns="0" bIns="0" rtlCol="0" anchor="ctr"/>
+          <a:lstStyle/>
+          <a:p>
+            <a:pPr algn="ctr" indent="0" marL="0">
+              <a:lnSpc>
+                <a:spcPct val="120000"/>
+              </a:lnSpc>
+              <a:buNone/>
+            </a:pPr>
+            <a:r>
+              <a:rPr lang="en-US" sz="1150" dirty="0">
+                <a:solidFill>
+                  <a:srgbClr val="5B6B79"/>
+                </a:solidFill>
+                <a:latin typeface="Calibri" pitchFamily="34" charset="0"/>
+                <a:ea typeface="Calibri" pitchFamily="34" charset="-122"/>
+                <a:cs typeface="Calibri" pitchFamily="34" charset="-120"/>
+              </a:rPr>
+              <a:t>It fetches the merchant name and amount, and shows 3 bank buttons.</a:t>
+            </a:r>
+            <a:endParaRPr lang="en-US" sz="1150" dirty="0"/>
+          </a:p>
+        </p:txBody>
+      </p:sp>
+      <p:pic>
+        <p:nvPicPr>
+          <p:cNvPr id="16" name="Image 3" descr="preencoded.png">    </p:cNvPr>
+          <p:cNvPicPr>
+            <a:picLocks noChangeAspect="1"/>
+          </p:cNvPicPr>
+          <p:nvPr/>
+        </p:nvPicPr>
+        <p:blipFill>
+          <a:blip r:embed="rId4"/>
+          <a:stretch>
+            <a:fillRect/>
+          </a:stretch>
+        </p:blipFill>
+        <p:spPr>
+          <a:xfrm>
+            <a:off x="5824728" y="3364992"/>
+            <a:ext cx="219456" cy="219456"/>
+          </a:xfrm>
+          <a:prstGeom prst="rect">
+            <a:avLst/>
+          </a:prstGeom>
+        </p:spPr>
+      </p:pic>
+      <p:sp>
+        <p:nvSpPr>
+          <p:cNvPr id="17" name="Shape 11"/>
+          <p:cNvSpPr/>
+          <p:nvPr/>
+        </p:nvSpPr>
+        <p:spPr>
+          <a:xfrm>
+            <a:off x="6035040" y="1371600"/>
+            <a:ext cx="2514600" cy="4206240"/>
+          </a:xfrm>
+          <a:prstGeom prst="roundRect">
+            <a:avLst>
+              <a:gd name="adj" fmla="val 2909"/>
+            </a:avLst>
+          </a:prstGeom>
+          <a:solidFill>
+            <a:srgbClr val="FFFFFF"/>
+          </a:solidFill>
+          <a:ln/>
+          <a:effectLst>
+            <a:outerShdw sx="100000" sy="100000" kx="0" ky="0" algn="bl" rotWithShape="0" blurRad="101600" dist="38100" dir="2700000">
+              <a:srgbClr val="000000">
+                <a:alpha val="12000"/>
+              </a:srgbClr>
+            </a:outerShdw>
+          </a:effectLst>
+        </p:spPr>
+      </p:sp>
+      <p:sp>
+        <p:nvSpPr>
+          <p:cNvPr id="18" name="Shape 12"/>
+          <p:cNvSpPr/>
+          <p:nvPr/>
+        </p:nvSpPr>
+        <p:spPr>
+          <a:xfrm>
+            <a:off x="6972300" y="1691640"/>
+            <a:ext cx="640080" cy="640080"/>
+          </a:xfrm>
+          <a:prstGeom prst="ellipse">
+            <a:avLst/>
+          </a:prstGeom>
+          <a:solidFill>
+            <a:srgbClr val="065A82"/>
+          </a:solidFill>
+          <a:ln/>
+        </p:spPr>
+      </p:sp>
+      <p:pic>
+        <p:nvPicPr>
+          <p:cNvPr id="19" name="Image 4" descr="preencoded.png">    </p:cNvPr>
+          <p:cNvPicPr>
+            <a:picLocks noChangeAspect="1"/>
+          </p:cNvPicPr>
+          <p:nvPr/>
+        </p:nvPicPr>
+        <p:blipFill>
+          <a:blip r:embed="rId5"/>
+          <a:stretch>
+            <a:fillRect/>
+          </a:stretch>
+        </p:blipFill>
+        <p:spPr>
+          <a:xfrm>
+            <a:off x="7127748" y="1847088"/>
+            <a:ext cx="329184" cy="329184"/>
+          </a:xfrm>
+          <a:prstGeom prst="rect">
+            <a:avLst/>
+          </a:prstGeom>
+        </p:spPr>
+      </p:pic>
+      <p:sp>
+        <p:nvSpPr>
+          <p:cNvPr id="20" name="Text 13"/>
+          <p:cNvSpPr/>
+          <p:nvPr/>
+        </p:nvSpPr>
+        <p:spPr>
+          <a:xfrm>
+            <a:off x="6172200" y="1508760"/>
+            <a:ext cx="365760" cy="365760"/>
+          </a:xfrm>
+          <a:prstGeom prst="rect">
+            <a:avLst/>
+          </a:prstGeom>
+          <a:noFill/>
+          <a:ln/>
+        </p:spPr>
+        <p:txBody>
+          <a:bodyPr wrap="square" lIns="0" tIns="0" rIns="0" bIns="0" rtlCol="0" anchor="ctr"/>
+          <a:lstStyle/>
+          <a:p>
+            <a:pPr indent="0" marL="0">
+              <a:buNone/>
+            </a:pPr>
+            <a:r>
+              <a:rPr lang="en-US" sz="1300" b="1" dirty="0">
+                <a:solidFill>
+                  <a:srgbClr val="5B6B79"/>
+                </a:solidFill>
+                <a:latin typeface="Calibri" pitchFamily="34" charset="0"/>
+                <a:ea typeface="Calibri" pitchFamily="34" charset="-122"/>
+                <a:cs typeface="Calibri" pitchFamily="34" charset="-120"/>
+              </a:rPr>
+              <a:t>3</a:t>
+            </a:r>
+            <a:endParaRPr lang="en-US" sz="1300" dirty="0"/>
+          </a:p>
+        </p:txBody>
+      </p:sp>
+      <p:sp>
+        <p:nvSpPr>
+          <p:cNvPr id="21" name="Text 14"/>
+          <p:cNvSpPr/>
+          <p:nvPr/>
+        </p:nvSpPr>
+        <p:spPr>
+          <a:xfrm>
+            <a:off x="6217920" y="2514600"/>
+            <a:ext cx="2148840" cy="685800"/>
+          </a:xfrm>
+          <a:prstGeom prst="rect">
+            <a:avLst/>
+          </a:prstGeom>
+          <a:noFill/>
+          <a:ln/>
+        </p:spPr>
+        <p:txBody>
+          <a:bodyPr wrap="square" lIns="0" tIns="0" rIns="0" bIns="0" rtlCol="0" anchor="ctr"/>
+          <a:lstStyle/>
+          <a:p>
+            <a:pPr algn="ctr" indent="0" marL="0">
+              <a:buNone/>
+            </a:pPr>
+            <a:r>
+              <a:rPr lang="en-US" sz="1500" b="1" dirty="0">
+                <a:solidFill>
+                  <a:srgbClr val="1A2233"/>
+                </a:solidFill>
+                <a:latin typeface="Cambria" pitchFamily="34" charset="0"/>
+                <a:ea typeface="Cambria" pitchFamily="34" charset="-122"/>
+                <a:cs typeface="Cambria" pitchFamily="34" charset="-120"/>
+              </a:rPr>
+              <a:t>You tap a bank</a:t>
+            </a:r>
+            <a:endParaRPr lang="en-US" sz="1500" dirty="0"/>
+          </a:p>
+        </p:txBody>
+      </p:sp>
+      <p:sp>
+        <p:nvSpPr>
+          <p:cNvPr id="22" name="Text 15"/>
+          <p:cNvSpPr/>
+          <p:nvPr/>
+        </p:nvSpPr>
+        <p:spPr>
+          <a:xfrm>
+            <a:off x="6263640" y="3246120"/>
+            <a:ext cx="2057400" cy="2103120"/>
+          </a:xfrm>
+          <a:prstGeom prst="rect">
+            <a:avLst/>
+          </a:prstGeom>
+          <a:noFill/>
+          <a:ln/>
+        </p:spPr>
+        <p:txBody>
+          <a:bodyPr wrap="square" lIns="0" tIns="0" rIns="0" bIns="0" rtlCol="0" anchor="ctr"/>
+          <a:lstStyle/>
+          <a:p>
+            <a:pPr algn="ctr" indent="0" marL="0">
+              <a:lnSpc>
+                <a:spcPct val="120000"/>
+              </a:lnSpc>
+              <a:buNone/>
+            </a:pPr>
+            <a:r>
+              <a:rPr lang="en-US" sz="1150" dirty="0">
+                <a:solidFill>
+                  <a:srgbClr val="5B6B79"/>
+                </a:solidFill>
+                <a:latin typeface="Calibri" pitchFamily="34" charset="0"/>
+                <a:ea typeface="Calibri" pitchFamily="34" charset="-122"/>
+                <a:cs typeface="Calibri" pitchFamily="34" charset="-120"/>
+              </a:rPr>
+              <a:t>The button opens a link like bankademo://pay — each bank app has its own.</a:t>
+            </a:r>
+            <a:endParaRPr lang="en-US" sz="1150" dirty="0"/>
+          </a:p>
+        </p:txBody>
+      </p:sp>
+      <p:pic>
+        <p:nvPicPr>
+          <p:cNvPr id="23" name="Image 5" descr="preencoded.png">    </p:cNvPr>
+          <p:cNvPicPr>
+            <a:picLocks noChangeAspect="1"/>
+          </p:cNvPicPr>
+          <p:nvPr/>
+        </p:nvPicPr>
+        <p:blipFill>
+          <a:blip r:embed="rId6"/>
+          <a:stretch>
+            <a:fillRect/>
+          </a:stretch>
+        </p:blipFill>
+        <p:spPr>
+          <a:xfrm>
+            <a:off x="8567928" y="3364992"/>
+            <a:ext cx="219456" cy="219456"/>
+          </a:xfrm>
+          <a:prstGeom prst="rect">
+            <a:avLst/>
+          </a:prstGeom>
+        </p:spPr>
+      </p:pic>
+      <p:sp>
+        <p:nvSpPr>
+          <p:cNvPr id="24" name="Shape 16"/>
+          <p:cNvSpPr/>
+          <p:nvPr/>
+        </p:nvSpPr>
+        <p:spPr>
+          <a:xfrm>
+            <a:off x="8778240" y="1371600"/>
+            <a:ext cx="2514600" cy="4206240"/>
+          </a:xfrm>
+          <a:prstGeom prst="roundRect">
+            <a:avLst>
+              <a:gd name="adj" fmla="val 2909"/>
+            </a:avLst>
+          </a:prstGeom>
+          <a:solidFill>
+            <a:srgbClr val="FFFFFF"/>
+          </a:solidFill>
+          <a:ln/>
+          <a:effectLst>
+            <a:outerShdw sx="100000" sy="100000" kx="0" ky="0" algn="bl" rotWithShape="0" blurRad="101600" dist="38100" dir="2700000">
+              <a:srgbClr val="000000">
+                <a:alpha val="12000"/>
+              </a:srgbClr>
+            </a:outerShdw>
+          </a:effectLst>
+        </p:spPr>
+      </p:sp>
+      <p:sp>
+        <p:nvSpPr>
+          <p:cNvPr id="25" name="Shape 17"/>
+          <p:cNvSpPr/>
+          <p:nvPr/>
+        </p:nvSpPr>
+        <p:spPr>
+          <a:xfrm>
+            <a:off x="9715500" y="1691640"/>
+            <a:ext cx="640080" cy="640080"/>
+          </a:xfrm>
+          <a:prstGeom prst="ellipse">
+            <a:avLst/>
+          </a:prstGeom>
+          <a:solidFill>
+            <a:srgbClr val="1C7293"/>
+          </a:solidFill>
+          <a:ln/>
+        </p:spPr>
+      </p:sp>
+      <p:pic>
+        <p:nvPicPr>
+          <p:cNvPr id="26" name="Image 6" descr="preencoded.png">    </p:cNvPr>
+          <p:cNvPicPr>
+            <a:picLocks noChangeAspect="1"/>
+          </p:cNvPicPr>
+          <p:nvPr/>
+        </p:nvPicPr>
+        <p:blipFill>
+          <a:blip r:embed="rId7"/>
+          <a:stretch>
+            <a:fillRect/>
+          </a:stretch>
+        </p:blipFill>
+        <p:spPr>
+          <a:xfrm>
+            <a:off x="9870948" y="1847088"/>
+            <a:ext cx="329184" cy="329184"/>
+          </a:xfrm>
+          <a:prstGeom prst="rect">
+            <a:avLst/>
+          </a:prstGeom>
+        </p:spPr>
+      </p:pic>
+      <p:sp>
+        <p:nvSpPr>
+          <p:cNvPr id="27" name="Text 18"/>
+          <p:cNvSpPr/>
+          <p:nvPr/>
+        </p:nvSpPr>
+        <p:spPr>
+          <a:xfrm>
+            <a:off x="8915400" y="1508760"/>
+            <a:ext cx="365760" cy="365760"/>
+          </a:xfrm>
+          <a:prstGeom prst="rect">
+            <a:avLst/>
+          </a:prstGeom>
+          <a:noFill/>
+          <a:ln/>
+        </p:spPr>
+        <p:txBody>
+          <a:bodyPr wrap="square" lIns="0" tIns="0" rIns="0" bIns="0" rtlCol="0" anchor="ctr"/>
+          <a:lstStyle/>
+          <a:p>
+            <a:pPr indent="0" marL="0">
+              <a:buNone/>
+            </a:pPr>
+            <a:r>
+              <a:rPr lang="en-US" sz="1300" b="1" dirty="0">
+                <a:solidFill>
+                  <a:srgbClr val="5B6B79"/>
+                </a:solidFill>
+                <a:latin typeface="Calibri" pitchFamily="34" charset="0"/>
+                <a:ea typeface="Calibri" pitchFamily="34" charset="-122"/>
+                <a:cs typeface="Calibri" pitchFamily="34" charset="-120"/>
+              </a:rPr>
+              <a:t>4</a:t>
+            </a:r>
+            <a:endParaRPr lang="en-US" sz="1300" dirty="0"/>
+          </a:p>
+        </p:txBody>
+      </p:sp>
+      <p:sp>
+        <p:nvSpPr>
+          <p:cNvPr id="28" name="Text 19"/>
+          <p:cNvSpPr/>
+          <p:nvPr/>
+        </p:nvSpPr>
+        <p:spPr>
+          <a:xfrm>
+            <a:off x="8961120" y="2514600"/>
+            <a:ext cx="2148840" cy="685800"/>
+          </a:xfrm>
+          <a:prstGeom prst="rect">
+            <a:avLst/>
+          </a:prstGeom>
+          <a:noFill/>
+          <a:ln/>
+        </p:spPr>
+        <p:txBody>
+          <a:bodyPr wrap="square" lIns="0" tIns="0" rIns="0" bIns="0" rtlCol="0" anchor="ctr"/>
+          <a:lstStyle/>
+          <a:p>
+            <a:pPr algn="ctr" indent="0" marL="0">
+              <a:buNone/>
+            </a:pPr>
+            <a:r>
+              <a:rPr lang="en-US" sz="1500" b="1" dirty="0">
+                <a:solidFill>
+                  <a:srgbClr val="1A2233"/>
+                </a:solidFill>
+                <a:latin typeface="Cambria" pitchFamily="34" charset="0"/>
+                <a:ea typeface="Cambria" pitchFamily="34" charset="-122"/>
+                <a:cs typeface="Cambria" pitchFamily="34" charset="-120"/>
+              </a:rPr>
+              <a:t>That bank app opens</a:t>
+            </a:r>
+            <a:endParaRPr lang="en-US" sz="1500" dirty="0"/>
+          </a:p>
+        </p:txBody>
+      </p:sp>
+      <p:sp>
+        <p:nvSpPr>
+          <p:cNvPr id="29" name="Text 20"/>
+          <p:cNvSpPr/>
+          <p:nvPr/>
+        </p:nvSpPr>
+        <p:spPr>
+          <a:xfrm>
+            <a:off x="9006840" y="3246120"/>
+            <a:ext cx="2057400" cy="2103120"/>
+          </a:xfrm>
+          <a:prstGeom prst="rect">
+            <a:avLst/>
+          </a:prstGeom>
+          <a:noFill/>
+          <a:ln/>
+        </p:spPr>
+        <p:txBody>
+          <a:bodyPr wrap="square" lIns="0" tIns="0" rIns="0" bIns="0" rtlCol="0" anchor="ctr"/>
+          <a:lstStyle/>
+          <a:p>
+            <a:pPr algn="ctr" indent="0" marL="0">
+              <a:lnSpc>
+                <a:spcPct val="120000"/>
+              </a:lnSpc>
+              <a:buNone/>
+            </a:pPr>
+            <a:r>
+              <a:rPr lang="en-US" sz="1150" dirty="0">
+                <a:solidFill>
+                  <a:srgbClr val="5B6B79"/>
+                </a:solidFill>
+                <a:latin typeface="Calibri" pitchFamily="34" charset="0"/>
+                <a:ea typeface="Calibri" pitchFamily="34" charset="-122"/>
+                <a:cs typeface="Calibri" pitchFamily="34" charset="-120"/>
+              </a:rPr>
+              <a:t>iOS recognizes the link belongs to that app and switches straight to it.</a:t>
+            </a:r>
+            <a:endParaRPr lang="en-US" sz="1150" dirty="0"/>
+          </a:p>
+        </p:txBody>
+      </p:sp>
+    </p:spTree>
+  </p:cSld>
+  <p:clrMapOvr>
+    <a:masterClrMapping/>
+  </p:clrMapOvr>
+</p:sld>
+</file>
+
+<file path=ppt/slides/slide6.xml><?xml version="1.0" encoding="utf-8"?>
+<p:sld xmlns:a="http://schemas.openxmlformats.org/drawingml/2006/main" xmlns:r="http://schemas.openxmlformats.org/officeDocument/2006/relationships" xmlns:p="http://schemas.openxmlformats.org/presentationml/2006/main">
+  <p:cSld name="Slide 6">
     <p:bg>
       <p:bgPr>
         <a:solidFill>
@@ -4611,7 +5924,7 @@
                 <a:ea typeface="Cambria" pitchFamily="34" charset="-122"/>
                 <a:cs typeface="Cambria" pitchFamily="34" charset="-120"/>
               </a:rPr>
-              <a:t>Inside each Flutter app: catching the link</a:t>
+              <a:t>Inside each app: catching the incoming link</a:t>
             </a:r>
             <a:endParaRPr lang="en-US" sz="2800" dirty="0"/>
           </a:p>
@@ -4650,7 +5963,7 @@
                 <a:ea typeface="Calibri" pitchFamily="34" charset="-122"/>
                 <a:cs typeface="Calibri" pitchFamily="34" charset="-120"/>
               </a:rPr>
-              <a:t>app_links package — two entry points, one dedupe guard</a:t>
+              <a:t>The app has to notice the link in two different situations</a:t>
             </a:r>
             <a:endParaRPr lang="en-US" sz="1400" dirty="0"/>
           </a:p>
@@ -4818,7 +6131,7 @@
                 <a:ea typeface="Cambria" pitchFamily="34" charset="-122"/>
                 <a:cs typeface="Cambria" pitchFamily="34" charset="-120"/>
               </a:rPr>
-              <a:t>getInitialLink()</a:t>
+              <a:t>Checked once, on startup</a:t>
             </a:r>
             <a:endParaRPr lang="en-US" sz="1600" dirty="0"/>
           </a:p>
@@ -4860,7 +6173,7 @@
                 <a:ea typeface="Calibri" pitchFamily="34" charset="-122"/>
                 <a:cs typeface="Calibri" pitchFamily="34" charset="-120"/>
               </a:rPr>
-              <a:t>Checked once at startup. Covers cold start — the app wasn't running and the link launched it directly.</a:t>
+              <a:t>The app wasn't running — the link is what launched it. Checked a single time when the app starts.</a:t>
             </a:r>
             <a:endParaRPr lang="en-US" sz="1200" dirty="0"/>
           </a:p>
@@ -4989,7 +6302,7 @@
                 <a:ea typeface="Calibri" pitchFamily="34" charset="-122"/>
                 <a:cs typeface="Calibri" pitchFamily="34" charset="-120"/>
               </a:rPr>
-              <a:t>WARM / OPEN</a:t>
+              <a:t>ALREADY OPEN</a:t>
             </a:r>
             <a:endParaRPr lang="en-US" sz="1050" dirty="0"/>
           </a:p>
@@ -5028,7 +6341,7 @@
                 <a:ea typeface="Cambria" pitchFamily="34" charset="-122"/>
                 <a:cs typeface="Cambria" pitchFamily="34" charset="-120"/>
               </a:rPr>
-              <a:t>uriLinkStream.listen(...)</a:t>
+              <a:t>Listened for, the whole time</a:t>
             </a:r>
             <a:endParaRPr lang="en-US" sz="1600" dirty="0"/>
           </a:p>
@@ -5070,7 +6383,7 @@
                 <a:ea typeface="Calibri" pitchFamily="34" charset="-122"/>
                 <a:cs typeface="Calibri" pitchFamily="34" charset="-120"/>
               </a:rPr>
-              <a:t>A live subscription. Fires while the app is backgrounded or already in the foreground when the link arrives.</a:t>
+              <a:t>The app was already open or in the background. A live subscription catches the link as it arrives.</a:t>
             </a:r>
             <a:endParaRPr lang="en-US" sz="1200" dirty="0"/>
           </a:p>
@@ -5157,7 +6470,7 @@
                 <a:ea typeface="Cambria" pitchFamily="34" charset="-122"/>
                 <a:cs typeface="Cambria" pitchFamily="34" charset="-120"/>
               </a:rPr>
-              <a:t>The bug both paths can trigger together</a:t>
+              <a:t>Bug: both paths can fire for the same link</a:t>
             </a:r>
             <a:endParaRPr lang="en-US" sz="1500" dirty="0"/>
           </a:p>
@@ -5199,7 +6512,7 @@
                 <a:ea typeface="Calibri" pitchFamily="34" charset="-122"/>
                 <a:cs typeface="Calibri" pitchFamily="34" charset="-120"/>
               </a:rPr>
-              <a:t>On cold start, uriLinkStream can re-emit the same URI that getInitialLink() already returned — without a guard this pushes the Confirm screen twice. Fixed by comparing every incoming URI against _lastHandledUri before acting.</a:t>
+              <a:t>On startup, both checks can report the same link — without a guard, the payment screen opened twice. Fixed by remembering the last link handled and ignoring repeats.</a:t>
             </a:r>
             <a:endParaRPr lang="en-US" sz="1200" dirty="0"/>
           </a:p>
@@ -5262,7 +6575,7 @@
                 <a:ea typeface="Cambria" pitchFamily="34" charset="-122"/>
                 <a:cs typeface="Cambria" pitchFamily="34" charset="-120"/>
               </a:rPr>
-              <a:t>Token extraction</a:t>
+              <a:t>Reading the token</a:t>
             </a:r>
             <a:endParaRPr lang="en-US" sz="1500" dirty="0"/>
           </a:p>
@@ -5307,7 +6620,7 @@
                 <a:ea typeface="Calibri" pitchFamily="34" charset="-122"/>
                 <a:cs typeface="Calibri" pitchFamily="34" charset="-120"/>
               </a:rPr>
-              <a:t>Custom scheme link</a:t>
+              <a:t>From a bank's own link:</a:t>
             </a:r>
             <a:endParaRPr lang="en-US" sz="1150" dirty="0"/>
           </a:p>
@@ -5353,7 +6666,7 @@
                 <a:ea typeface="Calibri" pitchFamily="34" charset="-122"/>
                 <a:cs typeface="Calibri" pitchFamily="34" charset="-120"/>
               </a:rPr>
-              <a:t>→ read from query params</a:t>
+              <a:t>→ token is right there in the link</a:t>
             </a:r>
             <a:endParaRPr lang="en-US" sz="1150" dirty="0"/>
           </a:p>
@@ -5399,7 +6712,7 @@
                 <a:ea typeface="Calibri" pitchFamily="34" charset="-122"/>
                 <a:cs typeface="Calibri" pitchFamily="34" charset="-120"/>
               </a:rPr>
-              <a:t>Universal-link-style</a:t>
+              <a:t>From the shared web link:</a:t>
             </a:r>
             <a:endParaRPr lang="en-US" sz="1150" dirty="0"/>
           </a:p>
@@ -5445,7 +6758,7 @@
                 <a:ea typeface="Calibri" pitchFamily="34" charset="-122"/>
                 <a:cs typeface="Calibri" pitchFamily="34" charset="-120"/>
               </a:rPr>
-              <a:t>→ read from last path segment</a:t>
+              <a:t>→ token is the last part of the address</a:t>
             </a:r>
             <a:endParaRPr lang="en-US" sz="1150" dirty="0"/>
           </a:p>
@@ -5459,9 +6772,9 @@
 </p:sld>
 </file>
 
-<file path=ppt/slides/slide6.xml><?xml version="1.0" encoding="utf-8"?>
+<file path=ppt/slides/slide7.xml><?xml version="1.0" encoding="utf-8"?>
 <p:sld xmlns:a="http://schemas.openxmlformats.org/drawingml/2006/main" xmlns:r="http://schemas.openxmlformats.org/officeDocument/2006/relationships" xmlns:p="http://schemas.openxmlformats.org/presentationml/2006/main">
-  <p:cSld name="Slide 6">
+  <p:cSld name="Slide 7">
     <p:bg>
       <p:bgPr>
         <a:solidFill>
@@ -5516,7 +6829,7 @@
                 <a:ea typeface="Cambria" pitchFamily="34" charset="-122"/>
                 <a:cs typeface="Cambria" pitchFamily="34" charset="-120"/>
               </a:rPr>
-              <a:t>Only one bank app can win the payment</a:t>
+              <a:t>Only one bank app can complete the payment</a:t>
             </a:r>
             <a:endParaRPr lang="en-US" sz="2800" dirty="0"/>
           </a:p>
@@ -5555,7 +6868,7 @@
                 <a:ea typeface="Calibri" pitchFamily="34" charset="-122"/>
                 <a:cs typeface="Calibri" pitchFamily="34" charset="-120"/>
               </a:rPr>
-              <a:t>POST /api/payload/:token/pay — atomic check-then-flip on the server</a:t>
+              <a:t>The server marks a payment "paid" the moment one bank confirms it</a:t>
             </a:r>
             <a:endParaRPr lang="en-US" sz="1400" dirty="0"/>
           </a:p>
@@ -5730,7 +7043,7 @@
                 <a:ea typeface="Calibri" pitchFamily="34" charset="-122"/>
                 <a:cs typeface="Calibri" pitchFamily="34" charset="-120"/>
               </a:rPr>
-              <a:t>APPROVE</a:t>
+              <a:t>APPROVED</a:t>
             </a:r>
             <a:endParaRPr lang="en-US" sz="1100" dirty="0"/>
           </a:p>
@@ -5772,7 +7085,7 @@
                 <a:ea typeface="Calibri" pitchFamily="34" charset="-122"/>
                 <a:cs typeface="Calibri" pitchFamily="34" charset="-120"/>
               </a:rPr>
-              <a:t>payload.paid was false → flips to true, paidBy: "bankA", returns 200</a:t>
+              <a:t>Taps Approve first. The server marks the payment as paid and confirms.</a:t>
             </a:r>
             <a:endParaRPr lang="en-US" sz="1200" dirty="0"/>
           </a:p>
@@ -5947,7 +7260,7 @@
                 <a:ea typeface="Calibri" pitchFamily="34" charset="-122"/>
                 <a:cs typeface="Calibri" pitchFamily="34" charset="-120"/>
               </a:rPr>
-              <a:t>REJECTED</a:t>
+              <a:t>TOO LATE</a:t>
             </a:r>
             <a:endParaRPr lang="en-US" sz="1100" dirty="0"/>
           </a:p>
@@ -5989,7 +7302,7 @@
                 <a:ea typeface="Calibri" pitchFamily="34" charset="-122"/>
                 <a:cs typeface="Calibri" pitchFamily="34" charset="-120"/>
               </a:rPr>
-              <a:t>payload.paid already true → server returns 409, app shows “already completed”</a:t>
+              <a:t>Taps Approve a moment later. The server says it's already paid, so it's rejected.</a:t>
             </a:r>
             <a:endParaRPr lang="en-US" sz="1200" dirty="0"/>
           </a:p>
@@ -6074,7 +7387,7 @@
                 <a:ea typeface="Cambria" pitchFamily="34" charset="-122"/>
                 <a:cs typeface="Cambria" pitchFamily="34" charset="-120"/>
               </a:rPr>
-              <a:t>On success (Bank A)</a:t>
+              <a:t>What happens for Bank A</a:t>
             </a:r>
             <a:endParaRPr lang="en-US" sz="1500" dirty="0"/>
           </a:p>
@@ -6120,7 +7433,7 @@
                 <a:ea typeface="Calibri" pitchFamily="34" charset="-122"/>
                 <a:cs typeface="Calibri" pitchFamily="34" charset="-120"/>
               </a:rPr>
-              <a:t>Deduct amount from local BalanceStore</a:t>
+              <a:t>The paid amount is taken off its balance</a:t>
             </a:r>
             <a:endParaRPr lang="en-US" sz="1250" dirty="0"/>
           </a:p>
@@ -6144,7 +7457,7 @@
                 <a:ea typeface="Calibri" pitchFamily="34" charset="-122"/>
                 <a:cs typeface="Calibri" pitchFamily="34" charset="-120"/>
               </a:rPr>
-              <a:t>ValueNotifier updates Home screen live</a:t>
+              <a:t>The home screen balance updates instantly</a:t>
             </a:r>
             <a:endParaRPr lang="en-US" sz="1250" dirty="0"/>
           </a:p>
@@ -6168,7 +7481,7 @@
                 <a:ea typeface="Calibri" pitchFamily="34" charset="-122"/>
                 <a:cs typeface="Calibri" pitchFamily="34" charset="-120"/>
               </a:rPr>
-              <a:t>Navigate to Success screen</a:t>
+              <a:t>The app shows the success screen</a:t>
             </a:r>
             <a:endParaRPr lang="en-US" sz="1250" dirty="0"/>
           </a:p>
@@ -6231,7 +7544,7 @@
         <p:spPr>
           <a:xfrm>
             <a:off x="1463040" y="5093208"/>
-            <a:ext cx="3657600" cy="365760"/>
+            <a:ext cx="5943600" cy="365760"/>
           </a:xfrm>
           <a:prstGeom prst="rect">
             <a:avLst/>
@@ -6255,7 +7568,7 @@
                 <a:ea typeface="Cambria" pitchFamily="34" charset="-122"/>
                 <a:cs typeface="Cambria" pitchFamily="34" charset="-120"/>
               </a:rPr>
-              <a:t>Never trusts the client</a:t>
+              <a:t>The app never assumes — it always asks</a:t>
             </a:r>
             <a:endParaRPr lang="en-US" sz="1500" dirty="0"/>
           </a:p>
@@ -6297,7 +7610,7 @@
                 <a:ea typeface="Calibri" pitchFamily="34" charset="-122"/>
                 <a:cs typeface="Calibri" pitchFamily="34" charset="-120"/>
               </a:rPr>
-              <a:t>Every app refetches merchant/amount fresh from GET /api/payload/:token before showing Confirm — nothing sensitive is trusted from the link itself, only the opaque token.</a:t>
+              <a:t>Before showing the payment, every bank app asks the server for the merchant name and amount again. The link itself only ever carries one thing — a token, not the actual payment details.</a:t>
             </a:r>
             <a:endParaRPr lang="en-US" sz="1200" dirty="0"/>
           </a:p>
@@ -6311,9 +7624,9 @@
 </p:sld>
 </file>
 
-<file path=ppt/slides/slide7.xml><?xml version="1.0" encoding="utf-8"?>
+<file path=ppt/slides/slide8.xml><?xml version="1.0" encoding="utf-8"?>
 <p:sld xmlns:a="http://schemas.openxmlformats.org/drawingml/2006/main" xmlns:r="http://schemas.openxmlformats.org/officeDocument/2006/relationships" xmlns:p="http://schemas.openxmlformats.org/presentationml/2006/main">
-  <p:cSld name="Slide 7">
+  <p:cSld name="Slide 8">
     <p:bg>
       <p:bgPr>
         <a:solidFill>
@@ -6368,7 +7681,7 @@
                 <a:ea typeface="Cambria" pitchFamily="34" charset="-122"/>
                 <a:cs typeface="Cambria" pitchFamily="34" charset="-120"/>
               </a:rPr>
-              <a:t>Why 3 real apps, not 1 app with flavors</a:t>
+              <a:t>Why 3 separate apps, not 1 app with settings</a:t>
             </a:r>
             <a:endParaRPr lang="en-US" sz="2800" dirty="0"/>
           </a:p>
@@ -6407,7 +7720,7 @@
                 <a:ea typeface="Calibri" pitchFamily="34" charset="-122"/>
                 <a:cs typeface="Calibri" pitchFamily="34" charset="-120"/>
               </a:rPr>
-              <a:t>A single binary can only be one app at a time on the device — the chooser needs 3 distinct installs</a:t>
+              <a:t>The chooser needs 3 apps installed at once — one app can't appear 3 times</a:t>
             </a:r>
             <a:endParaRPr lang="en-US" sz="1350" dirty="0"/>
           </a:p>
@@ -7220,7 +8533,7 @@
                 <a:ea typeface="Cambria" pitchFamily="34" charset="-122"/>
                 <a:cs typeface="Cambria" pitchFamily="34" charset="-120"/>
               </a:rPr>
-              <a:t>Duplicated, not shared</a:t>
+              <a:t>Copied, not shared</a:t>
             </a:r>
             <a:endParaRPr lang="en-US" sz="1400" dirty="0"/>
           </a:p>
@@ -7262,7 +8575,7 @@
                 <a:ea typeface="Calibri" pitchFamily="34" charset="-122"/>
                 <a:cs typeface="Calibri" pitchFamily="34" charset="-120"/>
               </a:rPr>
-              <a:t>Dart source (screens, deep-link handling, API calls) is copy-pasted across the 3 projects, not imported as a shared package — a bug fix in one must be applied to all three manually.</a:t>
+              <a:t>The 3 apps' code started as one copy, duplicated 3 times — it isn't shared behind the scenes. Fixing a bug in one app means copying that fix into the other two by hand.</a:t>
             </a:r>
             <a:endParaRPr lang="en-US" sz="1150" dirty="0"/>
           </a:p>
@@ -7276,9 +8589,9 @@
 </p:sld>
 </file>
 
-<file path=ppt/slides/slide8.xml><?xml version="1.0" encoding="utf-8"?>
+<file path=ppt/slides/slide9.xml><?xml version="1.0" encoding="utf-8"?>
 <p:sld xmlns:a="http://schemas.openxmlformats.org/drawingml/2006/main" xmlns:r="http://schemas.openxmlformats.org/officeDocument/2006/relationships" xmlns:p="http://schemas.openxmlformats.org/presentationml/2006/main">
-  <p:cSld name="Slide 8">
+  <p:cSld name="Slide 9">
     <p:bg>
       <p:bgPr>
         <a:solidFill>
@@ -7491,7 +8804,7 @@
                 <a:ea typeface="Calibri" pitchFamily="34" charset="-122"/>
                 <a:cs typeface="Calibri" pitchFamily="34" charset="-120"/>
               </a:rPr>
-              <a:t>All network calls (payload create/fetch/pay)</a:t>
+              <a:t>Every network request (create, fetch, and pay)</a:t>
             </a:r>
             <a:endParaRPr lang="en-US" sz="1300" dirty="0"/>
           </a:p>
@@ -7515,7 +8828,7 @@
                 <a:ea typeface="Calibri" pitchFamily="34" charset="-122"/>
                 <a:cs typeface="Calibri" pitchFamily="34" charset="-120"/>
               </a:rPr>
-              <a:t>QR generation and OS-level link resolution</a:t>
+              <a:t>The QR code and the actual link resolution on each phone</a:t>
             </a:r>
             <a:endParaRPr lang="en-US" sz="1300" dirty="0"/>
           </a:p>
@@ -7539,7 +8852,7 @@
                 <a:ea typeface="Calibri" pitchFamily="34" charset="-122"/>
                 <a:cs typeface="Calibri" pitchFamily="34" charset="-120"/>
               </a:rPr>
-              <a:t>Android chooser vs. iOS Safari fallback behavior</a:t>
+              <a:t>Android's chooser and iOS's Safari fallback, both genuinely triggered</a:t>
             </a:r>
             <a:endParaRPr lang="en-US" sz="1300" dirty="0"/>
           </a:p>
@@ -7563,7 +8876,7 @@
                 <a:ea typeface="Calibri" pitchFamily="34" charset="-122"/>
                 <a:cs typeface="Calibri" pitchFamily="34" charset="-120"/>
               </a:rPr>
-              <a:t>Cold/warm-start deep link handling</a:t>
+              <a:t>Handling the link whether the app is closed, open, or in the background</a:t>
             </a:r>
             <a:endParaRPr lang="en-US" sz="1300" dirty="0"/>
           </a:p>
@@ -7587,7 +8900,7 @@
                 <a:ea typeface="Calibri" pitchFamily="34" charset="-122"/>
                 <a:cs typeface="Calibri" pitchFamily="34" charset="-120"/>
               </a:rPr>
-              <a:t>Race-condition-safe single-use payment logic</a:t>
+              <a:t>One payment can only be completed once, even with 2 taps at once</a:t>
             </a:r>
             <a:endParaRPr lang="en-US" sz="1300" dirty="0"/>
           </a:p>
@@ -7611,7 +8924,7 @@
                 <a:ea typeface="Calibri" pitchFamily="34" charset="-122"/>
                 <a:cs typeface="Calibri" pitchFamily="34" charset="-120"/>
               </a:rPr>
-              <a:t>Clickjacking protection (X-Frame-Options / CSP)</a:t>
+              <a:t>Basic protection against the page being embedded on another site</a:t>
             </a:r>
             <a:endParaRPr lang="en-US" sz="1300" dirty="0"/>
           </a:p>
@@ -7769,7 +9082,7 @@
                 <a:ea typeface="Calibri" pitchFamily="34" charset="-122"/>
                 <a:cs typeface="Calibri" pitchFamily="34" charset="-120"/>
               </a:rPr>
-              <a:t>Bank balance — in-memory, resets on relaunch</a:t>
+              <a:t>The bank balance — just a number in the app, resets on relaunch</a:t>
             </a:r>
             <a:endParaRPr lang="en-US" sz="1300" dirty="0"/>
           </a:p>
@@ -7793,7 +9106,7 @@
                 <a:ea typeface="Calibri" pitchFamily="34" charset="-122"/>
                 <a:cs typeface="Calibri" pitchFamily="34" charset="-120"/>
               </a:rPr>
-              <a:t>The payment itself — no money moves, no bank rails</a:t>
+              <a:t>The payment — no real money moves, no real bank is involved</a:t>
             </a:r>
             <a:endParaRPr lang="en-US" sz="1300" dirty="0"/>
           </a:p>
@@ -7817,7 +9130,7 @@
                 <a:ea typeface="Calibri" pitchFamily="34" charset="-122"/>
                 <a:cs typeface="Calibri" pitchFamily="34" charset="-120"/>
               </a:rPr>
-              <a:t>“paidBy” is just a label, not a real settlement</a:t>
+              <a:t>Which bank "paid" is just a label the server stores, not a settlement</a:t>
             </a:r>
             <a:endParaRPr lang="en-US" sz="1300" dirty="0"/>
           </a:p>
@@ -7841,213 +9154,9 @@
                 <a:ea typeface="Calibri" pitchFamily="34" charset="-122"/>
                 <a:cs typeface="Calibri" pitchFamily="34" charset="-120"/>
               </a:rPr>
-              <a:t>App Link / Universal Link verification left off on purpose — real integrations would configure it per bank</a:t>
+              <a:t>Real apps would register properly with Android/Apple so their own link opens automatically — we skip that on purpose to keep the chooser/picker page</a:t>
             </a:r>
             <a:endParaRPr lang="en-US" sz="1300" dirty="0"/>
-          </a:p>
-        </p:txBody>
-      </p:sp>
-    </p:spTree>
-  </p:cSld>
-  <p:clrMapOvr>
-    <a:masterClrMapping/>
-  </p:clrMapOvr>
-</p:sld>
-</file>
-
-<file path=ppt/slides/slide9.xml><?xml version="1.0" encoding="utf-8"?>
-<p:sld xmlns:a="http://schemas.openxmlformats.org/drawingml/2006/main" xmlns:r="http://schemas.openxmlformats.org/officeDocument/2006/relationships" xmlns:p="http://schemas.openxmlformats.org/presentationml/2006/main">
-  <p:cSld name="Slide 9">
-    <p:bg>
-      <p:bgPr>
-        <a:solidFill>
-          <a:srgbClr val="21295C"/>
-        </a:solidFill>
-      </p:bgPr>
-    </p:bg>
-    <p:spTree>
-      <p:nvGrpSpPr>
-        <p:cNvPr id="1" name=""/>
-        <p:cNvGrpSpPr/>
-        <p:nvPr/>
-      </p:nvGrpSpPr>
-      <p:grpSpPr>
-        <a:xfrm>
-          <a:off x="0" y="0"/>
-          <a:ext cx="0" cy="0"/>
-          <a:chOff x="0" y="0"/>
-          <a:chExt cx="0" cy="0"/>
-        </a:xfrm>
-      </p:grpSpPr>
-      <p:sp>
-        <p:nvSpPr>
-          <p:cNvPr id="2" name="Shape 0"/>
-          <p:cNvSpPr/>
-          <p:nvPr/>
-        </p:nvSpPr>
-        <p:spPr>
-          <a:xfrm>
-            <a:off x="8686800" y="-1828800"/>
-            <a:ext cx="5486400" cy="5486400"/>
-          </a:xfrm>
-          <a:prstGeom prst="ellipse">
-            <a:avLst/>
-          </a:prstGeom>
-          <a:solidFill>
-            <a:srgbClr val="065A82">
-              <a:alpha val="45000"/>
-            </a:srgbClr>
-          </a:solidFill>
-          <a:ln/>
-        </p:spPr>
-      </p:sp>
-      <p:sp>
-        <p:nvSpPr>
-          <p:cNvPr id="3" name="Shape 1"/>
-          <p:cNvSpPr/>
-          <p:nvPr/>
-        </p:nvSpPr>
-        <p:spPr>
-          <a:xfrm>
-            <a:off x="-1828800" y="4572000"/>
-            <a:ext cx="4572000" cy="4572000"/>
-          </a:xfrm>
-          <a:prstGeom prst="ellipse">
-            <a:avLst/>
-          </a:prstGeom>
-          <a:solidFill>
-            <a:srgbClr val="1C7293">
-              <a:alpha val="35000"/>
-            </a:srgbClr>
-          </a:solidFill>
-          <a:ln/>
-        </p:spPr>
-      </p:sp>
-      <p:pic>
-        <p:nvPicPr>
-          <p:cNvPr id="4" name="Image 0" descr="preencoded.png">    </p:cNvPr>
-          <p:cNvPicPr>
-            <a:picLocks noChangeAspect="1"/>
-          </p:cNvPicPr>
-          <p:nvPr/>
-        </p:nvPicPr>
-        <p:blipFill>
-          <a:blip r:embed="rId1"/>
-          <a:stretch>
-            <a:fillRect/>
-          </a:stretch>
-        </p:blipFill>
-        <p:spPr>
-          <a:xfrm>
-            <a:off x="822960" y="1280160"/>
-            <a:ext cx="640080" cy="640080"/>
-          </a:xfrm>
-          <a:prstGeom prst="rect">
-            <a:avLst/>
-          </a:prstGeom>
-        </p:spPr>
-      </p:pic>
-      <p:sp>
-        <p:nvSpPr>
-          <p:cNvPr id="5" name="Text 2"/>
-          <p:cNvSpPr/>
-          <p:nvPr/>
-        </p:nvSpPr>
-        <p:spPr>
-          <a:xfrm>
-            <a:off x="822960" y="2103120"/>
-            <a:ext cx="9875520" cy="1645920"/>
-          </a:xfrm>
-          <a:prstGeom prst="rect">
-            <a:avLst/>
-          </a:prstGeom>
-          <a:noFill/>
-          <a:ln/>
-        </p:spPr>
-        <p:txBody>
-          <a:bodyPr wrap="square" lIns="0" tIns="0" rIns="0" bIns="0" rtlCol="0" anchor="ctr"/>
-          <a:lstStyle/>
-          <a:p>
-            <a:pPr indent="0" marL="0">
-              <a:lnSpc>
-                <a:spcPct val="110000"/>
-              </a:lnSpc>
-              <a:buNone/>
-            </a:pPr>
-            <a:r>
-              <a:rPr lang="en-US" sz="3400" b="1" dirty="0">
-                <a:solidFill>
-                  <a:srgbClr val="FFFFFF"/>
-                </a:solidFill>
-                <a:latin typeface="Cambria" pitchFamily="34" charset="0"/>
-                <a:ea typeface="Cambria" pitchFamily="34" charset="-122"/>
-                <a:cs typeface="Cambria" pitchFamily="34" charset="-120"/>
-              </a:rPr>
-              <a:t>One link. Two OS-native paths.</a:t>
-            </a:r>
-            <a:endParaRPr lang="en-US" sz="3400" dirty="0"/>
-          </a:p>
-          <a:p>
-            <a:pPr indent="0" marL="0">
-              <a:lnSpc>
-                <a:spcPct val="110000"/>
-              </a:lnSpc>
-              <a:buNone/>
-            </a:pPr>
-            <a:r>
-              <a:rPr lang="en-US" sz="3400" b="1" dirty="0">
-                <a:solidFill>
-                  <a:srgbClr val="FFFFFF"/>
-                </a:solidFill>
-                <a:latin typeface="Cambria" pitchFamily="34" charset="0"/>
-                <a:ea typeface="Cambria" pitchFamily="34" charset="-122"/>
-                <a:cs typeface="Cambria" pitchFamily="34" charset="-120"/>
-              </a:rPr>
-              <a:t>Three independent bank apps.</a:t>
-            </a:r>
-            <a:endParaRPr lang="en-US" sz="3400" dirty="0"/>
-          </a:p>
-        </p:txBody>
-      </p:sp>
-      <p:sp>
-        <p:nvSpPr>
-          <p:cNvPr id="6" name="Text 3"/>
-          <p:cNvSpPr/>
-          <p:nvPr/>
-        </p:nvSpPr>
-        <p:spPr>
-          <a:xfrm>
-            <a:off x="822960" y="3657600"/>
-            <a:ext cx="8686800" cy="731520"/>
-          </a:xfrm>
-          <a:prstGeom prst="rect">
-            <a:avLst/>
-          </a:prstGeom>
-          <a:noFill/>
-          <a:ln/>
-        </p:spPr>
-        <p:txBody>
-          <a:bodyPr wrap="square" lIns="0" tIns="0" rIns="0" bIns="0" rtlCol="0" anchor="ctr"/>
-          <a:lstStyle/>
-          <a:p>
-            <a:pPr indent="0" marL="0">
-              <a:lnSpc>
-                <a:spcPct val="125000"/>
-              </a:lnSpc>
-              <a:buNone/>
-            </a:pPr>
-            <a:r>
-              <a:rPr lang="en-US" sz="1500" dirty="0">
-                <a:solidFill>
-                  <a:srgbClr val="CADCFC"/>
-                </a:solidFill>
-                <a:latin typeface="Calibri" pitchFamily="34" charset="0"/>
-                <a:ea typeface="Calibri" pitchFamily="34" charset="-122"/>
-                <a:cs typeface="Calibri" pitchFamily="34" charset="-120"/>
-              </a:rPr>
-              <a:t>The entire chooser-vs-picker split comes from what's deliberately left unverified — not from a single line of platform-detection code.</a:t>
-            </a:r>
-            <a:endParaRPr lang="en-US" sz="1500" dirty="0"/>
           </a:p>
         </p:txBody>
       </p:sp>

</xml_diff>

<commit_message>
Fix deck: correct bank brand colors, reduce whitespace, fix icon contrast
</commit_message>
<xml_diff>
--- a/SGQR_Deep_Linking_Simulation.pptx
+++ b/SGQR_Deep_Linking_Simulation.pptx
@@ -2557,8 +2557,8 @@
         </p:nvSpPr>
         <p:spPr>
           <a:xfrm>
-            <a:off x="548640" y="1508760"/>
-            <a:ext cx="3520440" cy="4297680"/>
+            <a:off x="548640" y="1965960"/>
+            <a:ext cx="3520440" cy="3566160"/>
           </a:xfrm>
           <a:prstGeom prst="roundRect">
             <a:avLst>
@@ -2586,7 +2586,7 @@
         </p:nvSpPr>
         <p:spPr>
           <a:xfrm>
-            <a:off x="822960" y="1783080"/>
+            <a:off x="822960" y="2240280"/>
             <a:ext cx="685800" cy="685800"/>
           </a:xfrm>
           <a:prstGeom prst="roundRect">
@@ -2616,7 +2616,7 @@
         </p:blipFill>
         <p:spPr>
           <a:xfrm>
-            <a:off x="1005840" y="1965960"/>
+            <a:off x="1005840" y="2423160"/>
             <a:ext cx="320040" cy="320040"/>
           </a:xfrm>
           <a:prstGeom prst="rect">
@@ -2632,7 +2632,7 @@
         </p:nvSpPr>
         <p:spPr>
           <a:xfrm>
-            <a:off x="822960" y="2606040"/>
+            <a:off x="822960" y="3063240"/>
             <a:ext cx="2971800" cy="411480"/>
           </a:xfrm>
           <a:prstGeom prst="rect">
@@ -2671,7 +2671,7 @@
         </p:nvSpPr>
         <p:spPr>
           <a:xfrm>
-            <a:off x="822960" y="2999232"/>
+            <a:off x="822960" y="3456432"/>
             <a:ext cx="2971800" cy="320040"/>
           </a:xfrm>
           <a:prstGeom prst="rect">
@@ -2710,8 +2710,8 @@
         </p:nvSpPr>
         <p:spPr>
           <a:xfrm>
-            <a:off x="822960" y="3474720"/>
-            <a:ext cx="2971800" cy="2103120"/>
+            <a:off x="822960" y="3931920"/>
+            <a:ext cx="2971800" cy="1371600"/>
           </a:xfrm>
           <a:prstGeom prst="rect">
             <a:avLst/>
@@ -2804,8 +2804,8 @@
         </p:nvSpPr>
         <p:spPr>
           <a:xfrm>
-            <a:off x="4389120" y="1508760"/>
-            <a:ext cx="3520440" cy="4297680"/>
+            <a:off x="4389120" y="1965960"/>
+            <a:ext cx="3520440" cy="3566160"/>
           </a:xfrm>
           <a:prstGeom prst="roundRect">
             <a:avLst>
@@ -2833,7 +2833,7 @@
         </p:nvSpPr>
         <p:spPr>
           <a:xfrm>
-            <a:off x="4663440" y="1783080"/>
+            <a:off x="4663440" y="2240280"/>
             <a:ext cx="685800" cy="685800"/>
           </a:xfrm>
           <a:prstGeom prst="roundRect">
@@ -2863,7 +2863,7 @@
         </p:blipFill>
         <p:spPr>
           <a:xfrm>
-            <a:off x="4846320" y="1965960"/>
+            <a:off x="4846320" y="2423160"/>
             <a:ext cx="320040" cy="320040"/>
           </a:xfrm>
           <a:prstGeom prst="rect">
@@ -2879,7 +2879,7 @@
         </p:nvSpPr>
         <p:spPr>
           <a:xfrm>
-            <a:off x="4663440" y="2606040"/>
+            <a:off x="4663440" y="3063240"/>
             <a:ext cx="2971800" cy="411480"/>
           </a:xfrm>
           <a:prstGeom prst="rect">
@@ -2918,7 +2918,7 @@
         </p:nvSpPr>
         <p:spPr>
           <a:xfrm>
-            <a:off x="4663440" y="2999232"/>
+            <a:off x="4663440" y="3456432"/>
             <a:ext cx="2971800" cy="320040"/>
           </a:xfrm>
           <a:prstGeom prst="rect">
@@ -2957,8 +2957,8 @@
         </p:nvSpPr>
         <p:spPr>
           <a:xfrm>
-            <a:off x="4663440" y="3474720"/>
-            <a:ext cx="2971800" cy="2103120"/>
+            <a:off x="4663440" y="3931920"/>
+            <a:ext cx="2971800" cy="1371600"/>
           </a:xfrm>
           <a:prstGeom prst="rect">
             <a:avLst/>
@@ -3051,8 +3051,8 @@
         </p:nvSpPr>
         <p:spPr>
           <a:xfrm>
-            <a:off x="8229600" y="1508760"/>
-            <a:ext cx="3520440" cy="4297680"/>
+            <a:off x="8229600" y="1965960"/>
+            <a:ext cx="3520440" cy="3566160"/>
           </a:xfrm>
           <a:prstGeom prst="roundRect">
             <a:avLst>
@@ -3080,7 +3080,7 @@
         </p:nvSpPr>
         <p:spPr>
           <a:xfrm>
-            <a:off x="8503920" y="1783080"/>
+            <a:off x="8503920" y="2240280"/>
             <a:ext cx="685800" cy="685800"/>
           </a:xfrm>
           <a:prstGeom prst="roundRect">
@@ -3110,7 +3110,7 @@
         </p:blipFill>
         <p:spPr>
           <a:xfrm>
-            <a:off x="8686800" y="1965960"/>
+            <a:off x="8686800" y="2423160"/>
             <a:ext cx="320040" cy="320040"/>
           </a:xfrm>
           <a:prstGeom prst="rect">
@@ -3126,7 +3126,7 @@
         </p:nvSpPr>
         <p:spPr>
           <a:xfrm>
-            <a:off x="8503920" y="2606040"/>
+            <a:off x="8503920" y="3063240"/>
             <a:ext cx="2971800" cy="411480"/>
           </a:xfrm>
           <a:prstGeom prst="rect">
@@ -3165,7 +3165,7 @@
         </p:nvSpPr>
         <p:spPr>
           <a:xfrm>
-            <a:off x="8503920" y="2999232"/>
+            <a:off x="8503920" y="3456432"/>
             <a:ext cx="2971800" cy="320040"/>
           </a:xfrm>
           <a:prstGeom prst="rect">
@@ -3204,8 +3204,8 @@
         </p:nvSpPr>
         <p:spPr>
           <a:xfrm>
-            <a:off x="8503920" y="3474720"/>
-            <a:ext cx="2971800" cy="2103120"/>
+            <a:off x="8503920" y="3931920"/>
+            <a:ext cx="2971800" cy="1371600"/>
           </a:xfrm>
           <a:prstGeom prst="rect">
             <a:avLst/>
@@ -3408,7 +3408,7 @@
         </p:nvSpPr>
         <p:spPr>
           <a:xfrm>
-            <a:off x="5637276" y="1554480"/>
+            <a:off x="5637276" y="1828800"/>
             <a:ext cx="914400" cy="914400"/>
           </a:xfrm>
           <a:prstGeom prst="ellipse">
@@ -3436,7 +3436,7 @@
         </p:blipFill>
         <p:spPr>
           <a:xfrm>
-            <a:off x="5838444" y="1755648"/>
+            <a:off x="5838444" y="2029968"/>
             <a:ext cx="512064" cy="512064"/>
           </a:xfrm>
           <a:prstGeom prst="rect">
@@ -3452,12 +3452,12 @@
         </p:nvSpPr>
         <p:spPr>
           <a:xfrm>
-            <a:off x="640080" y="2743200"/>
-            <a:ext cx="4937760" cy="3291840"/>
+            <a:off x="640080" y="3017520"/>
+            <a:ext cx="4937760" cy="2651760"/>
           </a:xfrm>
           <a:prstGeom prst="roundRect">
             <a:avLst>
-              <a:gd name="adj" fmla="val 2222"/>
+              <a:gd name="adj" fmla="val 2759"/>
             </a:avLst>
           </a:prstGeom>
           <a:solidFill>
@@ -3476,7 +3476,7 @@
         </p:nvSpPr>
         <p:spPr>
           <a:xfrm>
-            <a:off x="914400" y="3017520"/>
+            <a:off x="914400" y="3291840"/>
             <a:ext cx="548640" cy="548640"/>
           </a:xfrm>
           <a:prstGeom prst="ellipse">
@@ -3504,7 +3504,7 @@
         </p:blipFill>
         <p:spPr>
           <a:xfrm>
-            <a:off x="1051560" y="3154680"/>
+            <a:off x="1051560" y="3429000"/>
             <a:ext cx="274320" cy="274320"/>
           </a:xfrm>
           <a:prstGeom prst="rect">
@@ -3520,7 +3520,7 @@
         </p:nvSpPr>
         <p:spPr>
           <a:xfrm>
-            <a:off x="1600200" y="2999232"/>
+            <a:off x="1600200" y="3273552"/>
             <a:ext cx="3749040" cy="365760"/>
           </a:xfrm>
           <a:prstGeom prst="rect">
@@ -3559,7 +3559,7 @@
         </p:nvSpPr>
         <p:spPr>
           <a:xfrm>
-            <a:off x="1600200" y="3337560"/>
+            <a:off x="1600200" y="3611880"/>
             <a:ext cx="3749040" cy="320040"/>
           </a:xfrm>
           <a:prstGeom prst="rect">
@@ -3598,8 +3598,8 @@
         </p:nvSpPr>
         <p:spPr>
           <a:xfrm>
-            <a:off x="914400" y="3794760"/>
-            <a:ext cx="4389120" cy="2011680"/>
+            <a:off x="914400" y="4069080"/>
+            <a:ext cx="4389120" cy="1371600"/>
           </a:xfrm>
           <a:prstGeom prst="rect">
             <a:avLst/>
@@ -3692,12 +3692,12 @@
         </p:nvSpPr>
         <p:spPr>
           <a:xfrm>
-            <a:off x="6611112" y="2743200"/>
-            <a:ext cx="4937760" cy="3291840"/>
+            <a:off x="6611112" y="3017520"/>
+            <a:ext cx="4937760" cy="2651760"/>
           </a:xfrm>
           <a:prstGeom prst="roundRect">
             <a:avLst>
-              <a:gd name="adj" fmla="val 2222"/>
+              <a:gd name="adj" fmla="val 2759"/>
             </a:avLst>
           </a:prstGeom>
           <a:solidFill>
@@ -3716,7 +3716,7 @@
         </p:nvSpPr>
         <p:spPr>
           <a:xfrm>
-            <a:off x="6885432" y="3017520"/>
+            <a:off x="6885432" y="3291840"/>
             <a:ext cx="548640" cy="548640"/>
           </a:xfrm>
           <a:prstGeom prst="ellipse">
@@ -3744,7 +3744,7 @@
         </p:blipFill>
         <p:spPr>
           <a:xfrm>
-            <a:off x="7022592" y="3154680"/>
+            <a:off x="7022592" y="3429000"/>
             <a:ext cx="274320" cy="274320"/>
           </a:xfrm>
           <a:prstGeom prst="rect">
@@ -3760,7 +3760,7 @@
         </p:nvSpPr>
         <p:spPr>
           <a:xfrm>
-            <a:off x="7571232" y="2999232"/>
+            <a:off x="7571232" y="3273552"/>
             <a:ext cx="3749040" cy="365760"/>
           </a:xfrm>
           <a:prstGeom prst="rect">
@@ -3799,7 +3799,7 @@
         </p:nvSpPr>
         <p:spPr>
           <a:xfrm>
-            <a:off x="7571232" y="3337560"/>
+            <a:off x="7571232" y="3611880"/>
             <a:ext cx="3749040" cy="320040"/>
           </a:xfrm>
           <a:prstGeom prst="rect">
@@ -3838,8 +3838,8 @@
         </p:nvSpPr>
         <p:spPr>
           <a:xfrm>
-            <a:off x="6885432" y="3794760"/>
-            <a:ext cx="4389120" cy="2011680"/>
+            <a:off x="6885432" y="4069080"/>
+            <a:ext cx="4389120" cy="1371600"/>
           </a:xfrm>
           <a:prstGeom prst="rect">
             <a:avLst/>
@@ -4042,8 +4042,8 @@
         </p:nvSpPr>
         <p:spPr>
           <a:xfrm>
-            <a:off x="548640" y="1463040"/>
-            <a:ext cx="2514600" cy="4114800"/>
+            <a:off x="548640" y="1600200"/>
+            <a:ext cx="2514600" cy="3291840"/>
           </a:xfrm>
           <a:prstGeom prst="roundRect">
             <a:avLst>
@@ -4071,7 +4071,7 @@
         </p:nvSpPr>
         <p:spPr>
           <a:xfrm>
-            <a:off x="1485900" y="1783080"/>
+            <a:off x="1485900" y="1874520"/>
             <a:ext cx="640080" cy="640080"/>
           </a:xfrm>
           <a:prstGeom prst="ellipse">
@@ -4099,7 +4099,7 @@
         </p:blipFill>
         <p:spPr>
           <a:xfrm>
-            <a:off x="1641348" y="1938528"/>
+            <a:off x="1641348" y="2029968"/>
             <a:ext cx="329184" cy="329184"/>
           </a:xfrm>
           <a:prstGeom prst="rect">
@@ -4115,7 +4115,7 @@
         </p:nvSpPr>
         <p:spPr>
           <a:xfrm>
-            <a:off x="685800" y="1600200"/>
+            <a:off x="685800" y="1737360"/>
             <a:ext cx="365760" cy="365760"/>
           </a:xfrm>
           <a:prstGeom prst="rect">
@@ -4154,8 +4154,8 @@
         </p:nvSpPr>
         <p:spPr>
           <a:xfrm>
-            <a:off x="731520" y="2606040"/>
-            <a:ext cx="2148840" cy="685800"/>
+            <a:off x="731520" y="2651760"/>
+            <a:ext cx="2148840" cy="640080"/>
           </a:xfrm>
           <a:prstGeom prst="rect">
             <a:avLst/>
@@ -4193,8 +4193,8 @@
         </p:nvSpPr>
         <p:spPr>
           <a:xfrm>
-            <a:off x="777240" y="3337560"/>
-            <a:ext cx="2057400" cy="2011680"/>
+            <a:off x="777240" y="3291840"/>
+            <a:ext cx="2057400" cy="1417320"/>
           </a:xfrm>
           <a:prstGeom prst="rect">
             <a:avLst/>
@@ -4243,7 +4243,7 @@
         </p:blipFill>
         <p:spPr>
           <a:xfrm>
-            <a:off x="3081528" y="3410712"/>
+            <a:off x="3081528" y="3136392"/>
             <a:ext cx="219456" cy="219456"/>
           </a:xfrm>
           <a:prstGeom prst="rect">
@@ -4259,8 +4259,8 @@
         </p:nvSpPr>
         <p:spPr>
           <a:xfrm>
-            <a:off x="3291840" y="1463040"/>
-            <a:ext cx="2514600" cy="4114800"/>
+            <a:off x="3291840" y="1600200"/>
+            <a:ext cx="2514600" cy="3291840"/>
           </a:xfrm>
           <a:prstGeom prst="roundRect">
             <a:avLst>
@@ -4288,7 +4288,7 @@
         </p:nvSpPr>
         <p:spPr>
           <a:xfrm>
-            <a:off x="4229100" y="1783080"/>
+            <a:off x="4229100" y="1874520"/>
             <a:ext cx="640080" cy="640080"/>
           </a:xfrm>
           <a:prstGeom prst="ellipse">
@@ -4316,7 +4316,7 @@
         </p:blipFill>
         <p:spPr>
           <a:xfrm>
-            <a:off x="4384548" y="1938528"/>
+            <a:off x="4384548" y="2029968"/>
             <a:ext cx="329184" cy="329184"/>
           </a:xfrm>
           <a:prstGeom prst="rect">
@@ -4332,7 +4332,7 @@
         </p:nvSpPr>
         <p:spPr>
           <a:xfrm>
-            <a:off x="3429000" y="1600200"/>
+            <a:off x="3429000" y="1737360"/>
             <a:ext cx="365760" cy="365760"/>
           </a:xfrm>
           <a:prstGeom prst="rect">
@@ -4371,8 +4371,8 @@
         </p:nvSpPr>
         <p:spPr>
           <a:xfrm>
-            <a:off x="3474720" y="2606040"/>
-            <a:ext cx="2148840" cy="685800"/>
+            <a:off x="3474720" y="2651760"/>
+            <a:ext cx="2148840" cy="640080"/>
           </a:xfrm>
           <a:prstGeom prst="rect">
             <a:avLst/>
@@ -4410,8 +4410,8 @@
         </p:nvSpPr>
         <p:spPr>
           <a:xfrm>
-            <a:off x="3520440" y="3337560"/>
-            <a:ext cx="2057400" cy="2011680"/>
+            <a:off x="3520440" y="3291840"/>
+            <a:ext cx="2057400" cy="1417320"/>
           </a:xfrm>
           <a:prstGeom prst="rect">
             <a:avLst/>
@@ -4460,7 +4460,7 @@
         </p:blipFill>
         <p:spPr>
           <a:xfrm>
-            <a:off x="5824728" y="3410712"/>
+            <a:off x="5824728" y="3136392"/>
             <a:ext cx="219456" cy="219456"/>
           </a:xfrm>
           <a:prstGeom prst="rect">
@@ -4476,8 +4476,8 @@
         </p:nvSpPr>
         <p:spPr>
           <a:xfrm>
-            <a:off x="6035040" y="1463040"/>
-            <a:ext cx="2514600" cy="4114800"/>
+            <a:off x="6035040" y="1600200"/>
+            <a:ext cx="2514600" cy="3291840"/>
           </a:xfrm>
           <a:prstGeom prst="roundRect">
             <a:avLst>
@@ -4505,7 +4505,7 @@
         </p:nvSpPr>
         <p:spPr>
           <a:xfrm>
-            <a:off x="6972300" y="1783080"/>
+            <a:off x="6972300" y="1874520"/>
             <a:ext cx="640080" cy="640080"/>
           </a:xfrm>
           <a:prstGeom prst="ellipse">
@@ -4533,7 +4533,7 @@
         </p:blipFill>
         <p:spPr>
           <a:xfrm>
-            <a:off x="7127748" y="1938528"/>
+            <a:off x="7127748" y="2029968"/>
             <a:ext cx="329184" cy="329184"/>
           </a:xfrm>
           <a:prstGeom prst="rect">
@@ -4549,7 +4549,7 @@
         </p:nvSpPr>
         <p:spPr>
           <a:xfrm>
-            <a:off x="6172200" y="1600200"/>
+            <a:off x="6172200" y="1737360"/>
             <a:ext cx="365760" cy="365760"/>
           </a:xfrm>
           <a:prstGeom prst="rect">
@@ -4588,8 +4588,8 @@
         </p:nvSpPr>
         <p:spPr>
           <a:xfrm>
-            <a:off x="6217920" y="2606040"/>
-            <a:ext cx="2148840" cy="685800"/>
+            <a:off x="6217920" y="2651760"/>
+            <a:ext cx="2148840" cy="640080"/>
           </a:xfrm>
           <a:prstGeom prst="rect">
             <a:avLst/>
@@ -4627,8 +4627,8 @@
         </p:nvSpPr>
         <p:spPr>
           <a:xfrm>
-            <a:off x="6263640" y="3337560"/>
-            <a:ext cx="2057400" cy="2011680"/>
+            <a:off x="6263640" y="3291840"/>
+            <a:ext cx="2057400" cy="1417320"/>
           </a:xfrm>
           <a:prstGeom prst="rect">
             <a:avLst/>
@@ -4677,7 +4677,7 @@
         </p:blipFill>
         <p:spPr>
           <a:xfrm>
-            <a:off x="8567928" y="3410712"/>
+            <a:off x="8567928" y="3136392"/>
             <a:ext cx="219456" cy="219456"/>
           </a:xfrm>
           <a:prstGeom prst="rect">
@@ -4693,8 +4693,8 @@
         </p:nvSpPr>
         <p:spPr>
           <a:xfrm>
-            <a:off x="8778240" y="1463040"/>
-            <a:ext cx="2514600" cy="4114800"/>
+            <a:off x="8778240" y="1600200"/>
+            <a:ext cx="2514600" cy="3291840"/>
           </a:xfrm>
           <a:prstGeom prst="roundRect">
             <a:avLst>
@@ -4722,7 +4722,7 @@
         </p:nvSpPr>
         <p:spPr>
           <a:xfrm>
-            <a:off x="9715500" y="1783080"/>
+            <a:off x="9715500" y="1874520"/>
             <a:ext cx="640080" cy="640080"/>
           </a:xfrm>
           <a:prstGeom prst="ellipse">
@@ -4750,7 +4750,7 @@
         </p:blipFill>
         <p:spPr>
           <a:xfrm>
-            <a:off x="9870948" y="1938528"/>
+            <a:off x="9870948" y="2029968"/>
             <a:ext cx="329184" cy="329184"/>
           </a:xfrm>
           <a:prstGeom prst="rect">
@@ -4766,7 +4766,7 @@
         </p:nvSpPr>
         <p:spPr>
           <a:xfrm>
-            <a:off x="8915400" y="1600200"/>
+            <a:off x="8915400" y="1737360"/>
             <a:ext cx="365760" cy="365760"/>
           </a:xfrm>
           <a:prstGeom prst="rect">
@@ -4805,8 +4805,8 @@
         </p:nvSpPr>
         <p:spPr>
           <a:xfrm>
-            <a:off x="8961120" y="2606040"/>
-            <a:ext cx="2148840" cy="685800"/>
+            <a:off x="8961120" y="2651760"/>
+            <a:ext cx="2148840" cy="640080"/>
           </a:xfrm>
           <a:prstGeom prst="rect">
             <a:avLst/>
@@ -4844,8 +4844,8 @@
         </p:nvSpPr>
         <p:spPr>
           <a:xfrm>
-            <a:off x="9006840" y="3337560"/>
-            <a:ext cx="2057400" cy="2011680"/>
+            <a:off x="9006840" y="3291840"/>
+            <a:ext cx="2057400" cy="1417320"/>
           </a:xfrm>
           <a:prstGeom prst="rect">
             <a:avLst/>
@@ -4886,12 +4886,12 @@
         </p:nvSpPr>
         <p:spPr>
           <a:xfrm>
-            <a:off x="548640" y="5715000"/>
-            <a:ext cx="11091672" cy="777240"/>
+            <a:off x="548640" y="5212080"/>
+            <a:ext cx="11091672" cy="960120"/>
           </a:xfrm>
           <a:prstGeom prst="roundRect">
             <a:avLst>
-              <a:gd name="adj" fmla="val 9412"/>
+              <a:gd name="adj" fmla="val 7619"/>
             </a:avLst>
           </a:prstGeom>
           <a:solidFill>
@@ -4910,8 +4910,8 @@
         </p:nvSpPr>
         <p:spPr>
           <a:xfrm>
-            <a:off x="822960" y="5715000"/>
-            <a:ext cx="10543032" cy="777240"/>
+            <a:off x="822960" y="5212080"/>
+            <a:ext cx="10543032" cy="960120"/>
           </a:xfrm>
           <a:prstGeom prst="rect">
             <a:avLst/>
@@ -4925,12 +4925,12 @@
           <a:p>
             <a:pPr indent="0" marL="0">
               <a:lnSpc>
-                <a:spcPct val="120000"/>
+                <a:spcPct val="125000"/>
               </a:lnSpc>
               <a:buNone/>
             </a:pPr>
             <a:r>
-              <a:rPr lang="en-US" sz="1200" dirty="0">
+              <a:rPr lang="en-US" sz="1300" dirty="0">
                 <a:solidFill>
                   <a:srgbClr val="6B2A1E"/>
                 </a:solidFill>
@@ -4940,7 +4940,7 @@
               </a:rPr>
               <a:t>Why intent:// and not https:// again? Chrome won't hand a link back to a browser (even itself) through this mechanism — it has to be a link only apps can claim.</a:t>
             </a:r>
-            <a:endParaRPr lang="en-US" sz="1200" dirty="0"/>
+            <a:endParaRPr lang="en-US" sz="1300" dirty="0"/>
           </a:p>
         </p:txBody>
       </p:sp>
@@ -5023,8 +5023,8 @@
         </p:nvSpPr>
         <p:spPr>
           <a:xfrm>
-            <a:off x="548640" y="1371600"/>
-            <a:ext cx="2514600" cy="4206240"/>
+            <a:off x="548640" y="1828800"/>
+            <a:ext cx="2514600" cy="3291840"/>
           </a:xfrm>
           <a:prstGeom prst="roundRect">
             <a:avLst>
@@ -5052,7 +5052,7 @@
         </p:nvSpPr>
         <p:spPr>
           <a:xfrm>
-            <a:off x="1485900" y="1691640"/>
+            <a:off x="1485900" y="2103120"/>
             <a:ext cx="640080" cy="640080"/>
           </a:xfrm>
           <a:prstGeom prst="ellipse">
@@ -5080,7 +5080,7 @@
         </p:blipFill>
         <p:spPr>
           <a:xfrm>
-            <a:off x="1641348" y="1847088"/>
+            <a:off x="1641348" y="2258568"/>
             <a:ext cx="329184" cy="329184"/>
           </a:xfrm>
           <a:prstGeom prst="rect">
@@ -5096,7 +5096,7 @@
         </p:nvSpPr>
         <p:spPr>
           <a:xfrm>
-            <a:off x="685800" y="1508760"/>
+            <a:off x="685800" y="1965960"/>
             <a:ext cx="365760" cy="365760"/>
           </a:xfrm>
           <a:prstGeom prst="rect">
@@ -5135,8 +5135,8 @@
         </p:nvSpPr>
         <p:spPr>
           <a:xfrm>
-            <a:off x="731520" y="2514600"/>
-            <a:ext cx="2148840" cy="685800"/>
+            <a:off x="731520" y="2880360"/>
+            <a:ext cx="2148840" cy="640080"/>
           </a:xfrm>
           <a:prstGeom prst="rect">
             <a:avLst/>
@@ -5174,8 +5174,8 @@
         </p:nvSpPr>
         <p:spPr>
           <a:xfrm>
-            <a:off x="777240" y="3246120"/>
-            <a:ext cx="2057400" cy="2103120"/>
+            <a:off x="777240" y="3520440"/>
+            <a:ext cx="2057400" cy="1417320"/>
           </a:xfrm>
           <a:prstGeom prst="rect">
             <a:avLst/>
@@ -5240,8 +5240,8 @@
         </p:nvSpPr>
         <p:spPr>
           <a:xfrm>
-            <a:off x="3291840" y="1371600"/>
-            <a:ext cx="2514600" cy="4206240"/>
+            <a:off x="3291840" y="1828800"/>
+            <a:ext cx="2514600" cy="3291840"/>
           </a:xfrm>
           <a:prstGeom prst="roundRect">
             <a:avLst>
@@ -5269,7 +5269,7 @@
         </p:nvSpPr>
         <p:spPr>
           <a:xfrm>
-            <a:off x="4229100" y="1691640"/>
+            <a:off x="4229100" y="2103120"/>
             <a:ext cx="640080" cy="640080"/>
           </a:xfrm>
           <a:prstGeom prst="ellipse">
@@ -5297,7 +5297,7 @@
         </p:blipFill>
         <p:spPr>
           <a:xfrm>
-            <a:off x="4384548" y="1847088"/>
+            <a:off x="4384548" y="2258568"/>
             <a:ext cx="329184" cy="329184"/>
           </a:xfrm>
           <a:prstGeom prst="rect">
@@ -5313,7 +5313,7 @@
         </p:nvSpPr>
         <p:spPr>
           <a:xfrm>
-            <a:off x="3429000" y="1508760"/>
+            <a:off x="3429000" y="1965960"/>
             <a:ext cx="365760" cy="365760"/>
           </a:xfrm>
           <a:prstGeom prst="rect">
@@ -5352,8 +5352,8 @@
         </p:nvSpPr>
         <p:spPr>
           <a:xfrm>
-            <a:off x="3474720" y="2514600"/>
-            <a:ext cx="2148840" cy="685800"/>
+            <a:off x="3474720" y="2880360"/>
+            <a:ext cx="2148840" cy="640080"/>
           </a:xfrm>
           <a:prstGeom prst="rect">
             <a:avLst/>
@@ -5391,8 +5391,8 @@
         </p:nvSpPr>
         <p:spPr>
           <a:xfrm>
-            <a:off x="3520440" y="3246120"/>
-            <a:ext cx="2057400" cy="2103120"/>
+            <a:off x="3520440" y="3520440"/>
+            <a:ext cx="2057400" cy="1417320"/>
           </a:xfrm>
           <a:prstGeom prst="rect">
             <a:avLst/>
@@ -5457,8 +5457,8 @@
         </p:nvSpPr>
         <p:spPr>
           <a:xfrm>
-            <a:off x="6035040" y="1371600"/>
-            <a:ext cx="2514600" cy="4206240"/>
+            <a:off x="6035040" y="1828800"/>
+            <a:ext cx="2514600" cy="3291840"/>
           </a:xfrm>
           <a:prstGeom prst="roundRect">
             <a:avLst>
@@ -5486,7 +5486,7 @@
         </p:nvSpPr>
         <p:spPr>
           <a:xfrm>
-            <a:off x="6972300" y="1691640"/>
+            <a:off x="6972300" y="2103120"/>
             <a:ext cx="640080" cy="640080"/>
           </a:xfrm>
           <a:prstGeom prst="ellipse">
@@ -5514,7 +5514,7 @@
         </p:blipFill>
         <p:spPr>
           <a:xfrm>
-            <a:off x="7127748" y="1847088"/>
+            <a:off x="7127748" y="2258568"/>
             <a:ext cx="329184" cy="329184"/>
           </a:xfrm>
           <a:prstGeom prst="rect">
@@ -5530,7 +5530,7 @@
         </p:nvSpPr>
         <p:spPr>
           <a:xfrm>
-            <a:off x="6172200" y="1508760"/>
+            <a:off x="6172200" y="1965960"/>
             <a:ext cx="365760" cy="365760"/>
           </a:xfrm>
           <a:prstGeom prst="rect">
@@ -5569,8 +5569,8 @@
         </p:nvSpPr>
         <p:spPr>
           <a:xfrm>
-            <a:off x="6217920" y="2514600"/>
-            <a:ext cx="2148840" cy="685800"/>
+            <a:off x="6217920" y="2880360"/>
+            <a:ext cx="2148840" cy="640080"/>
           </a:xfrm>
           <a:prstGeom prst="rect">
             <a:avLst/>
@@ -5608,8 +5608,8 @@
         </p:nvSpPr>
         <p:spPr>
           <a:xfrm>
-            <a:off x="6263640" y="3246120"/>
-            <a:ext cx="2057400" cy="2103120"/>
+            <a:off x="6263640" y="3520440"/>
+            <a:ext cx="2057400" cy="1417320"/>
           </a:xfrm>
           <a:prstGeom prst="rect">
             <a:avLst/>
@@ -5674,8 +5674,8 @@
         </p:nvSpPr>
         <p:spPr>
           <a:xfrm>
-            <a:off x="8778240" y="1371600"/>
-            <a:ext cx="2514600" cy="4206240"/>
+            <a:off x="8778240" y="1828800"/>
+            <a:ext cx="2514600" cy="3291840"/>
           </a:xfrm>
           <a:prstGeom prst="roundRect">
             <a:avLst>
@@ -5703,7 +5703,7 @@
         </p:nvSpPr>
         <p:spPr>
           <a:xfrm>
-            <a:off x="9715500" y="1691640"/>
+            <a:off x="9715500" y="2103120"/>
             <a:ext cx="640080" cy="640080"/>
           </a:xfrm>
           <a:prstGeom prst="ellipse">
@@ -5731,7 +5731,7 @@
         </p:blipFill>
         <p:spPr>
           <a:xfrm>
-            <a:off x="9870948" y="1847088"/>
+            <a:off x="9870948" y="2258568"/>
             <a:ext cx="329184" cy="329184"/>
           </a:xfrm>
           <a:prstGeom prst="rect">
@@ -5747,7 +5747,7 @@
         </p:nvSpPr>
         <p:spPr>
           <a:xfrm>
-            <a:off x="8915400" y="1508760"/>
+            <a:off x="8915400" y="1965960"/>
             <a:ext cx="365760" cy="365760"/>
           </a:xfrm>
           <a:prstGeom prst="rect">
@@ -5786,8 +5786,8 @@
         </p:nvSpPr>
         <p:spPr>
           <a:xfrm>
-            <a:off x="8961120" y="2514600"/>
-            <a:ext cx="2148840" cy="685800"/>
+            <a:off x="8961120" y="2880360"/>
+            <a:ext cx="2148840" cy="640080"/>
           </a:xfrm>
           <a:prstGeom prst="rect">
             <a:avLst/>
@@ -5825,8 +5825,8 @@
         </p:nvSpPr>
         <p:spPr>
           <a:xfrm>
-            <a:off x="9006840" y="3246120"/>
-            <a:ext cx="2057400" cy="2103120"/>
+            <a:off x="9006840" y="3520440"/>
+            <a:ext cx="2057400" cy="1417320"/>
           </a:xfrm>
           <a:prstGeom prst="rect">
             <a:avLst/>
@@ -6397,12 +6397,12 @@
         </p:nvSpPr>
         <p:spPr>
           <a:xfrm>
-            <a:off x="548640" y="4160520"/>
-            <a:ext cx="7863840" cy="1600200"/>
+            <a:off x="548640" y="4114800"/>
+            <a:ext cx="7863840" cy="1417320"/>
           </a:xfrm>
           <a:prstGeom prst="roundRect">
             <a:avLst>
-              <a:gd name="adj" fmla="val 4571"/>
+              <a:gd name="adj" fmla="val 5161"/>
             </a:avLst>
           </a:prstGeom>
           <a:solidFill>
@@ -6429,7 +6429,7 @@
         </p:blipFill>
         <p:spPr>
           <a:xfrm>
-            <a:off x="868680" y="4526280"/>
+            <a:off x="868680" y="4480560"/>
             <a:ext cx="502920" cy="502920"/>
           </a:xfrm>
           <a:prstGeom prst="rect">
@@ -6445,7 +6445,7 @@
         </p:nvSpPr>
         <p:spPr>
           <a:xfrm>
-            <a:off x="1554480" y="4389120"/>
+            <a:off x="1554480" y="4343400"/>
             <a:ext cx="6492240" cy="365760"/>
           </a:xfrm>
           <a:prstGeom prst="rect">
@@ -6484,8 +6484,8 @@
         </p:nvSpPr>
         <p:spPr>
           <a:xfrm>
-            <a:off x="1554480" y="4782312"/>
-            <a:ext cx="6492240" cy="777240"/>
+            <a:off x="1554480" y="4736592"/>
+            <a:ext cx="6492240" cy="594360"/>
           </a:xfrm>
           <a:prstGeom prst="rect">
             <a:avLst/>
@@ -6527,7 +6527,7 @@
         <p:spPr>
           <a:xfrm>
             <a:off x="8686800" y="1600200"/>
-            <a:ext cx="2953512" cy="4160520"/>
+            <a:ext cx="2953512" cy="3931920"/>
           </a:xfrm>
           <a:prstGeom prst="roundRect">
             <a:avLst>
@@ -6590,7 +6590,7 @@
         <p:spPr>
           <a:xfrm>
             <a:off x="8915400" y="2194560"/>
-            <a:ext cx="2496312" cy="3337560"/>
+            <a:ext cx="2496312" cy="3108960"/>
           </a:xfrm>
           <a:prstGeom prst="rect">
             <a:avLst/>
@@ -7317,11 +7317,11 @@
         <p:spPr>
           <a:xfrm>
             <a:off x="7178040" y="1554480"/>
-            <a:ext cx="4462272" cy="3017520"/>
+            <a:ext cx="4462272" cy="2514600"/>
           </a:xfrm>
           <a:prstGeom prst="roundRect">
             <a:avLst>
-              <a:gd name="adj" fmla="val 2424"/>
+              <a:gd name="adj" fmla="val 2909"/>
             </a:avLst>
           </a:prstGeom>
           <a:solidFill>
@@ -7734,16 +7734,16 @@
         </p:nvSpPr>
         <p:spPr>
           <a:xfrm>
-            <a:off x="822960" y="1600200"/>
-            <a:ext cx="3383280" cy="3291840"/>
+            <a:off x="822960" y="1691640"/>
+            <a:ext cx="3383280" cy="2743200"/>
           </a:xfrm>
           <a:prstGeom prst="roundRect">
             <a:avLst>
-              <a:gd name="adj" fmla="val 2778"/>
+              <a:gd name="adj" fmla="val 3333"/>
             </a:avLst>
           </a:prstGeom>
           <a:solidFill>
-            <a:srgbClr val="F96167"/>
+            <a:srgbClr val="E63946"/>
           </a:solidFill>
           <a:ln/>
         </p:spPr>
@@ -7756,8 +7756,8 @@
         </p:nvSpPr>
         <p:spPr>
           <a:xfrm>
-            <a:off x="2103120" y="1920240"/>
-            <a:ext cx="822960" cy="822960"/>
+            <a:off x="2148840" y="1965960"/>
+            <a:ext cx="731520" cy="731520"/>
           </a:xfrm>
           <a:prstGeom prst="ellipse">
             <a:avLst/>
@@ -7784,8 +7784,8 @@
         </p:blipFill>
         <p:spPr>
           <a:xfrm>
-            <a:off x="2286000" y="2103120"/>
-            <a:ext cx="457200" cy="457200"/>
+            <a:off x="2313432" y="2130552"/>
+            <a:ext cx="402336" cy="402336"/>
           </a:xfrm>
           <a:prstGeom prst="rect">
             <a:avLst/>
@@ -7800,8 +7800,8 @@
         </p:nvSpPr>
         <p:spPr>
           <a:xfrm>
-            <a:off x="822960" y="2880360"/>
-            <a:ext cx="3383280" cy="457200"/>
+            <a:off x="822960" y="2834640"/>
+            <a:ext cx="3383280" cy="365760"/>
           </a:xfrm>
           <a:prstGeom prst="rect">
             <a:avLst/>
@@ -7839,8 +7839,8 @@
         </p:nvSpPr>
         <p:spPr>
           <a:xfrm>
-            <a:off x="1097280" y="3429000"/>
-            <a:ext cx="2834640" cy="1280160"/>
+            <a:off x="1097280" y="3291840"/>
+            <a:ext cx="2834640" cy="1005840"/>
           </a:xfrm>
           <a:prstGeom prst="rect">
             <a:avLst/>
@@ -7854,10 +7854,10 @@
           <a:p>
             <a:pPr algn="ctr" indent="0" marL="0">
               <a:lnSpc>
-                <a:spcPct val="120000"/>
+                <a:spcPct val="125000"/>
               </a:lnSpc>
               <a:spcAft>
-                <a:spcPts val="300"/>
+                <a:spcPts val="600"/>
               </a:spcAft>
               <a:buNone/>
             </a:pPr>
@@ -7877,10 +7877,10 @@
           <a:p>
             <a:pPr algn="ctr" indent="0" marL="0">
               <a:lnSpc>
-                <a:spcPct val="120000"/>
+                <a:spcPct val="125000"/>
               </a:lnSpc>
               <a:spcAft>
-                <a:spcPts val="300"/>
+                <a:spcPts val="600"/>
               </a:spcAft>
               <a:buNone/>
             </a:pPr>
@@ -7900,56 +7900,33 @@
           <a:p>
             <a:pPr algn="ctr" indent="0" marL="0">
               <a:lnSpc>
-                <a:spcPct val="120000"/>
+                <a:spcPct val="125000"/>
               </a:lnSpc>
               <a:spcAft>
-                <a:spcPts val="300"/>
+                <a:spcPts val="600"/>
               </a:spcAft>
               <a:buNone/>
             </a:pPr>
             <a:r>
-              <a:rPr lang="en-US" sz="1200" dirty="0">
-                <a:solidFill>
-                  <a:srgbClr val="000000"/>
+              <a:rPr lang="en-US" sz="1200" b="1" dirty="0">
+                <a:solidFill>
+                  <a:srgbClr val="FFFFFF"/>
                 </a:solidFill>
                 <a:latin typeface="Calibri" pitchFamily="34" charset="0"/>
                 <a:ea typeface="Calibri" pitchFamily="34" charset="-122"/>
                 <a:cs typeface="Calibri" pitchFamily="34" charset="-120"/>
               </a:rPr>
-              <a:t> </a:t>
+              <a:t>URL Scheme</a:t>
             </a:r>
             <a:endParaRPr lang="en-US" sz="1200" dirty="0"/>
           </a:p>
           <a:p>
             <a:pPr algn="ctr" indent="0" marL="0">
               <a:lnSpc>
-                <a:spcPct val="120000"/>
+                <a:spcPct val="125000"/>
               </a:lnSpc>
               <a:spcAft>
-                <a:spcPts val="300"/>
-              </a:spcAft>
-              <a:buNone/>
-            </a:pPr>
-            <a:r>
-              <a:rPr lang="en-US" sz="1200" b="1" dirty="0">
-                <a:solidFill>
-                  <a:srgbClr val="FFFFFF"/>
-                </a:solidFill>
-                <a:latin typeface="Calibri" pitchFamily="34" charset="0"/>
-                <a:ea typeface="Calibri" pitchFamily="34" charset="-122"/>
-                <a:cs typeface="Calibri" pitchFamily="34" charset="-120"/>
-              </a:rPr>
-              <a:t>URL Scheme</a:t>
-            </a:r>
-            <a:endParaRPr lang="en-US" sz="1200" dirty="0"/>
-          </a:p>
-          <a:p>
-            <a:pPr algn="ctr" indent="0" marL="0">
-              <a:lnSpc>
-                <a:spcPct val="120000"/>
-              </a:lnSpc>
-              <a:spcAft>
-                <a:spcPts val="300"/>
+                <a:spcPts val="600"/>
               </a:spcAft>
               <a:buNone/>
             </a:pPr>
@@ -7976,16 +7953,16 @@
         </p:nvSpPr>
         <p:spPr>
           <a:xfrm>
-            <a:off x="4526280" y="1600200"/>
-            <a:ext cx="3383280" cy="3291840"/>
+            <a:off x="4526280" y="1691640"/>
+            <a:ext cx="3383280" cy="2743200"/>
           </a:xfrm>
           <a:prstGeom prst="roundRect">
             <a:avLst>
-              <a:gd name="adj" fmla="val 2778"/>
+              <a:gd name="adj" fmla="val 3333"/>
             </a:avLst>
           </a:prstGeom>
           <a:solidFill>
-            <a:srgbClr val="065A82"/>
+            <a:srgbClr val="1D3557"/>
           </a:solidFill>
           <a:ln/>
         </p:spPr>
@@ -7998,8 +7975,8 @@
         </p:nvSpPr>
         <p:spPr>
           <a:xfrm>
-            <a:off x="5806440" y="1920240"/>
-            <a:ext cx="822960" cy="822960"/>
+            <a:off x="5852160" y="1965960"/>
+            <a:ext cx="731520" cy="731520"/>
           </a:xfrm>
           <a:prstGeom prst="ellipse">
             <a:avLst/>
@@ -8026,8 +8003,8 @@
         </p:blipFill>
         <p:spPr>
           <a:xfrm>
-            <a:off x="5989320" y="2103120"/>
-            <a:ext cx="457200" cy="457200"/>
+            <a:off x="6016752" y="2130552"/>
+            <a:ext cx="402336" cy="402336"/>
           </a:xfrm>
           <a:prstGeom prst="rect">
             <a:avLst/>
@@ -8042,8 +8019,8 @@
         </p:nvSpPr>
         <p:spPr>
           <a:xfrm>
-            <a:off x="4526280" y="2880360"/>
-            <a:ext cx="3383280" cy="457200"/>
+            <a:off x="4526280" y="2834640"/>
+            <a:ext cx="3383280" cy="365760"/>
           </a:xfrm>
           <a:prstGeom prst="rect">
             <a:avLst/>
@@ -8081,8 +8058,8 @@
         </p:nvSpPr>
         <p:spPr>
           <a:xfrm>
-            <a:off x="4800600" y="3429000"/>
-            <a:ext cx="2834640" cy="1280160"/>
+            <a:off x="4800600" y="3291840"/>
+            <a:ext cx="2834640" cy="1005840"/>
           </a:xfrm>
           <a:prstGeom prst="rect">
             <a:avLst/>
@@ -8096,10 +8073,10 @@
           <a:p>
             <a:pPr algn="ctr" indent="0" marL="0">
               <a:lnSpc>
-                <a:spcPct val="120000"/>
+                <a:spcPct val="125000"/>
               </a:lnSpc>
               <a:spcAft>
-                <a:spcPts val="300"/>
+                <a:spcPts val="600"/>
               </a:spcAft>
               <a:buNone/>
             </a:pPr>
@@ -8119,10 +8096,10 @@
           <a:p>
             <a:pPr algn="ctr" indent="0" marL="0">
               <a:lnSpc>
-                <a:spcPct val="120000"/>
+                <a:spcPct val="125000"/>
               </a:lnSpc>
               <a:spcAft>
-                <a:spcPts val="300"/>
+                <a:spcPts val="600"/>
               </a:spcAft>
               <a:buNone/>
             </a:pPr>
@@ -8142,56 +8119,33 @@
           <a:p>
             <a:pPr algn="ctr" indent="0" marL="0">
               <a:lnSpc>
-                <a:spcPct val="120000"/>
+                <a:spcPct val="125000"/>
               </a:lnSpc>
               <a:spcAft>
-                <a:spcPts val="300"/>
+                <a:spcPts val="600"/>
               </a:spcAft>
               <a:buNone/>
             </a:pPr>
             <a:r>
-              <a:rPr lang="en-US" sz="1200" dirty="0">
-                <a:solidFill>
-                  <a:srgbClr val="000000"/>
+              <a:rPr lang="en-US" sz="1200" b="1" dirty="0">
+                <a:solidFill>
+                  <a:srgbClr val="FFFFFF"/>
                 </a:solidFill>
                 <a:latin typeface="Calibri" pitchFamily="34" charset="0"/>
                 <a:ea typeface="Calibri" pitchFamily="34" charset="-122"/>
                 <a:cs typeface="Calibri" pitchFamily="34" charset="-120"/>
               </a:rPr>
-              <a:t> </a:t>
+              <a:t>URL Scheme</a:t>
             </a:r>
             <a:endParaRPr lang="en-US" sz="1200" dirty="0"/>
           </a:p>
           <a:p>
             <a:pPr algn="ctr" indent="0" marL="0">
               <a:lnSpc>
-                <a:spcPct val="120000"/>
+                <a:spcPct val="125000"/>
               </a:lnSpc>
               <a:spcAft>
-                <a:spcPts val="300"/>
-              </a:spcAft>
-              <a:buNone/>
-            </a:pPr>
-            <a:r>
-              <a:rPr lang="en-US" sz="1200" b="1" dirty="0">
-                <a:solidFill>
-                  <a:srgbClr val="FFFFFF"/>
-                </a:solidFill>
-                <a:latin typeface="Calibri" pitchFamily="34" charset="0"/>
-                <a:ea typeface="Calibri" pitchFamily="34" charset="-122"/>
-                <a:cs typeface="Calibri" pitchFamily="34" charset="-120"/>
-              </a:rPr>
-              <a:t>URL Scheme</a:t>
-            </a:r>
-            <a:endParaRPr lang="en-US" sz="1200" dirty="0"/>
-          </a:p>
-          <a:p>
-            <a:pPr algn="ctr" indent="0" marL="0">
-              <a:lnSpc>
-                <a:spcPct val="120000"/>
-              </a:lnSpc>
-              <a:spcAft>
-                <a:spcPts val="300"/>
+                <a:spcPts val="600"/>
               </a:spcAft>
               <a:buNone/>
             </a:pPr>
@@ -8218,16 +8172,16 @@
         </p:nvSpPr>
         <p:spPr>
           <a:xfrm>
-            <a:off x="8229600" y="1600200"/>
-            <a:ext cx="3383280" cy="3291840"/>
+            <a:off x="8229600" y="1691640"/>
+            <a:ext cx="3383280" cy="2743200"/>
           </a:xfrm>
           <a:prstGeom prst="roundRect">
             <a:avLst>
-              <a:gd name="adj" fmla="val 2778"/>
+              <a:gd name="adj" fmla="val 3333"/>
             </a:avLst>
           </a:prstGeom>
           <a:solidFill>
-            <a:srgbClr val="1C7293"/>
+            <a:srgbClr val="2A9D8F"/>
           </a:solidFill>
           <a:ln/>
         </p:spPr>
@@ -8240,8 +8194,8 @@
         </p:nvSpPr>
         <p:spPr>
           <a:xfrm>
-            <a:off x="9509760" y="1920240"/>
-            <a:ext cx="822960" cy="822960"/>
+            <a:off x="9555480" y="1965960"/>
+            <a:ext cx="731520" cy="731520"/>
           </a:xfrm>
           <a:prstGeom prst="ellipse">
             <a:avLst/>
@@ -8268,8 +8222,8 @@
         </p:blipFill>
         <p:spPr>
           <a:xfrm>
-            <a:off x="9692640" y="2103120"/>
-            <a:ext cx="457200" cy="457200"/>
+            <a:off x="9720072" y="2130552"/>
+            <a:ext cx="402336" cy="402336"/>
           </a:xfrm>
           <a:prstGeom prst="rect">
             <a:avLst/>
@@ -8284,8 +8238,8 @@
         </p:nvSpPr>
         <p:spPr>
           <a:xfrm>
-            <a:off x="8229600" y="2880360"/>
-            <a:ext cx="3383280" cy="457200"/>
+            <a:off x="8229600" y="2834640"/>
+            <a:ext cx="3383280" cy="365760"/>
           </a:xfrm>
           <a:prstGeom prst="rect">
             <a:avLst/>
@@ -8323,8 +8277,8 @@
         </p:nvSpPr>
         <p:spPr>
           <a:xfrm>
-            <a:off x="8503920" y="3429000"/>
-            <a:ext cx="2834640" cy="1280160"/>
+            <a:off x="8503920" y="3291840"/>
+            <a:ext cx="2834640" cy="1005840"/>
           </a:xfrm>
           <a:prstGeom prst="rect">
             <a:avLst/>
@@ -8338,10 +8292,10 @@
           <a:p>
             <a:pPr algn="ctr" indent="0" marL="0">
               <a:lnSpc>
-                <a:spcPct val="120000"/>
+                <a:spcPct val="125000"/>
               </a:lnSpc>
               <a:spcAft>
-                <a:spcPts val="300"/>
+                <a:spcPts val="600"/>
               </a:spcAft>
               <a:buNone/>
             </a:pPr>
@@ -8361,10 +8315,10 @@
           <a:p>
             <a:pPr algn="ctr" indent="0" marL="0">
               <a:lnSpc>
-                <a:spcPct val="120000"/>
+                <a:spcPct val="125000"/>
               </a:lnSpc>
               <a:spcAft>
-                <a:spcPts val="300"/>
+                <a:spcPts val="600"/>
               </a:spcAft>
               <a:buNone/>
             </a:pPr>
@@ -8384,56 +8338,33 @@
           <a:p>
             <a:pPr algn="ctr" indent="0" marL="0">
               <a:lnSpc>
-                <a:spcPct val="120000"/>
+                <a:spcPct val="125000"/>
               </a:lnSpc>
               <a:spcAft>
-                <a:spcPts val="300"/>
+                <a:spcPts val="600"/>
               </a:spcAft>
               <a:buNone/>
             </a:pPr>
             <a:r>
-              <a:rPr lang="en-US" sz="1200" dirty="0">
-                <a:solidFill>
-                  <a:srgbClr val="000000"/>
+              <a:rPr lang="en-US" sz="1200" b="1" dirty="0">
+                <a:solidFill>
+                  <a:srgbClr val="FFFFFF"/>
                 </a:solidFill>
                 <a:latin typeface="Calibri" pitchFamily="34" charset="0"/>
                 <a:ea typeface="Calibri" pitchFamily="34" charset="-122"/>
                 <a:cs typeface="Calibri" pitchFamily="34" charset="-120"/>
               </a:rPr>
-              <a:t> </a:t>
+              <a:t>URL Scheme</a:t>
             </a:r>
             <a:endParaRPr lang="en-US" sz="1200" dirty="0"/>
           </a:p>
           <a:p>
             <a:pPr algn="ctr" indent="0" marL="0">
               <a:lnSpc>
-                <a:spcPct val="120000"/>
+                <a:spcPct val="125000"/>
               </a:lnSpc>
               <a:spcAft>
-                <a:spcPts val="300"/>
-              </a:spcAft>
-              <a:buNone/>
-            </a:pPr>
-            <a:r>
-              <a:rPr lang="en-US" sz="1200" b="1" dirty="0">
-                <a:solidFill>
-                  <a:srgbClr val="FFFFFF"/>
-                </a:solidFill>
-                <a:latin typeface="Calibri" pitchFamily="34" charset="0"/>
-                <a:ea typeface="Calibri" pitchFamily="34" charset="-122"/>
-                <a:cs typeface="Calibri" pitchFamily="34" charset="-120"/>
-              </a:rPr>
-              <a:t>URL Scheme</a:t>
-            </a:r>
-            <a:endParaRPr lang="en-US" sz="1200" dirty="0"/>
-          </a:p>
-          <a:p>
-            <a:pPr algn="ctr" indent="0" marL="0">
-              <a:lnSpc>
-                <a:spcPct val="120000"/>
-              </a:lnSpc>
-              <a:spcAft>
-                <a:spcPts val="300"/>
+                <a:spcPts val="600"/>
               </a:spcAft>
               <a:buNone/>
             </a:pPr>
@@ -8460,7 +8391,7 @@
         </p:nvSpPr>
         <p:spPr>
           <a:xfrm>
-            <a:off x="822960" y="5166360"/>
+            <a:off x="822960" y="4754880"/>
             <a:ext cx="10543032" cy="1234440"/>
           </a:xfrm>
           <a:prstGeom prst="roundRect">
@@ -8492,7 +8423,7 @@
         </p:blipFill>
         <p:spPr>
           <a:xfrm>
-            <a:off x="1097280" y="5486400"/>
+            <a:off x="1097280" y="5074920"/>
             <a:ext cx="502920" cy="502920"/>
           </a:xfrm>
           <a:prstGeom prst="rect">
@@ -8508,7 +8439,7 @@
         </p:nvSpPr>
         <p:spPr>
           <a:xfrm>
-            <a:off x="1737360" y="5330952"/>
+            <a:off x="1737360" y="4919472"/>
             <a:ext cx="4572000" cy="365760"/>
           </a:xfrm>
           <a:prstGeom prst="rect">
@@ -8547,7 +8478,7 @@
         </p:nvSpPr>
         <p:spPr>
           <a:xfrm>
-            <a:off x="1737360" y="5678424"/>
+            <a:off x="1737360" y="5266944"/>
             <a:ext cx="9262872" cy="640080"/>
           </a:xfrm>
           <a:prstGeom prst="rect">
@@ -8660,12 +8591,12 @@
         </p:nvSpPr>
         <p:spPr>
           <a:xfrm>
-            <a:off x="548640" y="1371600"/>
-            <a:ext cx="5349240" cy="4846320"/>
+            <a:off x="548640" y="1463040"/>
+            <a:ext cx="5349240" cy="4206240"/>
           </a:xfrm>
           <a:prstGeom prst="roundRect">
             <a:avLst>
-              <a:gd name="adj" fmla="val 1509"/>
+              <a:gd name="adj" fmla="val 1739"/>
             </a:avLst>
           </a:prstGeom>
           <a:solidFill>
@@ -8689,7 +8620,7 @@
         </p:nvSpPr>
         <p:spPr>
           <a:xfrm>
-            <a:off x="822960" y="1645920"/>
+            <a:off x="822960" y="1737360"/>
             <a:ext cx="594360" cy="594360"/>
           </a:xfrm>
           <a:prstGeom prst="ellipse">
@@ -8717,7 +8648,7 @@
         </p:blipFill>
         <p:spPr>
           <a:xfrm>
-            <a:off x="978408" y="1801368"/>
+            <a:off x="978408" y="1892808"/>
             <a:ext cx="283464" cy="283464"/>
           </a:xfrm>
           <a:prstGeom prst="rect">
@@ -8733,7 +8664,7 @@
         </p:nvSpPr>
         <p:spPr>
           <a:xfrm>
-            <a:off x="1554480" y="1737360"/>
+            <a:off x="1554480" y="1828800"/>
             <a:ext cx="4069080" cy="457200"/>
           </a:xfrm>
           <a:prstGeom prst="rect">
@@ -8772,8 +8703,8 @@
         </p:nvSpPr>
         <p:spPr>
           <a:xfrm>
-            <a:off x="868680" y="2514600"/>
-            <a:ext cx="4709160" cy="3474720"/>
+            <a:off x="868680" y="2606040"/>
+            <a:ext cx="4709160" cy="2834640"/>
           </a:xfrm>
           <a:prstGeom prst="rect">
             <a:avLst/>
@@ -8938,12 +8869,12 @@
         </p:nvSpPr>
         <p:spPr>
           <a:xfrm>
-            <a:off x="6263640" y="1371600"/>
-            <a:ext cx="5349240" cy="4846320"/>
+            <a:off x="6263640" y="1463040"/>
+            <a:ext cx="5349240" cy="4206240"/>
           </a:xfrm>
           <a:prstGeom prst="roundRect">
             <a:avLst>
-              <a:gd name="adj" fmla="val 1509"/>
+              <a:gd name="adj" fmla="val 1739"/>
             </a:avLst>
           </a:prstGeom>
           <a:solidFill>
@@ -8967,7 +8898,7 @@
         </p:nvSpPr>
         <p:spPr>
           <a:xfrm>
-            <a:off x="6537960" y="1645920"/>
+            <a:off x="6537960" y="1737360"/>
             <a:ext cx="594360" cy="594360"/>
           </a:xfrm>
           <a:prstGeom prst="ellipse">
@@ -8995,7 +8926,7 @@
         </p:blipFill>
         <p:spPr>
           <a:xfrm>
-            <a:off x="6693408" y="1801368"/>
+            <a:off x="6693408" y="1892808"/>
             <a:ext cx="283464" cy="283464"/>
           </a:xfrm>
           <a:prstGeom prst="rect">
@@ -9011,7 +8942,7 @@
         </p:nvSpPr>
         <p:spPr>
           <a:xfrm>
-            <a:off x="7269480" y="1737360"/>
+            <a:off x="7269480" y="1828800"/>
             <a:ext cx="4069080" cy="457200"/>
           </a:xfrm>
           <a:prstGeom prst="rect">
@@ -9050,8 +8981,8 @@
         </p:nvSpPr>
         <p:spPr>
           <a:xfrm>
-            <a:off x="6583680" y="2514600"/>
-            <a:ext cx="4709160" cy="3474720"/>
+            <a:off x="6583680" y="2606040"/>
+            <a:ext cx="4709160" cy="2834640"/>
           </a:xfrm>
           <a:prstGeom prst="rect">
             <a:avLst/>

</xml_diff>

<commit_message>
Update deck: add App Link verification experiment, explain why each platform's flow works the way it does
- New slide: "Why not just verify the Android App Link?" — documents
  the on-device test (all 3 apps verified, but no chooser appeared;
  Android silently opened the most-recently-installed verified app
  instead) and the conclusion that verification and the disambiguation
  dialog are mutually exclusive by design.
- Android and iOS flow slides now state the underlying "why" up front
  (unverified link / no Universal Link record) instead of just the
  "what happens" steps.
- iOS flow slide gained a callout explaining what would skip the
  picker page (a hosted apple-app-site-association + Associated
  Domains entitlement) and why we don't host one.
- Closing and Real-vs-Simulated slides updated to reference the actual
  verification test instead of a hypothetical.
- Reduced excess whitespace in card layouts (slides 2, 3, 5, 7).
</commit_message>
<xml_diff>
--- a/SGQR_Deep_Linking_Simulation.pptx
+++ b/SGQR_Deep_Linking_Simulation.pptx
@@ -15,9 +15,10 @@
     <p:sldId id="263" r:id="rId9"/>
     <p:sldId id="264" r:id="rId10"/>
     <p:sldId id="265" r:id="rId11"/>
+    <p:sldId id="266" r:id="rId12"/>
   </p:sldIdLst>
   <p:notesMasterIdLst>
-    <p:notesMasterId r:id="rId12"/>
+    <p:notesMasterId r:id="rId13"/>
   </p:notesMasterIdLst>
   <p:sldSz cx="12192000" cy="6858000"/>
   <p:notesSz cx="6858000" cy="12192000"/>
@@ -623,6 +624,94 @@
             <a:fld id="{F7021451-1387-4CA6-816F-3879F97B5CBC}" type="slidenum">
               <a:rPr lang="en-US"/>
               <a:t>10</a:t>
+            </a:fld>
+            <a:endParaRPr lang="en-US"/>
+          </a:p>
+        </p:txBody>
+      </p:sp>
+    </p:spTree>
+    <p:extLst>
+      <p:ext uri="{BB962C8B-B14F-4D97-AF65-F5344CB8AC3E}">
+        <p14:creationId xmlns:p14="http://schemas.microsoft.com/office/powerpoint/2010/main" val="1024086991"/>
+      </p:ext>
+    </p:extLst>
+  </p:cSld>
+  <p:clrMapOvr>
+    <a:masterClrMapping/>
+  </p:clrMapOvr>
+</p:notes>
+</file>
+
+<file path=ppt/notesSlides/notesSlide11.xml><?xml version="1.0" encoding="utf-8"?>
+<p:notes xmlns:a="http://schemas.openxmlformats.org/drawingml/2006/main" xmlns:r="http://schemas.openxmlformats.org/officeDocument/2006/relationships" xmlns:p="http://schemas.openxmlformats.org/presentationml/2006/main">
+  <p:cSld>
+    <p:spTree>
+      <p:nvGrpSpPr>
+        <p:cNvPr id="1" name=""/>
+        <p:cNvGrpSpPr/>
+        <p:nvPr/>
+      </p:nvGrpSpPr>
+      <p:grpSpPr>
+        <a:xfrm>
+          <a:off x="0" y="0"/>
+          <a:ext cx="0" cy="0"/>
+          <a:chOff x="0" y="0"/>
+          <a:chExt cx="0" cy="0"/>
+        </a:xfrm>
+      </p:grpSpPr>
+      <p:sp>
+        <p:nvSpPr>
+          <p:cNvPr id="2" name="Slide Image Placeholder 1"/>
+          <p:cNvSpPr>
+            <a:spLocks noGrp="1" noRot="1" noChangeAspect="1"/>
+          </p:cNvSpPr>
+          <p:nvPr>
+            <p:ph type="sldImg"/>
+          </p:nvPr>
+        </p:nvSpPr>
+        <p:spPr/>
+      </p:sp>
+      <p:sp>
+        <p:nvSpPr>
+          <p:cNvPr id="3" name="Notes Placeholder 2"/>
+          <p:cNvSpPr>
+            <a:spLocks noGrp="1"/>
+          </p:cNvSpPr>
+          <p:nvPr>
+            <p:ph type="body" idx="1"/>
+          </p:nvPr>
+        </p:nvSpPr>
+        <p:spPr/>
+        <p:txBody>
+          <a:bodyPr/>
+          <a:lstStyle/>
+          <a:p>
+            <a:r>
+              <a:rPr lang="en-US" dirty="0"/>
+              <a:t/>
+            </a:r>
+            <a:endParaRPr lang="en-US" dirty="0"/>
+          </a:p>
+        </p:txBody>
+      </p:sp>
+      <p:sp>
+        <p:nvSpPr>
+          <p:cNvPr id="4" name="Slide Number Placeholder 3"/>
+          <p:cNvSpPr>
+            <a:spLocks noGrp="1"/>
+          </p:cNvSpPr>
+          <p:nvPr>
+            <p:ph type="sldNum" sz="quarter" idx="10"/>
+          </p:nvPr>
+        </p:nvSpPr>
+        <p:spPr/>
+        <p:txBody>
+          <a:bodyPr/>
+          <a:lstStyle/>
+          <a:p>
+            <a:fld id="{F7021451-1387-4CA6-816F-3879F97B5CBC}" type="slidenum">
+              <a:rPr lang="en-US"/>
+              <a:t>11</a:t>
             </a:fld>
             <a:endParaRPr lang="en-US"/>
           </a:p>
@@ -2249,6 +2338,585 @@
     <p:bg>
       <p:bgPr>
         <a:solidFill>
+          <a:srgbClr val="F5F8FA"/>
+        </a:solidFill>
+      </p:bgPr>
+    </p:bg>
+    <p:spTree>
+      <p:nvGrpSpPr>
+        <p:cNvPr id="1" name=""/>
+        <p:cNvGrpSpPr/>
+        <p:nvPr/>
+      </p:nvGrpSpPr>
+      <p:grpSpPr>
+        <a:xfrm>
+          <a:off x="0" y="0"/>
+          <a:ext cx="0" cy="0"/>
+          <a:chOff x="0" y="0"/>
+          <a:chExt cx="0" cy="0"/>
+        </a:xfrm>
+      </p:grpSpPr>
+      <p:sp>
+        <p:nvSpPr>
+          <p:cNvPr id="2" name="Text 0"/>
+          <p:cNvSpPr/>
+          <p:nvPr/>
+        </p:nvSpPr>
+        <p:spPr>
+          <a:xfrm>
+            <a:off x="548640" y="411480"/>
+            <a:ext cx="9144000" cy="548640"/>
+          </a:xfrm>
+          <a:prstGeom prst="rect">
+            <a:avLst/>
+          </a:prstGeom>
+          <a:noFill/>
+          <a:ln/>
+        </p:spPr>
+        <p:txBody>
+          <a:bodyPr wrap="square" lIns="0" tIns="0" rIns="0" bIns="0" rtlCol="0" anchor="ctr"/>
+          <a:lstStyle/>
+          <a:p>
+            <a:pPr indent="0" marL="0">
+              <a:buNone/>
+            </a:pPr>
+            <a:r>
+              <a:rPr lang="en-US" sz="3000" b="1" dirty="0">
+                <a:solidFill>
+                  <a:srgbClr val="1A2233"/>
+                </a:solidFill>
+                <a:latin typeface="Cambria" pitchFamily="34" charset="0"/>
+                <a:ea typeface="Cambria" pitchFamily="34" charset="-122"/>
+                <a:cs typeface="Cambria" pitchFamily="34" charset="-120"/>
+              </a:rPr>
+              <a:t>What's real, what's simulated</a:t>
+            </a:r>
+            <a:endParaRPr lang="en-US" sz="3000" dirty="0"/>
+          </a:p>
+        </p:txBody>
+      </p:sp>
+      <p:sp>
+        <p:nvSpPr>
+          <p:cNvPr id="3" name="Shape 1"/>
+          <p:cNvSpPr/>
+          <p:nvPr/>
+        </p:nvSpPr>
+        <p:spPr>
+          <a:xfrm>
+            <a:off x="548640" y="1463040"/>
+            <a:ext cx="5349240" cy="4206240"/>
+          </a:xfrm>
+          <a:prstGeom prst="roundRect">
+            <a:avLst>
+              <a:gd name="adj" fmla="val 1739"/>
+            </a:avLst>
+          </a:prstGeom>
+          <a:solidFill>
+            <a:srgbClr val="FFFFFF"/>
+          </a:solidFill>
+          <a:ln/>
+          <a:effectLst>
+            <a:outerShdw sx="100000" sy="100000" kx="0" ky="0" algn="bl" rotWithShape="0" blurRad="101600" dist="38100" dir="2700000">
+              <a:srgbClr val="000000">
+                <a:alpha val="12000"/>
+              </a:srgbClr>
+            </a:outerShdw>
+          </a:effectLst>
+        </p:spPr>
+      </p:sp>
+      <p:sp>
+        <p:nvSpPr>
+          <p:cNvPr id="4" name="Shape 2"/>
+          <p:cNvSpPr/>
+          <p:nvPr/>
+        </p:nvSpPr>
+        <p:spPr>
+          <a:xfrm>
+            <a:off x="822960" y="1737360"/>
+            <a:ext cx="594360" cy="594360"/>
+          </a:xfrm>
+          <a:prstGeom prst="ellipse">
+            <a:avLst/>
+          </a:prstGeom>
+          <a:solidFill>
+            <a:srgbClr val="1C7293"/>
+          </a:solidFill>
+          <a:ln/>
+        </p:spPr>
+      </p:sp>
+      <p:pic>
+        <p:nvPicPr>
+          <p:cNvPr id="5" name="Image 0" descr="preencoded.png">    </p:cNvPr>
+          <p:cNvPicPr>
+            <a:picLocks noChangeAspect="1"/>
+          </p:cNvPicPr>
+          <p:nvPr/>
+        </p:nvPicPr>
+        <p:blipFill>
+          <a:blip r:embed="rId1"/>
+          <a:stretch>
+            <a:fillRect/>
+          </a:stretch>
+        </p:blipFill>
+        <p:spPr>
+          <a:xfrm>
+            <a:off x="978408" y="1892808"/>
+            <a:ext cx="283464" cy="283464"/>
+          </a:xfrm>
+          <a:prstGeom prst="rect">
+            <a:avLst/>
+          </a:prstGeom>
+        </p:spPr>
+      </p:pic>
+      <p:sp>
+        <p:nvSpPr>
+          <p:cNvPr id="6" name="Text 3"/>
+          <p:cNvSpPr/>
+          <p:nvPr/>
+        </p:nvSpPr>
+        <p:spPr>
+          <a:xfrm>
+            <a:off x="1554480" y="1828800"/>
+            <a:ext cx="4069080" cy="457200"/>
+          </a:xfrm>
+          <a:prstGeom prst="rect">
+            <a:avLst/>
+          </a:prstGeom>
+          <a:noFill/>
+          <a:ln/>
+        </p:spPr>
+        <p:txBody>
+          <a:bodyPr wrap="square" lIns="0" tIns="0" rIns="0" bIns="0" rtlCol="0" anchor="ctr"/>
+          <a:lstStyle/>
+          <a:p>
+            <a:pPr indent="0" marL="0">
+              <a:buNone/>
+            </a:pPr>
+            <a:r>
+              <a:rPr lang="en-US" sz="1900" b="1" dirty="0">
+                <a:solidFill>
+                  <a:srgbClr val="1A2233"/>
+                </a:solidFill>
+                <a:latin typeface="Cambria" pitchFamily="34" charset="0"/>
+                <a:ea typeface="Cambria" pitchFamily="34" charset="-122"/>
+                <a:cs typeface="Cambria" pitchFamily="34" charset="-120"/>
+              </a:rPr>
+              <a:t>Real</a:t>
+            </a:r>
+            <a:endParaRPr lang="en-US" sz="1900" dirty="0"/>
+          </a:p>
+        </p:txBody>
+      </p:sp>
+      <p:sp>
+        <p:nvSpPr>
+          <p:cNvPr id="7" name="Text 4"/>
+          <p:cNvSpPr/>
+          <p:nvPr/>
+        </p:nvSpPr>
+        <p:spPr>
+          <a:xfrm>
+            <a:off x="868680" y="2606040"/>
+            <a:ext cx="4709160" cy="2834640"/>
+          </a:xfrm>
+          <a:prstGeom prst="rect">
+            <a:avLst/>
+          </a:prstGeom>
+          <a:noFill/>
+          <a:ln/>
+        </p:spPr>
+        <p:txBody>
+          <a:bodyPr wrap="square" lIns="0" tIns="0" rIns="0" bIns="0" rtlCol="0" anchor="ctr"/>
+          <a:lstStyle/>
+          <a:p>
+            <a:pPr marL="342900" indent="-342900">
+              <a:lnSpc>
+                <a:spcPct val="125000"/>
+              </a:lnSpc>
+              <a:spcAft>
+                <a:spcPts val="1000"/>
+              </a:spcAft>
+              <a:buSzPct val="100000"/>
+              <a:buChar char="•"/>
+            </a:pPr>
+            <a:r>
+              <a:rPr lang="en-US" sz="1300" dirty="0">
+                <a:solidFill>
+                  <a:srgbClr val="1A2233"/>
+                </a:solidFill>
+                <a:latin typeface="Calibri" pitchFamily="34" charset="0"/>
+                <a:ea typeface="Calibri" pitchFamily="34" charset="-122"/>
+                <a:cs typeface="Calibri" pitchFamily="34" charset="-120"/>
+              </a:rPr>
+              <a:t>Every network request (create, fetch, and pay)</a:t>
+            </a:r>
+            <a:endParaRPr lang="en-US" sz="1300" dirty="0"/>
+          </a:p>
+          <a:p>
+            <a:pPr marL="342900" indent="-342900">
+              <a:lnSpc>
+                <a:spcPct val="125000"/>
+              </a:lnSpc>
+              <a:spcAft>
+                <a:spcPts val="1000"/>
+              </a:spcAft>
+              <a:buSzPct val="100000"/>
+              <a:buChar char="•"/>
+            </a:pPr>
+            <a:r>
+              <a:rPr lang="en-US" sz="1300" dirty="0">
+                <a:solidFill>
+                  <a:srgbClr val="1A2233"/>
+                </a:solidFill>
+                <a:latin typeface="Calibri" pitchFamily="34" charset="0"/>
+                <a:ea typeface="Calibri" pitchFamily="34" charset="-122"/>
+                <a:cs typeface="Calibri" pitchFamily="34" charset="-120"/>
+              </a:rPr>
+              <a:t>The QR code and the actual link resolution on each phone</a:t>
+            </a:r>
+            <a:endParaRPr lang="en-US" sz="1300" dirty="0"/>
+          </a:p>
+          <a:p>
+            <a:pPr marL="342900" indent="-342900">
+              <a:lnSpc>
+                <a:spcPct val="125000"/>
+              </a:lnSpc>
+              <a:spcAft>
+                <a:spcPts val="1000"/>
+              </a:spcAft>
+              <a:buSzPct val="100000"/>
+              <a:buChar char="•"/>
+            </a:pPr>
+            <a:r>
+              <a:rPr lang="en-US" sz="1300" dirty="0">
+                <a:solidFill>
+                  <a:srgbClr val="1A2233"/>
+                </a:solidFill>
+                <a:latin typeface="Calibri" pitchFamily="34" charset="0"/>
+                <a:ea typeface="Calibri" pitchFamily="34" charset="-122"/>
+                <a:cs typeface="Calibri" pitchFamily="34" charset="-120"/>
+              </a:rPr>
+              <a:t>Android's chooser and iOS's Safari fallback, both genuinely triggered</a:t>
+            </a:r>
+            <a:endParaRPr lang="en-US" sz="1300" dirty="0"/>
+          </a:p>
+          <a:p>
+            <a:pPr marL="342900" indent="-342900">
+              <a:lnSpc>
+                <a:spcPct val="125000"/>
+              </a:lnSpc>
+              <a:spcAft>
+                <a:spcPts val="1000"/>
+              </a:spcAft>
+              <a:buSzPct val="100000"/>
+              <a:buChar char="•"/>
+            </a:pPr>
+            <a:r>
+              <a:rPr lang="en-US" sz="1300" dirty="0">
+                <a:solidFill>
+                  <a:srgbClr val="1A2233"/>
+                </a:solidFill>
+                <a:latin typeface="Calibri" pitchFamily="34" charset="0"/>
+                <a:ea typeface="Calibri" pitchFamily="34" charset="-122"/>
+                <a:cs typeface="Calibri" pitchFamily="34" charset="-120"/>
+              </a:rPr>
+              <a:t>Handling the link whether the app is closed, open, or in the background</a:t>
+            </a:r>
+            <a:endParaRPr lang="en-US" sz="1300" dirty="0"/>
+          </a:p>
+          <a:p>
+            <a:pPr marL="342900" indent="-342900">
+              <a:lnSpc>
+                <a:spcPct val="125000"/>
+              </a:lnSpc>
+              <a:spcAft>
+                <a:spcPts val="1000"/>
+              </a:spcAft>
+              <a:buSzPct val="100000"/>
+              <a:buChar char="•"/>
+            </a:pPr>
+            <a:r>
+              <a:rPr lang="en-US" sz="1300" dirty="0">
+                <a:solidFill>
+                  <a:srgbClr val="1A2233"/>
+                </a:solidFill>
+                <a:latin typeface="Calibri" pitchFamily="34" charset="0"/>
+                <a:ea typeface="Calibri" pitchFamily="34" charset="-122"/>
+                <a:cs typeface="Calibri" pitchFamily="34" charset="-120"/>
+              </a:rPr>
+              <a:t>One payment can only be completed once, even with 2 taps at once</a:t>
+            </a:r>
+            <a:endParaRPr lang="en-US" sz="1300" dirty="0"/>
+          </a:p>
+          <a:p>
+            <a:pPr marL="342900" indent="-342900">
+              <a:lnSpc>
+                <a:spcPct val="125000"/>
+              </a:lnSpc>
+              <a:spcAft>
+                <a:spcPts val="1000"/>
+              </a:spcAft>
+              <a:buSzPct val="100000"/>
+              <a:buChar char="•"/>
+            </a:pPr>
+            <a:r>
+              <a:rPr lang="en-US" sz="1300" dirty="0">
+                <a:solidFill>
+                  <a:srgbClr val="1A2233"/>
+                </a:solidFill>
+                <a:latin typeface="Calibri" pitchFamily="34" charset="0"/>
+                <a:ea typeface="Calibri" pitchFamily="34" charset="-122"/>
+                <a:cs typeface="Calibri" pitchFamily="34" charset="-120"/>
+              </a:rPr>
+              <a:t>Basic protection against the page being embedded on another site</a:t>
+            </a:r>
+            <a:endParaRPr lang="en-US" sz="1300" dirty="0"/>
+          </a:p>
+        </p:txBody>
+      </p:sp>
+      <p:sp>
+        <p:nvSpPr>
+          <p:cNvPr id="8" name="Shape 5"/>
+          <p:cNvSpPr/>
+          <p:nvPr/>
+        </p:nvSpPr>
+        <p:spPr>
+          <a:xfrm>
+            <a:off x="6263640" y="1463040"/>
+            <a:ext cx="5349240" cy="4206240"/>
+          </a:xfrm>
+          <a:prstGeom prst="roundRect">
+            <a:avLst>
+              <a:gd name="adj" fmla="val 1739"/>
+            </a:avLst>
+          </a:prstGeom>
+          <a:solidFill>
+            <a:srgbClr val="FFFFFF"/>
+          </a:solidFill>
+          <a:ln/>
+          <a:effectLst>
+            <a:outerShdw sx="100000" sy="100000" kx="0" ky="0" algn="bl" rotWithShape="0" blurRad="101600" dist="38100" dir="2700000">
+              <a:srgbClr val="000000">
+                <a:alpha val="12000"/>
+              </a:srgbClr>
+            </a:outerShdw>
+          </a:effectLst>
+        </p:spPr>
+      </p:sp>
+      <p:sp>
+        <p:nvSpPr>
+          <p:cNvPr id="9" name="Shape 6"/>
+          <p:cNvSpPr/>
+          <p:nvPr/>
+        </p:nvSpPr>
+        <p:spPr>
+          <a:xfrm>
+            <a:off x="6537960" y="1737360"/>
+            <a:ext cx="594360" cy="594360"/>
+          </a:xfrm>
+          <a:prstGeom prst="ellipse">
+            <a:avLst/>
+          </a:prstGeom>
+          <a:solidFill>
+            <a:srgbClr val="F96167"/>
+          </a:solidFill>
+          <a:ln/>
+        </p:spPr>
+      </p:sp>
+      <p:pic>
+        <p:nvPicPr>
+          <p:cNvPr id="10" name="Image 1" descr="preencoded.png">    </p:cNvPr>
+          <p:cNvPicPr>
+            <a:picLocks noChangeAspect="1"/>
+          </p:cNvPicPr>
+          <p:nvPr/>
+        </p:nvPicPr>
+        <p:blipFill>
+          <a:blip r:embed="rId2"/>
+          <a:stretch>
+            <a:fillRect/>
+          </a:stretch>
+        </p:blipFill>
+        <p:spPr>
+          <a:xfrm>
+            <a:off x="6693408" y="1892808"/>
+            <a:ext cx="283464" cy="283464"/>
+          </a:xfrm>
+          <a:prstGeom prst="rect">
+            <a:avLst/>
+          </a:prstGeom>
+        </p:spPr>
+      </p:pic>
+      <p:sp>
+        <p:nvSpPr>
+          <p:cNvPr id="11" name="Text 7"/>
+          <p:cNvSpPr/>
+          <p:nvPr/>
+        </p:nvSpPr>
+        <p:spPr>
+          <a:xfrm>
+            <a:off x="7269480" y="1828800"/>
+            <a:ext cx="4069080" cy="457200"/>
+          </a:xfrm>
+          <a:prstGeom prst="rect">
+            <a:avLst/>
+          </a:prstGeom>
+          <a:noFill/>
+          <a:ln/>
+        </p:spPr>
+        <p:txBody>
+          <a:bodyPr wrap="square" lIns="0" tIns="0" rIns="0" bIns="0" rtlCol="0" anchor="ctr"/>
+          <a:lstStyle/>
+          <a:p>
+            <a:pPr indent="0" marL="0">
+              <a:buNone/>
+            </a:pPr>
+            <a:r>
+              <a:rPr lang="en-US" sz="1900" b="1" dirty="0">
+                <a:solidFill>
+                  <a:srgbClr val="1A2233"/>
+                </a:solidFill>
+                <a:latin typeface="Cambria" pitchFamily="34" charset="0"/>
+                <a:ea typeface="Cambria" pitchFamily="34" charset="-122"/>
+                <a:cs typeface="Cambria" pitchFamily="34" charset="-120"/>
+              </a:rPr>
+              <a:t>Simulated</a:t>
+            </a:r>
+            <a:endParaRPr lang="en-US" sz="1900" dirty="0"/>
+          </a:p>
+        </p:txBody>
+      </p:sp>
+      <p:sp>
+        <p:nvSpPr>
+          <p:cNvPr id="12" name="Text 8"/>
+          <p:cNvSpPr/>
+          <p:nvPr/>
+        </p:nvSpPr>
+        <p:spPr>
+          <a:xfrm>
+            <a:off x="6583680" y="2606040"/>
+            <a:ext cx="4709160" cy="2834640"/>
+          </a:xfrm>
+          <a:prstGeom prst="rect">
+            <a:avLst/>
+          </a:prstGeom>
+          <a:noFill/>
+          <a:ln/>
+        </p:spPr>
+        <p:txBody>
+          <a:bodyPr wrap="square" lIns="0" tIns="0" rIns="0" bIns="0" rtlCol="0" anchor="ctr"/>
+          <a:lstStyle/>
+          <a:p>
+            <a:pPr marL="342900" indent="-342900">
+              <a:lnSpc>
+                <a:spcPct val="125000"/>
+              </a:lnSpc>
+              <a:spcAft>
+                <a:spcPts val="1000"/>
+              </a:spcAft>
+              <a:buSzPct val="100000"/>
+              <a:buChar char="•"/>
+            </a:pPr>
+            <a:r>
+              <a:rPr lang="en-US" sz="1300" dirty="0">
+                <a:solidFill>
+                  <a:srgbClr val="1A2233"/>
+                </a:solidFill>
+                <a:latin typeface="Calibri" pitchFamily="34" charset="0"/>
+                <a:ea typeface="Calibri" pitchFamily="34" charset="-122"/>
+                <a:cs typeface="Calibri" pitchFamily="34" charset="-120"/>
+              </a:rPr>
+              <a:t>The bank balance — just a number in the app, resets on relaunch</a:t>
+            </a:r>
+            <a:endParaRPr lang="en-US" sz="1300" dirty="0"/>
+          </a:p>
+          <a:p>
+            <a:pPr marL="342900" indent="-342900">
+              <a:lnSpc>
+                <a:spcPct val="125000"/>
+              </a:lnSpc>
+              <a:spcAft>
+                <a:spcPts val="1000"/>
+              </a:spcAft>
+              <a:buSzPct val="100000"/>
+              <a:buChar char="•"/>
+            </a:pPr>
+            <a:r>
+              <a:rPr lang="en-US" sz="1300" dirty="0">
+                <a:solidFill>
+                  <a:srgbClr val="1A2233"/>
+                </a:solidFill>
+                <a:latin typeface="Calibri" pitchFamily="34" charset="0"/>
+                <a:ea typeface="Calibri" pitchFamily="34" charset="-122"/>
+                <a:cs typeface="Calibri" pitchFamily="34" charset="-120"/>
+              </a:rPr>
+              <a:t>The payment — no real money moves, no real bank is involved</a:t>
+            </a:r>
+            <a:endParaRPr lang="en-US" sz="1300" dirty="0"/>
+          </a:p>
+          <a:p>
+            <a:pPr marL="342900" indent="-342900">
+              <a:lnSpc>
+                <a:spcPct val="125000"/>
+              </a:lnSpc>
+              <a:spcAft>
+                <a:spcPts val="1000"/>
+              </a:spcAft>
+              <a:buSzPct val="100000"/>
+              <a:buChar char="•"/>
+            </a:pPr>
+            <a:r>
+              <a:rPr lang="en-US" sz="1300" dirty="0">
+                <a:solidFill>
+                  <a:srgbClr val="1A2233"/>
+                </a:solidFill>
+                <a:latin typeface="Calibri" pitchFamily="34" charset="0"/>
+                <a:ea typeface="Calibri" pitchFamily="34" charset="-122"/>
+                <a:cs typeface="Calibri" pitchFamily="34" charset="-120"/>
+              </a:rPr>
+              <a:t>Which bank "paid" is just a label the server stores, not a settlement</a:t>
+            </a:r>
+            <a:endParaRPr lang="en-US" sz="1300" dirty="0"/>
+          </a:p>
+          <a:p>
+            <a:pPr marL="342900" indent="-342900">
+              <a:lnSpc>
+                <a:spcPct val="125000"/>
+              </a:lnSpc>
+              <a:spcAft>
+                <a:spcPts val="1000"/>
+              </a:spcAft>
+              <a:buSzPct val="100000"/>
+              <a:buChar char="•"/>
+            </a:pPr>
+            <a:r>
+              <a:rPr lang="en-US" sz="1300" dirty="0">
+                <a:solidFill>
+                  <a:srgbClr val="1A2233"/>
+                </a:solidFill>
+                <a:latin typeface="Calibri" pitchFamily="34" charset="0"/>
+                <a:ea typeface="Calibri" pitchFamily="34" charset="-122"/>
+                <a:cs typeface="Calibri" pitchFamily="34" charset="-120"/>
+              </a:rPr>
+              <a:t>A real single-bank app would verify its Android App Link and register its iOS Universal Link — we tested that, and it's what removes the chooser, so we skip it on purpose here</a:t>
+            </a:r>
+            <a:endParaRPr lang="en-US" sz="1300" dirty="0"/>
+          </a:p>
+        </p:txBody>
+      </p:sp>
+    </p:spTree>
+  </p:cSld>
+  <p:clrMapOvr>
+    <a:masterClrMapping/>
+  </p:clrMapOvr>
+</p:sld>
+</file>
+
+<file path=ppt/slides/slide11.xml><?xml version="1.0" encoding="utf-8"?>
+<p:sld xmlns:a="http://schemas.openxmlformats.org/drawingml/2006/main" xmlns:r="http://schemas.openxmlformats.org/officeDocument/2006/relationships" xmlns:p="http://schemas.openxmlformats.org/presentationml/2006/main">
+  <p:cSld name="Slide 11">
+    <p:bg>
+      <p:bgPr>
+        <a:solidFill>
           <a:srgbClr val="21295C"/>
         </a:solidFill>
       </p:bgPr>
@@ -2433,7 +3101,7 @@
                 <a:ea typeface="Calibri" pitchFamily="34" charset="-122"/>
                 <a:cs typeface="Calibri" pitchFamily="34" charset="-120"/>
               </a:rPr>
-              <a:t>Most of the split comes from what each phone's OS does by default with an unregistered link — the app just gives Android one extra nudge to make the chooser appear.</a:t>
+              <a:t>Most of the split comes from what each phone's OS does by default with an unregistered link. We even tested making Android's link official — it removed the tap, but it removed the choice too, so we kept things unregistered on purpose.</a:t>
             </a:r>
             <a:endParaRPr lang="en-US" sz="1500" dirty="0"/>
           </a:p>
@@ -3584,7 +4252,7 @@
                 <a:ea typeface="Calibri" pitchFamily="34" charset="-122"/>
                 <a:cs typeface="Calibri" pitchFamily="34" charset="-120"/>
               </a:rPr>
-              <a:t>Opens in the default browser first</a:t>
+              <a:t>Why: the link is deliberately left unverified</a:t>
             </a:r>
             <a:endParaRPr lang="en-US" sz="1150" dirty="0"/>
           </a:p>
@@ -3630,7 +4298,7 @@
                 <a:ea typeface="Calibri" pitchFamily="34" charset="-122"/>
                 <a:cs typeface="Calibri" pitchFamily="34" charset="-120"/>
               </a:rPr>
-              <a:t>The link isn't "verified," so it opens like any normal web page</a:t>
+              <a:t>No app claims cryptographic ownership, so Android can't skip asking</a:t>
             </a:r>
             <a:endParaRPr lang="en-US" sz="1250" dirty="0"/>
           </a:p>
@@ -3654,7 +4322,7 @@
                 <a:ea typeface="Calibri" pitchFamily="34" charset="-122"/>
                 <a:cs typeface="Calibri" pitchFamily="34" charset="-120"/>
               </a:rPr>
-              <a:t>The page shows one button: "Continue to pay"</a:t>
+              <a:t>It opens in the default browser first, like any normal web page</a:t>
             </a:r>
             <a:endParaRPr lang="en-US" sz="1250" dirty="0"/>
           </a:p>
@@ -3678,7 +4346,7 @@
                 <a:ea typeface="Calibri" pitchFamily="34" charset="-122"/>
                 <a:cs typeface="Calibri" pitchFamily="34" charset="-120"/>
               </a:rPr>
-              <a:t>Tapping it opens the native chooser (next slide)</a:t>
+              <a:t>The page shows one button: "Continue to pay" (next slide)</a:t>
             </a:r>
             <a:endParaRPr lang="en-US" sz="1250" dirty="0"/>
           </a:p>
@@ -3824,7 +4492,7 @@
                 <a:ea typeface="Calibri" pitchFamily="34" charset="-122"/>
                 <a:cs typeface="Calibri" pitchFamily="34" charset="-120"/>
               </a:rPr>
-              <a:t>No app is registered for this address</a:t>
+              <a:t>Why: no Universal Link record is hosted for this domain</a:t>
             </a:r>
             <a:endParaRPr lang="en-US" sz="1150" dirty="0"/>
           </a:p>
@@ -3870,7 +4538,7 @@
                 <a:ea typeface="Calibri" pitchFamily="34" charset="-122"/>
                 <a:cs typeface="Calibri" pitchFamily="34" charset="-120"/>
               </a:rPr>
-              <a:t>iOS has no record linking this domain to an app</a:t>
+              <a:t>Apple requires a hosted association file to open an app directly</a:t>
             </a:r>
             <a:endParaRPr lang="en-US" sz="1250" dirty="0"/>
           </a:p>
@@ -3894,7 +4562,7 @@
                 <a:ea typeface="Calibri" pitchFamily="34" charset="-122"/>
                 <a:cs typeface="Calibri" pitchFamily="34" charset="-120"/>
               </a:rPr>
-              <a:t>So it just opens Safari, like any ordinary link</a:t>
+              <a:t>We don't host one, so iOS treats it as an ordinary link</a:t>
             </a:r>
             <a:endParaRPr lang="en-US" sz="1250" dirty="0"/>
           </a:p>
@@ -3918,7 +4586,7 @@
                 <a:ea typeface="Calibri" pitchFamily="34" charset="-122"/>
                 <a:cs typeface="Calibri" pitchFamily="34" charset="-120"/>
               </a:rPr>
-              <a:t>Safari shows the picker page: 3 bank buttons</a:t>
+              <a:t>Safari opens normally and shows the picker page: 3 bank buttons</a:t>
             </a:r>
             <a:endParaRPr lang="en-US" sz="1250" dirty="0"/>
           </a:p>
@@ -4958,6 +5626,478 @@
     <p:bg>
       <p:bgPr>
         <a:solidFill>
+          <a:srgbClr val="21295C"/>
+        </a:solidFill>
+      </p:bgPr>
+    </p:bg>
+    <p:spTree>
+      <p:nvGrpSpPr>
+        <p:cNvPr id="1" name=""/>
+        <p:cNvGrpSpPr/>
+        <p:nvPr/>
+      </p:nvGrpSpPr>
+      <p:grpSpPr>
+        <a:xfrm>
+          <a:off x="0" y="0"/>
+          <a:ext cx="0" cy="0"/>
+          <a:chOff x="0" y="0"/>
+          <a:chExt cx="0" cy="0"/>
+        </a:xfrm>
+      </p:grpSpPr>
+      <p:sp>
+        <p:nvSpPr>
+          <p:cNvPr id="2" name="Text 0"/>
+          <p:cNvSpPr/>
+          <p:nvPr/>
+        </p:nvSpPr>
+        <p:spPr>
+          <a:xfrm>
+            <a:off x="548640" y="411480"/>
+            <a:ext cx="10698480" cy="548640"/>
+          </a:xfrm>
+          <a:prstGeom prst="rect">
+            <a:avLst/>
+          </a:prstGeom>
+          <a:noFill/>
+          <a:ln/>
+        </p:spPr>
+        <p:txBody>
+          <a:bodyPr wrap="square" lIns="0" tIns="0" rIns="0" bIns="0" rtlCol="0" anchor="ctr"/>
+          <a:lstStyle/>
+          <a:p>
+            <a:pPr indent="0" marL="0">
+              <a:buNone/>
+            </a:pPr>
+            <a:r>
+              <a:rPr lang="en-US" sz="2800" b="1" dirty="0">
+                <a:solidFill>
+                  <a:srgbClr val="FFFFFF"/>
+                </a:solidFill>
+                <a:latin typeface="Cambria" pitchFamily="34" charset="0"/>
+                <a:ea typeface="Cambria" pitchFamily="34" charset="-122"/>
+                <a:cs typeface="Cambria" pitchFamily="34" charset="-120"/>
+              </a:rPr>
+              <a:t>Why not just verify the Android App Link?</a:t>
+            </a:r>
+            <a:endParaRPr lang="en-US" sz="2800" dirty="0"/>
+          </a:p>
+        </p:txBody>
+      </p:sp>
+      <p:sp>
+        <p:nvSpPr>
+          <p:cNvPr id="3" name="Text 1"/>
+          <p:cNvSpPr/>
+          <p:nvPr/>
+        </p:nvSpPr>
+        <p:spPr>
+          <a:xfrm>
+            <a:off x="548640" y="914400"/>
+            <a:ext cx="10515600" cy="365760"/>
+          </a:xfrm>
+          <a:prstGeom prst="rect">
+            <a:avLst/>
+          </a:prstGeom>
+          <a:noFill/>
+          <a:ln/>
+        </p:spPr>
+        <p:txBody>
+          <a:bodyPr wrap="square" lIns="0" tIns="0" rIns="0" bIns="0" rtlCol="0" anchor="ctr"/>
+          <a:lstStyle/>
+          <a:p>
+            <a:pPr indent="0" marL="0">
+              <a:buNone/>
+            </a:pPr>
+            <a:r>
+              <a:rPr lang="en-US" sz="1400" dirty="0">
+                <a:solidFill>
+                  <a:srgbClr val="CADCFC"/>
+                </a:solidFill>
+                <a:latin typeface="Calibri" pitchFamily="34" charset="0"/>
+                <a:ea typeface="Calibri" pitchFamily="34" charset="-122"/>
+                <a:cs typeface="Calibri" pitchFamily="34" charset="-120"/>
+              </a:rPr>
+              <a:t>We tested it directly on a device. Here's what actually happens.</a:t>
+            </a:r>
+            <a:endParaRPr lang="en-US" sz="1400" dirty="0"/>
+          </a:p>
+        </p:txBody>
+      </p:sp>
+      <p:sp>
+        <p:nvSpPr>
+          <p:cNvPr id="4" name="Shape 2"/>
+          <p:cNvSpPr/>
+          <p:nvPr/>
+        </p:nvSpPr>
+        <p:spPr>
+          <a:xfrm>
+            <a:off x="548640" y="1600200"/>
+            <a:ext cx="5349240" cy="3291840"/>
+          </a:xfrm>
+          <a:prstGeom prst="roundRect">
+            <a:avLst>
+              <a:gd name="adj" fmla="val 2222"/>
+            </a:avLst>
+          </a:prstGeom>
+          <a:solidFill>
+            <a:srgbClr val="065A82">
+              <a:alpha val="80000"/>
+            </a:srgbClr>
+          </a:solidFill>
+          <a:ln/>
+        </p:spPr>
+      </p:sp>
+      <p:sp>
+        <p:nvSpPr>
+          <p:cNvPr id="5" name="Text 3"/>
+          <p:cNvSpPr/>
+          <p:nvPr/>
+        </p:nvSpPr>
+        <p:spPr>
+          <a:xfrm>
+            <a:off x="822960" y="1828800"/>
+            <a:ext cx="4800600" cy="365760"/>
+          </a:xfrm>
+          <a:prstGeom prst="rect">
+            <a:avLst/>
+          </a:prstGeom>
+          <a:noFill/>
+          <a:ln/>
+        </p:spPr>
+        <p:txBody>
+          <a:bodyPr wrap="square" lIns="0" tIns="0" rIns="0" bIns="0" rtlCol="0" anchor="ctr"/>
+          <a:lstStyle/>
+          <a:p>
+            <a:pPr indent="0" marL="0">
+              <a:buNone/>
+            </a:pPr>
+            <a:r>
+              <a:rPr lang="en-US" sz="1700" b="1" dirty="0">
+                <a:solidFill>
+                  <a:srgbClr val="FFFFFF"/>
+                </a:solidFill>
+                <a:latin typeface="Cambria" pitchFamily="34" charset="0"/>
+                <a:ea typeface="Cambria" pitchFamily="34" charset="-122"/>
+                <a:cs typeface="Cambria" pitchFamily="34" charset="-120"/>
+              </a:rPr>
+              <a:t>The idea</a:t>
+            </a:r>
+            <a:endParaRPr lang="en-US" sz="1700" dirty="0"/>
+          </a:p>
+        </p:txBody>
+      </p:sp>
+      <p:sp>
+        <p:nvSpPr>
+          <p:cNvPr id="6" name="Text 4"/>
+          <p:cNvSpPr/>
+          <p:nvPr/>
+        </p:nvSpPr>
+        <p:spPr>
+          <a:xfrm>
+            <a:off x="822960" y="2377440"/>
+            <a:ext cx="4800600" cy="2286000"/>
+          </a:xfrm>
+          <a:prstGeom prst="rect">
+            <a:avLst/>
+          </a:prstGeom>
+          <a:noFill/>
+          <a:ln/>
+        </p:spPr>
+        <p:txBody>
+          <a:bodyPr wrap="square" lIns="0" tIns="0" rIns="0" bIns="0" rtlCol="0" anchor="ctr"/>
+          <a:lstStyle/>
+          <a:p>
+            <a:pPr marL="342900" indent="-342900">
+              <a:lnSpc>
+                <a:spcPct val="125000"/>
+              </a:lnSpc>
+              <a:spcAft>
+                <a:spcPts val="1200"/>
+              </a:spcAft>
+              <a:buSzPct val="100000"/>
+              <a:buChar char="•"/>
+            </a:pPr>
+            <a:r>
+              <a:rPr lang="en-US" sz="1250" dirty="0">
+                <a:solidFill>
+                  <a:srgbClr val="E4ECF5"/>
+                </a:solidFill>
+                <a:latin typeface="Calibri" pitchFamily="34" charset="0"/>
+                <a:ea typeface="Calibri" pitchFamily="34" charset="-122"/>
+                <a:cs typeface="Calibri" pitchFamily="34" charset="-120"/>
+              </a:rPr>
+              <a:t>Add android:autoVerify="true" to each app's intent-filter</a:t>
+            </a:r>
+            <a:endParaRPr lang="en-US" sz="1250" dirty="0"/>
+          </a:p>
+          <a:p>
+            <a:pPr marL="342900" indent="-342900">
+              <a:lnSpc>
+                <a:spcPct val="125000"/>
+              </a:lnSpc>
+              <a:spcAft>
+                <a:spcPts val="1200"/>
+              </a:spcAft>
+              <a:buSzPct val="100000"/>
+              <a:buChar char="•"/>
+            </a:pPr>
+            <a:r>
+              <a:rPr lang="en-US" sz="1250" dirty="0">
+                <a:solidFill>
+                  <a:srgbClr val="E4ECF5"/>
+                </a:solidFill>
+                <a:latin typeface="Calibri" pitchFamily="34" charset="0"/>
+                <a:ea typeface="Calibri" pitchFamily="34" charset="-122"/>
+                <a:cs typeface="Calibri" pitchFamily="34" charset="-120"/>
+              </a:rPr>
+              <a:t>Host /.well-known/assetlinks.json listing all 3 apps' real package names and signing certificate SHA-256 fingerprints</a:t>
+            </a:r>
+            <a:endParaRPr lang="en-US" sz="1250" dirty="0"/>
+          </a:p>
+          <a:p>
+            <a:pPr marL="342900" indent="-342900">
+              <a:lnSpc>
+                <a:spcPct val="125000"/>
+              </a:lnSpc>
+              <a:spcAft>
+                <a:spcPts val="1200"/>
+              </a:spcAft>
+              <a:buSzPct val="100000"/>
+              <a:buChar char="•"/>
+            </a:pPr>
+            <a:r>
+              <a:rPr lang="en-US" sz="1250" dirty="0">
+                <a:solidFill>
+                  <a:srgbClr val="E4ECF5"/>
+                </a:solidFill>
+                <a:latin typeface="Calibri" pitchFamily="34" charset="0"/>
+                <a:ea typeface="Calibri" pitchFamily="34" charset="-122"/>
+                <a:cs typeface="Calibri" pitchFamily="34" charset="-120"/>
+              </a:rPr>
+              <a:t>Android checks this file at install time — if it matches, the app is a verified owner of the link</a:t>
+            </a:r>
+            <a:endParaRPr lang="en-US" sz="1250" dirty="0"/>
+          </a:p>
+          <a:p>
+            <a:pPr marL="342900" indent="-342900">
+              <a:lnSpc>
+                <a:spcPct val="125000"/>
+              </a:lnSpc>
+              <a:spcAft>
+                <a:spcPts val="1200"/>
+              </a:spcAft>
+              <a:buSzPct val="100000"/>
+              <a:buChar char="•"/>
+            </a:pPr>
+            <a:r>
+              <a:rPr lang="en-US" sz="1250" dirty="0">
+                <a:solidFill>
+                  <a:srgbClr val="5EEAD4"/>
+                </a:solidFill>
+                <a:latin typeface="Calibri" pitchFamily="34" charset="0"/>
+                <a:ea typeface="Calibri" pitchFamily="34" charset="-122"/>
+                <a:cs typeface="Calibri" pitchFamily="34" charset="-120"/>
+              </a:rPr>
+              <a:t>Goal: skip the browser and the "Continue" tap entirely</a:t>
+            </a:r>
+            <a:endParaRPr lang="en-US" sz="1250" dirty="0"/>
+          </a:p>
+        </p:txBody>
+      </p:sp>
+      <p:sp>
+        <p:nvSpPr>
+          <p:cNvPr id="7" name="Shape 5"/>
+          <p:cNvSpPr/>
+          <p:nvPr/>
+        </p:nvSpPr>
+        <p:spPr>
+          <a:xfrm>
+            <a:off x="6217920" y="1600200"/>
+            <a:ext cx="5349240" cy="3291840"/>
+          </a:xfrm>
+          <a:prstGeom prst="roundRect">
+            <a:avLst>
+              <a:gd name="adj" fmla="val 2222"/>
+            </a:avLst>
+          </a:prstGeom>
+          <a:solidFill>
+            <a:srgbClr val="F96167">
+              <a:alpha val="85000"/>
+            </a:srgbClr>
+          </a:solidFill>
+          <a:ln/>
+        </p:spPr>
+      </p:sp>
+      <p:sp>
+        <p:nvSpPr>
+          <p:cNvPr id="8" name="Text 6"/>
+          <p:cNvSpPr/>
+          <p:nvPr/>
+        </p:nvSpPr>
+        <p:spPr>
+          <a:xfrm>
+            <a:off x="6492240" y="1828800"/>
+            <a:ext cx="4800600" cy="365760"/>
+          </a:xfrm>
+          <a:prstGeom prst="rect">
+            <a:avLst/>
+          </a:prstGeom>
+          <a:noFill/>
+          <a:ln/>
+        </p:spPr>
+        <p:txBody>
+          <a:bodyPr wrap="square" lIns="0" tIns="0" rIns="0" bIns="0" rtlCol="0" anchor="ctr"/>
+          <a:lstStyle/>
+          <a:p>
+            <a:pPr indent="0" marL="0">
+              <a:buNone/>
+            </a:pPr>
+            <a:r>
+              <a:rPr lang="en-US" sz="1700" b="1" dirty="0">
+                <a:solidFill>
+                  <a:srgbClr val="FFFFFF"/>
+                </a:solidFill>
+                <a:latin typeface="Cambria" pitchFamily="34" charset="0"/>
+                <a:ea typeface="Cambria" pitchFamily="34" charset="-122"/>
+                <a:cs typeface="Cambria" pitchFamily="34" charset="-120"/>
+              </a:rPr>
+              <a:t>What we found on-device</a:t>
+            </a:r>
+            <a:endParaRPr lang="en-US" sz="1700" dirty="0"/>
+          </a:p>
+        </p:txBody>
+      </p:sp>
+      <p:sp>
+        <p:nvSpPr>
+          <p:cNvPr id="9" name="Text 7"/>
+          <p:cNvSpPr/>
+          <p:nvPr/>
+        </p:nvSpPr>
+        <p:spPr>
+          <a:xfrm>
+            <a:off x="6492240" y="2377440"/>
+            <a:ext cx="4800600" cy="2286000"/>
+          </a:xfrm>
+          <a:prstGeom prst="rect">
+            <a:avLst/>
+          </a:prstGeom>
+          <a:noFill/>
+          <a:ln/>
+        </p:spPr>
+        <p:txBody>
+          <a:bodyPr wrap="square" lIns="0" tIns="0" rIns="0" bIns="0" rtlCol="0" anchor="ctr"/>
+          <a:lstStyle/>
+          <a:p>
+            <a:pPr marL="342900" indent="-342900">
+              <a:lnSpc>
+                <a:spcPct val="125000"/>
+              </a:lnSpc>
+              <a:spcAft>
+                <a:spcPts val="1200"/>
+              </a:spcAft>
+              <a:buSzPct val="100000"/>
+              <a:buChar char="•"/>
+            </a:pPr>
+            <a:r>
+              <a:rPr lang="en-US" sz="1250" dirty="0">
+                <a:solidFill>
+                  <a:srgbClr val="FDECEB"/>
+                </a:solidFill>
+                <a:latin typeface="Calibri" pitchFamily="34" charset="0"/>
+                <a:ea typeface="Calibri" pitchFamily="34" charset="-122"/>
+                <a:cs typeface="Calibri" pitchFamily="34" charset="-120"/>
+              </a:rPr>
+              <a:t>All 3 apps verified successfully (adb confirmed "verified" for each)</a:t>
+            </a:r>
+            <a:endParaRPr lang="en-US" sz="1250" dirty="0"/>
+          </a:p>
+          <a:p>
+            <a:pPr marL="342900" indent="-342900">
+              <a:lnSpc>
+                <a:spcPct val="125000"/>
+              </a:lnSpc>
+              <a:spcAft>
+                <a:spcPts val="1200"/>
+              </a:spcAft>
+              <a:buSzPct val="100000"/>
+              <a:buChar char="•"/>
+            </a:pPr>
+            <a:r>
+              <a:rPr lang="en-US" sz="1250" dirty="0">
+                <a:solidFill>
+                  <a:srgbClr val="FDECEB"/>
+                </a:solidFill>
+                <a:latin typeface="Calibri" pitchFamily="34" charset="0"/>
+                <a:ea typeface="Calibri" pitchFamily="34" charset="-122"/>
+                <a:cs typeface="Calibri" pitchFamily="34" charset="-120"/>
+              </a:rPr>
+              <a:t>But no chooser ever appeared — the link opened one app directly, instantly</a:t>
+            </a:r>
+            <a:endParaRPr lang="en-US" sz="1250" dirty="0"/>
+          </a:p>
+          <a:p>
+            <a:pPr marL="342900" indent="-342900">
+              <a:lnSpc>
+                <a:spcPct val="125000"/>
+              </a:lnSpc>
+              <a:spcAft>
+                <a:spcPts val="1200"/>
+              </a:spcAft>
+              <a:buSzPct val="100000"/>
+              <a:buChar char="•"/>
+            </a:pPr>
+            <a:r>
+              <a:rPr lang="en-US" sz="1250" dirty="0">
+                <a:solidFill>
+                  <a:srgbClr val="FDECEB"/>
+                </a:solidFill>
+                <a:latin typeface="Calibri" pitchFamily="34" charset="0"/>
+                <a:ea typeface="Calibri" pitchFamily="34" charset="-122"/>
+                <a:cs typeface="Calibri" pitchFamily="34" charset="-120"/>
+              </a:rPr>
+              <a:t>Reinstalling a different bank last changed which app opened — Android was picking the most-recently-installed verified app, silently</a:t>
+            </a:r>
+            <a:endParaRPr lang="en-US" sz="1250" dirty="0"/>
+          </a:p>
+          <a:p>
+            <a:pPr marL="342900" indent="-342900">
+              <a:lnSpc>
+                <a:spcPct val="125000"/>
+              </a:lnSpc>
+              <a:spcAft>
+                <a:spcPts val="1200"/>
+              </a:spcAft>
+              <a:buSzPct val="100000"/>
+              <a:buChar char="•"/>
+            </a:pPr>
+            <a:r>
+              <a:rPr lang="en-US" sz="1250" b="1" dirty="0">
+                <a:solidFill>
+                  <a:srgbClr val="FFFFFF"/>
+                </a:solidFill>
+                <a:latin typeface="Calibri" pitchFamily="34" charset="0"/>
+                <a:ea typeface="Calibri" pitchFamily="34" charset="-122"/>
+                <a:cs typeface="Calibri" pitchFamily="34" charset="-120"/>
+              </a:rPr>
+              <a:t>Verified App Links and the disambiguation dialog are mutually exclusive by design</a:t>
+            </a:r>
+            <a:endParaRPr lang="en-US" sz="1250" dirty="0"/>
+          </a:p>
+        </p:txBody>
+      </p:sp>
+    </p:spTree>
+  </p:cSld>
+  <p:clrMapOvr>
+    <a:masterClrMapping/>
+  </p:clrMapOvr>
+</p:sld>
+</file>
+
+<file path=ppt/slides/slide6.xml><?xml version="1.0" encoding="utf-8"?>
+<p:sld xmlns:a="http://schemas.openxmlformats.org/drawingml/2006/main" xmlns:r="http://schemas.openxmlformats.org/officeDocument/2006/relationships" xmlns:p="http://schemas.openxmlformats.org/presentationml/2006/main">
+  <p:cSld name="Slide 6">
+    <p:bg>
+      <p:bgPr>
+        <a:solidFill>
           <a:srgbClr val="F5F8FA"/>
         </a:solidFill>
       </p:bgPr>
@@ -5017,7 +6157,46 @@
       </p:sp>
       <p:sp>
         <p:nvSpPr>
-          <p:cNvPr id="3" name="Shape 1"/>
+          <p:cNvPr id="3" name="Text 1"/>
+          <p:cNvSpPr/>
+          <p:nvPr/>
+        </p:nvSpPr>
+        <p:spPr>
+          <a:xfrm>
+            <a:off x="548640" y="914400"/>
+            <a:ext cx="10515600" cy="365760"/>
+          </a:xfrm>
+          <a:prstGeom prst="rect">
+            <a:avLst/>
+          </a:prstGeom>
+          <a:noFill/>
+          <a:ln/>
+        </p:spPr>
+        <p:txBody>
+          <a:bodyPr wrap="square" lIns="0" tIns="0" rIns="0" bIns="0" rtlCol="0" anchor="ctr"/>
+          <a:lstStyle/>
+          <a:p>
+            <a:pPr indent="0" marL="0">
+              <a:buNone/>
+            </a:pPr>
+            <a:r>
+              <a:rPr lang="en-US" sz="1400" dirty="0">
+                <a:solidFill>
+                  <a:srgbClr val="5B6B79"/>
+                </a:solidFill>
+                <a:latin typeface="Calibri" pitchFamily="34" charset="0"/>
+                <a:ea typeface="Calibri" pitchFamily="34" charset="-122"/>
+                <a:cs typeface="Calibri" pitchFamily="34" charset="-120"/>
+              </a:rPr>
+              <a:t>Why this flow: no Universal Link is registered for this domain</a:t>
+            </a:r>
+            <a:endParaRPr lang="en-US" sz="1400" dirty="0"/>
+          </a:p>
+        </p:txBody>
+      </p:sp>
+      <p:sp>
+        <p:nvSpPr>
+          <p:cNvPr id="4" name="Shape 2"/>
           <p:cNvSpPr/>
           <p:nvPr/>
         </p:nvSpPr>
@@ -5046,7 +6225,7 @@
       </p:sp>
       <p:sp>
         <p:nvSpPr>
-          <p:cNvPr id="4" name="Shape 2"/>
+          <p:cNvPr id="5" name="Shape 3"/>
           <p:cNvSpPr/>
           <p:nvPr/>
         </p:nvSpPr>
@@ -5066,7 +6245,7 @@
       </p:sp>
       <p:pic>
         <p:nvPicPr>
-          <p:cNvPr id="5" name="Image 0" descr="preencoded.png">    </p:cNvPr>
+          <p:cNvPr id="6" name="Image 0" descr="preencoded.png">    </p:cNvPr>
           <p:cNvPicPr>
             <a:picLocks noChangeAspect="1"/>
           </p:cNvPicPr>
@@ -5090,7 +6269,7 @@
       </p:pic>
       <p:sp>
         <p:nvSpPr>
-          <p:cNvPr id="6" name="Text 3"/>
+          <p:cNvPr id="7" name="Text 4"/>
           <p:cNvSpPr/>
           <p:nvPr/>
         </p:nvSpPr>
@@ -5129,7 +6308,7 @@
       </p:sp>
       <p:sp>
         <p:nvSpPr>
-          <p:cNvPr id="7" name="Text 4"/>
+          <p:cNvPr id="8" name="Text 5"/>
           <p:cNvSpPr/>
           <p:nvPr/>
         </p:nvSpPr>
@@ -5168,7 +6347,7 @@
       </p:sp>
       <p:sp>
         <p:nvSpPr>
-          <p:cNvPr id="8" name="Text 5"/>
+          <p:cNvPr id="9" name="Text 6"/>
           <p:cNvSpPr/>
           <p:nvPr/>
         </p:nvSpPr>
@@ -5210,7 +6389,7 @@
       </p:sp>
       <p:pic>
         <p:nvPicPr>
-          <p:cNvPr id="9" name="Image 1" descr="preencoded.png">    </p:cNvPr>
+          <p:cNvPr id="10" name="Image 1" descr="preencoded.png">    </p:cNvPr>
           <p:cNvPicPr>
             <a:picLocks noChangeAspect="1"/>
           </p:cNvPicPr>
@@ -5234,7 +6413,7 @@
       </p:pic>
       <p:sp>
         <p:nvSpPr>
-          <p:cNvPr id="10" name="Shape 6"/>
+          <p:cNvPr id="11" name="Shape 7"/>
           <p:cNvSpPr/>
           <p:nvPr/>
         </p:nvSpPr>
@@ -5263,7 +6442,7 @@
       </p:sp>
       <p:sp>
         <p:nvSpPr>
-          <p:cNvPr id="11" name="Shape 7"/>
+          <p:cNvPr id="12" name="Shape 8"/>
           <p:cNvSpPr/>
           <p:nvPr/>
         </p:nvSpPr>
@@ -5283,7 +6462,7 @@
       </p:sp>
       <p:pic>
         <p:nvPicPr>
-          <p:cNvPr id="12" name="Image 2" descr="preencoded.png">    </p:cNvPr>
+          <p:cNvPr id="13" name="Image 2" descr="preencoded.png">    </p:cNvPr>
           <p:cNvPicPr>
             <a:picLocks noChangeAspect="1"/>
           </p:cNvPicPr>
@@ -5307,7 +6486,7 @@
       </p:pic>
       <p:sp>
         <p:nvSpPr>
-          <p:cNvPr id="13" name="Text 8"/>
+          <p:cNvPr id="14" name="Text 9"/>
           <p:cNvSpPr/>
           <p:nvPr/>
         </p:nvSpPr>
@@ -5346,7 +6525,7 @@
       </p:sp>
       <p:sp>
         <p:nvSpPr>
-          <p:cNvPr id="14" name="Text 9"/>
+          <p:cNvPr id="15" name="Text 10"/>
           <p:cNvSpPr/>
           <p:nvPr/>
         </p:nvSpPr>
@@ -5385,7 +6564,7 @@
       </p:sp>
       <p:sp>
         <p:nvSpPr>
-          <p:cNvPr id="15" name="Text 10"/>
+          <p:cNvPr id="16" name="Text 11"/>
           <p:cNvSpPr/>
           <p:nvPr/>
         </p:nvSpPr>
@@ -5427,7 +6606,7 @@
       </p:sp>
       <p:pic>
         <p:nvPicPr>
-          <p:cNvPr id="16" name="Image 3" descr="preencoded.png">    </p:cNvPr>
+          <p:cNvPr id="17" name="Image 3" descr="preencoded.png">    </p:cNvPr>
           <p:cNvPicPr>
             <a:picLocks noChangeAspect="1"/>
           </p:cNvPicPr>
@@ -5451,7 +6630,7 @@
       </p:pic>
       <p:sp>
         <p:nvSpPr>
-          <p:cNvPr id="17" name="Shape 11"/>
+          <p:cNvPr id="18" name="Shape 12"/>
           <p:cNvSpPr/>
           <p:nvPr/>
         </p:nvSpPr>
@@ -5480,7 +6659,7 @@
       </p:sp>
       <p:sp>
         <p:nvSpPr>
-          <p:cNvPr id="18" name="Shape 12"/>
+          <p:cNvPr id="19" name="Shape 13"/>
           <p:cNvSpPr/>
           <p:nvPr/>
         </p:nvSpPr>
@@ -5500,7 +6679,7 @@
       </p:sp>
       <p:pic>
         <p:nvPicPr>
-          <p:cNvPr id="19" name="Image 4" descr="preencoded.png">    </p:cNvPr>
+          <p:cNvPr id="20" name="Image 4" descr="preencoded.png">    </p:cNvPr>
           <p:cNvPicPr>
             <a:picLocks noChangeAspect="1"/>
           </p:cNvPicPr>
@@ -5524,7 +6703,7 @@
       </p:pic>
       <p:sp>
         <p:nvSpPr>
-          <p:cNvPr id="20" name="Text 13"/>
+          <p:cNvPr id="21" name="Text 14"/>
           <p:cNvSpPr/>
           <p:nvPr/>
         </p:nvSpPr>
@@ -5563,7 +6742,7 @@
       </p:sp>
       <p:sp>
         <p:nvSpPr>
-          <p:cNvPr id="21" name="Text 14"/>
+          <p:cNvPr id="22" name="Text 15"/>
           <p:cNvSpPr/>
           <p:nvPr/>
         </p:nvSpPr>
@@ -5602,7 +6781,7 @@
       </p:sp>
       <p:sp>
         <p:nvSpPr>
-          <p:cNvPr id="22" name="Text 15"/>
+          <p:cNvPr id="23" name="Text 16"/>
           <p:cNvSpPr/>
           <p:nvPr/>
         </p:nvSpPr>
@@ -5644,7 +6823,7 @@
       </p:sp>
       <p:pic>
         <p:nvPicPr>
-          <p:cNvPr id="23" name="Image 5" descr="preencoded.png">    </p:cNvPr>
+          <p:cNvPr id="24" name="Image 5" descr="preencoded.png">    </p:cNvPr>
           <p:cNvPicPr>
             <a:picLocks noChangeAspect="1"/>
           </p:cNvPicPr>
@@ -5668,7 +6847,7 @@
       </p:pic>
       <p:sp>
         <p:nvSpPr>
-          <p:cNvPr id="24" name="Shape 16"/>
+          <p:cNvPr id="25" name="Shape 17"/>
           <p:cNvSpPr/>
           <p:nvPr/>
         </p:nvSpPr>
@@ -5697,7 +6876,7 @@
       </p:sp>
       <p:sp>
         <p:nvSpPr>
-          <p:cNvPr id="25" name="Shape 17"/>
+          <p:cNvPr id="26" name="Shape 18"/>
           <p:cNvSpPr/>
           <p:nvPr/>
         </p:nvSpPr>
@@ -5717,7 +6896,7 @@
       </p:sp>
       <p:pic>
         <p:nvPicPr>
-          <p:cNvPr id="26" name="Image 6" descr="preencoded.png">    </p:cNvPr>
+          <p:cNvPr id="27" name="Image 6" descr="preencoded.png">    </p:cNvPr>
           <p:cNvPicPr>
             <a:picLocks noChangeAspect="1"/>
           </p:cNvPicPr>
@@ -5741,7 +6920,7 @@
       </p:pic>
       <p:sp>
         <p:nvSpPr>
-          <p:cNvPr id="27" name="Text 18"/>
+          <p:cNvPr id="28" name="Text 19"/>
           <p:cNvSpPr/>
           <p:nvPr/>
         </p:nvSpPr>
@@ -5780,7 +6959,7 @@
       </p:sp>
       <p:sp>
         <p:nvSpPr>
-          <p:cNvPr id="28" name="Text 19"/>
+          <p:cNvPr id="29" name="Text 20"/>
           <p:cNvSpPr/>
           <p:nvPr/>
         </p:nvSpPr>
@@ -5819,7 +6998,7 @@
       </p:sp>
       <p:sp>
         <p:nvSpPr>
-          <p:cNvPr id="29" name="Text 20"/>
+          <p:cNvPr id="30" name="Text 21"/>
           <p:cNvSpPr/>
           <p:nvPr/>
         </p:nvSpPr>
@@ -5856,6 +7035,72 @@
               <a:t>iOS recognizes the link belongs to that app and switches straight to it.</a:t>
             </a:r>
             <a:endParaRPr lang="en-US" sz="1150" dirty="0"/>
+          </a:p>
+        </p:txBody>
+      </p:sp>
+      <p:sp>
+        <p:nvSpPr>
+          <p:cNvPr id="31" name="Shape 22"/>
+          <p:cNvSpPr/>
+          <p:nvPr/>
+        </p:nvSpPr>
+        <p:spPr>
+          <a:xfrm>
+            <a:off x="548640" y="5440680"/>
+            <a:ext cx="11091672" cy="960120"/>
+          </a:xfrm>
+          <a:prstGeom prst="roundRect">
+            <a:avLst>
+              <a:gd name="adj" fmla="val 7619"/>
+            </a:avLst>
+          </a:prstGeom>
+          <a:solidFill>
+            <a:srgbClr val="1C7293">
+              <a:alpha val="85000"/>
+            </a:srgbClr>
+          </a:solidFill>
+          <a:ln/>
+        </p:spPr>
+      </p:sp>
+      <p:sp>
+        <p:nvSpPr>
+          <p:cNvPr id="32" name="Text 23"/>
+          <p:cNvSpPr/>
+          <p:nvPr/>
+        </p:nvSpPr>
+        <p:spPr>
+          <a:xfrm>
+            <a:off x="822960" y="5440680"/>
+            <a:ext cx="10543032" cy="960120"/>
+          </a:xfrm>
+          <a:prstGeom prst="rect">
+            <a:avLst/>
+          </a:prstGeom>
+          <a:noFill/>
+          <a:ln/>
+        </p:spPr>
+        <p:txBody>
+          <a:bodyPr wrap="square" lIns="0" tIns="0" rIns="0" bIns="0" rtlCol="0" anchor="ctr"/>
+          <a:lstStyle/>
+          <a:p>
+            <a:pPr indent="0" marL="0">
+              <a:lnSpc>
+                <a:spcPct val="125000"/>
+              </a:lnSpc>
+              <a:buNone/>
+            </a:pPr>
+            <a:r>
+              <a:rPr lang="en-US" sz="1300" dirty="0">
+                <a:solidFill>
+                  <a:srgbClr val="0B3B44"/>
+                </a:solidFill>
+                <a:latin typeface="Calibri" pitchFamily="34" charset="0"/>
+                <a:ea typeface="Calibri" pitchFamily="34" charset="-122"/>
+                <a:cs typeface="Calibri" pitchFamily="34" charset="-120"/>
+              </a:rPr>
+              <a:t>What would skip this page? A hosted apple-app-site-association file plus each app's Associated Domains entitlement — Apple's equivalent of Android's assetlinks.json. We don't host one on purpose, so Safari always gets a chance to show the picker.</a:t>
+            </a:r>
+            <a:endParaRPr lang="en-US" sz="1300" dirty="0"/>
           </a:p>
         </p:txBody>
       </p:sp>
@@ -5867,9 +7112,9 @@
 </p:sld>
 </file>
 
-<file path=ppt/slides/slide6.xml><?xml version="1.0" encoding="utf-8"?>
+<file path=ppt/slides/slide7.xml><?xml version="1.0" encoding="utf-8"?>
 <p:sld xmlns:a="http://schemas.openxmlformats.org/drawingml/2006/main" xmlns:r="http://schemas.openxmlformats.org/officeDocument/2006/relationships" xmlns:p="http://schemas.openxmlformats.org/presentationml/2006/main">
-  <p:cSld name="Slide 6">
+  <p:cSld name="Slide 7">
     <p:bg>
       <p:bgPr>
         <a:solidFill>
@@ -6772,9 +8017,9 @@
 </p:sld>
 </file>
 
-<file path=ppt/slides/slide7.xml><?xml version="1.0" encoding="utf-8"?>
+<file path=ppt/slides/slide8.xml><?xml version="1.0" encoding="utf-8"?>
 <p:sld xmlns:a="http://schemas.openxmlformats.org/drawingml/2006/main" xmlns:r="http://schemas.openxmlformats.org/officeDocument/2006/relationships" xmlns:p="http://schemas.openxmlformats.org/presentationml/2006/main">
-  <p:cSld name="Slide 7">
+  <p:cSld name="Slide 8">
     <p:bg>
       <p:bgPr>
         <a:solidFill>
@@ -7624,9 +8869,9 @@
 </p:sld>
 </file>
 
-<file path=ppt/slides/slide8.xml><?xml version="1.0" encoding="utf-8"?>
+<file path=ppt/slides/slide9.xml><?xml version="1.0" encoding="utf-8"?>
 <p:sld xmlns:a="http://schemas.openxmlformats.org/drawingml/2006/main" xmlns:r="http://schemas.openxmlformats.org/officeDocument/2006/relationships" xmlns:p="http://schemas.openxmlformats.org/presentationml/2006/main">
-  <p:cSld name="Slide 8">
+  <p:cSld name="Slide 9">
     <p:bg>
       <p:bgPr>
         <a:solidFill>
@@ -8509,585 +9754,6 @@
               <a:t>The 3 apps' code started as one copy, duplicated 3 times — it isn't shared behind the scenes. Fixing a bug in one app means copying that fix into the other two by hand.</a:t>
             </a:r>
             <a:endParaRPr lang="en-US" sz="1150" dirty="0"/>
-          </a:p>
-        </p:txBody>
-      </p:sp>
-    </p:spTree>
-  </p:cSld>
-  <p:clrMapOvr>
-    <a:masterClrMapping/>
-  </p:clrMapOvr>
-</p:sld>
-</file>
-
-<file path=ppt/slides/slide9.xml><?xml version="1.0" encoding="utf-8"?>
-<p:sld xmlns:a="http://schemas.openxmlformats.org/drawingml/2006/main" xmlns:r="http://schemas.openxmlformats.org/officeDocument/2006/relationships" xmlns:p="http://schemas.openxmlformats.org/presentationml/2006/main">
-  <p:cSld name="Slide 9">
-    <p:bg>
-      <p:bgPr>
-        <a:solidFill>
-          <a:srgbClr val="F5F8FA"/>
-        </a:solidFill>
-      </p:bgPr>
-    </p:bg>
-    <p:spTree>
-      <p:nvGrpSpPr>
-        <p:cNvPr id="1" name=""/>
-        <p:cNvGrpSpPr/>
-        <p:nvPr/>
-      </p:nvGrpSpPr>
-      <p:grpSpPr>
-        <a:xfrm>
-          <a:off x="0" y="0"/>
-          <a:ext cx="0" cy="0"/>
-          <a:chOff x="0" y="0"/>
-          <a:chExt cx="0" cy="0"/>
-        </a:xfrm>
-      </p:grpSpPr>
-      <p:sp>
-        <p:nvSpPr>
-          <p:cNvPr id="2" name="Text 0"/>
-          <p:cNvSpPr/>
-          <p:nvPr/>
-        </p:nvSpPr>
-        <p:spPr>
-          <a:xfrm>
-            <a:off x="548640" y="411480"/>
-            <a:ext cx="9144000" cy="548640"/>
-          </a:xfrm>
-          <a:prstGeom prst="rect">
-            <a:avLst/>
-          </a:prstGeom>
-          <a:noFill/>
-          <a:ln/>
-        </p:spPr>
-        <p:txBody>
-          <a:bodyPr wrap="square" lIns="0" tIns="0" rIns="0" bIns="0" rtlCol="0" anchor="ctr"/>
-          <a:lstStyle/>
-          <a:p>
-            <a:pPr indent="0" marL="0">
-              <a:buNone/>
-            </a:pPr>
-            <a:r>
-              <a:rPr lang="en-US" sz="3000" b="1" dirty="0">
-                <a:solidFill>
-                  <a:srgbClr val="1A2233"/>
-                </a:solidFill>
-                <a:latin typeface="Cambria" pitchFamily="34" charset="0"/>
-                <a:ea typeface="Cambria" pitchFamily="34" charset="-122"/>
-                <a:cs typeface="Cambria" pitchFamily="34" charset="-120"/>
-              </a:rPr>
-              <a:t>What's real, what's simulated</a:t>
-            </a:r>
-            <a:endParaRPr lang="en-US" sz="3000" dirty="0"/>
-          </a:p>
-        </p:txBody>
-      </p:sp>
-      <p:sp>
-        <p:nvSpPr>
-          <p:cNvPr id="3" name="Shape 1"/>
-          <p:cNvSpPr/>
-          <p:nvPr/>
-        </p:nvSpPr>
-        <p:spPr>
-          <a:xfrm>
-            <a:off x="548640" y="1463040"/>
-            <a:ext cx="5349240" cy="4206240"/>
-          </a:xfrm>
-          <a:prstGeom prst="roundRect">
-            <a:avLst>
-              <a:gd name="adj" fmla="val 1739"/>
-            </a:avLst>
-          </a:prstGeom>
-          <a:solidFill>
-            <a:srgbClr val="FFFFFF"/>
-          </a:solidFill>
-          <a:ln/>
-          <a:effectLst>
-            <a:outerShdw sx="100000" sy="100000" kx="0" ky="0" algn="bl" rotWithShape="0" blurRad="101600" dist="38100" dir="2700000">
-              <a:srgbClr val="000000">
-                <a:alpha val="12000"/>
-              </a:srgbClr>
-            </a:outerShdw>
-          </a:effectLst>
-        </p:spPr>
-      </p:sp>
-      <p:sp>
-        <p:nvSpPr>
-          <p:cNvPr id="4" name="Shape 2"/>
-          <p:cNvSpPr/>
-          <p:nvPr/>
-        </p:nvSpPr>
-        <p:spPr>
-          <a:xfrm>
-            <a:off x="822960" y="1737360"/>
-            <a:ext cx="594360" cy="594360"/>
-          </a:xfrm>
-          <a:prstGeom prst="ellipse">
-            <a:avLst/>
-          </a:prstGeom>
-          <a:solidFill>
-            <a:srgbClr val="1C7293"/>
-          </a:solidFill>
-          <a:ln/>
-        </p:spPr>
-      </p:sp>
-      <p:pic>
-        <p:nvPicPr>
-          <p:cNvPr id="5" name="Image 0" descr="preencoded.png">    </p:cNvPr>
-          <p:cNvPicPr>
-            <a:picLocks noChangeAspect="1"/>
-          </p:cNvPicPr>
-          <p:nvPr/>
-        </p:nvPicPr>
-        <p:blipFill>
-          <a:blip r:embed="rId1"/>
-          <a:stretch>
-            <a:fillRect/>
-          </a:stretch>
-        </p:blipFill>
-        <p:spPr>
-          <a:xfrm>
-            <a:off x="978408" y="1892808"/>
-            <a:ext cx="283464" cy="283464"/>
-          </a:xfrm>
-          <a:prstGeom prst="rect">
-            <a:avLst/>
-          </a:prstGeom>
-        </p:spPr>
-      </p:pic>
-      <p:sp>
-        <p:nvSpPr>
-          <p:cNvPr id="6" name="Text 3"/>
-          <p:cNvSpPr/>
-          <p:nvPr/>
-        </p:nvSpPr>
-        <p:spPr>
-          <a:xfrm>
-            <a:off x="1554480" y="1828800"/>
-            <a:ext cx="4069080" cy="457200"/>
-          </a:xfrm>
-          <a:prstGeom prst="rect">
-            <a:avLst/>
-          </a:prstGeom>
-          <a:noFill/>
-          <a:ln/>
-        </p:spPr>
-        <p:txBody>
-          <a:bodyPr wrap="square" lIns="0" tIns="0" rIns="0" bIns="0" rtlCol="0" anchor="ctr"/>
-          <a:lstStyle/>
-          <a:p>
-            <a:pPr indent="0" marL="0">
-              <a:buNone/>
-            </a:pPr>
-            <a:r>
-              <a:rPr lang="en-US" sz="1900" b="1" dirty="0">
-                <a:solidFill>
-                  <a:srgbClr val="1A2233"/>
-                </a:solidFill>
-                <a:latin typeface="Cambria" pitchFamily="34" charset="0"/>
-                <a:ea typeface="Cambria" pitchFamily="34" charset="-122"/>
-                <a:cs typeface="Cambria" pitchFamily="34" charset="-120"/>
-              </a:rPr>
-              <a:t>Real</a:t>
-            </a:r>
-            <a:endParaRPr lang="en-US" sz="1900" dirty="0"/>
-          </a:p>
-        </p:txBody>
-      </p:sp>
-      <p:sp>
-        <p:nvSpPr>
-          <p:cNvPr id="7" name="Text 4"/>
-          <p:cNvSpPr/>
-          <p:nvPr/>
-        </p:nvSpPr>
-        <p:spPr>
-          <a:xfrm>
-            <a:off x="868680" y="2606040"/>
-            <a:ext cx="4709160" cy="2834640"/>
-          </a:xfrm>
-          <a:prstGeom prst="rect">
-            <a:avLst/>
-          </a:prstGeom>
-          <a:noFill/>
-          <a:ln/>
-        </p:spPr>
-        <p:txBody>
-          <a:bodyPr wrap="square" lIns="0" tIns="0" rIns="0" bIns="0" rtlCol="0" anchor="ctr"/>
-          <a:lstStyle/>
-          <a:p>
-            <a:pPr marL="342900" indent="-342900">
-              <a:lnSpc>
-                <a:spcPct val="125000"/>
-              </a:lnSpc>
-              <a:spcAft>
-                <a:spcPts val="1000"/>
-              </a:spcAft>
-              <a:buSzPct val="100000"/>
-              <a:buChar char="•"/>
-            </a:pPr>
-            <a:r>
-              <a:rPr lang="en-US" sz="1300" dirty="0">
-                <a:solidFill>
-                  <a:srgbClr val="1A2233"/>
-                </a:solidFill>
-                <a:latin typeface="Calibri" pitchFamily="34" charset="0"/>
-                <a:ea typeface="Calibri" pitchFamily="34" charset="-122"/>
-                <a:cs typeface="Calibri" pitchFamily="34" charset="-120"/>
-              </a:rPr>
-              <a:t>Every network request (create, fetch, and pay)</a:t>
-            </a:r>
-            <a:endParaRPr lang="en-US" sz="1300" dirty="0"/>
-          </a:p>
-          <a:p>
-            <a:pPr marL="342900" indent="-342900">
-              <a:lnSpc>
-                <a:spcPct val="125000"/>
-              </a:lnSpc>
-              <a:spcAft>
-                <a:spcPts val="1000"/>
-              </a:spcAft>
-              <a:buSzPct val="100000"/>
-              <a:buChar char="•"/>
-            </a:pPr>
-            <a:r>
-              <a:rPr lang="en-US" sz="1300" dirty="0">
-                <a:solidFill>
-                  <a:srgbClr val="1A2233"/>
-                </a:solidFill>
-                <a:latin typeface="Calibri" pitchFamily="34" charset="0"/>
-                <a:ea typeface="Calibri" pitchFamily="34" charset="-122"/>
-                <a:cs typeface="Calibri" pitchFamily="34" charset="-120"/>
-              </a:rPr>
-              <a:t>The QR code and the actual link resolution on each phone</a:t>
-            </a:r>
-            <a:endParaRPr lang="en-US" sz="1300" dirty="0"/>
-          </a:p>
-          <a:p>
-            <a:pPr marL="342900" indent="-342900">
-              <a:lnSpc>
-                <a:spcPct val="125000"/>
-              </a:lnSpc>
-              <a:spcAft>
-                <a:spcPts val="1000"/>
-              </a:spcAft>
-              <a:buSzPct val="100000"/>
-              <a:buChar char="•"/>
-            </a:pPr>
-            <a:r>
-              <a:rPr lang="en-US" sz="1300" dirty="0">
-                <a:solidFill>
-                  <a:srgbClr val="1A2233"/>
-                </a:solidFill>
-                <a:latin typeface="Calibri" pitchFamily="34" charset="0"/>
-                <a:ea typeface="Calibri" pitchFamily="34" charset="-122"/>
-                <a:cs typeface="Calibri" pitchFamily="34" charset="-120"/>
-              </a:rPr>
-              <a:t>Android's chooser and iOS's Safari fallback, both genuinely triggered</a:t>
-            </a:r>
-            <a:endParaRPr lang="en-US" sz="1300" dirty="0"/>
-          </a:p>
-          <a:p>
-            <a:pPr marL="342900" indent="-342900">
-              <a:lnSpc>
-                <a:spcPct val="125000"/>
-              </a:lnSpc>
-              <a:spcAft>
-                <a:spcPts val="1000"/>
-              </a:spcAft>
-              <a:buSzPct val="100000"/>
-              <a:buChar char="•"/>
-            </a:pPr>
-            <a:r>
-              <a:rPr lang="en-US" sz="1300" dirty="0">
-                <a:solidFill>
-                  <a:srgbClr val="1A2233"/>
-                </a:solidFill>
-                <a:latin typeface="Calibri" pitchFamily="34" charset="0"/>
-                <a:ea typeface="Calibri" pitchFamily="34" charset="-122"/>
-                <a:cs typeface="Calibri" pitchFamily="34" charset="-120"/>
-              </a:rPr>
-              <a:t>Handling the link whether the app is closed, open, or in the background</a:t>
-            </a:r>
-            <a:endParaRPr lang="en-US" sz="1300" dirty="0"/>
-          </a:p>
-          <a:p>
-            <a:pPr marL="342900" indent="-342900">
-              <a:lnSpc>
-                <a:spcPct val="125000"/>
-              </a:lnSpc>
-              <a:spcAft>
-                <a:spcPts val="1000"/>
-              </a:spcAft>
-              <a:buSzPct val="100000"/>
-              <a:buChar char="•"/>
-            </a:pPr>
-            <a:r>
-              <a:rPr lang="en-US" sz="1300" dirty="0">
-                <a:solidFill>
-                  <a:srgbClr val="1A2233"/>
-                </a:solidFill>
-                <a:latin typeface="Calibri" pitchFamily="34" charset="0"/>
-                <a:ea typeface="Calibri" pitchFamily="34" charset="-122"/>
-                <a:cs typeface="Calibri" pitchFamily="34" charset="-120"/>
-              </a:rPr>
-              <a:t>One payment can only be completed once, even with 2 taps at once</a:t>
-            </a:r>
-            <a:endParaRPr lang="en-US" sz="1300" dirty="0"/>
-          </a:p>
-          <a:p>
-            <a:pPr marL="342900" indent="-342900">
-              <a:lnSpc>
-                <a:spcPct val="125000"/>
-              </a:lnSpc>
-              <a:spcAft>
-                <a:spcPts val="1000"/>
-              </a:spcAft>
-              <a:buSzPct val="100000"/>
-              <a:buChar char="•"/>
-            </a:pPr>
-            <a:r>
-              <a:rPr lang="en-US" sz="1300" dirty="0">
-                <a:solidFill>
-                  <a:srgbClr val="1A2233"/>
-                </a:solidFill>
-                <a:latin typeface="Calibri" pitchFamily="34" charset="0"/>
-                <a:ea typeface="Calibri" pitchFamily="34" charset="-122"/>
-                <a:cs typeface="Calibri" pitchFamily="34" charset="-120"/>
-              </a:rPr>
-              <a:t>Basic protection against the page being embedded on another site</a:t>
-            </a:r>
-            <a:endParaRPr lang="en-US" sz="1300" dirty="0"/>
-          </a:p>
-        </p:txBody>
-      </p:sp>
-      <p:sp>
-        <p:nvSpPr>
-          <p:cNvPr id="8" name="Shape 5"/>
-          <p:cNvSpPr/>
-          <p:nvPr/>
-        </p:nvSpPr>
-        <p:spPr>
-          <a:xfrm>
-            <a:off x="6263640" y="1463040"/>
-            <a:ext cx="5349240" cy="4206240"/>
-          </a:xfrm>
-          <a:prstGeom prst="roundRect">
-            <a:avLst>
-              <a:gd name="adj" fmla="val 1739"/>
-            </a:avLst>
-          </a:prstGeom>
-          <a:solidFill>
-            <a:srgbClr val="FFFFFF"/>
-          </a:solidFill>
-          <a:ln/>
-          <a:effectLst>
-            <a:outerShdw sx="100000" sy="100000" kx="0" ky="0" algn="bl" rotWithShape="0" blurRad="101600" dist="38100" dir="2700000">
-              <a:srgbClr val="000000">
-                <a:alpha val="12000"/>
-              </a:srgbClr>
-            </a:outerShdw>
-          </a:effectLst>
-        </p:spPr>
-      </p:sp>
-      <p:sp>
-        <p:nvSpPr>
-          <p:cNvPr id="9" name="Shape 6"/>
-          <p:cNvSpPr/>
-          <p:nvPr/>
-        </p:nvSpPr>
-        <p:spPr>
-          <a:xfrm>
-            <a:off x="6537960" y="1737360"/>
-            <a:ext cx="594360" cy="594360"/>
-          </a:xfrm>
-          <a:prstGeom prst="ellipse">
-            <a:avLst/>
-          </a:prstGeom>
-          <a:solidFill>
-            <a:srgbClr val="F96167"/>
-          </a:solidFill>
-          <a:ln/>
-        </p:spPr>
-      </p:sp>
-      <p:pic>
-        <p:nvPicPr>
-          <p:cNvPr id="10" name="Image 1" descr="preencoded.png">    </p:cNvPr>
-          <p:cNvPicPr>
-            <a:picLocks noChangeAspect="1"/>
-          </p:cNvPicPr>
-          <p:nvPr/>
-        </p:nvPicPr>
-        <p:blipFill>
-          <a:blip r:embed="rId2"/>
-          <a:stretch>
-            <a:fillRect/>
-          </a:stretch>
-        </p:blipFill>
-        <p:spPr>
-          <a:xfrm>
-            <a:off x="6693408" y="1892808"/>
-            <a:ext cx="283464" cy="283464"/>
-          </a:xfrm>
-          <a:prstGeom prst="rect">
-            <a:avLst/>
-          </a:prstGeom>
-        </p:spPr>
-      </p:pic>
-      <p:sp>
-        <p:nvSpPr>
-          <p:cNvPr id="11" name="Text 7"/>
-          <p:cNvSpPr/>
-          <p:nvPr/>
-        </p:nvSpPr>
-        <p:spPr>
-          <a:xfrm>
-            <a:off x="7269480" y="1828800"/>
-            <a:ext cx="4069080" cy="457200"/>
-          </a:xfrm>
-          <a:prstGeom prst="rect">
-            <a:avLst/>
-          </a:prstGeom>
-          <a:noFill/>
-          <a:ln/>
-        </p:spPr>
-        <p:txBody>
-          <a:bodyPr wrap="square" lIns="0" tIns="0" rIns="0" bIns="0" rtlCol="0" anchor="ctr"/>
-          <a:lstStyle/>
-          <a:p>
-            <a:pPr indent="0" marL="0">
-              <a:buNone/>
-            </a:pPr>
-            <a:r>
-              <a:rPr lang="en-US" sz="1900" b="1" dirty="0">
-                <a:solidFill>
-                  <a:srgbClr val="1A2233"/>
-                </a:solidFill>
-                <a:latin typeface="Cambria" pitchFamily="34" charset="0"/>
-                <a:ea typeface="Cambria" pitchFamily="34" charset="-122"/>
-                <a:cs typeface="Cambria" pitchFamily="34" charset="-120"/>
-              </a:rPr>
-              <a:t>Simulated</a:t>
-            </a:r>
-            <a:endParaRPr lang="en-US" sz="1900" dirty="0"/>
-          </a:p>
-        </p:txBody>
-      </p:sp>
-      <p:sp>
-        <p:nvSpPr>
-          <p:cNvPr id="12" name="Text 8"/>
-          <p:cNvSpPr/>
-          <p:nvPr/>
-        </p:nvSpPr>
-        <p:spPr>
-          <a:xfrm>
-            <a:off x="6583680" y="2606040"/>
-            <a:ext cx="4709160" cy="2834640"/>
-          </a:xfrm>
-          <a:prstGeom prst="rect">
-            <a:avLst/>
-          </a:prstGeom>
-          <a:noFill/>
-          <a:ln/>
-        </p:spPr>
-        <p:txBody>
-          <a:bodyPr wrap="square" lIns="0" tIns="0" rIns="0" bIns="0" rtlCol="0" anchor="ctr"/>
-          <a:lstStyle/>
-          <a:p>
-            <a:pPr marL="342900" indent="-342900">
-              <a:lnSpc>
-                <a:spcPct val="125000"/>
-              </a:lnSpc>
-              <a:spcAft>
-                <a:spcPts val="1000"/>
-              </a:spcAft>
-              <a:buSzPct val="100000"/>
-              <a:buChar char="•"/>
-            </a:pPr>
-            <a:r>
-              <a:rPr lang="en-US" sz="1300" dirty="0">
-                <a:solidFill>
-                  <a:srgbClr val="1A2233"/>
-                </a:solidFill>
-                <a:latin typeface="Calibri" pitchFamily="34" charset="0"/>
-                <a:ea typeface="Calibri" pitchFamily="34" charset="-122"/>
-                <a:cs typeface="Calibri" pitchFamily="34" charset="-120"/>
-              </a:rPr>
-              <a:t>The bank balance — just a number in the app, resets on relaunch</a:t>
-            </a:r>
-            <a:endParaRPr lang="en-US" sz="1300" dirty="0"/>
-          </a:p>
-          <a:p>
-            <a:pPr marL="342900" indent="-342900">
-              <a:lnSpc>
-                <a:spcPct val="125000"/>
-              </a:lnSpc>
-              <a:spcAft>
-                <a:spcPts val="1000"/>
-              </a:spcAft>
-              <a:buSzPct val="100000"/>
-              <a:buChar char="•"/>
-            </a:pPr>
-            <a:r>
-              <a:rPr lang="en-US" sz="1300" dirty="0">
-                <a:solidFill>
-                  <a:srgbClr val="1A2233"/>
-                </a:solidFill>
-                <a:latin typeface="Calibri" pitchFamily="34" charset="0"/>
-                <a:ea typeface="Calibri" pitchFamily="34" charset="-122"/>
-                <a:cs typeface="Calibri" pitchFamily="34" charset="-120"/>
-              </a:rPr>
-              <a:t>The payment — no real money moves, no real bank is involved</a:t>
-            </a:r>
-            <a:endParaRPr lang="en-US" sz="1300" dirty="0"/>
-          </a:p>
-          <a:p>
-            <a:pPr marL="342900" indent="-342900">
-              <a:lnSpc>
-                <a:spcPct val="125000"/>
-              </a:lnSpc>
-              <a:spcAft>
-                <a:spcPts val="1000"/>
-              </a:spcAft>
-              <a:buSzPct val="100000"/>
-              <a:buChar char="•"/>
-            </a:pPr>
-            <a:r>
-              <a:rPr lang="en-US" sz="1300" dirty="0">
-                <a:solidFill>
-                  <a:srgbClr val="1A2233"/>
-                </a:solidFill>
-                <a:latin typeface="Calibri" pitchFamily="34" charset="0"/>
-                <a:ea typeface="Calibri" pitchFamily="34" charset="-122"/>
-                <a:cs typeface="Calibri" pitchFamily="34" charset="-120"/>
-              </a:rPr>
-              <a:t>Which bank "paid" is just a label the server stores, not a settlement</a:t>
-            </a:r>
-            <a:endParaRPr lang="en-US" sz="1300" dirty="0"/>
-          </a:p>
-          <a:p>
-            <a:pPr marL="342900" indent="-342900">
-              <a:lnSpc>
-                <a:spcPct val="125000"/>
-              </a:lnSpc>
-              <a:spcAft>
-                <a:spcPts val="1000"/>
-              </a:spcAft>
-              <a:buSzPct val="100000"/>
-              <a:buChar char="•"/>
-            </a:pPr>
-            <a:r>
-              <a:rPr lang="en-US" sz="1300" dirty="0">
-                <a:solidFill>
-                  <a:srgbClr val="1A2233"/>
-                </a:solidFill>
-                <a:latin typeface="Calibri" pitchFamily="34" charset="0"/>
-                <a:ea typeface="Calibri" pitchFamily="34" charset="-122"/>
-                <a:cs typeface="Calibri" pitchFamily="34" charset="-120"/>
-              </a:rPr>
-              <a:t>Real apps would register properly with Android/Apple so their own link opens automatically — we skip that on purpose to keep the chooser/picker page</a:t>
-            </a:r>
-            <a:endParaRPr lang="en-US" sz="1300" dirty="0"/>
           </a:p>
         </p:txBody>
       </p:sp>

</xml_diff>

<commit_message>
Update deck for accuracy; replace glossary/risk doc with full documentation
- SGQR_Deep_Linking_Simulation.pptx: fixed the dedupe-guard slide, which
  described the old permanent-block behavior that was later found to be
  a bug (it blocked re-opening a payment link after cancelling); now
  describes the actual time-windowed fix. Added the picker-page
  auto-completion behavior to the single-use payment slide.
- Replaced SGQR_Glossary_and_Risks.docx with
  SGQR_Complete_Project_Documentation.docx: same glossary and risk
  tables (updated for the dedupe fix and the polling feature, with
  clickjacking now marked resolved/mitigated and both bugs marked
  resolved), plus new sections explaining the project end-to-end for
  both technical and non-technical readers — the constraint, the
  approach, why it's the best solution given tested alternatives, and
  how the website and apps work.
</commit_message>
<xml_diff>
--- a/SGQR_Deep_Linking_Simulation.pptx
+++ b/SGQR_Deep_Linking_Simulation.pptx
@@ -7715,7 +7715,7 @@
                 <a:ea typeface="Cambria" pitchFamily="34" charset="-122"/>
                 <a:cs typeface="Cambria" pitchFamily="34" charset="-120"/>
               </a:rPr>
-              <a:t>Bug: both paths can fire for the same link</a:t>
+              <a:t>Two bugs found here, both fixed</a:t>
             </a:r>
             <a:endParaRPr lang="en-US" sz="1500" dirty="0"/>
           </a:p>
@@ -7749,7 +7749,7 @@
               <a:buNone/>
             </a:pPr>
             <a:r>
-              <a:rPr lang="en-US" sz="1200" dirty="0">
+              <a:rPr lang="en-US" sz="1150" dirty="0">
                 <a:solidFill>
                   <a:srgbClr val="FDECEB"/>
                 </a:solidFill>
@@ -7757,9 +7757,9 @@
                 <a:ea typeface="Calibri" pitchFamily="34" charset="-122"/>
                 <a:cs typeface="Calibri" pitchFamily="34" charset="-120"/>
               </a:rPr>
-              <a:t>On startup, both checks can report the same link — without a guard, the payment screen opened twice. Fixed by remembering the last link handled and ignoring repeats.</a:t>
-            </a:r>
-            <a:endParaRPr lang="en-US" sz="1200" dirty="0"/>
+              <a:t>① On startup, both checks can report the same link, opening the payment screen twice. ② A permanent “ignore repeats” guard then blocked re-opening that link later (e.g. after cancelling). Fixed: only ignore a repeat within 2 seconds of the last one.</a:t>
+            </a:r>
+            <a:endParaRPr lang="en-US" sz="1150" dirty="0"/>
           </a:p>
         </p:txBody>
       </p:sp>
@@ -8562,11 +8562,11 @@
         <p:spPr>
           <a:xfrm>
             <a:off x="7178040" y="1554480"/>
-            <a:ext cx="4462272" cy="2514600"/>
+            <a:ext cx="4462272" cy="2834640"/>
           </a:xfrm>
           <a:prstGeom prst="roundRect">
             <a:avLst>
-              <a:gd name="adj" fmla="val 2909"/>
+              <a:gd name="adj" fmla="val 2581"/>
             </a:avLst>
           </a:prstGeom>
           <a:solidFill>
@@ -8647,7 +8647,7 @@
         <p:spPr>
           <a:xfrm>
             <a:off x="7452360" y="2468880"/>
-            <a:ext cx="3913632" cy="1920240"/>
+            <a:ext cx="3913632" cy="2240280"/>
           </a:xfrm>
           <a:prstGeom prst="rect">
             <a:avLst/>
@@ -8727,6 +8727,30 @@
                 <a:cs typeface="Calibri" pitchFamily="34" charset="-120"/>
               </a:rPr>
               <a:t>The app shows the success screen</a:t>
+            </a:r>
+            <a:endParaRPr lang="en-US" sz="1250" dirty="0"/>
+          </a:p>
+          <a:p>
+            <a:pPr marL="342900" indent="-342900">
+              <a:lnSpc>
+                <a:spcPct val="120000"/>
+              </a:lnSpc>
+              <a:spcAft>
+                <a:spcPts val="1000"/>
+              </a:spcAft>
+              <a:buSzPct val="100000"/>
+              <a:buChar char="•"/>
+            </a:pPr>
+            <a:r>
+              <a:rPr lang="en-US" sz="1250" dirty="0">
+                <a:solidFill>
+                  <a:srgbClr val="5EEAD4"/>
+                </a:solidFill>
+                <a:latin typeface="Calibri" pitchFamily="34" charset="0"/>
+                <a:ea typeface="Calibri" pitchFamily="34" charset="-122"/>
+                <a:cs typeface="Calibri" pitchFamily="34" charset="-120"/>
+              </a:rPr>
+              <a:t>Any open picker webpage flips to “completed” within ~2s (polling)</a:t>
             </a:r>
             <a:endParaRPr lang="en-US" sz="1250" dirty="0"/>
           </a:p>

</xml_diff>

<commit_message>
Document all 5 additional deep-linking methods in deck and Word doc
- Word doc: new Part 9 comparing all 6 methods (core approach + the 5
  new demo apps) with real device test results, renumbering Summary to
  Part 10.
- Deck: two new slides — a color-coded card grid of the 5 new methods,
  and a side-by-side breakdown of the two that are code-correct but
  blocked by a real external requirement (paid Apple Developer account,
  published App Store listing).
- Also includes the earlier "grid of bank tiles" wording fix to the
  sequence-diagram deck that was pending from prior work this session.

Co-Authored-By: Claude Sonnet 5 <noreply@anthropic.com>
</commit_message>
<xml_diff>
--- a/SGQR_Deep_Linking_Simulation.pptx
+++ b/SGQR_Deep_Linking_Simulation.pptx
@@ -15,6 +15,8 @@
     <p:sldId id="263" r:id="rId9"/>
     <p:sldId id="264" r:id="rId10"/>
     <p:sldId id="265" r:id="rId11"/>
+    <p:sldId id="268" r:id="rId19"/>
+    <p:sldId id="267" r:id="rId18"/>
     <p:sldId id="266" r:id="rId12"/>
   </p:sldIdLst>
   <p:notesMasterIdLst>
@@ -3115,6 +3117,1677 @@
 </p:sld>
 </file>
 
+<file path=ppt/slides/slide12.xml><?xml version="1.0" encoding="utf-8"?>
+<p:sld xmlns:a="http://schemas.openxmlformats.org/drawingml/2006/main" xmlns:r="http://schemas.openxmlformats.org/officeDocument/2006/relationships" xmlns:p="http://schemas.openxmlformats.org/presentationml/2006/main">
+  <p:cSld name="Slide 12">
+    <p:bg>
+      <p:bgPr>
+        <a:solidFill>
+          <a:srgbClr val="21295C"/>
+        </a:solidFill>
+      </p:bgPr>
+    </p:bg>
+    <p:spTree>
+      <p:nvGrpSpPr>
+        <p:cNvPr id="1" name=""/>
+        <p:cNvGrpSpPr/>
+        <p:nvPr/>
+      </p:nvGrpSpPr>
+      <p:grpSpPr>
+        <a:xfrm>
+          <a:off x="0" y="0"/>
+          <a:ext cx="0" cy="0"/>
+          <a:chOff x="0" y="0"/>
+          <a:chExt cx="0" cy="0"/>
+        </a:xfrm>
+      </p:grpSpPr>
+      <p:sp>
+        <p:nvSpPr>
+          <p:cNvPr id="2" name="Title"/>
+          <p:cNvSpPr/>
+          <p:nvPr/>
+        </p:nvSpPr>
+        <p:spPr>
+          <a:xfrm>
+            <a:off x="548640" y="330000"/>
+            <a:ext cx="11094720" cy="548640"/>
+          </a:xfrm>
+          <a:prstGeom prst="rect">
+            <a:avLst/>
+          </a:prstGeom>
+          <a:noFill/>
+          <a:ln/>
+        </p:spPr>
+        <p:txBody>
+          <a:bodyPr wrap="square" lIns="0" tIns="0" rIns="0" bIns="0" rtlCol="0" anchor="ctr"/>
+          <a:lstStyle/>
+          <a:p>
+            <a:pPr indent="0" marL="0">
+              <a:buNone/>
+            </a:pPr>
+            <a:r>
+              <a:rPr lang="en-US" sz="2800" b="1" dirty="0">
+                <a:solidFill>
+                  <a:srgbClr val="FFFFFF"/>
+                </a:solidFill>
+                <a:latin typeface="Cambria" pitchFamily="34" charset="0"/>
+                <a:ea typeface="Cambria" pitchFamily="34" charset="-122"/>
+                <a:cs typeface="Cambria" pitchFamily="34" charset="-120"/>
+              </a:rPr>
+              <a:t>Two Methods Were Correct but Blocked</a:t>
+            </a:r>
+          </a:p>
+        </p:txBody>
+      </p:sp>
+      <p:sp>
+        <p:nvSpPr>
+          <p:cNvPr id="3" name="Subtitle"/>
+          <p:cNvSpPr/>
+          <p:nvPr/>
+        </p:nvSpPr>
+        <p:spPr>
+          <a:xfrm>
+            <a:off x="548640" y="980000"/>
+            <a:ext cx="11094720" cy="400000"/>
+          </a:xfrm>
+          <a:prstGeom prst="rect">
+            <a:avLst/>
+          </a:prstGeom>
+          <a:noFill/>
+          <a:ln/>
+        </p:spPr>
+        <p:txBody>
+          <a:bodyPr wrap="square" lIns="0" tIns="0" rIns="0" bIns="0" rtlCol="0" anchor="t"/>
+          <a:lstStyle/>
+          <a:p>
+            <a:pPr indent="0" marL="0">
+              <a:buNone/>
+            </a:pPr>
+            <a:r>
+              <a:rPr lang="en-US" sz="1400" i="1" dirty="0">
+                <a:solidFill>
+                  <a:srgbClr val="F4A6A6"/>
+                </a:solidFill>
+                <a:latin typeface="Calibri" pitchFamily="34" charset="0"/>
+                <a:ea typeface="Calibri" pitchFamily="34" charset="-122"/>
+                <a:cs typeface="Calibri" pitchFamily="34" charset="-120"/>
+              </a:rPr>
+              <a:t>Code and hosting checked out — a real external requirement stopped them short</a:t>
+            </a:r>
+          </a:p>
+        </p:txBody>
+      </p:sp>
+      <p:sp>
+        <p:nvSpPr>
+          <p:cNvPr id="31" name="ColHeader"/>
+          <p:cNvSpPr/>
+          <p:nvPr/>
+        </p:nvSpPr>
+        <p:spPr>
+          <a:xfrm>
+            <a:off x="548640" y="1600000"/>
+            <a:ext cx="5347240" cy="500000"/>
+          </a:xfrm>
+          <a:prstGeom prst="rect">
+            <a:avLst/>
+          </a:prstGeom>
+          <a:noFill/>
+          <a:ln/>
+        </p:spPr>
+        <p:txBody>
+          <a:bodyPr wrap="square" lIns="0" tIns="0" rIns="0" bIns="0" anchor="ctr"/>
+          <a:lstStyle/>
+          <a:p>
+            <a:pPr indent="0" marL="0">
+              <a:buNone/>
+            </a:pPr>
+            <a:r>
+              <a:rPr lang="en-US" sz="2000" b="1" dirty="0">
+                <a:solidFill>
+                  <a:srgbClr val="8FD6E8"/>
+                </a:solidFill>
+                <a:latin typeface="Cambria" pitchFamily="34" charset="0"/>
+              </a:rPr>
+              <a:t>Verified iOS Universal Links</a:t>
+            </a:r>
+          </a:p>
+        </p:txBody>
+      </p:sp>
+      <p:sp>
+        <p:nvSpPr>
+          <p:cNvPr id="32" name="ColHeader"/>
+          <p:cNvSpPr/>
+          <p:nvPr/>
+        </p:nvSpPr>
+        <p:spPr>
+          <a:xfrm>
+            <a:off x="6295880" y="1600000"/>
+            <a:ext cx="5347240" cy="500000"/>
+          </a:xfrm>
+          <a:prstGeom prst="rect">
+            <a:avLst/>
+          </a:prstGeom>
+          <a:noFill/>
+          <a:ln/>
+        </p:spPr>
+        <p:txBody>
+          <a:bodyPr wrap="square" lIns="0" tIns="0" rIns="0" bIns="0" anchor="ctr"/>
+          <a:lstStyle/>
+          <a:p>
+            <a:pPr indent="0" marL="0">
+              <a:buNone/>
+            </a:pPr>
+            <a:r>
+              <a:rPr lang="en-US" sz="2000" b="1" dirty="0">
+                <a:solidFill>
+                  <a:srgbClr val="8FD6E8"/>
+                </a:solidFill>
+                <a:latin typeface="Cambria" pitchFamily="34" charset="0"/>
+              </a:rPr>
+              <a:t>iOS Smart App Banner</a:t>
+            </a:r>
+          </a:p>
+        </p:txBody>
+      </p:sp>
+      <p:sp>
+        <p:nvSpPr>
+          <p:cNvPr id="33" name="Panel"/>
+          <p:cNvSpPr/>
+          <p:nvPr/>
+        </p:nvSpPr>
+        <p:spPr>
+          <a:xfrm>
+            <a:off x="548640" y="2200000"/>
+            <a:ext cx="5347240" cy="4200000"/>
+          </a:xfrm>
+          <a:prstGeom prst="roundRect">
+            <a:avLst>
+              <a:gd name="adj" fmla="val 3500"/>
+            </a:avLst>
+          </a:prstGeom>
+          <a:solidFill>
+            <a:srgbClr val="FFFFFF"/>
+          </a:solidFill>
+          <a:ln>
+            <a:noFill/>
+          </a:ln>
+        </p:spPr>
+        <p:txBody>
+          <a:bodyPr/>
+          <a:lstStyle/>
+          <a:p>
+            <a:endParaRPr lang="en-US"/>
+          </a:p>
+        </p:txBody>
+      </p:sp>
+      <p:sp>
+        <p:nvSpPr>
+          <p:cNvPr id="34" name="PanelTitle"/>
+          <p:cNvSpPr/>
+          <p:nvPr/>
+        </p:nvSpPr>
+        <p:spPr>
+          <a:xfrm>
+            <a:off x="768640" y="2380000"/>
+            <a:ext cx="4907240" cy="420000"/>
+          </a:xfrm>
+          <a:prstGeom prst="rect">
+            <a:avLst/>
+          </a:prstGeom>
+          <a:noFill/>
+          <a:ln/>
+        </p:spPr>
+        <p:txBody>
+          <a:bodyPr wrap="square" lIns="0" tIns="0" rIns="0" bIns="0" anchor="t"/>
+          <a:lstStyle/>
+          <a:p>
+            <a:pPr indent="0" marL="0">
+              <a:buNone/>
+            </a:pPr>
+            <a:r>
+              <a:rPr lang="en-US" sz="1500" b="1" dirty="0">
+                <a:solidFill>
+                  <a:srgbClr val="0A7EA4"/>
+                </a:solidFill>
+                <a:latin typeface="Calibri" pitchFamily="34" charset="0"/>
+              </a:rPr>
+              <a:t>What we built</a:t>
+            </a:r>
+          </a:p>
+        </p:txBody>
+      </p:sp>
+      <p:sp>
+        <p:nvSpPr>
+          <p:cNvPr id="35" name="PanelBody"/>
+          <p:cNvSpPr/>
+          <p:nvPr/>
+        </p:nvSpPr>
+        <p:spPr>
+          <a:xfrm>
+            <a:off x="768640" y="2850000"/>
+            <a:ext cx="4907240" cy="3350000"/>
+          </a:xfrm>
+          <a:prstGeom prst="rect">
+            <a:avLst/>
+          </a:prstGeom>
+          <a:noFill/>
+          <a:ln/>
+        </p:spPr>
+        <p:txBody>
+          <a:bodyPr wrap="square" lIns="0" tIns="0" rIns="0" bIns="0" anchor="t"/>
+          <a:lstStyle/>
+          <a:p>
+            <a:pPr indent="0" marL="228600">
+              <a:lnSpc>
+                <a:spcPct val="115000"/>
+              </a:lnSpc>
+              <a:spcAft>
+                <a:spcPts val="900"/>
+              </a:spcAft>
+              <a:buFont typeface="Arial"/>
+              <a:buChar char="•"/>
+            </a:pPr>
+            <a:r>
+              <a:rPr lang="en-US" sz="1250" b="1" dirty="0">
+                <a:solidFill>
+                  <a:srgbClr val="1A2233"/>
+                </a:solidFill>
+                <a:latin typeface="Calibri" pitchFamily="34" charset="0"/>
+              </a:rPr>
+              <a:t>Entitlement: </a:t>
+            </a:r>
+            <a:r>
+              <a:rPr lang="en-US" sz="1250" dirty="0">
+                <a:solidFill>
+                  <a:srgbClr val="333333"/>
+                </a:solidFill>
+                <a:latin typeface="Calibri" pitchFamily="34" charset="0"/>
+              </a:rPr>
+              <a:t>Associated Domains, confirmed present in the signed binary via codesign.</a:t>
+            </a:r>
+          </a:p>
+          <a:p>
+            <a:pPr indent="0" marL="228600">
+              <a:lnSpc>
+                <a:spcPct val="115000"/>
+              </a:lnSpc>
+              <a:spcAft>
+                <a:spcPts val="900"/>
+              </a:spcAft>
+              <a:buFont typeface="Arial"/>
+              <a:buChar char="•"/>
+            </a:pPr>
+            <a:r>
+              <a:rPr lang="en-US" sz="1250" b="1" dirty="0">
+                <a:solidFill>
+                  <a:srgbClr val="1A2233"/>
+                </a:solidFill>
+                <a:latin typeface="Calibri" pitchFamily="34" charset="0"/>
+              </a:rPr>
+              <a:t>Hosting: </a:t>
+            </a:r>
+            <a:r>
+              <a:rPr lang="en-US" sz="1250" dirty="0">
+                <a:solidFill>
+                  <a:srgbClr val="333333"/>
+                </a:solidFill>
+                <a:latin typeface="Calibri" pitchFamily="34" charset="0"/>
+              </a:rPr>
+              <a:t>apple-app-site-association served correctly at /.well-known/.</a:t>
+            </a:r>
+          </a:p>
+          <a:p>
+            <a:pPr indent="0" marL="228600">
+              <a:lnSpc>
+                <a:spcPct val="115000"/>
+              </a:lnSpc>
+              <a:spcAft>
+                <a:spcPts val="900"/>
+              </a:spcAft>
+              <a:buFont typeface="Arial"/>
+              <a:buChar char="•"/>
+            </a:pPr>
+            <a:r>
+              <a:rPr lang="en-US" sz="1250" b="1" dirty="0">
+                <a:solidFill>
+                  <a:srgbClr val="1A2233"/>
+                </a:solidFill>
+                <a:latin typeface="Calibri" pitchFamily="34" charset="0"/>
+              </a:rPr>
+              <a:t>Blocker: </a:t>
+            </a:r>
+            <a:r>
+              <a:rPr lang="en-US" sz="1250" dirty="0">
+                <a:solidFill>
+                  <a:srgbClr val="333333"/>
+                </a:solidFill>
+                <a:latin typeface="Calibri" pitchFamily="34" charset="0"/>
+              </a:rPr>
+              <a:t>Full verification requires a paid Apple Developer Program membership.</a:t>
+            </a:r>
+          </a:p>
+          <a:p>
+            <a:pPr indent="0" marL="228600">
+              <a:lnSpc>
+                <a:spcPct val="115000"/>
+              </a:lnSpc>
+              <a:spcAft>
+                <a:spcPts val="900"/>
+              </a:spcAft>
+              <a:buFont typeface="Arial"/>
+              <a:buChar char="•"/>
+            </a:pPr>
+            <a:r>
+              <a:rPr lang="en-US" sz="1250" b="1" dirty="0">
+                <a:solidFill>
+                  <a:srgbClr val="1A2233"/>
+                </a:solidFill>
+                <a:latin typeface="Calibri" pitchFamily="34" charset="0"/>
+              </a:rPr>
+              <a:t>Observed: </a:t>
+            </a:r>
+            <a:r>
+              <a:rPr lang="en-US" sz="1250" dirty="0">
+                <a:solidFill>
+                  <a:srgbClr val="333333"/>
+                </a:solidFill>
+                <a:latin typeface="Calibri" pitchFamily="34" charset="0"/>
+              </a:rPr>
+              <a:t>iOS never created the per-app "Open Links" Settings entry — every test fell through to Safari with a manual banner, never a silent handoff.</a:t>
+            </a:r>
+          </a:p>
+        </p:txBody>
+      </p:sp>
+      <p:sp>
+        <p:nvSpPr>
+          <p:cNvPr id="36" name="Panel"/>
+          <p:cNvSpPr/>
+          <p:nvPr/>
+        </p:nvSpPr>
+        <p:spPr>
+          <a:xfrm>
+            <a:off x="6295880" y="2200000"/>
+            <a:ext cx="5347240" cy="4200000"/>
+          </a:xfrm>
+          <a:prstGeom prst="roundRect">
+            <a:avLst>
+              <a:gd name="adj" fmla="val 3500"/>
+            </a:avLst>
+          </a:prstGeom>
+          <a:solidFill>
+            <a:srgbClr val="FFFFFF"/>
+          </a:solidFill>
+          <a:ln>
+            <a:noFill/>
+          </a:ln>
+        </p:spPr>
+        <p:txBody>
+          <a:bodyPr/>
+          <a:lstStyle/>
+          <a:p>
+            <a:endParaRPr lang="en-US"/>
+          </a:p>
+        </p:txBody>
+      </p:sp>
+      <p:sp>
+        <p:nvSpPr>
+          <p:cNvPr id="37" name="PanelTitle"/>
+          <p:cNvSpPr/>
+          <p:nvPr/>
+        </p:nvSpPr>
+        <p:spPr>
+          <a:xfrm>
+            <a:off x="6515880" y="2380000"/>
+            <a:ext cx="4907240" cy="420000"/>
+          </a:xfrm>
+          <a:prstGeom prst="rect">
+            <a:avLst/>
+          </a:prstGeom>
+          <a:noFill/>
+          <a:ln/>
+        </p:spPr>
+        <p:txBody>
+          <a:bodyPr wrap="square" lIns="0" tIns="0" rIns="0" bIns="0" anchor="t"/>
+          <a:lstStyle/>
+          <a:p>
+            <a:pPr indent="0" marL="0">
+              <a:buNone/>
+            </a:pPr>
+            <a:r>
+              <a:rPr lang="en-US" sz="1500" b="1" dirty="0">
+                <a:solidFill>
+                  <a:srgbClr val="2A9D8F"/>
+                </a:solidFill>
+                <a:latin typeface="Calibri" pitchFamily="34" charset="0"/>
+              </a:rPr>
+              <a:t>What we built</a:t>
+            </a:r>
+          </a:p>
+        </p:txBody>
+      </p:sp>
+      <p:sp>
+        <p:nvSpPr>
+          <p:cNvPr id="38" name="PanelBody"/>
+          <p:cNvSpPr/>
+          <p:nvPr/>
+        </p:nvSpPr>
+        <p:spPr>
+          <a:xfrm>
+            <a:off x="6515880" y="2850000"/>
+            <a:ext cx="4907240" cy="3350000"/>
+          </a:xfrm>
+          <a:prstGeom prst="rect">
+            <a:avLst/>
+          </a:prstGeom>
+          <a:noFill/>
+          <a:ln/>
+        </p:spPr>
+        <p:txBody>
+          <a:bodyPr wrap="square" lIns="0" tIns="0" rIns="0" bIns="0" anchor="t"/>
+          <a:lstStyle/>
+          <a:p>
+            <a:pPr indent="0" marL="228600">
+              <a:lnSpc>
+                <a:spcPct val="115000"/>
+              </a:lnSpc>
+              <a:spcAft>
+                <a:spcPts val="900"/>
+              </a:spcAft>
+              <a:buFont typeface="Arial"/>
+              <a:buChar char="•"/>
+            </a:pPr>
+            <a:r>
+              <a:rPr lang="en-US" sz="1250" b="1" dirty="0">
+                <a:solidFill>
+                  <a:srgbClr val="1A2233"/>
+                </a:solidFill>
+                <a:latin typeface="Calibri" pitchFamily="34" charset="0"/>
+              </a:rPr>
+              <a:t>Tag: </a:t>
+            </a:r>
+            <a:r>
+              <a:rPr lang="en-US" sz="1250" dirty="0">
+                <a:solidFill>
+                  <a:srgbClr val="333333"/>
+                </a:solidFill>
+                <a:latin typeface="Calibri" pitchFamily="34" charset="0"/>
+              </a:rPr>
+              <a:t>A correct &lt;meta name="apple-itunes-app"&gt; with app-id and app-argument.</a:t>
+            </a:r>
+          </a:p>
+          <a:p>
+            <a:pPr indent="0" marL="228600">
+              <a:lnSpc>
+                <a:spcPct val="115000"/>
+              </a:lnSpc>
+              <a:spcAft>
+                <a:spcPts val="900"/>
+              </a:spcAft>
+              <a:buFont typeface="Arial"/>
+              <a:buChar char="•"/>
+            </a:pPr>
+            <a:r>
+              <a:rPr lang="en-US" sz="1250" b="1" dirty="0">
+                <a:solidFill>
+                  <a:srgbClr val="1A2233"/>
+                </a:solidFill>
+                <a:latin typeface="Calibri" pitchFamily="34" charset="0"/>
+              </a:rPr>
+              <a:t>Hosting: </a:t>
+            </a:r>
+            <a:r>
+              <a:rPr lang="en-US" sz="1250" dirty="0">
+                <a:solidFill>
+                  <a:srgbClr val="333333"/>
+                </a:solidFill>
+                <a:latin typeface="Calibri" pitchFamily="34" charset="0"/>
+              </a:rPr>
+              <a:t>Deployed and reachable — page loads fine in Safari.</a:t>
+            </a:r>
+          </a:p>
+          <a:p>
+            <a:pPr indent="0" marL="228600">
+              <a:lnSpc>
+                <a:spcPct val="115000"/>
+              </a:lnSpc>
+              <a:spcAft>
+                <a:spcPts val="900"/>
+              </a:spcAft>
+              <a:buFont typeface="Arial"/>
+              <a:buChar char="•"/>
+            </a:pPr>
+            <a:r>
+              <a:rPr lang="en-US" sz="1250" b="1" dirty="0">
+                <a:solidFill>
+                  <a:srgbClr val="1A2233"/>
+                </a:solidFill>
+                <a:latin typeface="Calibri" pitchFamily="34" charset="0"/>
+              </a:rPr>
+              <a:t>Blocker: </a:t>
+            </a:r>
+            <a:r>
+              <a:rPr lang="en-US" sz="1250" dirty="0">
+                <a:solidFill>
+                  <a:srgbClr val="333333"/>
+                </a:solidFill>
+                <a:latin typeface="Calibri" pitchFamily="34" charset="0"/>
+              </a:rPr>
+              <a:t>The app-id must match a real, published App Store listing.</a:t>
+            </a:r>
+          </a:p>
+          <a:p>
+            <a:pPr indent="0" marL="228600">
+              <a:lnSpc>
+                <a:spcPct val="115000"/>
+              </a:lnSpc>
+              <a:spcAft>
+                <a:spcPts val="900"/>
+              </a:spcAft>
+              <a:buFont typeface="Arial"/>
+              <a:buChar char="•"/>
+            </a:pPr>
+            <a:r>
+              <a:rPr lang="en-US" sz="1250" b="1" dirty="0">
+                <a:solidFill>
+                  <a:srgbClr val="1A2233"/>
+                </a:solidFill>
+                <a:latin typeface="Calibri" pitchFamily="34" charset="0"/>
+              </a:rPr>
+              <a:t>Observed: </a:t>
+            </a:r>
+            <a:r>
+              <a:rPr lang="en-US" sz="1250" dirty="0">
+                <a:solidFill>
+                  <a:srgbClr val="333333"/>
+                </a:solidFill>
+                <a:latin typeface="Calibri" pitchFamily="34" charset="0"/>
+              </a:rPr>
+              <a:t>Apple validates the app-id server-side, not just tag presence — a sideloaded, unpublished app can never trigger the banner, no matter how correct the tag is.</a:t>
+            </a:r>
+          </a:p>
+        </p:txBody>
+      </p:sp>
+    </p:spTree>
+  </p:cSld>
+  <p:clrMapOvr>
+    <a:overrideClrMapping bg1="lt1" tx1="dk1" bg2="lt2" tx2="dk2" accent1="accent1" accent2="accent2" accent3="accent3" accent4="accent4" accent5="accent5" accent6="accent6" hlink="hlink" folHlink="folHlink"/>
+  </p:clrMapOvr>
+</p:sld>
+</file>
+
+<file path=ppt/slides/slide13.xml><?xml version="1.0" encoding="utf-8"?>
+<p:sld xmlns:a="http://schemas.openxmlformats.org/drawingml/2006/main" xmlns:r="http://schemas.openxmlformats.org/officeDocument/2006/relationships" xmlns:p="http://schemas.openxmlformats.org/presentationml/2006/main">
+  <p:cSld name="Slide 13">
+    <p:bg>
+      <p:bgPr>
+        <a:solidFill>
+          <a:srgbClr val="21295C"/>
+        </a:solidFill>
+      </p:bgPr>
+    </p:bg>
+    <p:spTree>
+      <p:nvGrpSpPr>
+        <p:cNvPr id="1" name=""/>
+        <p:cNvGrpSpPr/>
+        <p:nvPr/>
+      </p:nvGrpSpPr>
+      <p:grpSpPr>
+        <a:xfrm>
+          <a:off x="0" y="0"/>
+          <a:ext cx="0" cy="0"/>
+          <a:chOff x="0" y="0"/>
+          <a:chExt cx="0" cy="0"/>
+        </a:xfrm>
+      </p:grpSpPr>
+      <p:sp>
+        <p:nvSpPr>
+          <p:cNvPr id="2" name="Title"/>
+          <p:cNvSpPr/>
+          <p:nvPr/>
+        </p:nvSpPr>
+        <p:spPr>
+          <a:xfrm>
+            <a:off x="548640" y="330000"/>
+            <a:ext cx="11094720" cy="548640"/>
+          </a:xfrm>
+          <a:prstGeom prst="rect">
+            <a:avLst/>
+          </a:prstGeom>
+          <a:noFill/>
+          <a:ln/>
+        </p:spPr>
+        <p:txBody>
+          <a:bodyPr wrap="square" lIns="0" tIns="0" rIns="0" bIns="0" rtlCol="0" anchor="ctr"/>
+          <a:lstStyle/>
+          <a:p>
+            <a:pPr indent="0" marL="0">
+              <a:buNone/>
+            </a:pPr>
+            <a:r>
+              <a:rPr lang="en-US" sz="2800" b="1" dirty="0">
+                <a:solidFill>
+                  <a:srgbClr val="FFFFFF"/>
+                </a:solidFill>
+                <a:latin typeface="Cambria" pitchFamily="34" charset="0"/>
+                <a:ea typeface="Cambria" pitchFamily="34" charset="-122"/>
+                <a:cs typeface="Cambria" pitchFamily="34" charset="-120"/>
+              </a:rPr>
+              <a:t>Other Deep-Linking Methods We Also Built</a:t>
+            </a:r>
+          </a:p>
+        </p:txBody>
+      </p:sp>
+      <p:sp>
+        <p:nvSpPr>
+          <p:cNvPr id="3" name="Subtitle"/>
+          <p:cNvSpPr/>
+          <p:nvPr/>
+        </p:nvSpPr>
+        <p:spPr>
+          <a:xfrm>
+            <a:off x="548640" y="980000"/>
+            <a:ext cx="11094720" cy="400000"/>
+          </a:xfrm>
+          <a:prstGeom prst="rect">
+            <a:avLst/>
+          </a:prstGeom>
+          <a:noFill/>
+          <a:ln/>
+        </p:spPr>
+        <p:txBody>
+          <a:bodyPr wrap="square" lIns="0" tIns="0" rIns="0" bIns="0" rtlCol="0" anchor="t"/>
+          <a:lstStyle/>
+          <a:p>
+            <a:pPr indent="0" marL="0">
+              <a:buNone/>
+            </a:pPr>
+            <a:r>
+              <a:rPr lang="en-US" sz="1400" i="1" dirty="0">
+                <a:solidFill>
+                  <a:srgbClr val="CADCFC"/>
+                </a:solidFill>
+                <a:latin typeface="Calibri" pitchFamily="34" charset="0"/>
+                <a:ea typeface="Calibri" pitchFamily="34" charset="-122"/>
+                <a:cs typeface="Calibri" pitchFamily="34" charset="-120"/>
+              </a:rPr>
+              <a:t>Five more mechanisms, each its own standalone app, each verified on a real device</a:t>
+            </a:r>
+          </a:p>
+        </p:txBody>
+      </p:sp>
+      <p:sp>
+        <p:nvSpPr>
+          <p:cNvPr id="11" name="Card"/>
+          <p:cNvSpPr/>
+          <p:nvPr/>
+        </p:nvSpPr>
+        <p:spPr>
+          <a:xfrm>
+            <a:off x="548640" y="1650000"/>
+            <a:ext cx="3598240" cy="2350000"/>
+          </a:xfrm>
+          <a:prstGeom prst="roundRect">
+            <a:avLst>
+              <a:gd name="adj" fmla="val 5000"/>
+            </a:avLst>
+          </a:prstGeom>
+          <a:solidFill>
+            <a:srgbClr val="6A4C93"/>
+          </a:solidFill>
+          <a:ln>
+            <a:noFill/>
+          </a:ln>
+          <a:effectLst>
+            <a:outerShdw sx="100000" sy="100000" kx="0" ky="0" algn="bl" rotWithShape="0" blurRad="76200" dist="25400" dir="2700000">
+              <a:srgbClr val="000000">
+                <a:alpha val="30000"/>
+              </a:srgbClr>
+            </a:outerShdw>
+          </a:effectLst>
+        </p:spPr>
+        <p:txBody>
+          <a:bodyPr wrap="square" lIns="0" tIns="0" rIns="0" bIns="0"/>
+          <a:lstStyle/>
+          <a:p>
+            <a:endParaRPr lang="en-US"/>
+          </a:p>
+        </p:txBody>
+      </p:sp>
+      <p:sp>
+        <p:nvSpPr>
+          <p:cNvPr id="12" name="CardTitle"/>
+          <p:cNvSpPr/>
+          <p:nvPr/>
+        </p:nvSpPr>
+        <p:spPr>
+          <a:xfrm>
+            <a:off x="728640" y="1800000"/>
+            <a:ext cx="3238240" cy="440000"/>
+          </a:xfrm>
+          <a:prstGeom prst="rect">
+            <a:avLst/>
+          </a:prstGeom>
+          <a:noFill/>
+          <a:ln/>
+        </p:spPr>
+        <p:txBody>
+          <a:bodyPr wrap="square" lIns="0" tIns="0" rIns="0" bIns="0" anchor="t"/>
+          <a:lstStyle/>
+          <a:p>
+            <a:pPr indent="0" marL="0">
+              <a:buNone/>
+            </a:pPr>
+            <a:r>
+              <a:rPr lang="en-US" sz="1500" b="1" dirty="0">
+                <a:solidFill>
+                  <a:srgbClr val="FFFFFF"/>
+                </a:solidFill>
+                <a:latin typeface="Cambria" pitchFamily="34" charset="0"/>
+              </a:rPr>
+              <a:t>Verified Android App Links</a:t>
+            </a:r>
+          </a:p>
+        </p:txBody>
+      </p:sp>
+      <p:sp>
+        <p:nvSpPr>
+          <p:cNvPr id="13" name="CardBody"/>
+          <p:cNvSpPr/>
+          <p:nvPr/>
+        </p:nvSpPr>
+        <p:spPr>
+          <a:xfrm>
+            <a:off x="728640" y="2250000"/>
+            <a:ext cx="3238240" cy="1400000"/>
+          </a:xfrm>
+          <a:prstGeom prst="rect">
+            <a:avLst/>
+          </a:prstGeom>
+          <a:noFill/>
+          <a:ln/>
+        </p:spPr>
+        <p:txBody>
+          <a:bodyPr wrap="square" lIns="0" tIns="0" rIns="0" bIns="0" anchor="t"/>
+          <a:lstStyle/>
+          <a:p>
+            <a:pPr indent="0" marL="0">
+              <a:lnSpc>
+                <a:spcPct val="118000"/>
+              </a:lnSpc>
+              <a:spcAft>
+                <a:spcPts val="600"/>
+              </a:spcAft>
+              <a:buNone/>
+            </a:pPr>
+            <a:r>
+              <a:rPr lang="en-US" sz="1150" dirty="0">
+                <a:solidFill>
+                  <a:srgbClr val="FFFFFF"/>
+                </a:solidFill>
+                <a:latin typeface="Calibri" pitchFamily="34" charset="0"/>
+              </a:rPr>
+              <a:t>autoVerify="true" + hosted</a:t>
+            </a:r>
+          </a:p>
+          <a:p>
+            <a:pPr indent="0" marL="0">
+              <a:lnSpc>
+                <a:spcPct val="118000"/>
+              </a:lnSpc>
+              <a:spcAft>
+                <a:spcPts val="600"/>
+              </a:spcAft>
+              <a:buNone/>
+            </a:pPr>
+            <a:r>
+              <a:rPr lang="en-US" sz="1150" dirty="0">
+                <a:solidFill>
+                  <a:srgbClr val="FFFFFF"/>
+                </a:solidFill>
+                <a:latin typeface="Calibri" pitchFamily="34" charset="0"/>
+              </a:rPr>
+              <a:t>assetlinks.json — proves domain</a:t>
+            </a:r>
+          </a:p>
+          <a:p>
+            <a:pPr indent="0" marL="0">
+              <a:lnSpc>
+                <a:spcPct val="118000"/>
+              </a:lnSpc>
+              <a:spcAft>
+                <a:spcPts val="600"/>
+              </a:spcAft>
+              <a:buNone/>
+            </a:pPr>
+            <a:r>
+              <a:rPr lang="en-US" sz="1150" dirty="0">
+                <a:solidFill>
+                  <a:srgbClr val="FFFFFF"/>
+                </a:solidFill>
+                <a:latin typeface="Calibri" pitchFamily="34" charset="0"/>
+              </a:rPr>
+              <a:t>ownership via signing cert.</a:t>
+            </a:r>
+          </a:p>
+        </p:txBody>
+      </p:sp>
+      <p:sp>
+        <p:nvSpPr>
+          <p:cNvPr id="14" name="Badge"/>
+          <p:cNvSpPr/>
+          <p:nvPr/>
+        </p:nvSpPr>
+        <p:spPr>
+          <a:xfrm>
+            <a:off x="728640" y="3580000"/>
+            <a:ext cx="3238240" cy="330000"/>
+          </a:xfrm>
+          <a:prstGeom prst="rect">
+            <a:avLst/>
+          </a:prstGeom>
+          <a:noFill/>
+          <a:ln/>
+        </p:spPr>
+        <p:txBody>
+          <a:bodyPr wrap="square" lIns="0" tIns="0" rIns="0" bIns="0" anchor="b"/>
+          <a:lstStyle/>
+          <a:p>
+            <a:pPr indent="0" marL="0">
+              <a:buNone/>
+            </a:pPr>
+            <a:r>
+              <a:rPr lang="en-US" sz="1050" b="1" i="1" dirty="0">
+                <a:solidFill>
+                  <a:srgbClr val="8CFFC1"/>
+                </a:solidFill>
+                <a:latin typeface="Calibri" pitchFamily="34" charset="0"/>
+              </a:rPr>
+              <a:t>✓ Tested live: opened directly,
+zero prompt, no chooser.</a:t>
+            </a:r>
+          </a:p>
+        </p:txBody>
+      </p:sp>
+      <p:sp>
+        <p:nvSpPr>
+          <p:cNvPr id="15" name="Card"/>
+          <p:cNvSpPr/>
+          <p:nvPr/>
+        </p:nvSpPr>
+        <p:spPr>
+          <a:xfrm>
+            <a:off x="4296880" y="1650000"/>
+            <a:ext cx="3598240" cy="2350000"/>
+          </a:xfrm>
+          <a:prstGeom prst="roundRect">
+            <a:avLst>
+              <a:gd name="adj" fmla="val 5000"/>
+            </a:avLst>
+          </a:prstGeom>
+          <a:solidFill>
+            <a:srgbClr val="0A7EA4"/>
+          </a:solidFill>
+          <a:ln>
+            <a:noFill/>
+          </a:ln>
+          <a:effectLst>
+            <a:outerShdw sx="100000" sy="100000" kx="0" ky="0" algn="bl" rotWithShape="0" blurRad="76200" dist="25400" dir="2700000">
+              <a:srgbClr val="000000">
+                <a:alpha val="30000"/>
+              </a:srgbClr>
+            </a:outerShdw>
+          </a:effectLst>
+        </p:spPr>
+        <p:txBody>
+          <a:bodyPr wrap="square" lIns="0" tIns="0" rIns="0" bIns="0"/>
+          <a:lstStyle/>
+          <a:p>
+            <a:endParaRPr lang="en-US"/>
+          </a:p>
+        </p:txBody>
+      </p:sp>
+      <p:sp>
+        <p:nvSpPr>
+          <p:cNvPr id="16" name="CardTitle"/>
+          <p:cNvSpPr/>
+          <p:nvPr/>
+        </p:nvSpPr>
+        <p:spPr>
+          <a:xfrm>
+            <a:off x="4476880" y="1800000"/>
+            <a:ext cx="3238240" cy="440000"/>
+          </a:xfrm>
+          <a:prstGeom prst="rect">
+            <a:avLst/>
+          </a:prstGeom>
+          <a:noFill/>
+          <a:ln/>
+        </p:spPr>
+        <p:txBody>
+          <a:bodyPr wrap="square" lIns="0" tIns="0" rIns="0" bIns="0" anchor="t"/>
+          <a:lstStyle/>
+          <a:p>
+            <a:pPr indent="0" marL="0">
+              <a:buNone/>
+            </a:pPr>
+            <a:r>
+              <a:rPr lang="en-US" sz="1500" b="1" dirty="0">
+                <a:solidFill>
+                  <a:srgbClr val="FFFFFF"/>
+                </a:solidFill>
+                <a:latin typeface="Cambria" pitchFamily="34" charset="0"/>
+              </a:rPr>
+              <a:t>Verified iOS Universal Links</a:t>
+            </a:r>
+          </a:p>
+        </p:txBody>
+      </p:sp>
+      <p:sp>
+        <p:nvSpPr>
+          <p:cNvPr id="17" name="CardBody"/>
+          <p:cNvSpPr/>
+          <p:nvPr/>
+        </p:nvSpPr>
+        <p:spPr>
+          <a:xfrm>
+            <a:off x="4476880" y="2250000"/>
+            <a:ext cx="3238240" cy="1400000"/>
+          </a:xfrm>
+          <a:prstGeom prst="rect">
+            <a:avLst/>
+          </a:prstGeom>
+          <a:noFill/>
+          <a:ln/>
+        </p:spPr>
+        <p:txBody>
+          <a:bodyPr wrap="square" lIns="0" tIns="0" rIns="0" bIns="0" anchor="t"/>
+          <a:lstStyle/>
+          <a:p>
+            <a:pPr indent="0" marL="0">
+              <a:lnSpc>
+                <a:spcPct val="118000"/>
+              </a:lnSpc>
+              <a:spcAft>
+                <a:spcPts val="600"/>
+              </a:spcAft>
+              <a:buNone/>
+            </a:pPr>
+            <a:r>
+              <a:rPr lang="en-US" sz="1150" dirty="0">
+                <a:solidFill>
+                  <a:srgbClr val="FFFFFF"/>
+                </a:solidFill>
+                <a:latin typeface="Calibri" pitchFamily="34" charset="0"/>
+              </a:rPr>
+              <a:t>Associated Domains entitlement</a:t>
+            </a:r>
+          </a:p>
+          <a:p>
+            <a:pPr indent="0" marL="0">
+              <a:lnSpc>
+                <a:spcPct val="118000"/>
+              </a:lnSpc>
+              <a:spcAft>
+                <a:spcPts val="600"/>
+              </a:spcAft>
+              <a:buNone/>
+            </a:pPr>
+            <a:r>
+              <a:rPr lang="en-US" sz="1150" dirty="0">
+                <a:solidFill>
+                  <a:srgbClr val="FFFFFF"/>
+                </a:solidFill>
+                <a:latin typeface="Calibri" pitchFamily="34" charset="0"/>
+              </a:rPr>
+              <a:t>+ hosted apple-app-site-</a:t>
+            </a:r>
+          </a:p>
+          <a:p>
+            <a:pPr indent="0" marL="0">
+              <a:lnSpc>
+                <a:spcPct val="118000"/>
+              </a:lnSpc>
+              <a:spcAft>
+                <a:spcPts val="600"/>
+              </a:spcAft>
+              <a:buNone/>
+            </a:pPr>
+            <a:r>
+              <a:rPr lang="en-US" sz="1150" dirty="0">
+                <a:solidFill>
+                  <a:srgbClr val="FFFFFF"/>
+                </a:solidFill>
+                <a:latin typeface="Calibri" pitchFamily="34" charset="0"/>
+              </a:rPr>
+              <a:t>association.</a:t>
+            </a:r>
+          </a:p>
+        </p:txBody>
+      </p:sp>
+      <p:sp>
+        <p:nvSpPr>
+          <p:cNvPr id="18" name="Badge"/>
+          <p:cNvSpPr/>
+          <p:nvPr/>
+        </p:nvSpPr>
+        <p:spPr>
+          <a:xfrm>
+            <a:off x="4476880" y="3580000"/>
+            <a:ext cx="3238240" cy="330000"/>
+          </a:xfrm>
+          <a:prstGeom prst="rect">
+            <a:avLst/>
+          </a:prstGeom>
+          <a:noFill/>
+          <a:ln/>
+        </p:spPr>
+        <p:txBody>
+          <a:bodyPr wrap="square" lIns="0" tIns="0" rIns="0" bIns="0" anchor="b"/>
+          <a:lstStyle/>
+          <a:p>
+            <a:pPr indent="0" marL="0">
+              <a:buNone/>
+            </a:pPr>
+            <a:r>
+              <a:rPr lang="en-US" sz="1050" b="1" i="1" dirty="0">
+                <a:solidFill>
+                  <a:srgbClr val="FFD966"/>
+                </a:solidFill>
+                <a:latin typeface="Calibri" pitchFamily="34" charset="0"/>
+              </a:rPr>
+              <a:t>⚠ Needs a paid Apple Dev
+account to fully verify — see next slide.</a:t>
+            </a:r>
+          </a:p>
+        </p:txBody>
+      </p:sp>
+      <p:sp>
+        <p:nvSpPr>
+          <p:cNvPr id="19" name="Card"/>
+          <p:cNvSpPr/>
+          <p:nvPr/>
+        </p:nvSpPr>
+        <p:spPr>
+          <a:xfrm>
+            <a:off x="8045120" y="1650000"/>
+            <a:ext cx="3598240" cy="2350000"/>
+          </a:xfrm>
+          <a:prstGeom prst="roundRect">
+            <a:avLst>
+              <a:gd name="adj" fmla="val 5000"/>
+            </a:avLst>
+          </a:prstGeom>
+          <a:solidFill>
+            <a:srgbClr val="2A9D8F"/>
+          </a:solidFill>
+          <a:ln>
+            <a:noFill/>
+          </a:ln>
+          <a:effectLst>
+            <a:outerShdw sx="100000" sy="100000" kx="0" ky="0" algn="bl" rotWithShape="0" blurRad="76200" dist="25400" dir="2700000">
+              <a:srgbClr val="000000">
+                <a:alpha val="30000"/>
+              </a:srgbClr>
+            </a:outerShdw>
+          </a:effectLst>
+        </p:spPr>
+        <p:txBody>
+          <a:bodyPr wrap="square" lIns="0" tIns="0" rIns="0" bIns="0"/>
+          <a:lstStyle/>
+          <a:p>
+            <a:endParaRPr lang="en-US"/>
+          </a:p>
+        </p:txBody>
+      </p:sp>
+      <p:sp>
+        <p:nvSpPr>
+          <p:cNvPr id="20" name="CardTitle"/>
+          <p:cNvSpPr/>
+          <p:nvPr/>
+        </p:nvSpPr>
+        <p:spPr>
+          <a:xfrm>
+            <a:off x="8225120" y="1800000"/>
+            <a:ext cx="3238240" cy="440000"/>
+          </a:xfrm>
+          <a:prstGeom prst="rect">
+            <a:avLst/>
+          </a:prstGeom>
+          <a:noFill/>
+          <a:ln/>
+        </p:spPr>
+        <p:txBody>
+          <a:bodyPr wrap="square" lIns="0" tIns="0" rIns="0" bIns="0" anchor="t"/>
+          <a:lstStyle/>
+          <a:p>
+            <a:pPr indent="0" marL="0">
+              <a:buNone/>
+            </a:pPr>
+            <a:r>
+              <a:rPr lang="en-US" sz="1500" b="1" dirty="0">
+                <a:solidFill>
+                  <a:srgbClr val="FFFFFF"/>
+                </a:solidFill>
+                <a:latin typeface="Cambria" pitchFamily="34" charset="0"/>
+              </a:rPr>
+              <a:t>iOS Smart App Banner</a:t>
+            </a:r>
+          </a:p>
+        </p:txBody>
+      </p:sp>
+      <p:sp>
+        <p:nvSpPr>
+          <p:cNvPr id="21" name="CardBody"/>
+          <p:cNvSpPr/>
+          <p:nvPr/>
+        </p:nvSpPr>
+        <p:spPr>
+          <a:xfrm>
+            <a:off x="8225120" y="2250000"/>
+            <a:ext cx="3238240" cy="1400000"/>
+          </a:xfrm>
+          <a:prstGeom prst="rect">
+            <a:avLst/>
+          </a:prstGeom>
+          <a:noFill/>
+          <a:ln/>
+        </p:spPr>
+        <p:txBody>
+          <a:bodyPr wrap="square" lIns="0" tIns="0" rIns="0" bIns="0" anchor="t"/>
+          <a:lstStyle/>
+          <a:p>
+            <a:pPr indent="0" marL="0">
+              <a:lnSpc>
+                <a:spcPct val="118000"/>
+              </a:lnSpc>
+              <a:spcAft>
+                <a:spcPts val="600"/>
+              </a:spcAft>
+              <a:buNone/>
+            </a:pPr>
+            <a:r>
+              <a:rPr lang="en-US" sz="1150" dirty="0">
+                <a:solidFill>
+                  <a:srgbClr val="FFFFFF"/>
+                </a:solidFill>
+                <a:latin typeface="Calibri" pitchFamily="34" charset="0"/>
+              </a:rPr>
+              <a:t>A webpage &lt;meta&gt; tag offering</a:t>
+            </a:r>
+          </a:p>
+          <a:p>
+            <a:pPr indent="0" marL="0">
+              <a:lnSpc>
+                <a:spcPct val="118000"/>
+              </a:lnSpc>
+              <a:spcAft>
+                <a:spcPts val="600"/>
+              </a:spcAft>
+              <a:buNone/>
+            </a:pPr>
+            <a:r>
+              <a:rPr lang="en-US" sz="1150" dirty="0">
+                <a:solidFill>
+                  <a:srgbClr val="FFFFFF"/>
+                </a:solidFill>
+                <a:latin typeface="Calibri" pitchFamily="34" charset="0"/>
+              </a:rPr>
+              <a:t>to open (or install) the app —</a:t>
+            </a:r>
+          </a:p>
+          <a:p>
+            <a:pPr indent="0" marL="0">
+              <a:lnSpc>
+                <a:spcPct val="118000"/>
+              </a:lnSpc>
+              <a:spcAft>
+                <a:spcPts val="600"/>
+              </a:spcAft>
+              <a:buNone/>
+            </a:pPr>
+            <a:r>
+              <a:rPr lang="en-US" sz="1150" dirty="0">
+                <a:solidFill>
+                  <a:srgbClr val="FFFFFF"/>
+                </a:solidFill>
+                <a:latin typeface="Calibri" pitchFamily="34" charset="0"/>
+              </a:rPr>
+              <a:t>no entitlement needed.</a:t>
+            </a:r>
+          </a:p>
+        </p:txBody>
+      </p:sp>
+      <p:sp>
+        <p:nvSpPr>
+          <p:cNvPr id="22" name="Badge"/>
+          <p:cNvSpPr/>
+          <p:nvPr/>
+        </p:nvSpPr>
+        <p:spPr>
+          <a:xfrm>
+            <a:off x="8225120" y="3580000"/>
+            <a:ext cx="3238240" cy="330000"/>
+          </a:xfrm>
+          <a:prstGeom prst="rect">
+            <a:avLst/>
+          </a:prstGeom>
+          <a:noFill/>
+          <a:ln/>
+        </p:spPr>
+        <p:txBody>
+          <a:bodyPr wrap="square" lIns="0" tIns="0" rIns="0" bIns="0" anchor="b"/>
+          <a:lstStyle/>
+          <a:p>
+            <a:pPr indent="0" marL="0">
+              <a:buNone/>
+            </a:pPr>
+            <a:r>
+              <a:rPr lang="en-US" sz="1050" b="1" i="1" dirty="0">
+                <a:solidFill>
+                  <a:srgbClr val="FFD966"/>
+                </a:solidFill>
+                <a:latin typeface="Calibri" pitchFamily="34" charset="0"/>
+              </a:rPr>
+              <a:t>⚠ Needs a real App Store
+listing to render — see next slide.</a:t>
+            </a:r>
+          </a:p>
+        </p:txBody>
+      </p:sp>
+      <p:sp>
+        <p:nvSpPr>
+          <p:cNvPr id="23" name="Card"/>
+          <p:cNvSpPr/>
+          <p:nvPr/>
+        </p:nvSpPr>
+        <p:spPr>
+          <a:xfrm>
+            <a:off x="2422760" y="4150000"/>
+            <a:ext cx="3598240" cy="2350000"/>
+          </a:xfrm>
+          <a:prstGeom prst="roundRect">
+            <a:avLst>
+              <a:gd name="adj" fmla="val 5000"/>
+            </a:avLst>
+          </a:prstGeom>
+          <a:solidFill>
+            <a:srgbClr val="E07A5F"/>
+          </a:solidFill>
+          <a:ln>
+            <a:noFill/>
+          </a:ln>
+          <a:effectLst>
+            <a:outerShdw sx="100000" sy="100000" kx="0" ky="0" algn="bl" rotWithShape="0" blurRad="76200" dist="25400" dir="2700000">
+              <a:srgbClr val="000000">
+                <a:alpha val="30000"/>
+              </a:srgbClr>
+            </a:outerShdw>
+          </a:effectLst>
+        </p:spPr>
+        <p:txBody>
+          <a:bodyPr wrap="square" lIns="0" tIns="0" rIns="0" bIns="0"/>
+          <a:lstStyle/>
+          <a:p>
+            <a:endParaRPr lang="en-US"/>
+          </a:p>
+        </p:txBody>
+      </p:sp>
+      <p:sp>
+        <p:nvSpPr>
+          <p:cNvPr id="24" name="CardTitle"/>
+          <p:cNvSpPr/>
+          <p:nvPr/>
+        </p:nvSpPr>
+        <p:spPr>
+          <a:xfrm>
+            <a:off x="2602760" y="4300000"/>
+            <a:ext cx="3238240" cy="440000"/>
+          </a:xfrm>
+          <a:prstGeom prst="rect">
+            <a:avLst/>
+          </a:prstGeom>
+          <a:noFill/>
+          <a:ln/>
+        </p:spPr>
+        <p:txBody>
+          <a:bodyPr wrap="square" lIns="0" tIns="0" rIns="0" bIns="0" anchor="t"/>
+          <a:lstStyle/>
+          <a:p>
+            <a:pPr indent="0" marL="0">
+              <a:buNone/>
+            </a:pPr>
+            <a:r>
+              <a:rPr lang="en-US" sz="1500" b="1" dirty="0">
+                <a:solidFill>
+                  <a:srgbClr val="FFFFFF"/>
+                </a:solidFill>
+                <a:latin typeface="Cambria" pitchFamily="34" charset="0"/>
+              </a:rPr>
+              <a:t>Explicit-Package Intent</a:t>
+            </a:r>
+          </a:p>
+        </p:txBody>
+      </p:sp>
+      <p:sp>
+        <p:nvSpPr>
+          <p:cNvPr id="25" name="CardBody"/>
+          <p:cNvSpPr/>
+          <p:nvPr/>
+        </p:nvSpPr>
+        <p:spPr>
+          <a:xfrm>
+            <a:off x="2602760" y="4750000"/>
+            <a:ext cx="3238240" cy="1400000"/>
+          </a:xfrm>
+          <a:prstGeom prst="rect">
+            <a:avLst/>
+          </a:prstGeom>
+          <a:noFill/>
+          <a:ln/>
+        </p:spPr>
+        <p:txBody>
+          <a:bodyPr wrap="square" lIns="0" tIns="0" rIns="0" bIns="0" anchor="t"/>
+          <a:lstStyle/>
+          <a:p>
+            <a:pPr indent="0" marL="0">
+              <a:lnSpc>
+                <a:spcPct val="118000"/>
+              </a:lnSpc>
+              <a:spcAft>
+                <a:spcPts val="600"/>
+              </a:spcAft>
+              <a:buNone/>
+            </a:pPr>
+            <a:r>
+              <a:rPr lang="en-US" sz="1150" dirty="0">
+                <a:solidFill>
+                  <a:srgbClr val="FFFFFF"/>
+                </a:solidFill>
+                <a:latin typeface="Calibri" pitchFamily="34" charset="0"/>
+              </a:rPr>
+              <a:t>Link names the exact target</a:t>
+            </a:r>
+          </a:p>
+          <a:p>
+            <a:pPr indent="0" marL="0">
+              <a:lnSpc>
+                <a:spcPct val="118000"/>
+              </a:lnSpc>
+              <a:spcAft>
+                <a:spcPts val="600"/>
+              </a:spcAft>
+              <a:buNone/>
+            </a:pPr>
+            <a:r>
+              <a:rPr lang="en-US" sz="1150" dirty="0">
+                <a:solidFill>
+                  <a:srgbClr val="FFFFFF"/>
+                </a:solidFill>
+                <a:latin typeface="Calibri" pitchFamily="34" charset="0"/>
+              </a:rPr>
+              <a:t>package directly — Android has</a:t>
+            </a:r>
+          </a:p>
+          <a:p>
+            <a:pPr indent="0" marL="0">
+              <a:lnSpc>
+                <a:spcPct val="118000"/>
+              </a:lnSpc>
+              <a:spcAft>
+                <a:spcPts val="600"/>
+              </a:spcAft>
+              <a:buNone/>
+            </a:pPr>
+            <a:r>
+              <a:rPr lang="en-US" sz="1150" dirty="0">
+                <a:solidFill>
+                  <a:srgbClr val="FFFFFF"/>
+                </a:solidFill>
+                <a:latin typeface="Calibri" pitchFamily="34" charset="0"/>
+              </a:rPr>
+              <a:t>nothing left to disambiguate.</a:t>
+            </a:r>
+          </a:p>
+        </p:txBody>
+      </p:sp>
+      <p:sp>
+        <p:nvSpPr>
+          <p:cNvPr id="26" name="Badge"/>
+          <p:cNvSpPr/>
+          <p:nvPr/>
+        </p:nvSpPr>
+        <p:spPr>
+          <a:xfrm>
+            <a:off x="2602760" y="6080000"/>
+            <a:ext cx="3238240" cy="330000"/>
+          </a:xfrm>
+          <a:prstGeom prst="rect">
+            <a:avLst/>
+          </a:prstGeom>
+          <a:noFill/>
+          <a:ln/>
+        </p:spPr>
+        <p:txBody>
+          <a:bodyPr wrap="square" lIns="0" tIns="0" rIns="0" bIns="0" anchor="b"/>
+          <a:lstStyle/>
+          <a:p>
+            <a:pPr indent="0" marL="0">
+              <a:buNone/>
+            </a:pPr>
+            <a:r>
+              <a:rPr lang="en-US" sz="1050" b="1" i="1" dirty="0">
+                <a:solidFill>
+                  <a:srgbClr val="8CFFC1"/>
+                </a:solidFill>
+                <a:latin typeface="Calibri" pitchFamily="34" charset="0"/>
+              </a:rPr>
+              <a:t>✓ Tested live: opened directly,
+zero prompt, no chooser.</a:t>
+            </a:r>
+          </a:p>
+        </p:txBody>
+      </p:sp>
+      <p:sp>
+        <p:nvSpPr>
+          <p:cNvPr id="27" name="Card"/>
+          <p:cNvSpPr/>
+          <p:nvPr/>
+        </p:nvSpPr>
+        <p:spPr>
+          <a:xfrm>
+            <a:off x="6171000" y="4150000"/>
+            <a:ext cx="3598240" cy="2350000"/>
+          </a:xfrm>
+          <a:prstGeom prst="roundRect">
+            <a:avLst>
+              <a:gd name="adj" fmla="val 5000"/>
+            </a:avLst>
+          </a:prstGeom>
+          <a:solidFill>
+            <a:srgbClr val="9B5DE5"/>
+          </a:solidFill>
+          <a:ln>
+            <a:noFill/>
+          </a:ln>
+          <a:effectLst>
+            <a:outerShdw sx="100000" sy="100000" kx="0" ky="0" algn="bl" rotWithShape="0" blurRad="76200" dist="25400" dir="2700000">
+              <a:srgbClr val="000000">
+                <a:alpha val="30000"/>
+              </a:srgbClr>
+            </a:outerShdw>
+          </a:effectLst>
+        </p:spPr>
+        <p:txBody>
+          <a:bodyPr wrap="square" lIns="0" tIns="0" rIns="0" bIns="0"/>
+          <a:lstStyle/>
+          <a:p>
+            <a:endParaRPr lang="en-US"/>
+          </a:p>
+        </p:txBody>
+      </p:sp>
+      <p:sp>
+        <p:nvSpPr>
+          <p:cNvPr id="28" name="CardTitle"/>
+          <p:cNvSpPr/>
+          <p:nvPr/>
+        </p:nvSpPr>
+        <p:spPr>
+          <a:xfrm>
+            <a:off x="6351000" y="4300000"/>
+            <a:ext cx="3238240" cy="440000"/>
+          </a:xfrm>
+          <a:prstGeom prst="rect">
+            <a:avLst/>
+          </a:prstGeom>
+          <a:noFill/>
+          <a:ln/>
+        </p:spPr>
+        <p:txBody>
+          <a:bodyPr wrap="square" lIns="0" tIns="0" rIns="0" bIns="0" anchor="t"/>
+          <a:lstStyle/>
+          <a:p>
+            <a:pPr indent="0" marL="0">
+              <a:buNone/>
+            </a:pPr>
+            <a:r>
+              <a:rPr lang="en-US" sz="1500" b="1" dirty="0">
+                <a:solidFill>
+                  <a:srgbClr val="FFFFFF"/>
+                </a:solidFill>
+                <a:latin typeface="Cambria" pitchFamily="34" charset="0"/>
+              </a:rPr>
+              <a:t>Deferred Deep Linking</a:t>
+            </a:r>
+          </a:p>
+        </p:txBody>
+      </p:sp>
+      <p:sp>
+        <p:nvSpPr>
+          <p:cNvPr id="29" name="CardBody"/>
+          <p:cNvSpPr/>
+          <p:nvPr/>
+        </p:nvSpPr>
+        <p:spPr>
+          <a:xfrm>
+            <a:off x="6351000" y="4750000"/>
+            <a:ext cx="3238240" cy="1400000"/>
+          </a:xfrm>
+          <a:prstGeom prst="rect">
+            <a:avLst/>
+          </a:prstGeom>
+          <a:noFill/>
+          <a:ln/>
+        </p:spPr>
+        <p:txBody>
+          <a:bodyPr wrap="square" lIns="0" tIns="0" rIns="0" bIns="0" anchor="t"/>
+          <a:lstStyle/>
+          <a:p>
+            <a:pPr indent="0" marL="0">
+              <a:lnSpc>
+                <a:spcPct val="118000"/>
+              </a:lnSpc>
+              <a:spcAft>
+                <a:spcPts val="600"/>
+              </a:spcAft>
+              <a:buNone/>
+            </a:pPr>
+            <a:r>
+              <a:rPr lang="en-US" sz="1150" dirty="0">
+                <a:solidFill>
+                  <a:srgbClr val="FFFFFF"/>
+                </a:solidFill>
+                <a:latin typeface="Calibri" pitchFamily="34" charset="0"/>
+              </a:rPr>
+              <a:t>Simulated via clipboard — the</a:t>
+            </a:r>
+          </a:p>
+          <a:p>
+            <a:pPr indent="0" marL="0">
+              <a:lnSpc>
+                <a:spcPct val="118000"/>
+              </a:lnSpc>
+              <a:spcAft>
+                <a:spcPts val="600"/>
+              </a:spcAft>
+              <a:buNone/>
+            </a:pPr>
+            <a:r>
+              <a:rPr lang="en-US" sz="1150" dirty="0">
+                <a:solidFill>
+                  <a:srgbClr val="FFFFFF"/>
+                </a:solidFill>
+                <a:latin typeface="Calibri" pitchFamily="34" charset="0"/>
+              </a:rPr>
+              <a:t>real store-based mechanism</a:t>
+            </a:r>
+          </a:p>
+          <a:p>
+            <a:pPr indent="0" marL="0">
+              <a:lnSpc>
+                <a:spcPct val="118000"/>
+              </a:lnSpc>
+              <a:spcAft>
+                <a:spcPts val="600"/>
+              </a:spcAft>
+              <a:buNone/>
+            </a:pPr>
+            <a:r>
+              <a:rPr lang="en-US" sz="1150" dirty="0">
+                <a:solidFill>
+                  <a:srgbClr val="FFFFFF"/>
+                </a:solidFill>
+                <a:latin typeface="Calibri" pitchFamily="34" charset="0"/>
+              </a:rPr>
+              <a:t>isn't possible when sideloaded.</a:t>
+            </a:r>
+          </a:p>
+        </p:txBody>
+      </p:sp>
+      <p:sp>
+        <p:nvSpPr>
+          <p:cNvPr id="30" name="Badge"/>
+          <p:cNvSpPr/>
+          <p:nvPr/>
+        </p:nvSpPr>
+        <p:spPr>
+          <a:xfrm>
+            <a:off x="6351000" y="6080000"/>
+            <a:ext cx="3238240" cy="330000"/>
+          </a:xfrm>
+          <a:prstGeom prst="rect">
+            <a:avLst/>
+          </a:prstGeom>
+          <a:noFill/>
+          <a:ln/>
+        </p:spPr>
+        <p:txBody>
+          <a:bodyPr wrap="square" lIns="0" tIns="0" rIns="0" bIns="0" anchor="b"/>
+          <a:lstStyle/>
+          <a:p>
+            <a:pPr indent="0" marL="0">
+              <a:buNone/>
+            </a:pPr>
+            <a:r>
+              <a:rPr lang="en-US" sz="1050" b="1" i="1" dirty="0">
+                <a:solidFill>
+                  <a:srgbClr val="8CFFC1"/>
+                </a:solidFill>
+                <a:latin typeface="Calibri" pitchFamily="34" charset="0"/>
+              </a:rPr>
+              <a:t>✓ Tested live on Android + iOS:
+correct token recovered both times.</a:t>
+            </a:r>
+          </a:p>
+        </p:txBody>
+      </p:sp>
+    </p:spTree>
+  </p:cSld>
+  <p:clrMapOvr>
+    <a:overrideClrMapping bg1="lt1" tx1="dk1" bg2="lt2" tx2="dk2" accent1="accent1" accent2="accent2" accent3="accent3" accent4="accent4" accent5="accent5" accent6="accent6" hlink="hlink" folHlink="folHlink"/>
+  </p:clrMapOvr>
+</p:sld>
+</file>
+
 <file path=ppt/slides/slide2.xml><?xml version="1.0" encoding="utf-8"?>
 <p:sld xmlns:a="http://schemas.openxmlformats.org/drawingml/2006/main" xmlns:r="http://schemas.openxmlformats.org/officeDocument/2006/relationships" xmlns:p="http://schemas.openxmlformats.org/presentationml/2006/main">
   <p:cSld name="Slide 2">
@@ -3681,7 +5354,7 @@
                 <a:ea typeface="Calibri" pitchFamily="34" charset="-122"/>
                 <a:cs typeface="Calibri" pitchFamily="34" charset="-120"/>
               </a:rPr>
-              <a:t>Shows 3 buttons: Bank A, B, C</a:t>
+              <a:t>Shows a 4-per-row grid of bank tiles</a:t>
             </a:r>
             <a:endParaRPr lang="en-US" sz="1300" dirty="0"/>
           </a:p>
@@ -4586,7 +6259,7 @@
                 <a:ea typeface="Calibri" pitchFamily="34" charset="-122"/>
                 <a:cs typeface="Calibri" pitchFamily="34" charset="-120"/>
               </a:rPr>
-              <a:t>Safari opens normally and shows the picker page: 3 bank buttons</a:t>
+              <a:t>Safari opens normally and shows the picker page: a grid of bank tiles, 4 per row</a:t>
             </a:r>
             <a:endParaRPr lang="en-US" sz="1250" dirty="0"/>
           </a:p>
@@ -6598,7 +8271,7 @@
                 <a:ea typeface="Calibri" pitchFamily="34" charset="-122"/>
                 <a:cs typeface="Calibri" pitchFamily="34" charset="-120"/>
               </a:rPr>
-              <a:t>It fetches the merchant name and amount, and shows 3 bank buttons.</a:t>
+              <a:t>It fetches the merchant name and amount, and shows a grid of bank tiles, 4 per row.</a:t>
             </a:r>
             <a:endParaRPr lang="en-US" sz="1150" dirty="0"/>
           </a:p>

</xml_diff>

<commit_message>
Give Bank 1-5 a distinct color palette from Bank A/B/C
Bank 3 (iOS Smart App Banner) previously reused Bank C's exact color
(2A9D8F). New palette: Bank 1=6A4C93, Bank 2=118AB2, Bank 3=B5651D
(darker for white-text contrast), Bank 4=E07A5F, Bank 5=D81E5B — all
distinct from A/B/C's E63946/1D3557/2A9D8F and from each other.

Also updates the deck's method-grid and comparison slides to the same
palette and adds "Bank N —" labels, and adds a Bank N mapping table +
explanatory paragraph to the Word doc's Part 9.

Co-Authored-By: Claude Sonnet 5 <noreply@anthropic.com>
</commit_message>
<xml_diff>
--- a/SGQR_Deep_Linking_Simulation.pptx
+++ b/SGQR_Deep_Linking_Simulation.pptx
@@ -3248,7 +3248,7 @@
                 </a:solidFill>
                 <a:latin typeface="Cambria" pitchFamily="34" charset="0"/>
               </a:rPr>
-              <a:t>Verified iOS Universal Links</a:t>
+              <a:t>Bank 2 — Verified iOS Universal Links</a:t>
             </a:r>
           </a:p>
         </p:txBody>
@@ -3284,7 +3284,7 @@
                 </a:solidFill>
                 <a:latin typeface="Cambria" pitchFamily="34" charset="0"/>
               </a:rPr>
-              <a:t>iOS Smart App Banner</a:t>
+              <a:t>Bank 3 — iOS Smart App Banner</a:t>
             </a:r>
           </a:p>
         </p:txBody>
@@ -3347,7 +3347,7 @@
             <a:r>
               <a:rPr lang="en-US" sz="1500" b="1" dirty="0">
                 <a:solidFill>
-                  <a:srgbClr val="0A7EA4"/>
+                  <a:srgbClr val="118AB2"/>
                 </a:solidFill>
                 <a:latin typeface="Calibri" pitchFamily="34" charset="0"/>
               </a:rPr>
@@ -3556,7 +3556,7 @@
             <a:r>
               <a:rPr lang="en-US" sz="1500" b="1" dirty="0">
                 <a:solidFill>
-                  <a:srgbClr val="2A9D8F"/>
+                  <a:srgbClr val="B5651D"/>
                 </a:solidFill>
                 <a:latin typeface="Calibri" pitchFamily="34" charset="0"/>
               </a:rPr>
@@ -3884,7 +3884,7 @@
                 </a:solidFill>
                 <a:latin typeface="Cambria" pitchFamily="34" charset="0"/>
               </a:rPr>
-              <a:t>Verified Android App Links</a:t>
+              <a:t>Bank 1 — Verified Android App Links</a:t>
             </a:r>
           </a:p>
         </p:txBody>
@@ -4025,7 +4025,7 @@
             </a:avLst>
           </a:prstGeom>
           <a:solidFill>
-            <a:srgbClr val="0A7EA4"/>
+            <a:srgbClr val="118AB2"/>
           </a:solidFill>
           <a:ln>
             <a:noFill/>
@@ -4077,7 +4077,7 @@
                 </a:solidFill>
                 <a:latin typeface="Cambria" pitchFamily="34" charset="0"/>
               </a:rPr>
-              <a:t>Verified iOS Universal Links</a:t>
+              <a:t>Bank 2 — Verified iOS Universal Links</a:t>
             </a:r>
           </a:p>
         </p:txBody>
@@ -4218,7 +4218,7 @@
             </a:avLst>
           </a:prstGeom>
           <a:solidFill>
-            <a:srgbClr val="2A9D8F"/>
+            <a:srgbClr val="B5651D"/>
           </a:solidFill>
           <a:ln>
             <a:noFill/>
@@ -4270,7 +4270,7 @@
                 </a:solidFill>
                 <a:latin typeface="Cambria" pitchFamily="34" charset="0"/>
               </a:rPr>
-              <a:t>iOS Smart App Banner</a:t>
+              <a:t>Bank 3 — iOS Smart App Banner</a:t>
             </a:r>
           </a:p>
         </p:txBody>
@@ -4463,7 +4463,7 @@
                 </a:solidFill>
                 <a:latin typeface="Cambria" pitchFamily="34" charset="0"/>
               </a:rPr>
-              <a:t>Explicit-Package Intent</a:t>
+              <a:t>Bank 4 — Explicit-Package Intent</a:t>
             </a:r>
           </a:p>
         </p:txBody>
@@ -4604,7 +4604,7 @@
             </a:avLst>
           </a:prstGeom>
           <a:solidFill>
-            <a:srgbClr val="9B5DE5"/>
+            <a:srgbClr val="D81E5B"/>
           </a:solidFill>
           <a:ln>
             <a:noFill/>
@@ -4656,7 +4656,7 @@
                 </a:solidFill>
                 <a:latin typeface="Cambria" pitchFamily="34" charset="0"/>
               </a:rPr>
-              <a:t>Deferred Deep Linking</a:t>
+              <a:t>Bank 5 — Deferred Deep Linking</a:t>
             </a:r>
           </a:p>
         </p:txBody>

</xml_diff>

<commit_message>
Verify all 5 methods on the "wrong" platform too; document results
Built and installed every Android-only app on iOS and every iOS-only app
on Android (no code changes needed — each already declares zero URL
space on the platform it doesn't target), confirming live that:
- Bank 1/4 (Android-only) are completely invisible on iOS
- Bank 2/3 (iOS-only) are completely invisible on Android
- Bank 5 (deferred) genuinely works identically on both

Adds a "Cross-Platform Verification" table to both the deck (new slide)
and the Word doc (new subsection in Part 9), color-coded by outcome.

Co-Authored-By: Claude Sonnet 5 <noreply@anthropic.com>
</commit_message>
<xml_diff>
--- a/SGQR_Deep_Linking_Simulation.pptx
+++ b/SGQR_Deep_Linking_Simulation.pptx
@@ -17,6 +17,7 @@
     <p:sldId id="265" r:id="rId11"/>
     <p:sldId id="268" r:id="rId19"/>
     <p:sldId id="267" r:id="rId18"/>
+    <p:sldId id="269" r:id="rId20"/>
     <p:sldId id="266" r:id="rId12"/>
   </p:sldIdLst>
   <p:notesMasterIdLst>
@@ -4788,6 +4789,864 @@
 </p:sld>
 </file>
 
+<file path=ppt/slides/slide14.xml><?xml version="1.0" encoding="utf-8"?>
+<p:sld xmlns:a="http://schemas.openxmlformats.org/drawingml/2006/main" xmlns:r="http://schemas.openxmlformats.org/officeDocument/2006/relationships" xmlns:p="http://schemas.openxmlformats.org/presentationml/2006/main">
+  <p:cSld name="Slide 14">
+    <p:bg>
+      <p:bgPr>
+        <a:solidFill>
+          <a:srgbClr val="21295C"/>
+        </a:solidFill>
+      </p:bgPr>
+    </p:bg>
+    <p:spTree>
+      <p:nvGrpSpPr>
+        <p:cNvPr id="1" name=""/>
+        <p:cNvGrpSpPr/>
+        <p:nvPr/>
+      </p:nvGrpSpPr>
+      <p:grpSpPr>
+        <a:xfrm>
+          <a:off x="0" y="0"/>
+          <a:ext cx="0" cy="0"/>
+          <a:chOff x="0" y="0"/>
+          <a:chExt cx="0" cy="0"/>
+        </a:xfrm>
+      </p:grpSpPr>
+      <p:sp>
+        <p:nvSpPr>
+          <p:cNvPr id="2" name="Title"/>
+          <p:cNvSpPr/>
+          <p:nvPr/>
+        </p:nvSpPr>
+        <p:spPr>
+          <a:xfrm>
+            <a:off x="548640" y="330000"/>
+            <a:ext cx="11094720" cy="548640"/>
+          </a:xfrm>
+          <a:prstGeom prst="rect">
+            <a:avLst/>
+          </a:prstGeom>
+          <a:noFill/>
+          <a:ln/>
+        </p:spPr>
+        <p:txBody>
+          <a:bodyPr wrap="square" lIns="0" tIns="0" rIns="0" bIns="0" rtlCol="0" anchor="ctr"/>
+          <a:lstStyle/>
+          <a:p>
+            <a:pPr indent="0" marL="0">
+              <a:buNone/>
+            </a:pPr>
+            <a:r>
+              <a:rPr lang="en-US" sz="2800" b="1" dirty="0">
+                <a:solidFill>
+                  <a:srgbClr val="FFFFFF"/>
+                </a:solidFill>
+                <a:latin typeface="Cambria" pitchFamily="34" charset="0"/>
+                <a:ea typeface="Cambria" pitchFamily="34" charset="-122"/>
+                <a:cs typeface="Cambria" pitchFamily="34" charset="-120"/>
+              </a:rPr>
+              <a:t>Cross-Platform Verification: Confirmed Live</a:t>
+            </a:r>
+          </a:p>
+        </p:txBody>
+      </p:sp>
+      <p:sp>
+        <p:nvSpPr>
+          <p:cNvPr id="3" name="Subtitle"/>
+          <p:cNvSpPr/>
+          <p:nvPr/>
+        </p:nvSpPr>
+        <p:spPr>
+          <a:xfrm>
+            <a:off x="548640" y="980000"/>
+            <a:ext cx="11094720" cy="400000"/>
+          </a:xfrm>
+          <a:prstGeom prst="rect">
+            <a:avLst/>
+          </a:prstGeom>
+          <a:noFill/>
+          <a:ln/>
+        </p:spPr>
+        <p:txBody>
+          <a:bodyPr wrap="square" lIns="0" tIns="0" rIns="0" bIns="0" rtlCol="0" anchor="t"/>
+          <a:lstStyle/>
+          <a:p>
+            <a:pPr indent="0" marL="0">
+              <a:buNone/>
+            </a:pPr>
+            <a:r>
+              <a:rPr lang="en-US" sz="1400" i="1" dirty="0">
+                <a:solidFill>
+                  <a:srgbClr val="CADCFC"/>
+                </a:solidFill>
+                <a:latin typeface="Calibri" pitchFamily="34" charset="0"/>
+                <a:ea typeface="Calibri" pitchFamily="34" charset="-122"/>
+                <a:cs typeface="Calibri" pitchFamily="34" charset="-120"/>
+              </a:rPr>
+              <a:t>Every app was also installed on the "wrong" platform to confirm the negative case</a:t>
+            </a:r>
+          </a:p>
+        </p:txBody>
+      </p:sp>
+      <p:sp>
+        <p:nvSpPr>
+          <p:cNvPr id="39" name="THead"/>
+          <p:cNvSpPr/>
+          <p:nvPr/>
+        </p:nvSpPr>
+        <p:spPr>
+          <a:xfrm>
+            <a:off x="548640" y="1750000"/>
+            <a:ext cx="2600000" cy="500000"/>
+          </a:xfrm>
+          <a:prstGeom prst="rect">
+            <a:avLst/>
+          </a:prstGeom>
+          <a:solidFill>
+            <a:srgbClr val="21295C"/>
+          </a:solidFill>
+          <a:ln>
+            <a:noFill/>
+          </a:ln>
+        </p:spPr>
+        <p:txBody>
+          <a:bodyPr wrap="square" lIns="90000" tIns="45000" rIns="90000" bIns="45000" anchor="ctr"/>
+          <a:lstStyle/>
+          <a:p>
+            <a:pPr indent="0" marL="0">
+              <a:buNone/>
+            </a:pPr>
+            <a:r>
+              <a:rPr lang="en-US" sz="1300" b="1" dirty="0">
+                <a:solidFill>
+                  <a:srgbClr val="FFFFFF"/>
+                </a:solidFill>
+                <a:latin typeface="Calibri" pitchFamily="34" charset="0"/>
+              </a:rPr>
+              <a:t>App</a:t>
+            </a:r>
+          </a:p>
+        </p:txBody>
+      </p:sp>
+      <p:sp>
+        <p:nvSpPr>
+          <p:cNvPr id="40" name="THead"/>
+          <p:cNvSpPr/>
+          <p:nvPr/>
+        </p:nvSpPr>
+        <p:spPr>
+          <a:xfrm>
+            <a:off x="3148640" y="1750000"/>
+            <a:ext cx="4700000" cy="500000"/>
+          </a:xfrm>
+          <a:prstGeom prst="rect">
+            <a:avLst/>
+          </a:prstGeom>
+          <a:solidFill>
+            <a:srgbClr val="21295C"/>
+          </a:solidFill>
+          <a:ln>
+            <a:noFill/>
+          </a:ln>
+        </p:spPr>
+        <p:txBody>
+          <a:bodyPr wrap="square" lIns="90000" tIns="45000" rIns="90000" bIns="45000" anchor="ctr"/>
+          <a:lstStyle/>
+          <a:p>
+            <a:pPr indent="0" marL="0">
+              <a:buNone/>
+            </a:pPr>
+            <a:r>
+              <a:rPr lang="en-US" sz="1300" b="1" dirty="0">
+                <a:solidFill>
+                  <a:srgbClr val="FFFFFF"/>
+                </a:solidFill>
+                <a:latin typeface="Calibri" pitchFamily="34" charset="0"/>
+              </a:rPr>
+              <a:t>On Android</a:t>
+            </a:r>
+          </a:p>
+        </p:txBody>
+      </p:sp>
+      <p:sp>
+        <p:nvSpPr>
+          <p:cNvPr id="41" name="THead"/>
+          <p:cNvSpPr/>
+          <p:nvPr/>
+        </p:nvSpPr>
+        <p:spPr>
+          <a:xfrm>
+            <a:off x="7848640" y="1750000"/>
+            <a:ext cx="4700000" cy="500000"/>
+          </a:xfrm>
+          <a:prstGeom prst="rect">
+            <a:avLst/>
+          </a:prstGeom>
+          <a:solidFill>
+            <a:srgbClr val="21295C"/>
+          </a:solidFill>
+          <a:ln>
+            <a:noFill/>
+          </a:ln>
+        </p:spPr>
+        <p:txBody>
+          <a:bodyPr wrap="square" lIns="90000" tIns="45000" rIns="90000" bIns="45000" anchor="ctr"/>
+          <a:lstStyle/>
+          <a:p>
+            <a:pPr indent="0" marL="0">
+              <a:buNone/>
+            </a:pPr>
+            <a:r>
+              <a:rPr lang="en-US" sz="1300" b="1" dirty="0">
+                <a:solidFill>
+                  <a:srgbClr val="FFFFFF"/>
+                </a:solidFill>
+                <a:latin typeface="Calibri" pitchFamily="34" charset="0"/>
+              </a:rPr>
+              <a:t>On iOS</a:t>
+            </a:r>
+          </a:p>
+        </p:txBody>
+      </p:sp>
+      <p:sp>
+        <p:nvSpPr>
+          <p:cNvPr id="42" name="TCell"/>
+          <p:cNvSpPr/>
+          <p:nvPr/>
+        </p:nvSpPr>
+        <p:spPr>
+          <a:xfrm>
+            <a:off x="548640" y="2250000"/>
+            <a:ext cx="2600000" cy="700000"/>
+          </a:xfrm>
+          <a:prstGeom prst="rect">
+            <a:avLst/>
+          </a:prstGeom>
+          <a:solidFill>
+            <a:srgbClr val="FFFFFF"/>
+          </a:solidFill>
+          <a:ln w="6350">
+            <a:solidFill>
+              <a:srgbClr val="D9D9D9"/>
+            </a:solidFill>
+          </a:ln>
+        </p:spPr>
+        <p:txBody>
+          <a:bodyPr wrap="square" lIns="90000" tIns="45000" rIns="90000" bIns="45000" anchor="ctr"/>
+          <a:lstStyle/>
+          <a:p>
+            <a:pPr indent="0" marL="0">
+              <a:buNone/>
+            </a:pPr>
+            <a:r>
+              <a:rPr lang="en-US" sz="1100" b="1" dirty="0">
+                <a:solidFill>
+                  <a:srgbClr val="1A2233"/>
+                </a:solidFill>
+                <a:latin typeface="Calibri" pitchFamily="34" charset="0"/>
+              </a:rPr>
+              <a:t>Bank 1 — App Links</a:t>
+            </a:r>
+          </a:p>
+        </p:txBody>
+      </p:sp>
+      <p:sp>
+        <p:nvSpPr>
+          <p:cNvPr id="43" name="TCell"/>
+          <p:cNvSpPr/>
+          <p:nvPr/>
+        </p:nvSpPr>
+        <p:spPr>
+          <a:xfrm>
+            <a:off x="3148640" y="2250000"/>
+            <a:ext cx="4700000" cy="700000"/>
+          </a:xfrm>
+          <a:prstGeom prst="rect">
+            <a:avLst/>
+          </a:prstGeom>
+          <a:solidFill>
+            <a:srgbClr val="8CFFC1"/>
+          </a:solidFill>
+          <a:ln w="6350">
+            <a:solidFill>
+              <a:srgbClr val="D9D9D9"/>
+            </a:solidFill>
+          </a:ln>
+        </p:spPr>
+        <p:txBody>
+          <a:bodyPr wrap="square" lIns="90000" tIns="45000" rIns="90000" bIns="45000" anchor="ctr"/>
+          <a:lstStyle/>
+          <a:p>
+            <a:pPr indent="0" marL="0">
+              <a:buNone/>
+            </a:pPr>
+            <a:r>
+              <a:rPr lang="en-US" sz="1100" dirty="0">
+                <a:solidFill>
+                  <a:srgbClr val="1A2233"/>
+                </a:solidFill>
+                <a:latin typeface="Calibri" pitchFamily="34" charset="0"/>
+              </a:rPr>
+              <a:t>Opens directly, zero prompt</a:t>
+            </a:r>
+          </a:p>
+        </p:txBody>
+      </p:sp>
+      <p:sp>
+        <p:nvSpPr>
+          <p:cNvPr id="44" name="TCell"/>
+          <p:cNvSpPr/>
+          <p:nvPr/>
+        </p:nvSpPr>
+        <p:spPr>
+          <a:xfrm>
+            <a:off x="7848640" y="2250000"/>
+            <a:ext cx="4700000" cy="700000"/>
+          </a:xfrm>
+          <a:prstGeom prst="rect">
+            <a:avLst/>
+          </a:prstGeom>
+          <a:solidFill>
+            <a:srgbClr val="FBEAEA"/>
+          </a:solidFill>
+          <a:ln w="6350">
+            <a:solidFill>
+              <a:srgbClr val="D9D9D9"/>
+            </a:solidFill>
+          </a:ln>
+        </p:spPr>
+        <p:txBody>
+          <a:bodyPr wrap="square" lIns="90000" tIns="45000" rIns="90000" bIns="45000" anchor="ctr"/>
+          <a:lstStyle/>
+          <a:p>
+            <a:pPr indent="0" marL="0">
+              <a:buNone/>
+            </a:pPr>
+            <a:r>
+              <a:rPr lang="en-US" sz="1100" dirty="0">
+                <a:solidFill>
+                  <a:srgbClr val="1A2233"/>
+                </a:solidFill>
+                <a:latin typeface="Calibri" pitchFamily="34" charset="0"/>
+              </a:rPr>
+              <a:t>Just a webpage — never a candidate</a:t>
+            </a:r>
+          </a:p>
+        </p:txBody>
+      </p:sp>
+      <p:sp>
+        <p:nvSpPr>
+          <p:cNvPr id="45" name="TCell"/>
+          <p:cNvSpPr/>
+          <p:nvPr/>
+        </p:nvSpPr>
+        <p:spPr>
+          <a:xfrm>
+            <a:off x="548640" y="2950000"/>
+            <a:ext cx="2600000" cy="700000"/>
+          </a:xfrm>
+          <a:prstGeom prst="rect">
+            <a:avLst/>
+          </a:prstGeom>
+          <a:solidFill>
+            <a:srgbClr val="FFFFFF"/>
+          </a:solidFill>
+          <a:ln w="6350">
+            <a:solidFill>
+              <a:srgbClr val="D9D9D9"/>
+            </a:solidFill>
+          </a:ln>
+        </p:spPr>
+        <p:txBody>
+          <a:bodyPr wrap="square" lIns="90000" tIns="45000" rIns="90000" bIns="45000" anchor="ctr"/>
+          <a:lstStyle/>
+          <a:p>
+            <a:pPr indent="0" marL="0">
+              <a:buNone/>
+            </a:pPr>
+            <a:r>
+              <a:rPr lang="en-US" sz="1100" b="1" dirty="0">
+                <a:solidFill>
+                  <a:srgbClr val="1A2233"/>
+                </a:solidFill>
+                <a:latin typeface="Calibri" pitchFamily="34" charset="0"/>
+              </a:rPr>
+              <a:t>Bank 2 — Universal Links</a:t>
+            </a:r>
+          </a:p>
+        </p:txBody>
+      </p:sp>
+      <p:sp>
+        <p:nvSpPr>
+          <p:cNvPr id="46" name="TCell"/>
+          <p:cNvSpPr/>
+          <p:nvPr/>
+        </p:nvSpPr>
+        <p:spPr>
+          <a:xfrm>
+            <a:off x="3148640" y="2950000"/>
+            <a:ext cx="4700000" cy="700000"/>
+          </a:xfrm>
+          <a:prstGeom prst="rect">
+            <a:avLst/>
+          </a:prstGeom>
+          <a:solidFill>
+            <a:srgbClr val="FBEAEA"/>
+          </a:solidFill>
+          <a:ln w="6350">
+            <a:solidFill>
+              <a:srgbClr val="D9D9D9"/>
+            </a:solidFill>
+          </a:ln>
+        </p:spPr>
+        <p:txBody>
+          <a:bodyPr wrap="square" lIns="90000" tIns="45000" rIns="90000" bIns="45000" anchor="ctr"/>
+          <a:lstStyle/>
+          <a:p>
+            <a:pPr indent="0" marL="0">
+              <a:buNone/>
+            </a:pPr>
+            <a:r>
+              <a:rPr lang="en-US" sz="1100" dirty="0">
+                <a:solidFill>
+                  <a:srgbClr val="1A2233"/>
+                </a:solidFill>
+                <a:latin typeface="Calibri" pitchFamily="34" charset="0"/>
+              </a:rPr>
+              <a:t>Just opens Chrome — never a candidate</a:t>
+            </a:r>
+          </a:p>
+        </p:txBody>
+      </p:sp>
+      <p:sp>
+        <p:nvSpPr>
+          <p:cNvPr id="47" name="TCell"/>
+          <p:cNvSpPr/>
+          <p:nvPr/>
+        </p:nvSpPr>
+        <p:spPr>
+          <a:xfrm>
+            <a:off x="7848640" y="2950000"/>
+            <a:ext cx="4700000" cy="700000"/>
+          </a:xfrm>
+          <a:prstGeom prst="rect">
+            <a:avLst/>
+          </a:prstGeom>
+          <a:solidFill>
+            <a:srgbClr val="FFE9B3"/>
+          </a:solidFill>
+          <a:ln w="6350">
+            <a:solidFill>
+              <a:srgbClr val="D9D9D9"/>
+            </a:solidFill>
+          </a:ln>
+        </p:spPr>
+        <p:txBody>
+          <a:bodyPr wrap="square" lIns="90000" tIns="45000" rIns="90000" bIns="45000" anchor="ctr"/>
+          <a:lstStyle/>
+          <a:p>
+            <a:pPr indent="0" marL="0">
+              <a:buNone/>
+            </a:pPr>
+            <a:r>
+              <a:rPr lang="en-US" sz="1100" dirty="0">
+                <a:solidFill>
+                  <a:srgbClr val="1A2233"/>
+                </a:solidFill>
+                <a:latin typeface="Calibri" pitchFamily="34" charset="0"/>
+              </a:rPr>
+              <a:t>Safari + manual banner (free-account limit)</a:t>
+            </a:r>
+          </a:p>
+        </p:txBody>
+      </p:sp>
+      <p:sp>
+        <p:nvSpPr>
+          <p:cNvPr id="48" name="TCell"/>
+          <p:cNvSpPr/>
+          <p:nvPr/>
+        </p:nvSpPr>
+        <p:spPr>
+          <a:xfrm>
+            <a:off x="548640" y="3650000"/>
+            <a:ext cx="2600000" cy="700000"/>
+          </a:xfrm>
+          <a:prstGeom prst="rect">
+            <a:avLst/>
+          </a:prstGeom>
+          <a:solidFill>
+            <a:srgbClr val="FFFFFF"/>
+          </a:solidFill>
+          <a:ln w="6350">
+            <a:solidFill>
+              <a:srgbClr val="D9D9D9"/>
+            </a:solidFill>
+          </a:ln>
+        </p:spPr>
+        <p:txBody>
+          <a:bodyPr wrap="square" lIns="90000" tIns="45000" rIns="90000" bIns="45000" anchor="ctr"/>
+          <a:lstStyle/>
+          <a:p>
+            <a:pPr indent="0" marL="0">
+              <a:buNone/>
+            </a:pPr>
+            <a:r>
+              <a:rPr lang="en-US" sz="1100" b="1" dirty="0">
+                <a:solidFill>
+                  <a:srgbClr val="1A2233"/>
+                </a:solidFill>
+                <a:latin typeface="Calibri" pitchFamily="34" charset="0"/>
+              </a:rPr>
+              <a:t>Bank 3 — Smart Banner</a:t>
+            </a:r>
+          </a:p>
+        </p:txBody>
+      </p:sp>
+      <p:sp>
+        <p:nvSpPr>
+          <p:cNvPr id="49" name="TCell"/>
+          <p:cNvSpPr/>
+          <p:nvPr/>
+        </p:nvSpPr>
+        <p:spPr>
+          <a:xfrm>
+            <a:off x="3148640" y="3650000"/>
+            <a:ext cx="4700000" cy="700000"/>
+          </a:xfrm>
+          <a:prstGeom prst="rect">
+            <a:avLst/>
+          </a:prstGeom>
+          <a:solidFill>
+            <a:srgbClr val="FBEAEA"/>
+          </a:solidFill>
+          <a:ln w="6350">
+            <a:solidFill>
+              <a:srgbClr val="D9D9D9"/>
+            </a:solidFill>
+          </a:ln>
+        </p:spPr>
+        <p:txBody>
+          <a:bodyPr wrap="square" lIns="90000" tIns="45000" rIns="90000" bIns="45000" anchor="ctr"/>
+          <a:lstStyle/>
+          <a:p>
+            <a:pPr indent="0" marL="0">
+              <a:buNone/>
+            </a:pPr>
+            <a:r>
+              <a:rPr lang="en-US" sz="1100" dirty="0">
+                <a:solidFill>
+                  <a:srgbClr val="1A2233"/>
+                </a:solidFill>
+                <a:latin typeface="Calibri" pitchFamily="34" charset="0"/>
+              </a:rPr>
+              <a:t>Just opens Chrome — never a candidate</a:t>
+            </a:r>
+          </a:p>
+        </p:txBody>
+      </p:sp>
+      <p:sp>
+        <p:nvSpPr>
+          <p:cNvPr id="50" name="TCell"/>
+          <p:cNvSpPr/>
+          <p:nvPr/>
+        </p:nvSpPr>
+        <p:spPr>
+          <a:xfrm>
+            <a:off x="7848640" y="3650000"/>
+            <a:ext cx="4700000" cy="700000"/>
+          </a:xfrm>
+          <a:prstGeom prst="rect">
+            <a:avLst/>
+          </a:prstGeom>
+          <a:solidFill>
+            <a:srgbClr val="FFE9B3"/>
+          </a:solidFill>
+          <a:ln w="6350">
+            <a:solidFill>
+              <a:srgbClr val="D9D9D9"/>
+            </a:solidFill>
+          </a:ln>
+        </p:spPr>
+        <p:txBody>
+          <a:bodyPr wrap="square" lIns="90000" tIns="45000" rIns="90000" bIns="45000" anchor="ctr"/>
+          <a:lstStyle/>
+          <a:p>
+            <a:pPr indent="0" marL="0">
+              <a:buNone/>
+            </a:pPr>
+            <a:r>
+              <a:rPr lang="en-US" sz="1100" dirty="0">
+                <a:solidFill>
+                  <a:srgbClr val="1A2233"/>
+                </a:solidFill>
+                <a:latin typeface="Calibri" pitchFamily="34" charset="0"/>
+              </a:rPr>
+              <a:t>Banner can't render (needs App Store listing)</a:t>
+            </a:r>
+          </a:p>
+        </p:txBody>
+      </p:sp>
+      <p:sp>
+        <p:nvSpPr>
+          <p:cNvPr id="51" name="TCell"/>
+          <p:cNvSpPr/>
+          <p:nvPr/>
+        </p:nvSpPr>
+        <p:spPr>
+          <a:xfrm>
+            <a:off x="548640" y="4350000"/>
+            <a:ext cx="2600000" cy="700000"/>
+          </a:xfrm>
+          <a:prstGeom prst="rect">
+            <a:avLst/>
+          </a:prstGeom>
+          <a:solidFill>
+            <a:srgbClr val="FFFFFF"/>
+          </a:solidFill>
+          <a:ln w="6350">
+            <a:solidFill>
+              <a:srgbClr val="D9D9D9"/>
+            </a:solidFill>
+          </a:ln>
+        </p:spPr>
+        <p:txBody>
+          <a:bodyPr wrap="square" lIns="90000" tIns="45000" rIns="90000" bIns="45000" anchor="ctr"/>
+          <a:lstStyle/>
+          <a:p>
+            <a:pPr indent="0" marL="0">
+              <a:buNone/>
+            </a:pPr>
+            <a:r>
+              <a:rPr lang="en-US" sz="1100" b="1" dirty="0">
+                <a:solidFill>
+                  <a:srgbClr val="1A2233"/>
+                </a:solidFill>
+                <a:latin typeface="Calibri" pitchFamily="34" charset="0"/>
+              </a:rPr>
+              <a:t>Bank 4 — Explicit Intent</a:t>
+            </a:r>
+          </a:p>
+        </p:txBody>
+      </p:sp>
+      <p:sp>
+        <p:nvSpPr>
+          <p:cNvPr id="52" name="TCell"/>
+          <p:cNvSpPr/>
+          <p:nvPr/>
+        </p:nvSpPr>
+        <p:spPr>
+          <a:xfrm>
+            <a:off x="3148640" y="4350000"/>
+            <a:ext cx="4700000" cy="700000"/>
+          </a:xfrm>
+          <a:prstGeom prst="rect">
+            <a:avLst/>
+          </a:prstGeom>
+          <a:solidFill>
+            <a:srgbClr val="8CFFC1"/>
+          </a:solidFill>
+          <a:ln w="6350">
+            <a:solidFill>
+              <a:srgbClr val="D9D9D9"/>
+            </a:solidFill>
+          </a:ln>
+        </p:spPr>
+        <p:txBody>
+          <a:bodyPr wrap="square" lIns="90000" tIns="45000" rIns="90000" bIns="45000" anchor="ctr"/>
+          <a:lstStyle/>
+          <a:p>
+            <a:pPr indent="0" marL="0">
+              <a:buNone/>
+            </a:pPr>
+            <a:r>
+              <a:rPr lang="en-US" sz="1100" dirty="0">
+                <a:solidFill>
+                  <a:srgbClr val="1A2233"/>
+                </a:solidFill>
+                <a:latin typeface="Calibri" pitchFamily="34" charset="0"/>
+              </a:rPr>
+              <a:t>Opens directly, zero prompt</a:t>
+            </a:r>
+          </a:p>
+        </p:txBody>
+      </p:sp>
+      <p:sp>
+        <p:nvSpPr>
+          <p:cNvPr id="53" name="TCell"/>
+          <p:cNvSpPr/>
+          <p:nvPr/>
+        </p:nvSpPr>
+        <p:spPr>
+          <a:xfrm>
+            <a:off x="7848640" y="4350000"/>
+            <a:ext cx="4700000" cy="700000"/>
+          </a:xfrm>
+          <a:prstGeom prst="rect">
+            <a:avLst/>
+          </a:prstGeom>
+          <a:solidFill>
+            <a:srgbClr val="FBEAEA"/>
+          </a:solidFill>
+          <a:ln w="6350">
+            <a:solidFill>
+              <a:srgbClr val="D9D9D9"/>
+            </a:solidFill>
+          </a:ln>
+        </p:spPr>
+        <p:txBody>
+          <a:bodyPr wrap="square" lIns="90000" tIns="45000" rIns="90000" bIns="45000" anchor="ctr"/>
+          <a:lstStyle/>
+          <a:p>
+            <a:pPr indent="0" marL="0">
+              <a:buNone/>
+            </a:pPr>
+            <a:r>
+              <a:rPr lang="en-US" sz="1100" dirty="0">
+                <a:solidFill>
+                  <a:srgbClr val="1A2233"/>
+                </a:solidFill>
+                <a:latin typeface="Calibri" pitchFamily="34" charset="0"/>
+              </a:rPr>
+              <a:t>Just a webpage — never a candidate</a:t>
+            </a:r>
+          </a:p>
+        </p:txBody>
+      </p:sp>
+      <p:sp>
+        <p:nvSpPr>
+          <p:cNvPr id="54" name="TCell"/>
+          <p:cNvSpPr/>
+          <p:nvPr/>
+        </p:nvSpPr>
+        <p:spPr>
+          <a:xfrm>
+            <a:off x="548640" y="5050000"/>
+            <a:ext cx="2600000" cy="700000"/>
+          </a:xfrm>
+          <a:prstGeom prst="rect">
+            <a:avLst/>
+          </a:prstGeom>
+          <a:solidFill>
+            <a:srgbClr val="FFFFFF"/>
+          </a:solidFill>
+          <a:ln w="6350">
+            <a:solidFill>
+              <a:srgbClr val="D9D9D9"/>
+            </a:solidFill>
+          </a:ln>
+        </p:spPr>
+        <p:txBody>
+          <a:bodyPr wrap="square" lIns="90000" tIns="45000" rIns="90000" bIns="45000" anchor="ctr"/>
+          <a:lstStyle/>
+          <a:p>
+            <a:pPr indent="0" marL="0">
+              <a:buNone/>
+            </a:pPr>
+            <a:r>
+              <a:rPr lang="en-US" sz="1100" b="1" dirty="0">
+                <a:solidFill>
+                  <a:srgbClr val="1A2233"/>
+                </a:solidFill>
+                <a:latin typeface="Calibri" pitchFamily="34" charset="0"/>
+              </a:rPr>
+              <a:t>Bank 5 — Deferred Linking</a:t>
+            </a:r>
+          </a:p>
+        </p:txBody>
+      </p:sp>
+      <p:sp>
+        <p:nvSpPr>
+          <p:cNvPr id="55" name="TCell"/>
+          <p:cNvSpPr/>
+          <p:nvPr/>
+        </p:nvSpPr>
+        <p:spPr>
+          <a:xfrm>
+            <a:off x="3148640" y="5050000"/>
+            <a:ext cx="4700000" cy="700000"/>
+          </a:xfrm>
+          <a:prstGeom prst="rect">
+            <a:avLst/>
+          </a:prstGeom>
+          <a:solidFill>
+            <a:srgbClr val="8CFFC1"/>
+          </a:solidFill>
+          <a:ln w="6350">
+            <a:solidFill>
+              <a:srgbClr val="D9D9D9"/>
+            </a:solidFill>
+          </a:ln>
+        </p:spPr>
+        <p:txBody>
+          <a:bodyPr wrap="square" lIns="90000" tIns="45000" rIns="90000" bIns="45000" anchor="ctr"/>
+          <a:lstStyle/>
+          <a:p>
+            <a:pPr indent="0" marL="0">
+              <a:buNone/>
+            </a:pPr>
+            <a:r>
+              <a:rPr lang="en-US" sz="1100" dirty="0">
+                <a:solidFill>
+                  <a:srgbClr val="1A2233"/>
+                </a:solidFill>
+                <a:latin typeface="Calibri" pitchFamily="34" charset="0"/>
+              </a:rPr>
+              <a:t>Correct token recovered</a:t>
+            </a:r>
+          </a:p>
+        </p:txBody>
+      </p:sp>
+      <p:sp>
+        <p:nvSpPr>
+          <p:cNvPr id="56" name="TCell"/>
+          <p:cNvSpPr/>
+          <p:nvPr/>
+        </p:nvSpPr>
+        <p:spPr>
+          <a:xfrm>
+            <a:off x="7848640" y="5050000"/>
+            <a:ext cx="4700000" cy="700000"/>
+          </a:xfrm>
+          <a:prstGeom prst="rect">
+            <a:avLst/>
+          </a:prstGeom>
+          <a:solidFill>
+            <a:srgbClr val="8CFFC1"/>
+          </a:solidFill>
+          <a:ln w="6350">
+            <a:solidFill>
+              <a:srgbClr val="D9D9D9"/>
+            </a:solidFill>
+          </a:ln>
+        </p:spPr>
+        <p:txBody>
+          <a:bodyPr wrap="square" lIns="90000" tIns="45000" rIns="90000" bIns="45000" anchor="ctr"/>
+          <a:lstStyle/>
+          <a:p>
+            <a:pPr indent="0" marL="0">
+              <a:buNone/>
+            </a:pPr>
+            <a:r>
+              <a:rPr lang="en-US" sz="1100" dirty="0">
+                <a:solidFill>
+                  <a:srgbClr val="1A2233"/>
+                </a:solidFill>
+                <a:latin typeface="Calibri" pitchFamily="34" charset="0"/>
+              </a:rPr>
+              <a:t>Correct token recovered — identical to Android</a:t>
+            </a:r>
+          </a:p>
+        </p:txBody>
+      </p:sp>
+    </p:spTree>
+  </p:cSld>
+  <p:clrMapOvr>
+    <a:overrideClrMapping bg1="lt1" tx1="dk1" bg2="lt2" tx2="dk2" accent1="accent1" accent2="accent2" accent3="accent3" accent4="accent4" accent5="accent5" accent6="accent6" hlink="hlink" folHlink="folHlink"/>
+  </p:clrMapOvr>
+</p:sld>
+</file>
+
 <file path=ppt/slides/slide2.xml><?xml version="1.0" encoding="utf-8"?>
 <p:sld xmlns:a="http://schemas.openxmlformats.org/drawingml/2006/main" xmlns:r="http://schemas.openxmlformats.org/officeDocument/2006/relationships" xmlns:p="http://schemas.openxmlformats.org/presentationml/2006/main">
   <p:cSld name="Slide 2">

</xml_diff>

<commit_message>
Reposition conclusion + include unregistered link in all comparisons
- Moved "Why We Chose an Unregistered Link" to come AFTER the 5
  alternative method slides/section in both the deck and Word doc,
  reframed as a conclusion synthesized from having built and tested
  all 5 alternatives, rather than an early assertion.
- Added a "Unregistered link (Bank A/B/C)" row to both Cross-Platform
  Verification tables (deck slide + Word doc), so every method
  comparison in this project is now fully inclusive of all 6
  approaches, not just the 5 new ones.

Co-Authored-By: Claude Sonnet 5 <noreply@anthropic.com>
</commit_message>
<xml_diff>
--- a/SGQR_Deep_Linking_Simulation.pptx
+++ b/SGQR_Deep_Linking_Simulation.pptx
@@ -10,7 +10,6 @@
     <p:sldId id="257" r:id="rId3"/>
     <p:sldId id="258" r:id="rId4"/>
     <p:sldId id="259" r:id="rId5"/>
-    <p:sldId id="270" r:id="rId21"/>
     <p:sldId id="260" r:id="rId6"/>
     <p:sldId id="261" r:id="rId7"/>
     <p:sldId id="262" r:id="rId8"/>
@@ -22,6 +21,7 @@
     <p:sldId id="274" r:id="rId25"/>
     <p:sldId id="275" r:id="rId26"/>
     <p:sldId id="276" r:id="rId27"/>
+    <p:sldId id="270" r:id="rId21"/>
     <p:sldId id="267" r:id="rId18"/>
     <p:sldId id="269" r:id="rId20"/>
     <p:sldId id="266" r:id="rId12"/>
@@ -3824,14 +3824,14 @@
       </p:sp>
       <p:sp>
         <p:nvSpPr>
-          <p:cNvPr id="39" name="THead"/>
-          <p:cNvSpPr/>
-          <p:nvPr/>
-        </p:nvSpPr>
-        <p:spPr>
-          <a:xfrm>
-            <a:off x="548640" y="1750000"/>
-            <a:ext cx="2600000" cy="500000"/>
+          <p:cNvPr id="11" name="THead"/>
+          <p:cNvSpPr/>
+          <p:nvPr/>
+        </p:nvSpPr>
+        <p:spPr>
+          <a:xfrm>
+            <a:off x="548640" y="1650000"/>
+            <a:ext cx="2600000" cy="480000"/>
           </a:xfrm>
           <a:prstGeom prst="rect">
             <a:avLst/>
@@ -3864,14 +3864,14 @@
       </p:sp>
       <p:sp>
         <p:nvSpPr>
-          <p:cNvPr id="40" name="THead"/>
-          <p:cNvSpPr/>
-          <p:nvPr/>
-        </p:nvSpPr>
-        <p:spPr>
-          <a:xfrm>
-            <a:off x="3148640" y="1750000"/>
-            <a:ext cx="4700000" cy="500000"/>
+          <p:cNvPr id="12" name="THead"/>
+          <p:cNvSpPr/>
+          <p:nvPr/>
+        </p:nvSpPr>
+        <p:spPr>
+          <a:xfrm>
+            <a:off x="3148640" y="1650000"/>
+            <a:ext cx="4700000" cy="480000"/>
           </a:xfrm>
           <a:prstGeom prst="rect">
             <a:avLst/>
@@ -3904,14 +3904,14 @@
       </p:sp>
       <p:sp>
         <p:nvSpPr>
-          <p:cNvPr id="41" name="THead"/>
-          <p:cNvSpPr/>
-          <p:nvPr/>
-        </p:nvSpPr>
-        <p:spPr>
-          <a:xfrm>
-            <a:off x="7848640" y="1750000"/>
-            <a:ext cx="4700000" cy="500000"/>
+          <p:cNvPr id="13" name="THead"/>
+          <p:cNvSpPr/>
+          <p:nvPr/>
+        </p:nvSpPr>
+        <p:spPr>
+          <a:xfrm>
+            <a:off x="7848640" y="1650000"/>
+            <a:ext cx="4700000" cy="480000"/>
           </a:xfrm>
           <a:prstGeom prst="rect">
             <a:avLst/>
@@ -3944,13 +3944,13 @@
       </p:sp>
       <p:sp>
         <p:nvSpPr>
-          <p:cNvPr id="42" name="TCell"/>
-          <p:cNvSpPr/>
-          <p:nvPr/>
-        </p:nvSpPr>
-        <p:spPr>
-          <a:xfrm>
-            <a:off x="548640" y="2250000"/>
+          <p:cNvPr id="14" name="TCell"/>
+          <p:cNvSpPr/>
+          <p:nvPr/>
+        </p:nvSpPr>
+        <p:spPr>
+          <a:xfrm>
+            <a:off x="548640" y="2130000"/>
             <a:ext cx="2600000" cy="700000"/>
           </a:xfrm>
           <a:prstGeom prst="rect">
@@ -3966,7 +3966,7 @@
           </a:ln>
         </p:spPr>
         <p:txBody>
-          <a:bodyPr wrap="square" lIns="90000" tIns="45000" rIns="90000" bIns="45000" anchor="ctr"/>
+          <a:bodyPr wrap="square" lIns="90000" tIns="40000" rIns="90000" bIns="40000" anchor="ctr"/>
           <a:lstStyle/>
           <a:p>
             <a:pPr indent="0" marL="0">
@@ -3979,6 +3979,132 @@
                 </a:solidFill>
                 <a:latin typeface="Calibri" pitchFamily="34" charset="0"/>
               </a:rPr>
+              <a:t>Unregistered link (Bank A/B/C)</a:t>
+            </a:r>
+          </a:p>
+        </p:txBody>
+      </p:sp>
+      <p:sp>
+        <p:nvSpPr>
+          <p:cNvPr id="15" name="TCell"/>
+          <p:cNvSpPr/>
+          <p:nvPr/>
+        </p:nvSpPr>
+        <p:spPr>
+          <a:xfrm>
+            <a:off x="3148640" y="2130000"/>
+            <a:ext cx="4700000" cy="700000"/>
+          </a:xfrm>
+          <a:prstGeom prst="rect">
+            <a:avLst/>
+          </a:prstGeom>
+          <a:solidFill>
+            <a:srgbClr val="E8F5F0"/>
+          </a:solidFill>
+          <a:ln w="6350">
+            <a:solidFill>
+              <a:srgbClr val="D9D9D9"/>
+            </a:solidFill>
+          </a:ln>
+        </p:spPr>
+        <p:txBody>
+          <a:bodyPr wrap="square" lIns="90000" tIns="40000" rIns="90000" bIns="40000" anchor="ctr"/>
+          <a:lstStyle/>
+          <a:p>
+            <a:pPr indent="0" marL="0">
+              <a:buNone/>
+            </a:pPr>
+            <a:r>
+              <a:rPr lang="en-US" sz="1100" dirty="0">
+                <a:solidFill>
+                  <a:srgbClr val="1A2233"/>
+                </a:solidFill>
+                <a:latin typeface="Calibri" pitchFamily="34" charset="0"/>
+              </a:rPr>
+              <a:t>Native chooser — the real, working point of this project.</a:t>
+            </a:r>
+          </a:p>
+        </p:txBody>
+      </p:sp>
+      <p:sp>
+        <p:nvSpPr>
+          <p:cNvPr id="16" name="TCell"/>
+          <p:cNvSpPr/>
+          <p:nvPr/>
+        </p:nvSpPr>
+        <p:spPr>
+          <a:xfrm>
+            <a:off x="7848640" y="2130000"/>
+            <a:ext cx="4700000" cy="700000"/>
+          </a:xfrm>
+          <a:prstGeom prst="rect">
+            <a:avLst/>
+          </a:prstGeom>
+          <a:solidFill>
+            <a:srgbClr val="E8F5F0"/>
+          </a:solidFill>
+          <a:ln w="6350">
+            <a:solidFill>
+              <a:srgbClr val="D9D9D9"/>
+            </a:solidFill>
+          </a:ln>
+        </p:spPr>
+        <p:txBody>
+          <a:bodyPr wrap="square" lIns="90000" tIns="40000" rIns="90000" bIns="40000" anchor="ctr"/>
+          <a:lstStyle/>
+          <a:p>
+            <a:pPr indent="0" marL="0">
+              <a:buNone/>
+            </a:pPr>
+            <a:r>
+              <a:rPr lang="en-US" sz="1100" dirty="0">
+                <a:solidFill>
+                  <a:srgbClr val="1A2233"/>
+                </a:solidFill>
+                <a:latin typeface="Calibri" pitchFamily="34" charset="0"/>
+              </a:rPr>
+              <a:t>Web picker grid — the real, working point of this project.</a:t>
+            </a:r>
+          </a:p>
+        </p:txBody>
+      </p:sp>
+      <p:sp>
+        <p:nvSpPr>
+          <p:cNvPr id="17" name="TCell"/>
+          <p:cNvSpPr/>
+          <p:nvPr/>
+        </p:nvSpPr>
+        <p:spPr>
+          <a:xfrm>
+            <a:off x="548640" y="2830000"/>
+            <a:ext cx="2600000" cy="700000"/>
+          </a:xfrm>
+          <a:prstGeom prst="rect">
+            <a:avLst/>
+          </a:prstGeom>
+          <a:solidFill>
+            <a:srgbClr val="FFFFFF"/>
+          </a:solidFill>
+          <a:ln w="6350">
+            <a:solidFill>
+              <a:srgbClr val="D9D9D9"/>
+            </a:solidFill>
+          </a:ln>
+        </p:spPr>
+        <p:txBody>
+          <a:bodyPr wrap="square" lIns="90000" tIns="40000" rIns="90000" bIns="40000" anchor="ctr"/>
+          <a:lstStyle/>
+          <a:p>
+            <a:pPr indent="0" marL="0">
+              <a:buNone/>
+            </a:pPr>
+            <a:r>
+              <a:rPr lang="en-US" sz="1100" b="1" dirty="0">
+                <a:solidFill>
+                  <a:srgbClr val="1A2233"/>
+                </a:solidFill>
+                <a:latin typeface="Calibri" pitchFamily="34" charset="0"/>
+              </a:rPr>
               <a:t>Bank 1 — App Links</a:t>
             </a:r>
           </a:p>
@@ -3986,13 +4112,13 @@
       </p:sp>
       <p:sp>
         <p:nvSpPr>
-          <p:cNvPr id="43" name="TCell"/>
-          <p:cNvSpPr/>
-          <p:nvPr/>
-        </p:nvSpPr>
-        <p:spPr>
-          <a:xfrm>
-            <a:off x="3148640" y="2250000"/>
+          <p:cNvPr id="18" name="TCell"/>
+          <p:cNvSpPr/>
+          <p:nvPr/>
+        </p:nvSpPr>
+        <p:spPr>
+          <a:xfrm>
+            <a:off x="3148640" y="2830000"/>
             <a:ext cx="4700000" cy="700000"/>
           </a:xfrm>
           <a:prstGeom prst="rect">
@@ -4008,7 +4134,7 @@
           </a:ln>
         </p:spPr>
         <p:txBody>
-          <a:bodyPr wrap="square" lIns="90000" tIns="45000" rIns="90000" bIns="45000" anchor="ctr"/>
+          <a:bodyPr wrap="square" lIns="90000" tIns="40000" rIns="90000" bIns="40000" anchor="ctr"/>
           <a:lstStyle/>
           <a:p>
             <a:pPr indent="0" marL="0">
@@ -4028,13 +4154,13 @@
       </p:sp>
       <p:sp>
         <p:nvSpPr>
-          <p:cNvPr id="44" name="TCell"/>
-          <p:cNvSpPr/>
-          <p:nvPr/>
-        </p:nvSpPr>
-        <p:spPr>
-          <a:xfrm>
-            <a:off x="7848640" y="2250000"/>
+          <p:cNvPr id="19" name="TCell"/>
+          <p:cNvSpPr/>
+          <p:nvPr/>
+        </p:nvSpPr>
+        <p:spPr>
+          <a:xfrm>
+            <a:off x="7848640" y="2830000"/>
             <a:ext cx="4700000" cy="700000"/>
           </a:xfrm>
           <a:prstGeom prst="rect">
@@ -4050,7 +4176,7 @@
           </a:ln>
         </p:spPr>
         <p:txBody>
-          <a:bodyPr wrap="square" lIns="90000" tIns="45000" rIns="90000" bIns="45000" anchor="ctr"/>
+          <a:bodyPr wrap="square" lIns="90000" tIns="40000" rIns="90000" bIns="40000" anchor="ctr"/>
           <a:lstStyle/>
           <a:p>
             <a:pPr indent="0" marL="0">
@@ -4070,13 +4196,13 @@
       </p:sp>
       <p:sp>
         <p:nvSpPr>
-          <p:cNvPr id="45" name="TCell"/>
-          <p:cNvSpPr/>
-          <p:nvPr/>
-        </p:nvSpPr>
-        <p:spPr>
-          <a:xfrm>
-            <a:off x="548640" y="2950000"/>
+          <p:cNvPr id="20" name="TCell"/>
+          <p:cNvSpPr/>
+          <p:nvPr/>
+        </p:nvSpPr>
+        <p:spPr>
+          <a:xfrm>
+            <a:off x="548640" y="3530000"/>
             <a:ext cx="2600000" cy="700000"/>
           </a:xfrm>
           <a:prstGeom prst="rect">
@@ -4092,7 +4218,7 @@
           </a:ln>
         </p:spPr>
         <p:txBody>
-          <a:bodyPr wrap="square" lIns="90000" tIns="45000" rIns="90000" bIns="45000" anchor="ctr"/>
+          <a:bodyPr wrap="square" lIns="90000" tIns="40000" rIns="90000" bIns="40000" anchor="ctr"/>
           <a:lstStyle/>
           <a:p>
             <a:pPr indent="0" marL="0">
@@ -4112,13 +4238,13 @@
       </p:sp>
       <p:sp>
         <p:nvSpPr>
-          <p:cNvPr id="46" name="TCell"/>
-          <p:cNvSpPr/>
-          <p:nvPr/>
-        </p:nvSpPr>
-        <p:spPr>
-          <a:xfrm>
-            <a:off x="3148640" y="2950000"/>
+          <p:cNvPr id="21" name="TCell"/>
+          <p:cNvSpPr/>
+          <p:nvPr/>
+        </p:nvSpPr>
+        <p:spPr>
+          <a:xfrm>
+            <a:off x="3148640" y="3530000"/>
             <a:ext cx="4700000" cy="700000"/>
           </a:xfrm>
           <a:prstGeom prst="rect">
@@ -4134,7 +4260,7 @@
           </a:ln>
         </p:spPr>
         <p:txBody>
-          <a:bodyPr wrap="square" lIns="90000" tIns="45000" rIns="90000" bIns="45000" anchor="ctr"/>
+          <a:bodyPr wrap="square" lIns="90000" tIns="40000" rIns="90000" bIns="40000" anchor="ctr"/>
           <a:lstStyle/>
           <a:p>
             <a:pPr indent="0" marL="0">
@@ -4154,13 +4280,13 @@
       </p:sp>
       <p:sp>
         <p:nvSpPr>
-          <p:cNvPr id="47" name="TCell"/>
-          <p:cNvSpPr/>
-          <p:nvPr/>
-        </p:nvSpPr>
-        <p:spPr>
-          <a:xfrm>
-            <a:off x="7848640" y="2950000"/>
+          <p:cNvPr id="22" name="TCell"/>
+          <p:cNvSpPr/>
+          <p:nvPr/>
+        </p:nvSpPr>
+        <p:spPr>
+          <a:xfrm>
+            <a:off x="7848640" y="3530000"/>
             <a:ext cx="4700000" cy="700000"/>
           </a:xfrm>
           <a:prstGeom prst="rect">
@@ -4176,7 +4302,7 @@
           </a:ln>
         </p:spPr>
         <p:txBody>
-          <a:bodyPr wrap="square" lIns="90000" tIns="45000" rIns="90000" bIns="45000" anchor="ctr"/>
+          <a:bodyPr wrap="square" lIns="90000" tIns="40000" rIns="90000" bIns="40000" anchor="ctr"/>
           <a:lstStyle/>
           <a:p>
             <a:pPr indent="0" marL="0">
@@ -4196,13 +4322,13 @@
       </p:sp>
       <p:sp>
         <p:nvSpPr>
-          <p:cNvPr id="48" name="TCell"/>
-          <p:cNvSpPr/>
-          <p:nvPr/>
-        </p:nvSpPr>
-        <p:spPr>
-          <a:xfrm>
-            <a:off x="548640" y="3650000"/>
+          <p:cNvPr id="23" name="TCell"/>
+          <p:cNvSpPr/>
+          <p:nvPr/>
+        </p:nvSpPr>
+        <p:spPr>
+          <a:xfrm>
+            <a:off x="548640" y="4230000"/>
             <a:ext cx="2600000" cy="700000"/>
           </a:xfrm>
           <a:prstGeom prst="rect">
@@ -4218,7 +4344,7 @@
           </a:ln>
         </p:spPr>
         <p:txBody>
-          <a:bodyPr wrap="square" lIns="90000" tIns="45000" rIns="90000" bIns="45000" anchor="ctr"/>
+          <a:bodyPr wrap="square" lIns="90000" tIns="40000" rIns="90000" bIns="40000" anchor="ctr"/>
           <a:lstStyle/>
           <a:p>
             <a:pPr indent="0" marL="0">
@@ -4238,13 +4364,13 @@
       </p:sp>
       <p:sp>
         <p:nvSpPr>
-          <p:cNvPr id="49" name="TCell"/>
-          <p:cNvSpPr/>
-          <p:nvPr/>
-        </p:nvSpPr>
-        <p:spPr>
-          <a:xfrm>
-            <a:off x="3148640" y="3650000"/>
+          <p:cNvPr id="24" name="TCell"/>
+          <p:cNvSpPr/>
+          <p:nvPr/>
+        </p:nvSpPr>
+        <p:spPr>
+          <a:xfrm>
+            <a:off x="3148640" y="4230000"/>
             <a:ext cx="4700000" cy="700000"/>
           </a:xfrm>
           <a:prstGeom prst="rect">
@@ -4260,7 +4386,7 @@
           </a:ln>
         </p:spPr>
         <p:txBody>
-          <a:bodyPr wrap="square" lIns="90000" tIns="45000" rIns="90000" bIns="45000" anchor="ctr"/>
+          <a:bodyPr wrap="square" lIns="90000" tIns="40000" rIns="90000" bIns="40000" anchor="ctr"/>
           <a:lstStyle/>
           <a:p>
             <a:pPr indent="0" marL="0">
@@ -4280,13 +4406,13 @@
       </p:sp>
       <p:sp>
         <p:nvSpPr>
-          <p:cNvPr id="50" name="TCell"/>
-          <p:cNvSpPr/>
-          <p:nvPr/>
-        </p:nvSpPr>
-        <p:spPr>
-          <a:xfrm>
-            <a:off x="7848640" y="3650000"/>
+          <p:cNvPr id="25" name="TCell"/>
+          <p:cNvSpPr/>
+          <p:nvPr/>
+        </p:nvSpPr>
+        <p:spPr>
+          <a:xfrm>
+            <a:off x="7848640" y="4230000"/>
             <a:ext cx="4700000" cy="700000"/>
           </a:xfrm>
           <a:prstGeom prst="rect">
@@ -4302,7 +4428,7 @@
           </a:ln>
         </p:spPr>
         <p:txBody>
-          <a:bodyPr wrap="square" lIns="90000" tIns="45000" rIns="90000" bIns="45000" anchor="ctr"/>
+          <a:bodyPr wrap="square" lIns="90000" tIns="40000" rIns="90000" bIns="40000" anchor="ctr"/>
           <a:lstStyle/>
           <a:p>
             <a:pPr indent="0" marL="0">
@@ -4322,13 +4448,13 @@
       </p:sp>
       <p:sp>
         <p:nvSpPr>
-          <p:cNvPr id="51" name="TCell"/>
-          <p:cNvSpPr/>
-          <p:nvPr/>
-        </p:nvSpPr>
-        <p:spPr>
-          <a:xfrm>
-            <a:off x="548640" y="4350000"/>
+          <p:cNvPr id="26" name="TCell"/>
+          <p:cNvSpPr/>
+          <p:nvPr/>
+        </p:nvSpPr>
+        <p:spPr>
+          <a:xfrm>
+            <a:off x="548640" y="4930000"/>
             <a:ext cx="2600000" cy="700000"/>
           </a:xfrm>
           <a:prstGeom prst="rect">
@@ -4344,7 +4470,7 @@
           </a:ln>
         </p:spPr>
         <p:txBody>
-          <a:bodyPr wrap="square" lIns="90000" tIns="45000" rIns="90000" bIns="45000" anchor="ctr"/>
+          <a:bodyPr wrap="square" lIns="90000" tIns="40000" rIns="90000" bIns="40000" anchor="ctr"/>
           <a:lstStyle/>
           <a:p>
             <a:pPr indent="0" marL="0">
@@ -4364,13 +4490,13 @@
       </p:sp>
       <p:sp>
         <p:nvSpPr>
-          <p:cNvPr id="52" name="TCell"/>
-          <p:cNvSpPr/>
-          <p:nvPr/>
-        </p:nvSpPr>
-        <p:spPr>
-          <a:xfrm>
-            <a:off x="3148640" y="4350000"/>
+          <p:cNvPr id="27" name="TCell"/>
+          <p:cNvSpPr/>
+          <p:nvPr/>
+        </p:nvSpPr>
+        <p:spPr>
+          <a:xfrm>
+            <a:off x="3148640" y="4930000"/>
             <a:ext cx="4700000" cy="700000"/>
           </a:xfrm>
           <a:prstGeom prst="rect">
@@ -4386,7 +4512,7 @@
           </a:ln>
         </p:spPr>
         <p:txBody>
-          <a:bodyPr wrap="square" lIns="90000" tIns="45000" rIns="90000" bIns="45000" anchor="ctr"/>
+          <a:bodyPr wrap="square" lIns="90000" tIns="40000" rIns="90000" bIns="40000" anchor="ctr"/>
           <a:lstStyle/>
           <a:p>
             <a:pPr indent="0" marL="0">
@@ -4406,13 +4532,13 @@
       </p:sp>
       <p:sp>
         <p:nvSpPr>
-          <p:cNvPr id="53" name="TCell"/>
-          <p:cNvSpPr/>
-          <p:nvPr/>
-        </p:nvSpPr>
-        <p:spPr>
-          <a:xfrm>
-            <a:off x="7848640" y="4350000"/>
+          <p:cNvPr id="28" name="TCell"/>
+          <p:cNvSpPr/>
+          <p:nvPr/>
+        </p:nvSpPr>
+        <p:spPr>
+          <a:xfrm>
+            <a:off x="7848640" y="4930000"/>
             <a:ext cx="4700000" cy="700000"/>
           </a:xfrm>
           <a:prstGeom prst="rect">
@@ -4428,7 +4554,7 @@
           </a:ln>
         </p:spPr>
         <p:txBody>
-          <a:bodyPr wrap="square" lIns="90000" tIns="45000" rIns="90000" bIns="45000" anchor="ctr"/>
+          <a:bodyPr wrap="square" lIns="90000" tIns="40000" rIns="90000" bIns="40000" anchor="ctr"/>
           <a:lstStyle/>
           <a:p>
             <a:pPr indent="0" marL="0">
@@ -4448,13 +4574,13 @@
       </p:sp>
       <p:sp>
         <p:nvSpPr>
-          <p:cNvPr id="54" name="TCell"/>
-          <p:cNvSpPr/>
-          <p:nvPr/>
-        </p:nvSpPr>
-        <p:spPr>
-          <a:xfrm>
-            <a:off x="548640" y="5050000"/>
+          <p:cNvPr id="29" name="TCell"/>
+          <p:cNvSpPr/>
+          <p:nvPr/>
+        </p:nvSpPr>
+        <p:spPr>
+          <a:xfrm>
+            <a:off x="548640" y="5630000"/>
             <a:ext cx="2600000" cy="700000"/>
           </a:xfrm>
           <a:prstGeom prst="rect">
@@ -4470,7 +4596,7 @@
           </a:ln>
         </p:spPr>
         <p:txBody>
-          <a:bodyPr wrap="square" lIns="90000" tIns="45000" rIns="90000" bIns="45000" anchor="ctr"/>
+          <a:bodyPr wrap="square" lIns="90000" tIns="40000" rIns="90000" bIns="40000" anchor="ctr"/>
           <a:lstStyle/>
           <a:p>
             <a:pPr indent="0" marL="0">
@@ -4490,13 +4616,13 @@
       </p:sp>
       <p:sp>
         <p:nvSpPr>
-          <p:cNvPr id="55" name="TCell"/>
-          <p:cNvSpPr/>
-          <p:nvPr/>
-        </p:nvSpPr>
-        <p:spPr>
-          <a:xfrm>
-            <a:off x="3148640" y="5050000"/>
+          <p:cNvPr id="30" name="TCell"/>
+          <p:cNvSpPr/>
+          <p:nvPr/>
+        </p:nvSpPr>
+        <p:spPr>
+          <a:xfrm>
+            <a:off x="3148640" y="5630000"/>
             <a:ext cx="4700000" cy="700000"/>
           </a:xfrm>
           <a:prstGeom prst="rect">
@@ -4512,7 +4638,7 @@
           </a:ln>
         </p:spPr>
         <p:txBody>
-          <a:bodyPr wrap="square" lIns="90000" tIns="45000" rIns="90000" bIns="45000" anchor="ctr"/>
+          <a:bodyPr wrap="square" lIns="90000" tIns="40000" rIns="90000" bIns="40000" anchor="ctr"/>
           <a:lstStyle/>
           <a:p>
             <a:pPr indent="0" marL="0">
@@ -4532,13 +4658,13 @@
       </p:sp>
       <p:sp>
         <p:nvSpPr>
-          <p:cNvPr id="56" name="TCell"/>
-          <p:cNvSpPr/>
-          <p:nvPr/>
-        </p:nvSpPr>
-        <p:spPr>
-          <a:xfrm>
-            <a:off x="7848640" y="5050000"/>
+          <p:cNvPr id="31" name="TCell"/>
+          <p:cNvSpPr/>
+          <p:nvPr/>
+        </p:nvSpPr>
+        <p:spPr>
+          <a:xfrm>
+            <a:off x="7848640" y="5630000"/>
             <a:ext cx="4700000" cy="700000"/>
           </a:xfrm>
           <a:prstGeom prst="rect">
@@ -4554,7 +4680,7 @@
           </a:ln>
         </p:spPr>
         <p:txBody>
-          <a:bodyPr wrap="square" lIns="90000" tIns="45000" rIns="90000" bIns="45000" anchor="ctr"/>
+          <a:bodyPr wrap="square" lIns="90000" tIns="40000" rIns="90000" bIns="40000" anchor="ctr"/>
           <a:lstStyle/>
           <a:p>
             <a:pPr indent="0" marL="0">
@@ -4582,7 +4708,7 @@
 
 <file path=ppt/slides/slide15.xml><?xml version="1.0" encoding="utf-8"?>
 <p:sld xmlns:a="http://schemas.openxmlformats.org/drawingml/2006/main" xmlns:r="http://schemas.openxmlformats.org/officeDocument/2006/relationships" xmlns:p="http://schemas.openxmlformats.org/presentationml/2006/main">
-  <p:cSld name="WhyUnregistered">
+  <p:cSld name="WhyUnregisteredConclusion">
     <p:bg>
       <p:bgPr>
         <a:solidFill>
@@ -4606,7 +4732,7 @@
       </p:grpSpPr>
       <p:sp>
         <p:nvSpPr>
-          <p:cNvPr id="41" name="TB"/>
+          <p:cNvPr id="122" name="TB"/>
           <p:cNvSpPr/>
           <p:nvPr/>
         </p:nvSpPr>
@@ -4635,14 +4761,14 @@
                 </a:solidFill>
                 <a:latin typeface="Cambria" pitchFamily="34" charset="0"/>
               </a:rPr>
-              <a:t>Why We Chose an Unregistered Link</a:t>
-            </a:r>
-          </a:p>
-        </p:txBody>
-      </p:sp>
-      <p:sp>
-        <p:nvSpPr>
-          <p:cNvPr id="42" name="TB"/>
+              <a:t>Why Unregistered Link Still Wins</a:t>
+            </a:r>
+          </a:p>
+        </p:txBody>
+      </p:sp>
+      <p:sp>
+        <p:nvSpPr>
+          <p:cNvPr id="123" name="TB"/>
           <p:cNvSpPr/>
           <p:nvPr/>
         </p:nvSpPr>
@@ -4671,21 +4797,21 @@
                 </a:solidFill>
                 <a:latin typeface="Calibri" pitchFamily="34" charset="0"/>
               </a:rPr>
-              <a:t>The deciding factor: it produces the same user flow on both platforms</a:t>
-            </a:r>
-          </a:p>
-        </p:txBody>
-      </p:sp>
-      <p:sp>
-        <p:nvSpPr>
-          <p:cNvPr id="43" name="Box"/>
+              <a:t>Having built and tested all 5 alternatives, this is the conclusion they point to</a:t>
+            </a:r>
+          </a:p>
+        </p:txBody>
+      </p:sp>
+      <p:sp>
+        <p:nvSpPr>
+          <p:cNvPr id="124" name="Box"/>
           <p:cNvSpPr/>
           <p:nvPr/>
         </p:nvSpPr>
         <p:spPr>
           <a:xfrm>
             <a:off x="548640" y="1650000"/>
-            <a:ext cx="5450000" cy="2300000"/>
+            <a:ext cx="5450000" cy="2100000"/>
           </a:xfrm>
           <a:prstGeom prst="roundRect">
             <a:avLst>
@@ -4709,7 +4835,7 @@
       </p:sp>
       <p:sp>
         <p:nvSpPr>
-          <p:cNvPr id="44" name="TB"/>
+          <p:cNvPr id="125" name="TB"/>
           <p:cNvSpPr/>
           <p:nvPr/>
         </p:nvSpPr>
@@ -4745,14 +4871,14 @@
       </p:sp>
       <p:sp>
         <p:nvSpPr>
-          <p:cNvPr id="45" name="TB"/>
+          <p:cNvPr id="126" name="TB"/>
           <p:cNvSpPr/>
           <p:nvPr/>
         </p:nvSpPr>
         <p:spPr>
           <a:xfrm>
             <a:off x="748640" y="2110000"/>
-            <a:ext cx="5050000" cy="1720000"/>
+            <a:ext cx="5050000" cy="1520000"/>
           </a:xfrm>
           <a:prstGeom prst="rect">
             <a:avLst/>
@@ -4768,7 +4894,7 @@
               <a:buNone/>
             </a:pPr>
             <a:r>
-              <a:rPr lang="en-US" sz="1300" dirty="0">
+              <a:rPr lang="en-US" sz="1250" dirty="0">
                 <a:solidFill>
                   <a:srgbClr val="1A2233"/>
                 </a:solidFill>
@@ -4782,7 +4908,7 @@
               <a:buNone/>
             </a:pPr>
             <a:r>
-              <a:rPr lang="en-US" sz="1300" dirty="0">
+              <a:rPr lang="en-US" sz="1250" dirty="0">
                 <a:solidFill>
                   <a:srgbClr val="1A2233"/>
                 </a:solidFill>
@@ -4796,7 +4922,7 @@
               <a:buNone/>
             </a:pPr>
             <a:r>
-              <a:rPr lang="en-US" sz="1300" dirty="0">
+              <a:rPr lang="en-US" sz="1250" dirty="0">
                 <a:solidFill>
                   <a:srgbClr val="1A2233"/>
                 </a:solidFill>
@@ -4810,7 +4936,7 @@
               <a:buNone/>
             </a:pPr>
             <a:r>
-              <a:rPr lang="en-US" sz="1300" dirty="0">
+              <a:rPr lang="en-US" sz="1250" dirty="0">
                 <a:solidFill>
                   <a:srgbClr val="1A2233"/>
                 </a:solidFill>
@@ -4823,14 +4949,14 @@
       </p:sp>
       <p:sp>
         <p:nvSpPr>
-          <p:cNvPr id="46" name="Box"/>
+          <p:cNvPr id="127" name="Box"/>
           <p:cNvSpPr/>
           <p:nvPr/>
         </p:nvSpPr>
         <p:spPr>
           <a:xfrm>
             <a:off x="6193360" y="1650000"/>
-            <a:ext cx="5450000" cy="2300000"/>
+            <a:ext cx="5450000" cy="2100000"/>
           </a:xfrm>
           <a:prstGeom prst="roundRect">
             <a:avLst>
@@ -4854,7 +4980,7 @@
       </p:sp>
       <p:sp>
         <p:nvSpPr>
-          <p:cNvPr id="47" name="TB"/>
+          <p:cNvPr id="128" name="TB"/>
           <p:cNvSpPr/>
           <p:nvPr/>
         </p:nvSpPr>
@@ -4890,14 +5016,14 @@
       </p:sp>
       <p:sp>
         <p:nvSpPr>
-          <p:cNvPr id="48" name="TB"/>
+          <p:cNvPr id="129" name="TB"/>
           <p:cNvSpPr/>
           <p:nvPr/>
         </p:nvSpPr>
         <p:spPr>
           <a:xfrm>
             <a:off x="6393360" y="2110000"/>
-            <a:ext cx="5050000" cy="1720000"/>
+            <a:ext cx="5050000" cy="1520000"/>
           </a:xfrm>
           <a:prstGeom prst="rect">
             <a:avLst/>
@@ -4913,7 +5039,7 @@
               <a:buNone/>
             </a:pPr>
             <a:r>
-              <a:rPr lang="en-US" sz="1300" dirty="0">
+              <a:rPr lang="en-US" sz="1250" dirty="0">
                 <a:solidFill>
                   <a:srgbClr val="1A2233"/>
                 </a:solidFill>
@@ -4927,7 +5053,7 @@
               <a:buNone/>
             </a:pPr>
             <a:r>
-              <a:rPr lang="en-US" sz="1300" dirty="0">
+              <a:rPr lang="en-US" sz="1250" dirty="0">
                 <a:solidFill>
                   <a:srgbClr val="1A2233"/>
                 </a:solidFill>
@@ -4941,7 +5067,7 @@
               <a:buNone/>
             </a:pPr>
             <a:r>
-              <a:rPr lang="en-US" sz="1300" dirty="0">
+              <a:rPr lang="en-US" sz="1250" dirty="0">
                 <a:solidFill>
                   <a:srgbClr val="1A2233"/>
                 </a:solidFill>
@@ -4955,7 +5081,7 @@
               <a:buNone/>
             </a:pPr>
             <a:r>
-              <a:rPr lang="en-US" sz="1300" dirty="0">
+              <a:rPr lang="en-US" sz="1250" dirty="0">
                 <a:solidFill>
                   <a:srgbClr val="1A2233"/>
                 </a:solidFill>
@@ -4968,14 +5094,14 @@
       </p:sp>
       <p:sp>
         <p:nvSpPr>
-          <p:cNvPr id="49" name="Box"/>
-          <p:cNvSpPr/>
-          <p:nvPr/>
-        </p:nvSpPr>
-        <p:spPr>
-          <a:xfrm>
-            <a:off x="548640" y="4150000"/>
-            <a:ext cx="11094720" cy="1500000"/>
+          <p:cNvPr id="130" name="Box"/>
+          <p:cNvSpPr/>
+          <p:nvPr/>
+        </p:nvSpPr>
+        <p:spPr>
+          <a:xfrm>
+            <a:off x="548640" y="3950000"/>
+            <a:ext cx="11094720" cy="1350000"/>
           </a:xfrm>
           <a:prstGeom prst="roundRect">
             <a:avLst>
@@ -4999,13 +5125,13 @@
       </p:sp>
       <p:sp>
         <p:nvSpPr>
-          <p:cNvPr id="50" name="TB"/>
-          <p:cNvSpPr/>
-          <p:nvPr/>
-        </p:nvSpPr>
-        <p:spPr>
-          <a:xfrm>
-            <a:off x="748640" y="4280000"/>
+          <p:cNvPr id="131" name="TB"/>
+          <p:cNvSpPr/>
+          <p:nvPr/>
+        </p:nvSpPr>
+        <p:spPr>
+          <a:xfrm>
+            <a:off x="748640" y="4080000"/>
             <a:ext cx="10694720" cy="320000"/>
           </a:xfrm>
           <a:prstGeom prst="rect">
@@ -5028,21 +5154,21 @@
                 </a:solidFill>
                 <a:latin typeface="Calibri" pitchFamily="34" charset="0"/>
               </a:rPr>
-              <a:t>The point</a:t>
-            </a:r>
-          </a:p>
-        </p:txBody>
-      </p:sp>
-      <p:sp>
-        <p:nvSpPr>
-          <p:cNvPr id="51" name="TB"/>
-          <p:cNvSpPr/>
-          <p:nvPr/>
-        </p:nvSpPr>
-        <p:spPr>
-          <a:xfrm>
-            <a:off x="748640" y="4610000"/>
-            <a:ext cx="10694720" cy="920000"/>
+              <a:t>What the 5 alternatives actually proved</a:t>
+            </a:r>
+          </a:p>
+        </p:txBody>
+      </p:sp>
+      <p:sp>
+        <p:nvSpPr>
+          <p:cNvPr id="132" name="TB"/>
+          <p:cNvSpPr/>
+          <p:nvPr/>
+        </p:nvSpPr>
+        <p:spPr>
+          <a:xfrm>
+            <a:off x="748640" y="4410000"/>
+            <a:ext cx="10694720" cy="770000"/>
           </a:xfrm>
           <a:prstGeom prst="rect">
             <a:avLst/>
@@ -5058,55 +5184,55 @@
               <a:buNone/>
             </a:pPr>
             <a:r>
-              <a:rPr lang="en-US" sz="1250" dirty="0">
+              <a:rPr lang="en-US" sz="1150" dirty="0">
                 <a:solidFill>
                   <a:srgbClr val="1A2233"/>
                 </a:solidFill>
                 <a:latin typeface="Calibri" pitchFamily="34" charset="0"/>
               </a:rPr>
-              <a:t>Neither platform's link is ever verified or registered with the OS. That single choice is what makes both</a:t>
-            </a:r>
-          </a:p>
-          <a:p>
-            <a:pPr indent="0" marL="0">
-              <a:buNone/>
-            </a:pPr>
-            <a:r>
-              <a:rPr lang="en-US" sz="1250" dirty="0">
+              <a:t>Bank 1 and Bank 4 show verification/naming CAN remove the chooser — but only by picking one app in</a:t>
+            </a:r>
+          </a:p>
+          <a:p>
+            <a:pPr indent="0" marL="0">
+              <a:buNone/>
+            </a:pPr>
+            <a:r>
+              <a:rPr lang="en-US" sz="1150" dirty="0">
                 <a:solidFill>
                   <a:srgbClr val="1A2233"/>
                 </a:solidFill>
                 <a:latin typeface="Calibri" pitchFamily="34" charset="0"/>
               </a:rPr>
-              <a:t>flows land in the same place: the user always ends up choosing a bank, on both phones, from one QR code —</a:t>
-            </a:r>
-          </a:p>
-          <a:p>
-            <a:pPr indent="0" marL="0">
-              <a:buNone/>
-            </a:pPr>
-            <a:r>
-              <a:rPr lang="en-US" sz="1250" dirty="0">
+              <a:t>advance, defeating the "any of 3 banks" requirement. Bank 2 and Bank 3 show iOS verification is real but</a:t>
+            </a:r>
+          </a:p>
+          <a:p>
+            <a:pPr indent="0" marL="0">
+              <a:buNone/>
+            </a:pPr>
+            <a:r>
+              <a:rPr lang="en-US" sz="1150" dirty="0">
                 <a:solidFill>
                   <a:srgbClr val="1A2233"/>
                 </a:solidFill>
                 <a:latin typeface="Calibri" pitchFamily="34" charset="0"/>
               </a:rPr>
-              <a:t>instead of two platforms behaving in two unrelated ways that would each need separate testing and upkeep.</a:t>
-            </a:r>
-          </a:p>
-        </p:txBody>
-      </p:sp>
-      <p:sp>
-        <p:nvSpPr>
-          <p:cNvPr id="52" name="Box"/>
-          <p:cNvSpPr/>
-          <p:nvPr/>
-        </p:nvSpPr>
-        <p:spPr>
-          <a:xfrm>
-            <a:off x="548640" y="5850000"/>
-            <a:ext cx="11094720" cy="900000"/>
+              <a:t>gated behind external requirements this project can't meet. Bank 5 shows a different problem entirely.</a:t>
+            </a:r>
+          </a:p>
+        </p:txBody>
+      </p:sp>
+      <p:sp>
+        <p:nvSpPr>
+          <p:cNvPr id="133" name="Box"/>
+          <p:cNvSpPr/>
+          <p:nvPr/>
+        </p:nvSpPr>
+        <p:spPr>
+          <a:xfrm>
+            <a:off x="548640" y="5500000"/>
+            <a:ext cx="11094720" cy="1150000"/>
           </a:xfrm>
           <a:prstGeom prst="roundRect">
             <a:avLst>
@@ -5130,13 +5256,13 @@
       </p:sp>
       <p:sp>
         <p:nvSpPr>
-          <p:cNvPr id="53" name="TB"/>
-          <p:cNvSpPr/>
-          <p:nvPr/>
-        </p:nvSpPr>
-        <p:spPr>
-          <a:xfrm>
-            <a:off x="748640" y="5980000"/>
+          <p:cNvPr id="134" name="TB"/>
+          <p:cNvSpPr/>
+          <p:nvPr/>
+        </p:nvSpPr>
+        <p:spPr>
+          <a:xfrm>
+            <a:off x="748640" y="5630000"/>
             <a:ext cx="10694720" cy="320000"/>
           </a:xfrm>
           <a:prstGeom prst="rect">
@@ -5159,21 +5285,21 @@
                 </a:solidFill>
                 <a:latin typeface="Calibri" pitchFamily="34" charset="0"/>
               </a:rPr>
-              <a:t>The trade-off</a:t>
-            </a:r>
-          </a:p>
-        </p:txBody>
-      </p:sp>
-      <p:sp>
-        <p:nvSpPr>
-          <p:cNvPr id="54" name="TB"/>
-          <p:cNvSpPr/>
-          <p:nvPr/>
-        </p:nvSpPr>
-        <p:spPr>
-          <a:xfrm>
-            <a:off x="748640" y="6310000"/>
-            <a:ext cx="10694720" cy="320000"/>
+              <a:t>The conclusion</a:t>
+            </a:r>
+          </a:p>
+        </p:txBody>
+      </p:sp>
+      <p:sp>
+        <p:nvSpPr>
+          <p:cNvPr id="135" name="TB"/>
+          <p:cNvSpPr/>
+          <p:nvPr/>
+        </p:nvSpPr>
+        <p:spPr>
+          <a:xfrm>
+            <a:off x="748640" y="5960000"/>
+            <a:ext cx="10694720" cy="570000"/>
           </a:xfrm>
           <a:prstGeom prst="rect">
             <a:avLst/>
@@ -5189,27 +5315,41 @@
               <a:buNone/>
             </a:pPr>
             <a:r>
-              <a:rPr lang="en-US" sz="1200" dirty="0">
+              <a:rPr lang="en-US" sz="1150" dirty="0">
                 <a:solidFill>
                   <a:srgbClr val="1A2233"/>
                 </a:solidFill>
                 <a:latin typeface="Calibri" pitchFamily="34" charset="0"/>
               </a:rPr>
-              <a:t>This is a deliberate choice, not a limitation avoided by accident — Bank 1, 2, and 4 in this project all prove</a:t>
-            </a:r>
-          </a:p>
-          <a:p>
-            <a:pPr indent="0" marL="0">
-              <a:buNone/>
-            </a:pPr>
-            <a:r>
-              <a:rPr lang="en-US" sz="1200" dirty="0">
+              <a:t>None of the 5 alternatives were ever going to solve "same user flow, both platforms, any of 3 banks" —</a:t>
+            </a:r>
+          </a:p>
+          <a:p>
+            <a:pPr indent="0" marL="0">
+              <a:buNone/>
+            </a:pPr>
+            <a:r>
+              <a:rPr lang="en-US" sz="1150" dirty="0">
                 <a:solidFill>
                   <a:srgbClr val="1A2233"/>
                 </a:solidFill>
                 <a:latin typeface="Calibri" pitchFamily="34" charset="0"/>
               </a:rPr>
-              <a:t>that registering/verifying a link is possible; it just produces a different (single-app, no-choice) outcome.</a:t>
+              <a:t>each solves a narrower problem instead. Unregistered link is not the leftover option; it is the only one of</a:t>
+            </a:r>
+          </a:p>
+          <a:p>
+            <a:pPr indent="0" marL="0">
+              <a:buNone/>
+            </a:pPr>
+            <a:r>
+              <a:rPr lang="en-US" sz="1150" dirty="0">
+                <a:solidFill>
+                  <a:srgbClr val="1A2233"/>
+                </a:solidFill>
+                <a:latin typeface="Calibri" pitchFamily="34" charset="0"/>
+              </a:rPr>
+              <a:t>these 6 approaches actually shaped around this project's specific requirement.</a:t>
             </a:r>
           </a:p>
         </p:txBody>

</xml_diff>

<commit_message>
Reorder all 3 documents: methods first, unregistered link last
Unregistered link (Bank A/B/C) is this project's concluding solution,
so it now comes last everywhere a method comparison or narrative
sequence appears, with Bank 1-5 showcased first:

- Main deck: overview table, cross-platform table, and slide order all
  reordered (Bank 1-5 → core mechanism explanation → conclusion slide
  → closing).
- Word doc: both Part 9 comparison tables reordered the same way.
- Sequence deck: Bank 1 diagram + cross-platform negative case + the
  all-6-methods table now come first, with the 4 core sequence
  diagrams (Android chooser, iOS handoff, single-use approval, journey
  comparison) moved to the end.

Co-Authored-By: Claude Sonnet 5 <noreply@anthropic.com>
</commit_message>
<xml_diff>
--- a/SGQR_Deep_Linking_Simulation.pptx
+++ b/SGQR_Deep_Linking_Simulation.pptx
@@ -7,6 +7,13 @@
   <p:sldIdLst>
     <p:sldId id="256" r:id="rId2"/>
     <p:sldId id="271" r:id="rId22"/>
+    <p:sldId id="272" r:id="rId23"/>
+    <p:sldId id="273" r:id="rId24"/>
+    <p:sldId id="274" r:id="rId25"/>
+    <p:sldId id="275" r:id="rId26"/>
+    <p:sldId id="276" r:id="rId27"/>
+    <p:sldId id="267" r:id="rId18"/>
+    <p:sldId id="269" r:id="rId20"/>
     <p:sldId id="257" r:id="rId3"/>
     <p:sldId id="258" r:id="rId4"/>
     <p:sldId id="259" r:id="rId5"/>
@@ -16,14 +23,7 @@
     <p:sldId id="263" r:id="rId9"/>
     <p:sldId id="264" r:id="rId10"/>
     <p:sldId id="265" r:id="rId11"/>
-    <p:sldId id="272" r:id="rId23"/>
-    <p:sldId id="273" r:id="rId24"/>
-    <p:sldId id="274" r:id="rId25"/>
-    <p:sldId id="275" r:id="rId26"/>
-    <p:sldId id="276" r:id="rId27"/>
     <p:sldId id="270" r:id="rId21"/>
-    <p:sldId id="267" r:id="rId18"/>
-    <p:sldId id="269" r:id="rId20"/>
     <p:sldId id="266" r:id="rId12"/>
   </p:sldIdLst>
   <p:notesMasterIdLst>
@@ -3776,8 +3776,6 @@
                   <a:srgbClr val="FFFFFF"/>
                 </a:solidFill>
                 <a:latin typeface="Cambria" pitchFamily="34" charset="0"/>
-                <a:ea typeface="Cambria" pitchFamily="34" charset="-122"/>
-                <a:cs typeface="Cambria" pitchFamily="34" charset="-120"/>
               </a:rPr>
               <a:t>Cross-Platform Verification: Confirmed Live</a:t>
             </a:r>
@@ -3814,8 +3812,6 @@
                   <a:srgbClr val="CADCFC"/>
                 </a:solidFill>
                 <a:latin typeface="Calibri" pitchFamily="34" charset="0"/>
-                <a:ea typeface="Calibri" pitchFamily="34" charset="-122"/>
-                <a:cs typeface="Calibri" pitchFamily="34" charset="-120"/>
               </a:rPr>
               <a:t>Every app was also installed on the "wrong" platform to confirm the negative case</a:t>
             </a:r>
@@ -3824,7 +3820,7 @@
       </p:sp>
       <p:sp>
         <p:nvSpPr>
-          <p:cNvPr id="11" name="THead"/>
+          <p:cNvPr id="1001" name="THead"/>
           <p:cNvSpPr/>
           <p:nvPr/>
         </p:nvSpPr>
@@ -3864,7 +3860,7 @@
       </p:sp>
       <p:sp>
         <p:nvSpPr>
-          <p:cNvPr id="12" name="THead"/>
+          <p:cNvPr id="1002" name="THead"/>
           <p:cNvSpPr/>
           <p:nvPr/>
         </p:nvSpPr>
@@ -3904,7 +3900,7 @@
       </p:sp>
       <p:sp>
         <p:nvSpPr>
-          <p:cNvPr id="13" name="THead"/>
+          <p:cNvPr id="1003" name="THead"/>
           <p:cNvSpPr/>
           <p:nvPr/>
         </p:nvSpPr>
@@ -3944,7 +3940,7 @@
       </p:sp>
       <p:sp>
         <p:nvSpPr>
-          <p:cNvPr id="14" name="TCell"/>
+          <p:cNvPr id="1004" name="TCell"/>
           <p:cNvSpPr/>
           <p:nvPr/>
         </p:nvSpPr>
@@ -3979,6 +3975,636 @@
                 </a:solidFill>
                 <a:latin typeface="Calibri" pitchFamily="34" charset="0"/>
               </a:rPr>
+              <a:t>Bank 1 — App Links</a:t>
+            </a:r>
+          </a:p>
+        </p:txBody>
+      </p:sp>
+      <p:sp>
+        <p:nvSpPr>
+          <p:cNvPr id="1005" name="TCell"/>
+          <p:cNvSpPr/>
+          <p:nvPr/>
+        </p:nvSpPr>
+        <p:spPr>
+          <a:xfrm>
+            <a:off x="3148640" y="2130000"/>
+            <a:ext cx="4700000" cy="700000"/>
+          </a:xfrm>
+          <a:prstGeom prst="rect">
+            <a:avLst/>
+          </a:prstGeom>
+          <a:solidFill>
+            <a:srgbClr val="8CFFC1"/>
+          </a:solidFill>
+          <a:ln w="6350">
+            <a:solidFill>
+              <a:srgbClr val="D9D9D9"/>
+            </a:solidFill>
+          </a:ln>
+        </p:spPr>
+        <p:txBody>
+          <a:bodyPr wrap="square" lIns="90000" tIns="40000" rIns="90000" bIns="40000" anchor="ctr"/>
+          <a:lstStyle/>
+          <a:p>
+            <a:pPr indent="0" marL="0">
+              <a:buNone/>
+            </a:pPr>
+            <a:r>
+              <a:rPr lang="en-US" sz="1100" dirty="0">
+                <a:solidFill>
+                  <a:srgbClr val="1A2233"/>
+                </a:solidFill>
+                <a:latin typeface="Calibri" pitchFamily="34" charset="0"/>
+              </a:rPr>
+              <a:t>Opens directly, zero prompt</a:t>
+            </a:r>
+          </a:p>
+        </p:txBody>
+      </p:sp>
+      <p:sp>
+        <p:nvSpPr>
+          <p:cNvPr id="1006" name="TCell"/>
+          <p:cNvSpPr/>
+          <p:nvPr/>
+        </p:nvSpPr>
+        <p:spPr>
+          <a:xfrm>
+            <a:off x="7848640" y="2130000"/>
+            <a:ext cx="4700000" cy="700000"/>
+          </a:xfrm>
+          <a:prstGeom prst="rect">
+            <a:avLst/>
+          </a:prstGeom>
+          <a:solidFill>
+            <a:srgbClr val="FBEAEA"/>
+          </a:solidFill>
+          <a:ln w="6350">
+            <a:solidFill>
+              <a:srgbClr val="D9D9D9"/>
+            </a:solidFill>
+          </a:ln>
+        </p:spPr>
+        <p:txBody>
+          <a:bodyPr wrap="square" lIns="90000" tIns="40000" rIns="90000" bIns="40000" anchor="ctr"/>
+          <a:lstStyle/>
+          <a:p>
+            <a:pPr indent="0" marL="0">
+              <a:buNone/>
+            </a:pPr>
+            <a:r>
+              <a:rPr lang="en-US" sz="1100" dirty="0">
+                <a:solidFill>
+                  <a:srgbClr val="1A2233"/>
+                </a:solidFill>
+                <a:latin typeface="Calibri" pitchFamily="34" charset="0"/>
+              </a:rPr>
+              <a:t>Just a webpage — the app is never involved</a:t>
+            </a:r>
+          </a:p>
+        </p:txBody>
+      </p:sp>
+      <p:sp>
+        <p:nvSpPr>
+          <p:cNvPr id="1007" name="TCell"/>
+          <p:cNvSpPr/>
+          <p:nvPr/>
+        </p:nvSpPr>
+        <p:spPr>
+          <a:xfrm>
+            <a:off x="548640" y="2830000"/>
+            <a:ext cx="2600000" cy="700000"/>
+          </a:xfrm>
+          <a:prstGeom prst="rect">
+            <a:avLst/>
+          </a:prstGeom>
+          <a:solidFill>
+            <a:srgbClr val="FFFFFF"/>
+          </a:solidFill>
+          <a:ln w="6350">
+            <a:solidFill>
+              <a:srgbClr val="D9D9D9"/>
+            </a:solidFill>
+          </a:ln>
+        </p:spPr>
+        <p:txBody>
+          <a:bodyPr wrap="square" lIns="90000" tIns="40000" rIns="90000" bIns="40000" anchor="ctr"/>
+          <a:lstStyle/>
+          <a:p>
+            <a:pPr indent="0" marL="0">
+              <a:buNone/>
+            </a:pPr>
+            <a:r>
+              <a:rPr lang="en-US" sz="1100" b="1" dirty="0">
+                <a:solidFill>
+                  <a:srgbClr val="1A2233"/>
+                </a:solidFill>
+                <a:latin typeface="Calibri" pitchFamily="34" charset="0"/>
+              </a:rPr>
+              <a:t>Bank 2 — Universal Links</a:t>
+            </a:r>
+          </a:p>
+        </p:txBody>
+      </p:sp>
+      <p:sp>
+        <p:nvSpPr>
+          <p:cNvPr id="1008" name="TCell"/>
+          <p:cNvSpPr/>
+          <p:nvPr/>
+        </p:nvSpPr>
+        <p:spPr>
+          <a:xfrm>
+            <a:off x="3148640" y="2830000"/>
+            <a:ext cx="4700000" cy="700000"/>
+          </a:xfrm>
+          <a:prstGeom prst="rect">
+            <a:avLst/>
+          </a:prstGeom>
+          <a:solidFill>
+            <a:srgbClr val="FBEAEA"/>
+          </a:solidFill>
+          <a:ln w="6350">
+            <a:solidFill>
+              <a:srgbClr val="D9D9D9"/>
+            </a:solidFill>
+          </a:ln>
+        </p:spPr>
+        <p:txBody>
+          <a:bodyPr wrap="square" lIns="90000" tIns="40000" rIns="90000" bIns="40000" anchor="ctr"/>
+          <a:lstStyle/>
+          <a:p>
+            <a:pPr indent="0" marL="0">
+              <a:buNone/>
+            </a:pPr>
+            <a:r>
+              <a:rPr lang="en-US" sz="1100" dirty="0">
+                <a:solidFill>
+                  <a:srgbClr val="1A2233"/>
+                </a:solidFill>
+                <a:latin typeface="Calibri" pitchFamily="34" charset="0"/>
+              </a:rPr>
+              <a:t>Just opens Chrome — the app is never involved</a:t>
+            </a:r>
+          </a:p>
+        </p:txBody>
+      </p:sp>
+      <p:sp>
+        <p:nvSpPr>
+          <p:cNvPr id="1009" name="TCell"/>
+          <p:cNvSpPr/>
+          <p:nvPr/>
+        </p:nvSpPr>
+        <p:spPr>
+          <a:xfrm>
+            <a:off x="7848640" y="2830000"/>
+            <a:ext cx="4700000" cy="700000"/>
+          </a:xfrm>
+          <a:prstGeom prst="rect">
+            <a:avLst/>
+          </a:prstGeom>
+          <a:solidFill>
+            <a:srgbClr val="FFE9B3"/>
+          </a:solidFill>
+          <a:ln w="6350">
+            <a:solidFill>
+              <a:srgbClr val="D9D9D9"/>
+            </a:solidFill>
+          </a:ln>
+        </p:spPr>
+        <p:txBody>
+          <a:bodyPr wrap="square" lIns="90000" tIns="40000" rIns="90000" bIns="40000" anchor="ctr"/>
+          <a:lstStyle/>
+          <a:p>
+            <a:pPr indent="0" marL="0">
+              <a:buNone/>
+            </a:pPr>
+            <a:r>
+              <a:rPr lang="en-US" sz="1100" dirty="0">
+                <a:solidFill>
+                  <a:srgbClr val="1A2233"/>
+                </a:solidFill>
+                <a:latin typeface="Calibri" pitchFamily="34" charset="0"/>
+              </a:rPr>
+              <a:t>Safari + manual banner (free-account limit)</a:t>
+            </a:r>
+          </a:p>
+        </p:txBody>
+      </p:sp>
+      <p:sp>
+        <p:nvSpPr>
+          <p:cNvPr id="1010" name="TCell"/>
+          <p:cNvSpPr/>
+          <p:nvPr/>
+        </p:nvSpPr>
+        <p:spPr>
+          <a:xfrm>
+            <a:off x="548640" y="3530000"/>
+            <a:ext cx="2600000" cy="700000"/>
+          </a:xfrm>
+          <a:prstGeom prst="rect">
+            <a:avLst/>
+          </a:prstGeom>
+          <a:solidFill>
+            <a:srgbClr val="FFFFFF"/>
+          </a:solidFill>
+          <a:ln w="6350">
+            <a:solidFill>
+              <a:srgbClr val="D9D9D9"/>
+            </a:solidFill>
+          </a:ln>
+        </p:spPr>
+        <p:txBody>
+          <a:bodyPr wrap="square" lIns="90000" tIns="40000" rIns="90000" bIns="40000" anchor="ctr"/>
+          <a:lstStyle/>
+          <a:p>
+            <a:pPr indent="0" marL="0">
+              <a:buNone/>
+            </a:pPr>
+            <a:r>
+              <a:rPr lang="en-US" sz="1100" b="1" dirty="0">
+                <a:solidFill>
+                  <a:srgbClr val="1A2233"/>
+                </a:solidFill>
+                <a:latin typeface="Calibri" pitchFamily="34" charset="0"/>
+              </a:rPr>
+              <a:t>Bank 3 — Smart Banner</a:t>
+            </a:r>
+          </a:p>
+        </p:txBody>
+      </p:sp>
+      <p:sp>
+        <p:nvSpPr>
+          <p:cNvPr id="1011" name="TCell"/>
+          <p:cNvSpPr/>
+          <p:nvPr/>
+        </p:nvSpPr>
+        <p:spPr>
+          <a:xfrm>
+            <a:off x="3148640" y="3530000"/>
+            <a:ext cx="4700000" cy="700000"/>
+          </a:xfrm>
+          <a:prstGeom prst="rect">
+            <a:avLst/>
+          </a:prstGeom>
+          <a:solidFill>
+            <a:srgbClr val="FBEAEA"/>
+          </a:solidFill>
+          <a:ln w="6350">
+            <a:solidFill>
+              <a:srgbClr val="D9D9D9"/>
+            </a:solidFill>
+          </a:ln>
+        </p:spPr>
+        <p:txBody>
+          <a:bodyPr wrap="square" lIns="90000" tIns="40000" rIns="90000" bIns="40000" anchor="ctr"/>
+          <a:lstStyle/>
+          <a:p>
+            <a:pPr indent="0" marL="0">
+              <a:buNone/>
+            </a:pPr>
+            <a:r>
+              <a:rPr lang="en-US" sz="1100" dirty="0">
+                <a:solidFill>
+                  <a:srgbClr val="1A2233"/>
+                </a:solidFill>
+                <a:latin typeface="Calibri" pitchFamily="34" charset="0"/>
+              </a:rPr>
+              <a:t>Just opens Chrome — the app is never involved</a:t>
+            </a:r>
+          </a:p>
+        </p:txBody>
+      </p:sp>
+      <p:sp>
+        <p:nvSpPr>
+          <p:cNvPr id="1012" name="TCell"/>
+          <p:cNvSpPr/>
+          <p:nvPr/>
+        </p:nvSpPr>
+        <p:spPr>
+          <a:xfrm>
+            <a:off x="7848640" y="3530000"/>
+            <a:ext cx="4700000" cy="700000"/>
+          </a:xfrm>
+          <a:prstGeom prst="rect">
+            <a:avLst/>
+          </a:prstGeom>
+          <a:solidFill>
+            <a:srgbClr val="FFE9B3"/>
+          </a:solidFill>
+          <a:ln w="6350">
+            <a:solidFill>
+              <a:srgbClr val="D9D9D9"/>
+            </a:solidFill>
+          </a:ln>
+        </p:spPr>
+        <p:txBody>
+          <a:bodyPr wrap="square" lIns="90000" tIns="40000" rIns="90000" bIns="40000" anchor="ctr"/>
+          <a:lstStyle/>
+          <a:p>
+            <a:pPr indent="0" marL="0">
+              <a:buNone/>
+            </a:pPr>
+            <a:r>
+              <a:rPr lang="en-US" sz="1100" dirty="0">
+                <a:solidFill>
+                  <a:srgbClr val="1A2233"/>
+                </a:solidFill>
+                <a:latin typeface="Calibri" pitchFamily="34" charset="0"/>
+              </a:rPr>
+              <a:t>Banner can't render (needs App Store listing)</a:t>
+            </a:r>
+          </a:p>
+        </p:txBody>
+      </p:sp>
+      <p:sp>
+        <p:nvSpPr>
+          <p:cNvPr id="1013" name="TCell"/>
+          <p:cNvSpPr/>
+          <p:nvPr/>
+        </p:nvSpPr>
+        <p:spPr>
+          <a:xfrm>
+            <a:off x="548640" y="4230000"/>
+            <a:ext cx="2600000" cy="700000"/>
+          </a:xfrm>
+          <a:prstGeom prst="rect">
+            <a:avLst/>
+          </a:prstGeom>
+          <a:solidFill>
+            <a:srgbClr val="FFFFFF"/>
+          </a:solidFill>
+          <a:ln w="6350">
+            <a:solidFill>
+              <a:srgbClr val="D9D9D9"/>
+            </a:solidFill>
+          </a:ln>
+        </p:spPr>
+        <p:txBody>
+          <a:bodyPr wrap="square" lIns="90000" tIns="40000" rIns="90000" bIns="40000" anchor="ctr"/>
+          <a:lstStyle/>
+          <a:p>
+            <a:pPr indent="0" marL="0">
+              <a:buNone/>
+            </a:pPr>
+            <a:r>
+              <a:rPr lang="en-US" sz="1100" b="1" dirty="0">
+                <a:solidFill>
+                  <a:srgbClr val="1A2233"/>
+                </a:solidFill>
+                <a:latin typeface="Calibri" pitchFamily="34" charset="0"/>
+              </a:rPr>
+              <a:t>Bank 4 — Explicit Intent</a:t>
+            </a:r>
+          </a:p>
+        </p:txBody>
+      </p:sp>
+      <p:sp>
+        <p:nvSpPr>
+          <p:cNvPr id="1014" name="TCell"/>
+          <p:cNvSpPr/>
+          <p:nvPr/>
+        </p:nvSpPr>
+        <p:spPr>
+          <a:xfrm>
+            <a:off x="3148640" y="4230000"/>
+            <a:ext cx="4700000" cy="700000"/>
+          </a:xfrm>
+          <a:prstGeom prst="rect">
+            <a:avLst/>
+          </a:prstGeom>
+          <a:solidFill>
+            <a:srgbClr val="8CFFC1"/>
+          </a:solidFill>
+          <a:ln w="6350">
+            <a:solidFill>
+              <a:srgbClr val="D9D9D9"/>
+            </a:solidFill>
+          </a:ln>
+        </p:spPr>
+        <p:txBody>
+          <a:bodyPr wrap="square" lIns="90000" tIns="40000" rIns="90000" bIns="40000" anchor="ctr"/>
+          <a:lstStyle/>
+          <a:p>
+            <a:pPr indent="0" marL="0">
+              <a:buNone/>
+            </a:pPr>
+            <a:r>
+              <a:rPr lang="en-US" sz="1100" dirty="0">
+                <a:solidFill>
+                  <a:srgbClr val="1A2233"/>
+                </a:solidFill>
+                <a:latin typeface="Calibri" pitchFamily="34" charset="0"/>
+              </a:rPr>
+              <a:t>Opens directly, zero prompt</a:t>
+            </a:r>
+          </a:p>
+        </p:txBody>
+      </p:sp>
+      <p:sp>
+        <p:nvSpPr>
+          <p:cNvPr id="1015" name="TCell"/>
+          <p:cNvSpPr/>
+          <p:nvPr/>
+        </p:nvSpPr>
+        <p:spPr>
+          <a:xfrm>
+            <a:off x="7848640" y="4230000"/>
+            <a:ext cx="4700000" cy="700000"/>
+          </a:xfrm>
+          <a:prstGeom prst="rect">
+            <a:avLst/>
+          </a:prstGeom>
+          <a:solidFill>
+            <a:srgbClr val="FBEAEA"/>
+          </a:solidFill>
+          <a:ln w="6350">
+            <a:solidFill>
+              <a:srgbClr val="D9D9D9"/>
+            </a:solidFill>
+          </a:ln>
+        </p:spPr>
+        <p:txBody>
+          <a:bodyPr wrap="square" lIns="90000" tIns="40000" rIns="90000" bIns="40000" anchor="ctr"/>
+          <a:lstStyle/>
+          <a:p>
+            <a:pPr indent="0" marL="0">
+              <a:buNone/>
+            </a:pPr>
+            <a:r>
+              <a:rPr lang="en-US" sz="1100" dirty="0">
+                <a:solidFill>
+                  <a:srgbClr val="1A2233"/>
+                </a:solidFill>
+                <a:latin typeface="Calibri" pitchFamily="34" charset="0"/>
+              </a:rPr>
+              <a:t>Just a webpage — the app is never involved</a:t>
+            </a:r>
+          </a:p>
+        </p:txBody>
+      </p:sp>
+      <p:sp>
+        <p:nvSpPr>
+          <p:cNvPr id="1016" name="TCell"/>
+          <p:cNvSpPr/>
+          <p:nvPr/>
+        </p:nvSpPr>
+        <p:spPr>
+          <a:xfrm>
+            <a:off x="548640" y="4930000"/>
+            <a:ext cx="2600000" cy="700000"/>
+          </a:xfrm>
+          <a:prstGeom prst="rect">
+            <a:avLst/>
+          </a:prstGeom>
+          <a:solidFill>
+            <a:srgbClr val="FFFFFF"/>
+          </a:solidFill>
+          <a:ln w="6350">
+            <a:solidFill>
+              <a:srgbClr val="D9D9D9"/>
+            </a:solidFill>
+          </a:ln>
+        </p:spPr>
+        <p:txBody>
+          <a:bodyPr wrap="square" lIns="90000" tIns="40000" rIns="90000" bIns="40000" anchor="ctr"/>
+          <a:lstStyle/>
+          <a:p>
+            <a:pPr indent="0" marL="0">
+              <a:buNone/>
+            </a:pPr>
+            <a:r>
+              <a:rPr lang="en-US" sz="1100" b="1" dirty="0">
+                <a:solidFill>
+                  <a:srgbClr val="1A2233"/>
+                </a:solidFill>
+                <a:latin typeface="Calibri" pitchFamily="34" charset="0"/>
+              </a:rPr>
+              <a:t>Bank 5 — Deferred Linking</a:t>
+            </a:r>
+          </a:p>
+        </p:txBody>
+      </p:sp>
+      <p:sp>
+        <p:nvSpPr>
+          <p:cNvPr id="1017" name="TCell"/>
+          <p:cNvSpPr/>
+          <p:nvPr/>
+        </p:nvSpPr>
+        <p:spPr>
+          <a:xfrm>
+            <a:off x="3148640" y="4930000"/>
+            <a:ext cx="4700000" cy="700000"/>
+          </a:xfrm>
+          <a:prstGeom prst="rect">
+            <a:avLst/>
+          </a:prstGeom>
+          <a:solidFill>
+            <a:srgbClr val="8CFFC1"/>
+          </a:solidFill>
+          <a:ln w="6350">
+            <a:solidFill>
+              <a:srgbClr val="D9D9D9"/>
+            </a:solidFill>
+          </a:ln>
+        </p:spPr>
+        <p:txBody>
+          <a:bodyPr wrap="square" lIns="90000" tIns="40000" rIns="90000" bIns="40000" anchor="ctr"/>
+          <a:lstStyle/>
+          <a:p>
+            <a:pPr indent="0" marL="0">
+              <a:buNone/>
+            </a:pPr>
+            <a:r>
+              <a:rPr lang="en-US" sz="1100" dirty="0">
+                <a:solidFill>
+                  <a:srgbClr val="1A2233"/>
+                </a:solidFill>
+                <a:latin typeface="Calibri" pitchFamily="34" charset="0"/>
+              </a:rPr>
+              <a:t>Correct token recovered</a:t>
+            </a:r>
+          </a:p>
+        </p:txBody>
+      </p:sp>
+      <p:sp>
+        <p:nvSpPr>
+          <p:cNvPr id="1018" name="TCell"/>
+          <p:cNvSpPr/>
+          <p:nvPr/>
+        </p:nvSpPr>
+        <p:spPr>
+          <a:xfrm>
+            <a:off x="7848640" y="4930000"/>
+            <a:ext cx="4700000" cy="700000"/>
+          </a:xfrm>
+          <a:prstGeom prst="rect">
+            <a:avLst/>
+          </a:prstGeom>
+          <a:solidFill>
+            <a:srgbClr val="8CFFC1"/>
+          </a:solidFill>
+          <a:ln w="6350">
+            <a:solidFill>
+              <a:srgbClr val="D9D9D9"/>
+            </a:solidFill>
+          </a:ln>
+        </p:spPr>
+        <p:txBody>
+          <a:bodyPr wrap="square" lIns="90000" tIns="40000" rIns="90000" bIns="40000" anchor="ctr"/>
+          <a:lstStyle/>
+          <a:p>
+            <a:pPr indent="0" marL="0">
+              <a:buNone/>
+            </a:pPr>
+            <a:r>
+              <a:rPr lang="en-US" sz="1100" dirty="0">
+                <a:solidFill>
+                  <a:srgbClr val="1A2233"/>
+                </a:solidFill>
+                <a:latin typeface="Calibri" pitchFamily="34" charset="0"/>
+              </a:rPr>
+              <a:t>Correct token recovered — identical to Android</a:t>
+            </a:r>
+          </a:p>
+        </p:txBody>
+      </p:sp>
+      <p:sp>
+        <p:nvSpPr>
+          <p:cNvPr id="1019" name="TCell"/>
+          <p:cNvSpPr/>
+          <p:nvPr/>
+        </p:nvSpPr>
+        <p:spPr>
+          <a:xfrm>
+            <a:off x="548640" y="5630000"/>
+            <a:ext cx="2600000" cy="700000"/>
+          </a:xfrm>
+          <a:prstGeom prst="rect">
+            <a:avLst/>
+          </a:prstGeom>
+          <a:solidFill>
+            <a:srgbClr val="FFFFFF"/>
+          </a:solidFill>
+          <a:ln w="6350">
+            <a:solidFill>
+              <a:srgbClr val="D9D9D9"/>
+            </a:solidFill>
+          </a:ln>
+        </p:spPr>
+        <p:txBody>
+          <a:bodyPr wrap="square" lIns="90000" tIns="40000" rIns="90000" bIns="40000" anchor="ctr"/>
+          <a:lstStyle/>
+          <a:p>
+            <a:pPr indent="0" marL="0">
+              <a:buNone/>
+            </a:pPr>
+            <a:r>
+              <a:rPr lang="en-US" sz="1100" b="1" dirty="0">
+                <a:solidFill>
+                  <a:srgbClr val="1A2233"/>
+                </a:solidFill>
+                <a:latin typeface="Calibri" pitchFamily="34" charset="0"/>
+              </a:rPr>
               <a:t>Unregistered link (Bank A/B/C)</a:t>
             </a:r>
           </a:p>
@@ -3986,13 +4612,13 @@
       </p:sp>
       <p:sp>
         <p:nvSpPr>
-          <p:cNvPr id="15" name="TCell"/>
-          <p:cNvSpPr/>
-          <p:nvPr/>
-        </p:nvSpPr>
-        <p:spPr>
-          <a:xfrm>
-            <a:off x="3148640" y="2130000"/>
+          <p:cNvPr id="1020" name="TCell"/>
+          <p:cNvSpPr/>
+          <p:nvPr/>
+        </p:nvSpPr>
+        <p:spPr>
+          <a:xfrm>
+            <a:off x="3148640" y="5630000"/>
             <a:ext cx="4700000" cy="700000"/>
           </a:xfrm>
           <a:prstGeom prst="rect">
@@ -4021,20 +4647,20 @@
                 </a:solidFill>
                 <a:latin typeface="Calibri" pitchFamily="34" charset="0"/>
               </a:rPr>
-              <a:t>Native chooser — the real, working point of this project.</a:t>
-            </a:r>
-          </a:p>
-        </p:txBody>
-      </p:sp>
-      <p:sp>
-        <p:nvSpPr>
-          <p:cNvPr id="16" name="TCell"/>
-          <p:cNvSpPr/>
-          <p:nvPr/>
-        </p:nvSpPr>
-        <p:spPr>
-          <a:xfrm>
-            <a:off x="7848640" y="2130000"/>
+              <a:t>Native chooser — the real, working point of this project, not a fallback.</a:t>
+            </a:r>
+          </a:p>
+        </p:txBody>
+      </p:sp>
+      <p:sp>
+        <p:nvSpPr>
+          <p:cNvPr id="1021" name="TCell"/>
+          <p:cNvSpPr/>
+          <p:nvPr/>
+        </p:nvSpPr>
+        <p:spPr>
+          <a:xfrm>
+            <a:off x="7848640" y="5630000"/>
             <a:ext cx="4700000" cy="700000"/>
           </a:xfrm>
           <a:prstGeom prst="rect">
@@ -4063,637 +4689,7 @@
                 </a:solidFill>
                 <a:latin typeface="Calibri" pitchFamily="34" charset="0"/>
               </a:rPr>
-              <a:t>Web picker grid — the real, working point of this project.</a:t>
-            </a:r>
-          </a:p>
-        </p:txBody>
-      </p:sp>
-      <p:sp>
-        <p:nvSpPr>
-          <p:cNvPr id="17" name="TCell"/>
-          <p:cNvSpPr/>
-          <p:nvPr/>
-        </p:nvSpPr>
-        <p:spPr>
-          <a:xfrm>
-            <a:off x="548640" y="2830000"/>
-            <a:ext cx="2600000" cy="700000"/>
-          </a:xfrm>
-          <a:prstGeom prst="rect">
-            <a:avLst/>
-          </a:prstGeom>
-          <a:solidFill>
-            <a:srgbClr val="FFFFFF"/>
-          </a:solidFill>
-          <a:ln w="6350">
-            <a:solidFill>
-              <a:srgbClr val="D9D9D9"/>
-            </a:solidFill>
-          </a:ln>
-        </p:spPr>
-        <p:txBody>
-          <a:bodyPr wrap="square" lIns="90000" tIns="40000" rIns="90000" bIns="40000" anchor="ctr"/>
-          <a:lstStyle/>
-          <a:p>
-            <a:pPr indent="0" marL="0">
-              <a:buNone/>
-            </a:pPr>
-            <a:r>
-              <a:rPr lang="en-US" sz="1100" b="1" dirty="0">
-                <a:solidFill>
-                  <a:srgbClr val="1A2233"/>
-                </a:solidFill>
-                <a:latin typeface="Calibri" pitchFamily="34" charset="0"/>
-              </a:rPr>
-              <a:t>Bank 1 — App Links</a:t>
-            </a:r>
-          </a:p>
-        </p:txBody>
-      </p:sp>
-      <p:sp>
-        <p:nvSpPr>
-          <p:cNvPr id="18" name="TCell"/>
-          <p:cNvSpPr/>
-          <p:nvPr/>
-        </p:nvSpPr>
-        <p:spPr>
-          <a:xfrm>
-            <a:off x="3148640" y="2830000"/>
-            <a:ext cx="4700000" cy="700000"/>
-          </a:xfrm>
-          <a:prstGeom prst="rect">
-            <a:avLst/>
-          </a:prstGeom>
-          <a:solidFill>
-            <a:srgbClr val="8CFFC1"/>
-          </a:solidFill>
-          <a:ln w="6350">
-            <a:solidFill>
-              <a:srgbClr val="D9D9D9"/>
-            </a:solidFill>
-          </a:ln>
-        </p:spPr>
-        <p:txBody>
-          <a:bodyPr wrap="square" lIns="90000" tIns="40000" rIns="90000" bIns="40000" anchor="ctr"/>
-          <a:lstStyle/>
-          <a:p>
-            <a:pPr indent="0" marL="0">
-              <a:buNone/>
-            </a:pPr>
-            <a:r>
-              <a:rPr lang="en-US" sz="1100" dirty="0">
-                <a:solidFill>
-                  <a:srgbClr val="1A2233"/>
-                </a:solidFill>
-                <a:latin typeface="Calibri" pitchFamily="34" charset="0"/>
-              </a:rPr>
-              <a:t>Opens directly, zero prompt</a:t>
-            </a:r>
-          </a:p>
-        </p:txBody>
-      </p:sp>
-      <p:sp>
-        <p:nvSpPr>
-          <p:cNvPr id="19" name="TCell"/>
-          <p:cNvSpPr/>
-          <p:nvPr/>
-        </p:nvSpPr>
-        <p:spPr>
-          <a:xfrm>
-            <a:off x="7848640" y="2830000"/>
-            <a:ext cx="4700000" cy="700000"/>
-          </a:xfrm>
-          <a:prstGeom prst="rect">
-            <a:avLst/>
-          </a:prstGeom>
-          <a:solidFill>
-            <a:srgbClr val="FBEAEA"/>
-          </a:solidFill>
-          <a:ln w="6350">
-            <a:solidFill>
-              <a:srgbClr val="D9D9D9"/>
-            </a:solidFill>
-          </a:ln>
-        </p:spPr>
-        <p:txBody>
-          <a:bodyPr wrap="square" lIns="90000" tIns="40000" rIns="90000" bIns="40000" anchor="ctr"/>
-          <a:lstStyle/>
-          <a:p>
-            <a:pPr indent="0" marL="0">
-              <a:buNone/>
-            </a:pPr>
-            <a:r>
-              <a:rPr lang="en-US" sz="1100" dirty="0">
-                <a:solidFill>
-                  <a:srgbClr val="1A2233"/>
-                </a:solidFill>
-                <a:latin typeface="Calibri" pitchFamily="34" charset="0"/>
-              </a:rPr>
-              <a:t>Just a webpage — the app is never involved</a:t>
-            </a:r>
-          </a:p>
-        </p:txBody>
-      </p:sp>
-      <p:sp>
-        <p:nvSpPr>
-          <p:cNvPr id="20" name="TCell"/>
-          <p:cNvSpPr/>
-          <p:nvPr/>
-        </p:nvSpPr>
-        <p:spPr>
-          <a:xfrm>
-            <a:off x="548640" y="3530000"/>
-            <a:ext cx="2600000" cy="700000"/>
-          </a:xfrm>
-          <a:prstGeom prst="rect">
-            <a:avLst/>
-          </a:prstGeom>
-          <a:solidFill>
-            <a:srgbClr val="FFFFFF"/>
-          </a:solidFill>
-          <a:ln w="6350">
-            <a:solidFill>
-              <a:srgbClr val="D9D9D9"/>
-            </a:solidFill>
-          </a:ln>
-        </p:spPr>
-        <p:txBody>
-          <a:bodyPr wrap="square" lIns="90000" tIns="40000" rIns="90000" bIns="40000" anchor="ctr"/>
-          <a:lstStyle/>
-          <a:p>
-            <a:pPr indent="0" marL="0">
-              <a:buNone/>
-            </a:pPr>
-            <a:r>
-              <a:rPr lang="en-US" sz="1100" b="1" dirty="0">
-                <a:solidFill>
-                  <a:srgbClr val="1A2233"/>
-                </a:solidFill>
-                <a:latin typeface="Calibri" pitchFamily="34" charset="0"/>
-              </a:rPr>
-              <a:t>Bank 2 — Universal Links</a:t>
-            </a:r>
-          </a:p>
-        </p:txBody>
-      </p:sp>
-      <p:sp>
-        <p:nvSpPr>
-          <p:cNvPr id="21" name="TCell"/>
-          <p:cNvSpPr/>
-          <p:nvPr/>
-        </p:nvSpPr>
-        <p:spPr>
-          <a:xfrm>
-            <a:off x="3148640" y="3530000"/>
-            <a:ext cx="4700000" cy="700000"/>
-          </a:xfrm>
-          <a:prstGeom prst="rect">
-            <a:avLst/>
-          </a:prstGeom>
-          <a:solidFill>
-            <a:srgbClr val="FBEAEA"/>
-          </a:solidFill>
-          <a:ln w="6350">
-            <a:solidFill>
-              <a:srgbClr val="D9D9D9"/>
-            </a:solidFill>
-          </a:ln>
-        </p:spPr>
-        <p:txBody>
-          <a:bodyPr wrap="square" lIns="90000" tIns="40000" rIns="90000" bIns="40000" anchor="ctr"/>
-          <a:lstStyle/>
-          <a:p>
-            <a:pPr indent="0" marL="0">
-              <a:buNone/>
-            </a:pPr>
-            <a:r>
-              <a:rPr lang="en-US" sz="1100" dirty="0">
-                <a:solidFill>
-                  <a:srgbClr val="1A2233"/>
-                </a:solidFill>
-                <a:latin typeface="Calibri" pitchFamily="34" charset="0"/>
-              </a:rPr>
-              <a:t>Just opens Chrome — the app is never involved</a:t>
-            </a:r>
-          </a:p>
-        </p:txBody>
-      </p:sp>
-      <p:sp>
-        <p:nvSpPr>
-          <p:cNvPr id="22" name="TCell"/>
-          <p:cNvSpPr/>
-          <p:nvPr/>
-        </p:nvSpPr>
-        <p:spPr>
-          <a:xfrm>
-            <a:off x="7848640" y="3530000"/>
-            <a:ext cx="4700000" cy="700000"/>
-          </a:xfrm>
-          <a:prstGeom prst="rect">
-            <a:avLst/>
-          </a:prstGeom>
-          <a:solidFill>
-            <a:srgbClr val="FFE9B3"/>
-          </a:solidFill>
-          <a:ln w="6350">
-            <a:solidFill>
-              <a:srgbClr val="D9D9D9"/>
-            </a:solidFill>
-          </a:ln>
-        </p:spPr>
-        <p:txBody>
-          <a:bodyPr wrap="square" lIns="90000" tIns="40000" rIns="90000" bIns="40000" anchor="ctr"/>
-          <a:lstStyle/>
-          <a:p>
-            <a:pPr indent="0" marL="0">
-              <a:buNone/>
-            </a:pPr>
-            <a:r>
-              <a:rPr lang="en-US" sz="1100" dirty="0">
-                <a:solidFill>
-                  <a:srgbClr val="1A2233"/>
-                </a:solidFill>
-                <a:latin typeface="Calibri" pitchFamily="34" charset="0"/>
-              </a:rPr>
-              <a:t>Safari + manual banner (free-account limit)</a:t>
-            </a:r>
-          </a:p>
-        </p:txBody>
-      </p:sp>
-      <p:sp>
-        <p:nvSpPr>
-          <p:cNvPr id="23" name="TCell"/>
-          <p:cNvSpPr/>
-          <p:nvPr/>
-        </p:nvSpPr>
-        <p:spPr>
-          <a:xfrm>
-            <a:off x="548640" y="4230000"/>
-            <a:ext cx="2600000" cy="700000"/>
-          </a:xfrm>
-          <a:prstGeom prst="rect">
-            <a:avLst/>
-          </a:prstGeom>
-          <a:solidFill>
-            <a:srgbClr val="FFFFFF"/>
-          </a:solidFill>
-          <a:ln w="6350">
-            <a:solidFill>
-              <a:srgbClr val="D9D9D9"/>
-            </a:solidFill>
-          </a:ln>
-        </p:spPr>
-        <p:txBody>
-          <a:bodyPr wrap="square" lIns="90000" tIns="40000" rIns="90000" bIns="40000" anchor="ctr"/>
-          <a:lstStyle/>
-          <a:p>
-            <a:pPr indent="0" marL="0">
-              <a:buNone/>
-            </a:pPr>
-            <a:r>
-              <a:rPr lang="en-US" sz="1100" b="1" dirty="0">
-                <a:solidFill>
-                  <a:srgbClr val="1A2233"/>
-                </a:solidFill>
-                <a:latin typeface="Calibri" pitchFamily="34" charset="0"/>
-              </a:rPr>
-              <a:t>Bank 3 — Smart Banner</a:t>
-            </a:r>
-          </a:p>
-        </p:txBody>
-      </p:sp>
-      <p:sp>
-        <p:nvSpPr>
-          <p:cNvPr id="24" name="TCell"/>
-          <p:cNvSpPr/>
-          <p:nvPr/>
-        </p:nvSpPr>
-        <p:spPr>
-          <a:xfrm>
-            <a:off x="3148640" y="4230000"/>
-            <a:ext cx="4700000" cy="700000"/>
-          </a:xfrm>
-          <a:prstGeom prst="rect">
-            <a:avLst/>
-          </a:prstGeom>
-          <a:solidFill>
-            <a:srgbClr val="FBEAEA"/>
-          </a:solidFill>
-          <a:ln w="6350">
-            <a:solidFill>
-              <a:srgbClr val="D9D9D9"/>
-            </a:solidFill>
-          </a:ln>
-        </p:spPr>
-        <p:txBody>
-          <a:bodyPr wrap="square" lIns="90000" tIns="40000" rIns="90000" bIns="40000" anchor="ctr"/>
-          <a:lstStyle/>
-          <a:p>
-            <a:pPr indent="0" marL="0">
-              <a:buNone/>
-            </a:pPr>
-            <a:r>
-              <a:rPr lang="en-US" sz="1100" dirty="0">
-                <a:solidFill>
-                  <a:srgbClr val="1A2233"/>
-                </a:solidFill>
-                <a:latin typeface="Calibri" pitchFamily="34" charset="0"/>
-              </a:rPr>
-              <a:t>Just opens Chrome — the app is never involved</a:t>
-            </a:r>
-          </a:p>
-        </p:txBody>
-      </p:sp>
-      <p:sp>
-        <p:nvSpPr>
-          <p:cNvPr id="25" name="TCell"/>
-          <p:cNvSpPr/>
-          <p:nvPr/>
-        </p:nvSpPr>
-        <p:spPr>
-          <a:xfrm>
-            <a:off x="7848640" y="4230000"/>
-            <a:ext cx="4700000" cy="700000"/>
-          </a:xfrm>
-          <a:prstGeom prst="rect">
-            <a:avLst/>
-          </a:prstGeom>
-          <a:solidFill>
-            <a:srgbClr val="FFE9B3"/>
-          </a:solidFill>
-          <a:ln w="6350">
-            <a:solidFill>
-              <a:srgbClr val="D9D9D9"/>
-            </a:solidFill>
-          </a:ln>
-        </p:spPr>
-        <p:txBody>
-          <a:bodyPr wrap="square" lIns="90000" tIns="40000" rIns="90000" bIns="40000" anchor="ctr"/>
-          <a:lstStyle/>
-          <a:p>
-            <a:pPr indent="0" marL="0">
-              <a:buNone/>
-            </a:pPr>
-            <a:r>
-              <a:rPr lang="en-US" sz="1100" dirty="0">
-                <a:solidFill>
-                  <a:srgbClr val="1A2233"/>
-                </a:solidFill>
-                <a:latin typeface="Calibri" pitchFamily="34" charset="0"/>
-              </a:rPr>
-              <a:t>Banner can't render (needs App Store listing)</a:t>
-            </a:r>
-          </a:p>
-        </p:txBody>
-      </p:sp>
-      <p:sp>
-        <p:nvSpPr>
-          <p:cNvPr id="26" name="TCell"/>
-          <p:cNvSpPr/>
-          <p:nvPr/>
-        </p:nvSpPr>
-        <p:spPr>
-          <a:xfrm>
-            <a:off x="548640" y="4930000"/>
-            <a:ext cx="2600000" cy="700000"/>
-          </a:xfrm>
-          <a:prstGeom prst="rect">
-            <a:avLst/>
-          </a:prstGeom>
-          <a:solidFill>
-            <a:srgbClr val="FFFFFF"/>
-          </a:solidFill>
-          <a:ln w="6350">
-            <a:solidFill>
-              <a:srgbClr val="D9D9D9"/>
-            </a:solidFill>
-          </a:ln>
-        </p:spPr>
-        <p:txBody>
-          <a:bodyPr wrap="square" lIns="90000" tIns="40000" rIns="90000" bIns="40000" anchor="ctr"/>
-          <a:lstStyle/>
-          <a:p>
-            <a:pPr indent="0" marL="0">
-              <a:buNone/>
-            </a:pPr>
-            <a:r>
-              <a:rPr lang="en-US" sz="1100" b="1" dirty="0">
-                <a:solidFill>
-                  <a:srgbClr val="1A2233"/>
-                </a:solidFill>
-                <a:latin typeface="Calibri" pitchFamily="34" charset="0"/>
-              </a:rPr>
-              <a:t>Bank 4 — Explicit Intent</a:t>
-            </a:r>
-          </a:p>
-        </p:txBody>
-      </p:sp>
-      <p:sp>
-        <p:nvSpPr>
-          <p:cNvPr id="27" name="TCell"/>
-          <p:cNvSpPr/>
-          <p:nvPr/>
-        </p:nvSpPr>
-        <p:spPr>
-          <a:xfrm>
-            <a:off x="3148640" y="4930000"/>
-            <a:ext cx="4700000" cy="700000"/>
-          </a:xfrm>
-          <a:prstGeom prst="rect">
-            <a:avLst/>
-          </a:prstGeom>
-          <a:solidFill>
-            <a:srgbClr val="8CFFC1"/>
-          </a:solidFill>
-          <a:ln w="6350">
-            <a:solidFill>
-              <a:srgbClr val="D9D9D9"/>
-            </a:solidFill>
-          </a:ln>
-        </p:spPr>
-        <p:txBody>
-          <a:bodyPr wrap="square" lIns="90000" tIns="40000" rIns="90000" bIns="40000" anchor="ctr"/>
-          <a:lstStyle/>
-          <a:p>
-            <a:pPr indent="0" marL="0">
-              <a:buNone/>
-            </a:pPr>
-            <a:r>
-              <a:rPr lang="en-US" sz="1100" dirty="0">
-                <a:solidFill>
-                  <a:srgbClr val="1A2233"/>
-                </a:solidFill>
-                <a:latin typeface="Calibri" pitchFamily="34" charset="0"/>
-              </a:rPr>
-              <a:t>Opens directly, zero prompt</a:t>
-            </a:r>
-          </a:p>
-        </p:txBody>
-      </p:sp>
-      <p:sp>
-        <p:nvSpPr>
-          <p:cNvPr id="28" name="TCell"/>
-          <p:cNvSpPr/>
-          <p:nvPr/>
-        </p:nvSpPr>
-        <p:spPr>
-          <a:xfrm>
-            <a:off x="7848640" y="4930000"/>
-            <a:ext cx="4700000" cy="700000"/>
-          </a:xfrm>
-          <a:prstGeom prst="rect">
-            <a:avLst/>
-          </a:prstGeom>
-          <a:solidFill>
-            <a:srgbClr val="FBEAEA"/>
-          </a:solidFill>
-          <a:ln w="6350">
-            <a:solidFill>
-              <a:srgbClr val="D9D9D9"/>
-            </a:solidFill>
-          </a:ln>
-        </p:spPr>
-        <p:txBody>
-          <a:bodyPr wrap="square" lIns="90000" tIns="40000" rIns="90000" bIns="40000" anchor="ctr"/>
-          <a:lstStyle/>
-          <a:p>
-            <a:pPr indent="0" marL="0">
-              <a:buNone/>
-            </a:pPr>
-            <a:r>
-              <a:rPr lang="en-US" sz="1100" dirty="0">
-                <a:solidFill>
-                  <a:srgbClr val="1A2233"/>
-                </a:solidFill>
-                <a:latin typeface="Calibri" pitchFamily="34" charset="0"/>
-              </a:rPr>
-              <a:t>Just a webpage — the app is never involved</a:t>
-            </a:r>
-          </a:p>
-        </p:txBody>
-      </p:sp>
-      <p:sp>
-        <p:nvSpPr>
-          <p:cNvPr id="29" name="TCell"/>
-          <p:cNvSpPr/>
-          <p:nvPr/>
-        </p:nvSpPr>
-        <p:spPr>
-          <a:xfrm>
-            <a:off x="548640" y="5630000"/>
-            <a:ext cx="2600000" cy="700000"/>
-          </a:xfrm>
-          <a:prstGeom prst="rect">
-            <a:avLst/>
-          </a:prstGeom>
-          <a:solidFill>
-            <a:srgbClr val="FFFFFF"/>
-          </a:solidFill>
-          <a:ln w="6350">
-            <a:solidFill>
-              <a:srgbClr val="D9D9D9"/>
-            </a:solidFill>
-          </a:ln>
-        </p:spPr>
-        <p:txBody>
-          <a:bodyPr wrap="square" lIns="90000" tIns="40000" rIns="90000" bIns="40000" anchor="ctr"/>
-          <a:lstStyle/>
-          <a:p>
-            <a:pPr indent="0" marL="0">
-              <a:buNone/>
-            </a:pPr>
-            <a:r>
-              <a:rPr lang="en-US" sz="1100" b="1" dirty="0">
-                <a:solidFill>
-                  <a:srgbClr val="1A2233"/>
-                </a:solidFill>
-                <a:latin typeface="Calibri" pitchFamily="34" charset="0"/>
-              </a:rPr>
-              <a:t>Bank 5 — Deferred Linking</a:t>
-            </a:r>
-          </a:p>
-        </p:txBody>
-      </p:sp>
-      <p:sp>
-        <p:nvSpPr>
-          <p:cNvPr id="30" name="TCell"/>
-          <p:cNvSpPr/>
-          <p:nvPr/>
-        </p:nvSpPr>
-        <p:spPr>
-          <a:xfrm>
-            <a:off x="3148640" y="5630000"/>
-            <a:ext cx="4700000" cy="700000"/>
-          </a:xfrm>
-          <a:prstGeom prst="rect">
-            <a:avLst/>
-          </a:prstGeom>
-          <a:solidFill>
-            <a:srgbClr val="8CFFC1"/>
-          </a:solidFill>
-          <a:ln w="6350">
-            <a:solidFill>
-              <a:srgbClr val="D9D9D9"/>
-            </a:solidFill>
-          </a:ln>
-        </p:spPr>
-        <p:txBody>
-          <a:bodyPr wrap="square" lIns="90000" tIns="40000" rIns="90000" bIns="40000" anchor="ctr"/>
-          <a:lstStyle/>
-          <a:p>
-            <a:pPr indent="0" marL="0">
-              <a:buNone/>
-            </a:pPr>
-            <a:r>
-              <a:rPr lang="en-US" sz="1100" dirty="0">
-                <a:solidFill>
-                  <a:srgbClr val="1A2233"/>
-                </a:solidFill>
-                <a:latin typeface="Calibri" pitchFamily="34" charset="0"/>
-              </a:rPr>
-              <a:t>Correct token recovered</a:t>
-            </a:r>
-          </a:p>
-        </p:txBody>
-      </p:sp>
-      <p:sp>
-        <p:nvSpPr>
-          <p:cNvPr id="31" name="TCell"/>
-          <p:cNvSpPr/>
-          <p:nvPr/>
-        </p:nvSpPr>
-        <p:spPr>
-          <a:xfrm>
-            <a:off x="7848640" y="5630000"/>
-            <a:ext cx="4700000" cy="700000"/>
-          </a:xfrm>
-          <a:prstGeom prst="rect">
-            <a:avLst/>
-          </a:prstGeom>
-          <a:solidFill>
-            <a:srgbClr val="8CFFC1"/>
-          </a:solidFill>
-          <a:ln w="6350">
-            <a:solidFill>
-              <a:srgbClr val="D9D9D9"/>
-            </a:solidFill>
-          </a:ln>
-        </p:spPr>
-        <p:txBody>
-          <a:bodyPr wrap="square" lIns="90000" tIns="40000" rIns="90000" bIns="40000" anchor="ctr"/>
-          <a:lstStyle/>
-          <a:p>
-            <a:pPr indent="0" marL="0">
-              <a:buNone/>
-            </a:pPr>
-            <a:r>
-              <a:rPr lang="en-US" sz="1100" dirty="0">
-                <a:solidFill>
-                  <a:srgbClr val="1A2233"/>
-                </a:solidFill>
-                <a:latin typeface="Calibri" pitchFamily="34" charset="0"/>
-              </a:rPr>
-              <a:t>Correct token recovered — identical to Android</a:t>
+              <a:t>Web picker grid — the real, working point of this project, not a fallback.</a:t>
             </a:r>
           </a:p>
         </p:txBody>
@@ -5388,7 +5384,7 @@
       </p:grpSpPr>
       <p:sp>
         <p:nvSpPr>
-          <p:cNvPr id="11" name="TB"/>
+          <p:cNvPr id="11" name="Title"/>
           <p:cNvSpPr/>
           <p:nvPr/>
         </p:nvSpPr>
@@ -5404,7 +5400,7 @@
           <a:ln/>
         </p:spPr>
         <p:txBody>
-          <a:bodyPr wrap="square" lIns="0" tIns="0" rIns="0" bIns="0" anchor="t"/>
+          <a:bodyPr wrap="square" lIns="0" tIns="0" rIns="0" bIns="0" anchor="ctr"/>
           <a:lstStyle/>
           <a:p>
             <a:pPr indent="0" marL="0">
@@ -5424,7 +5420,7 @@
       </p:sp>
       <p:sp>
         <p:nvSpPr>
-          <p:cNvPr id="12" name="TB"/>
+          <p:cNvPr id="12" name="Subtitle"/>
           <p:cNvSpPr/>
           <p:nvPr/>
         </p:nvSpPr>
@@ -5453,7 +5449,7 @@
                 </a:solidFill>
                 <a:latin typeface="Calibri" pitchFamily="34" charset="0"/>
               </a:rPr>
-              <a:t>This project builds and tests every one of them — not just the one Bank A/B/C uses</a:t>
+              <a:t>Five alternatives explored first, concluding with the approach this project actually uses</a:t>
             </a:r>
           </a:p>
         </p:txBody>
@@ -5655,7 +5651,7 @@
                 </a:solidFill>
                 <a:latin typeface="Calibri" pitchFamily="34" charset="0"/>
               </a:rPr>
-              <a:t>0</a:t>
+              <a:t>1</a:t>
             </a:r>
           </a:p>
         </p:txBody>
@@ -5697,7 +5693,7 @@
                 </a:solidFill>
                 <a:latin typeface="Calibri" pitchFamily="34" charset="0"/>
               </a:rPr>
-              <a:t>Unregistered link</a:t>
+              <a:t>Verified Android App Links</a:t>
             </a:r>
           </a:p>
         </p:txBody>
@@ -5739,7 +5735,7 @@
                 </a:solidFill>
                 <a:latin typeface="Calibri" pitchFamily="34" charset="0"/>
               </a:rPr>
-              <a:t>Bank A / B / C</a:t>
+              <a:t>Bank 1</a:t>
             </a:r>
           </a:p>
         </p:txBody>
@@ -5781,7 +5777,7 @@
                 </a:solidFill>
                 <a:latin typeface="Calibri" pitchFamily="34" charset="0"/>
               </a:rPr>
-              <a:t>No verification — the chooser/picker IS the point</a:t>
+              <a:t>OS proves domain ownership — chooser disappears</a:t>
             </a:r>
           </a:p>
         </p:txBody>
@@ -5823,7 +5819,7 @@
                 </a:solidFill>
                 <a:latin typeface="Calibri" pitchFamily="34" charset="0"/>
               </a:rPr>
-              <a:t>1</a:t>
+              <a:t>2</a:t>
             </a:r>
           </a:p>
         </p:txBody>
@@ -5865,7 +5861,7 @@
                 </a:solidFill>
                 <a:latin typeface="Calibri" pitchFamily="34" charset="0"/>
               </a:rPr>
-              <a:t>Verified Android App Links</a:t>
+              <a:t>Verified iOS Universal Links</a:t>
             </a:r>
           </a:p>
         </p:txBody>
@@ -5907,7 +5903,7 @@
                 </a:solidFill>
                 <a:latin typeface="Calibri" pitchFamily="34" charset="0"/>
               </a:rPr>
-              <a:t>Bank 1</a:t>
+              <a:t>Bank 2</a:t>
             </a:r>
           </a:p>
         </p:txBody>
@@ -5949,7 +5945,7 @@
                 </a:solidFill>
                 <a:latin typeface="Calibri" pitchFamily="34" charset="0"/>
               </a:rPr>
-              <a:t>OS proves domain ownership — chooser disappears</a:t>
+              <a:t>Same idea on iOS — blocked by a paid-account requirement</a:t>
             </a:r>
           </a:p>
         </p:txBody>
@@ -5991,7 +5987,7 @@
                 </a:solidFill>
                 <a:latin typeface="Calibri" pitchFamily="34" charset="0"/>
               </a:rPr>
-              <a:t>2</a:t>
+              <a:t>3</a:t>
             </a:r>
           </a:p>
         </p:txBody>
@@ -6033,7 +6029,7 @@
                 </a:solidFill>
                 <a:latin typeface="Calibri" pitchFamily="34" charset="0"/>
               </a:rPr>
-              <a:t>Verified iOS Universal Links</a:t>
+              <a:t>iOS Smart App Banner</a:t>
             </a:r>
           </a:p>
         </p:txBody>
@@ -6075,7 +6071,7 @@
                 </a:solidFill>
                 <a:latin typeface="Calibri" pitchFamily="34" charset="0"/>
               </a:rPr>
-              <a:t>Bank 2</a:t>
+              <a:t>Bank 3</a:t>
             </a:r>
           </a:p>
         </p:txBody>
@@ -6117,7 +6113,7 @@
                 </a:solidFill>
                 <a:latin typeface="Calibri" pitchFamily="34" charset="0"/>
               </a:rPr>
-              <a:t>Same idea on iOS — blocked by a paid-account requirement</a:t>
+              <a:t>A webpage hint, not a verified link — blocked by App Store listing</a:t>
             </a:r>
           </a:p>
         </p:txBody>
@@ -6159,7 +6155,7 @@
                 </a:solidFill>
                 <a:latin typeface="Calibri" pitchFamily="34" charset="0"/>
               </a:rPr>
-              <a:t>3</a:t>
+              <a:t>4</a:t>
             </a:r>
           </a:p>
         </p:txBody>
@@ -6201,7 +6197,7 @@
                 </a:solidFill>
                 <a:latin typeface="Calibri" pitchFamily="34" charset="0"/>
               </a:rPr>
-              <a:t>iOS Smart App Banner</a:t>
+              <a:t>Android Explicit-Package Intent</a:t>
             </a:r>
           </a:p>
         </p:txBody>
@@ -6243,7 +6239,7 @@
                 </a:solidFill>
                 <a:latin typeface="Calibri" pitchFamily="34" charset="0"/>
               </a:rPr>
-              <a:t>Bank 3</a:t>
+              <a:t>Bank 4</a:t>
             </a:r>
           </a:p>
         </p:txBody>
@@ -6285,7 +6281,7 @@
                 </a:solidFill>
                 <a:latin typeface="Calibri" pitchFamily="34" charset="0"/>
               </a:rPr>
-              <a:t>A webpage hint, not a verified link — blocked by App Store listing</a:t>
+              <a:t>The sender just states the answer — no verification needed</a:t>
             </a:r>
           </a:p>
         </p:txBody>
@@ -6327,7 +6323,7 @@
                 </a:solidFill>
                 <a:latin typeface="Calibri" pitchFamily="34" charset="0"/>
               </a:rPr>
-              <a:t>4</a:t>
+              <a:t>5</a:t>
             </a:r>
           </a:p>
         </p:txBody>
@@ -6369,7 +6365,7 @@
                 </a:solidFill>
                 <a:latin typeface="Calibri" pitchFamily="34" charset="0"/>
               </a:rPr>
-              <a:t>Android Explicit-Package Intent</a:t>
+              <a:t>Deferred Deep Linking</a:t>
             </a:r>
           </a:p>
         </p:txBody>
@@ -6411,7 +6407,7 @@
                 </a:solidFill>
                 <a:latin typeface="Calibri" pitchFamily="34" charset="0"/>
               </a:rPr>
-              <a:t>Bank 4</a:t>
+              <a:t>Bank 5</a:t>
             </a:r>
           </a:p>
         </p:txBody>
@@ -6453,7 +6449,7 @@
                 </a:solidFill>
                 <a:latin typeface="Calibri" pitchFamily="34" charset="0"/>
               </a:rPr>
-              <a:t>The sender just states the answer — no verification needed</a:t>
+              <a:t>Carries the destination across an app install, via clipboard</a:t>
             </a:r>
           </a:p>
         </p:txBody>
@@ -6473,7 +6469,7 @@
             <a:avLst/>
           </a:prstGeom>
           <a:solidFill>
-            <a:srgbClr val="F5F8FA"/>
+            <a:srgbClr val="E8F5F0"/>
           </a:solidFill>
           <a:ln w="6350">
             <a:solidFill>
@@ -6495,7 +6491,7 @@
                 </a:solidFill>
                 <a:latin typeface="Calibri" pitchFamily="34" charset="0"/>
               </a:rPr>
-              <a:t>5</a:t>
+              <a:t>6</a:t>
             </a:r>
           </a:p>
         </p:txBody>
@@ -6515,7 +6511,7 @@
             <a:avLst/>
           </a:prstGeom>
           <a:solidFill>
-            <a:srgbClr val="F5F8FA"/>
+            <a:srgbClr val="E8F5F0"/>
           </a:solidFill>
           <a:ln w="6350">
             <a:solidFill>
@@ -6537,7 +6533,7 @@
                 </a:solidFill>
                 <a:latin typeface="Calibri" pitchFamily="34" charset="0"/>
               </a:rPr>
-              <a:t>Deferred Deep Linking</a:t>
+              <a:t>Unregistered link (the conclusion)</a:t>
             </a:r>
           </a:p>
         </p:txBody>
@@ -6557,7 +6553,7 @@
             <a:avLst/>
           </a:prstGeom>
           <a:solidFill>
-            <a:srgbClr val="F5F8FA"/>
+            <a:srgbClr val="E8F5F0"/>
           </a:solidFill>
           <a:ln w="6350">
             <a:solidFill>
@@ -6573,13 +6569,13 @@
               <a:buNone/>
             </a:pPr>
             <a:r>
-              <a:rPr lang="en-US" sz="1150" dirty="0">
+              <a:rPr lang="en-US" sz="1150" b="1" dirty="0">
                 <a:solidFill>
                   <a:srgbClr val="1A2233"/>
                 </a:solidFill>
                 <a:latin typeface="Calibri" pitchFamily="34" charset="0"/>
               </a:rPr>
-              <a:t>Bank 5</a:t>
+              <a:t>Bank A / B / C</a:t>
             </a:r>
           </a:p>
         </p:txBody>
@@ -6599,7 +6595,7 @@
             <a:avLst/>
           </a:prstGeom>
           <a:solidFill>
-            <a:srgbClr val="F5F8FA"/>
+            <a:srgbClr val="E8F5F0"/>
           </a:solidFill>
           <a:ln w="6350">
             <a:solidFill>
@@ -6615,13 +6611,13 @@
               <a:buNone/>
             </a:pPr>
             <a:r>
-              <a:rPr lang="en-US" sz="1150" dirty="0">
+              <a:rPr lang="en-US" sz="1150" b="1" dirty="0">
                 <a:solidFill>
                   <a:srgbClr val="1A2233"/>
                 </a:solidFill>
                 <a:latin typeface="Calibri" pitchFamily="34" charset="0"/>
               </a:rPr>
-              <a:t>Carries the destination across an app install, via clipboard</a:t>
+              <a:t>No verification — the chooser/picker IS the point</a:t>
             </a:r>
           </a:p>
         </p:txBody>

</xml_diff>